<commit_message>
Document verified deployment and deferred phone acceptance
</commit_message>
<xml_diff>
--- a/docs/slides/cisco-home-telephony.pptx
+++ b/docs/slides/cisco-home-telephony.pptx
@@ -2,30 +2,30 @@
 <file path=ppt/presentation.xml><?xml version="1.0" encoding="utf-8"?>
 <p:presentation xmlns:p="http://schemas.openxmlformats.org/presentationml/2006/main">
   <p:sldMasterIdLst>
-    <p:sldMasterId xmlns:r="http://schemas.openxmlformats.org/officeDocument/2006/relationships" id="2147483648" r:id="Ra80a938e42ac4512"/>
+    <p:sldMasterId xmlns:r="http://schemas.openxmlformats.org/officeDocument/2006/relationships" id="2147483648" r:id="Rc60615b1ea994c6e"/>
   </p:sldMasterIdLst>
   <p:notesMasterIdLst>
-    <p:notesMasterId xmlns:r="http://schemas.openxmlformats.org/officeDocument/2006/relationships" r:id="R9eca0e15447e4bc0"/>
+    <p:notesMasterId xmlns:r="http://schemas.openxmlformats.org/officeDocument/2006/relationships" r:id="Red0308d7f24a42f7"/>
   </p:notesMasterIdLst>
   <p:sldIdLst>
-    <p:sldId xmlns:r="http://schemas.openxmlformats.org/officeDocument/2006/relationships" id="256" r:id="R278d9568bea141d6"/>
-    <p:sldId xmlns:r="http://schemas.openxmlformats.org/officeDocument/2006/relationships" id="257" r:id="R05c5268c6f864440"/>
-    <p:sldId xmlns:r="http://schemas.openxmlformats.org/officeDocument/2006/relationships" id="258" r:id="R57edc19640bb4a19"/>
-    <p:sldId xmlns:r="http://schemas.openxmlformats.org/officeDocument/2006/relationships" id="259" r:id="R3a1dba5b40664d7c"/>
-    <p:sldId xmlns:r="http://schemas.openxmlformats.org/officeDocument/2006/relationships" id="260" r:id="R0411dea0fa3e425b"/>
-    <p:sldId xmlns:r="http://schemas.openxmlformats.org/officeDocument/2006/relationships" id="261" r:id="R7050e9602cd7419e"/>
-    <p:sldId xmlns:r="http://schemas.openxmlformats.org/officeDocument/2006/relationships" id="262" r:id="R3f2e8f5aedb248ee"/>
-    <p:sldId xmlns:r="http://schemas.openxmlformats.org/officeDocument/2006/relationships" id="263" r:id="R86d9345c78f84dd0"/>
-    <p:sldId xmlns:r="http://schemas.openxmlformats.org/officeDocument/2006/relationships" id="264" r:id="R8a17a9014e264060"/>
-    <p:sldId xmlns:r="http://schemas.openxmlformats.org/officeDocument/2006/relationships" id="265" r:id="R46bae09052504a17"/>
-    <p:sldId xmlns:r="http://schemas.openxmlformats.org/officeDocument/2006/relationships" id="266" r:id="R0db2c9aa171d4046"/>
-    <p:sldId xmlns:r="http://schemas.openxmlformats.org/officeDocument/2006/relationships" id="267" r:id="Rbb76095bf9964d33"/>
-    <p:sldId xmlns:r="http://schemas.openxmlformats.org/officeDocument/2006/relationships" id="268" r:id="Rb6cc4cf71ff641d8"/>
-    <p:sldId xmlns:r="http://schemas.openxmlformats.org/officeDocument/2006/relationships" id="269" r:id="R4f25602663b24b1a"/>
-    <p:sldId xmlns:r="http://schemas.openxmlformats.org/officeDocument/2006/relationships" id="270" r:id="R82f9b173acd24727"/>
-    <p:sldId xmlns:r="http://schemas.openxmlformats.org/officeDocument/2006/relationships" id="271" r:id="R2828495136d24bd9"/>
-    <p:sldId xmlns:r="http://schemas.openxmlformats.org/officeDocument/2006/relationships" id="272" r:id="R290e82c1513c4c1a"/>
-    <p:sldId xmlns:r="http://schemas.openxmlformats.org/officeDocument/2006/relationships" id="273" r:id="R19b3fd6628c94dcf"/>
+    <p:sldId xmlns:r="http://schemas.openxmlformats.org/officeDocument/2006/relationships" id="256" r:id="Rf680a2e95ae44a2a"/>
+    <p:sldId xmlns:r="http://schemas.openxmlformats.org/officeDocument/2006/relationships" id="257" r:id="Rbe3a4dbc74da42eb"/>
+    <p:sldId xmlns:r="http://schemas.openxmlformats.org/officeDocument/2006/relationships" id="258" r:id="R9a56e51a9a1b4c92"/>
+    <p:sldId xmlns:r="http://schemas.openxmlformats.org/officeDocument/2006/relationships" id="259" r:id="R4a6853c181ec49b7"/>
+    <p:sldId xmlns:r="http://schemas.openxmlformats.org/officeDocument/2006/relationships" id="260" r:id="R6ac73f7ae48948dd"/>
+    <p:sldId xmlns:r="http://schemas.openxmlformats.org/officeDocument/2006/relationships" id="261" r:id="R13a62048ce3d49fb"/>
+    <p:sldId xmlns:r="http://schemas.openxmlformats.org/officeDocument/2006/relationships" id="262" r:id="Rb1a076189df7400c"/>
+    <p:sldId xmlns:r="http://schemas.openxmlformats.org/officeDocument/2006/relationships" id="263" r:id="R8f46d56bf77c408b"/>
+    <p:sldId xmlns:r="http://schemas.openxmlformats.org/officeDocument/2006/relationships" id="264" r:id="Rbc4d8875a1f14856"/>
+    <p:sldId xmlns:r="http://schemas.openxmlformats.org/officeDocument/2006/relationships" id="265" r:id="Re916562666994f3b"/>
+    <p:sldId xmlns:r="http://schemas.openxmlformats.org/officeDocument/2006/relationships" id="266" r:id="Re86db2a43cd44283"/>
+    <p:sldId xmlns:r="http://schemas.openxmlformats.org/officeDocument/2006/relationships" id="267" r:id="R0baad21cfc02454d"/>
+    <p:sldId xmlns:r="http://schemas.openxmlformats.org/officeDocument/2006/relationships" id="268" r:id="R011339494f074099"/>
+    <p:sldId xmlns:r="http://schemas.openxmlformats.org/officeDocument/2006/relationships" id="269" r:id="Rc421db799f6641b5"/>
+    <p:sldId xmlns:r="http://schemas.openxmlformats.org/officeDocument/2006/relationships" id="270" r:id="R70feb78dd01b4be6"/>
+    <p:sldId xmlns:r="http://schemas.openxmlformats.org/officeDocument/2006/relationships" id="271" r:id="Rdfaf4f82ae4b4d4a"/>
+    <p:sldId xmlns:r="http://schemas.openxmlformats.org/officeDocument/2006/relationships" id="272" r:id="R46fa2b66ee454dcb"/>
+    <p:sldId xmlns:r="http://schemas.openxmlformats.org/officeDocument/2006/relationships" id="273" r:id="Re798a9f0e11045da"/>
   </p:sldIdLst>
   <p:sldSz cx="12192000" cy="6858000"/>
   <p:notesSz cx="6858000" cy="9144000"/>
@@ -1109,7 +1109,7 @@
           <a:lstStyle xmlns:a="http://schemas.openxmlformats.org/drawingml/2006/main"/>
           <a:p xmlns:a="http://schemas.openxmlformats.org/drawingml/2006/main">
             <a:r>
-              <a:t>Status snapshot: October 17, 2026. SIP2SIP and Linphone account activation completed. Callcentric IP Freedom account activation completed with a $0 plan and $0 balance. The provider dashboard blocks outbound calls pending risk review by support. The profile stays disabled. SIP credential verification and PBX registration remain pending. Free accounts do not imply free PSTN calls. SIP2SIP 802 uses the official 4444 echo destination. Callcentric 801 uses its official 17771234567 test account once enabled. Linphone requires an explicitly verified free peer, with no invented echo number. FWD issued credentials but its mandatory identity-verification flow opened a Verification Fee checkout, so activation stopped. Google Voice supplies no official free generic Asterisk SIP trunk. Working external calls require actual REGISTER, answer and bidirectional RTP evidence. Sources: https://sip2sip.info/help/ ; https://www.callcentric.com/rate/plans/ip_freedom/ ; https://www.callcentric.com/support/device/asterisk/17_pjsip ; https://www.linphone.org/en/faq/ ; https://www.fwdialup.com/mission ; https://knowledge.workspace.google.com/admin/voice/sip-link-requirements ; docs/external-sip.md and docs/extended-services-research.md.</a:t>
+              <a:t>Status snapshot: October 17, 2026. SIP2SIP, Callcentric and Linphone all reached Registered in the live Asterisk instance. Callcentric IP Freedom account activation completed with a $0 plan and $0 balance, but the provider dashboard blocks outbound calls pending risk review by support. Callcentric and Linphone are registration-only, with no active 801 or 803 dial route; Linphone still needs an explicitly verified free peer. SIP2SIP 802 targets the official 4444 echo destination. Its external audio pilot was deferred at the user's request, so registration is verified but external call media is not. Free accounts do not imply free PSTN calls. FWD issued credentials but its mandatory identity-verification flow opened a Verification Fee checkout, so activation stopped. Google Voice supplies no official free generic Asterisk SIP trunk. Working external calls require an answered call and bidirectional RTP evidence in addition to REGISTER. Sources: https://sip2sip.info/help/ ; https://www.callcentric.com/rate/plans/ip_freedom/ ; https://www.callcentric.com/support/device/asterisk/17_pjsip ; https://www.linphone.org/en/faq/ ; https://www.fwdialup.com/mission ; https://knowledge.workspace.google.com/admin/voice/sip-link-requirements ; docs/external-sip.md and docs/extended-services-research.md.</a:t>
             </a:r>
           </a:p>
         </p:txBody>
@@ -1791,7 +1791,7 @@
           <p:cNvPr id="3" name="Title">
             <a:extLst xmlns:a="http://schemas.openxmlformats.org/drawingml/2006/main">
               <a:ext uri="{FF2B5EF4-FFF2-40B4-BE49-F238E27FC236}">
-                <a16:creationId xmlns:a16="http://schemas.microsoft.com/office/drawing/2014/main" id="{E040781D-80A3-4945-877E-B66414BCCC23}"/>
+                <a16:creationId xmlns:a16="http://schemas.microsoft.com/office/drawing/2014/main" id="{1AD149AB-ABB9-4042-B0D9-2434C853CEDB}"/>
               </a:ext>
             </a:extLst>
           </p:cNvPr>
@@ -2020,7 +2020,7 @@
           <p:cNvPr id="2" name="Subtitle">
             <a:extLst xmlns:a="http://schemas.openxmlformats.org/drawingml/2006/main">
               <a:ext uri="{FF2B5EF4-FFF2-40B4-BE49-F238E27FC236}">
-                <a16:creationId xmlns:a16="http://schemas.microsoft.com/office/drawing/2014/main" id="{1F47C90D-2AF4-4C25-93B3-443617218020}"/>
+                <a16:creationId xmlns:a16="http://schemas.microsoft.com/office/drawing/2014/main" id="{859D3B9E-F704-4EB2-9D99-7E8914737A18}"/>
               </a:ext>
             </a:extLst>
           </p:cNvPr>
@@ -2266,7 +2266,7 @@
           <p:cNvPr id="2" name="Section title">
             <a:extLst xmlns:a="http://schemas.openxmlformats.org/drawingml/2006/main">
               <a:ext uri="{FF2B5EF4-FFF2-40B4-BE49-F238E27FC236}">
-                <a16:creationId xmlns:a16="http://schemas.microsoft.com/office/drawing/2014/main" id="{CA3CF43E-93F8-4476-BA65-993018897952}"/>
+                <a16:creationId xmlns:a16="http://schemas.microsoft.com/office/drawing/2014/main" id="{7B1AEB8A-A6E4-4478-89DB-99E2D48075E1}"/>
               </a:ext>
             </a:extLst>
           </p:cNvPr>
@@ -2512,7 +2512,7 @@
           <p:cNvPr id="3" name="Title">
             <a:extLst xmlns:a="http://schemas.openxmlformats.org/drawingml/2006/main">
               <a:ext uri="{FF2B5EF4-FFF2-40B4-BE49-F238E27FC236}">
-                <a16:creationId xmlns:a16="http://schemas.microsoft.com/office/drawing/2014/main" id="{C461CD8A-FFD3-4ABF-8A67-C263244E6B2D}"/>
+                <a16:creationId xmlns:a16="http://schemas.microsoft.com/office/drawing/2014/main" id="{0A75401D-4611-4749-B64B-8A843DE419A1}"/>
               </a:ext>
             </a:extLst>
           </p:cNvPr>
@@ -2741,7 +2741,7 @@
           <p:cNvPr id="2" name="Body">
             <a:extLst xmlns:a="http://schemas.openxmlformats.org/drawingml/2006/main">
               <a:ext uri="{FF2B5EF4-FFF2-40B4-BE49-F238E27FC236}">
-                <a16:creationId xmlns:a16="http://schemas.microsoft.com/office/drawing/2014/main" id="{CA35D21E-F24F-4F37-B384-494A913ED9A2}"/>
+                <a16:creationId xmlns:a16="http://schemas.microsoft.com/office/drawing/2014/main" id="{7C5EEA92-2B24-4097-8B88-97478A0B1366}"/>
               </a:ext>
             </a:extLst>
           </p:cNvPr>
@@ -2987,7 +2987,7 @@
           <p:cNvPr id="4" name="Title">
             <a:extLst xmlns:a="http://schemas.openxmlformats.org/drawingml/2006/main">
               <a:ext uri="{FF2B5EF4-FFF2-40B4-BE49-F238E27FC236}">
-                <a16:creationId xmlns:a16="http://schemas.microsoft.com/office/drawing/2014/main" id="{57892153-305A-4F9E-A978-2BD603EB8FE5}"/>
+                <a16:creationId xmlns:a16="http://schemas.microsoft.com/office/drawing/2014/main" id="{2473EB3C-A760-4EB7-AF42-F1B00BA7BD91}"/>
               </a:ext>
             </a:extLst>
           </p:cNvPr>
@@ -3216,7 +3216,7 @@
           <p:cNvPr id="2" name="Left column">
             <a:extLst xmlns:a="http://schemas.openxmlformats.org/drawingml/2006/main">
               <a:ext uri="{FF2B5EF4-FFF2-40B4-BE49-F238E27FC236}">
-                <a16:creationId xmlns:a16="http://schemas.microsoft.com/office/drawing/2014/main" id="{9791A854-1833-42BF-9394-A610F2D2A2A6}"/>
+                <a16:creationId xmlns:a16="http://schemas.microsoft.com/office/drawing/2014/main" id="{1D21B46E-AE81-42D1-9624-ED0FDB6980B4}"/>
               </a:ext>
             </a:extLst>
           </p:cNvPr>
@@ -3445,7 +3445,7 @@
           <p:cNvPr id="3" name="Right column">
             <a:extLst xmlns:a="http://schemas.openxmlformats.org/drawingml/2006/main">
               <a:ext uri="{FF2B5EF4-FFF2-40B4-BE49-F238E27FC236}">
-                <a16:creationId xmlns:a16="http://schemas.microsoft.com/office/drawing/2014/main" id="{3C7AE063-CB92-4808-B9FF-C6C3779F05FB}"/>
+                <a16:creationId xmlns:a16="http://schemas.microsoft.com/office/drawing/2014/main" id="{C374C08D-B727-44B9-97C1-47F34023BF58}"/>
               </a:ext>
             </a:extLst>
           </p:cNvPr>
@@ -3691,7 +3691,7 @@
           <p:cNvPr id="3" name="Title">
             <a:extLst xmlns:a="http://schemas.openxmlformats.org/drawingml/2006/main">
               <a:ext uri="{FF2B5EF4-FFF2-40B4-BE49-F238E27FC236}">
-                <a16:creationId xmlns:a16="http://schemas.microsoft.com/office/drawing/2014/main" id="{5D290ADC-CFF5-4ADA-9400-BA4CB466CAD1}"/>
+                <a16:creationId xmlns:a16="http://schemas.microsoft.com/office/drawing/2014/main" id="{83F6A7C2-853E-4B03-85E6-B862B4CBE038}"/>
               </a:ext>
             </a:extLst>
           </p:cNvPr>
@@ -3920,7 +3920,7 @@
           <p:cNvPr id="2" name="Left column">
             <a:extLst xmlns:a="http://schemas.openxmlformats.org/drawingml/2006/main">
               <a:ext uri="{FF2B5EF4-FFF2-40B4-BE49-F238E27FC236}">
-                <a16:creationId xmlns:a16="http://schemas.microsoft.com/office/drawing/2014/main" id="{60A07F59-E7C1-4454-AE45-CA9481CFCD51}"/>
+                <a16:creationId xmlns:a16="http://schemas.microsoft.com/office/drawing/2014/main" id="{CE5044DC-D96E-4A6F-AD97-DBB76BB65751}"/>
               </a:ext>
             </a:extLst>
           </p:cNvPr>
@@ -4187,12 +4187,12 @@
   </p:cSld>
   <p:clrMap bg1="lt1" tx1="dk1" bg2="lt2" tx2="dk2" accent1="accent1" accent2="accent2" accent3="accent3" accent4="accent4" accent5="accent5" accent6="accent6" hlink="hlink" folHlink="folHlink"/>
   <p:sldLayoutIdLst>
-    <p:sldLayoutId xmlns:r="http://schemas.openxmlformats.org/officeDocument/2006/relationships" id="2147483649" r:id="Rf8cc51be5b7043e6"/>
-    <p:sldLayoutId xmlns:r="http://schemas.openxmlformats.org/officeDocument/2006/relationships" id="2147483650" r:id="R44df3f11c46e44a5"/>
-    <p:sldLayoutId xmlns:r="http://schemas.openxmlformats.org/officeDocument/2006/relationships" id="2147483651" r:id="Rd67cf15e1b1440e7"/>
-    <p:sldLayoutId xmlns:r="http://schemas.openxmlformats.org/officeDocument/2006/relationships" id="2147483652" r:id="Rf1b6e85625d0435d"/>
-    <p:sldLayoutId xmlns:r="http://schemas.openxmlformats.org/officeDocument/2006/relationships" id="2147483653" r:id="Ra55d744493444dc9"/>
-    <p:sldLayoutId xmlns:r="http://schemas.openxmlformats.org/officeDocument/2006/relationships" id="2147483654" r:id="R1f5b5ebe926e4d06"/>
+    <p:sldLayoutId xmlns:r="http://schemas.openxmlformats.org/officeDocument/2006/relationships" id="2147483649" r:id="Rde5d239d68234a9b"/>
+    <p:sldLayoutId xmlns:r="http://schemas.openxmlformats.org/officeDocument/2006/relationships" id="2147483650" r:id="R5d3d64e130a84a15"/>
+    <p:sldLayoutId xmlns:r="http://schemas.openxmlformats.org/officeDocument/2006/relationships" id="2147483651" r:id="R15b2b6745c574089"/>
+    <p:sldLayoutId xmlns:r="http://schemas.openxmlformats.org/officeDocument/2006/relationships" id="2147483652" r:id="R870dc5cffd124297"/>
+    <p:sldLayoutId xmlns:r="http://schemas.openxmlformats.org/officeDocument/2006/relationships" id="2147483653" r:id="R656aacb3f90f4641"/>
+    <p:sldLayoutId xmlns:r="http://schemas.openxmlformats.org/officeDocument/2006/relationships" id="2147483654" r:id="Rbc1bb7cb833e491f"/>
   </p:sldLayoutIdLst>
   <p:txStyles>
     <p:titleStyle>
@@ -4743,7 +4743,7 @@
           <p:cNvPr id="7" name="">
             <a:extLst xmlns:a="http://schemas.openxmlformats.org/drawingml/2006/main">
               <a:ext uri="{FF2B5EF4-FFF2-40B4-BE49-F238E27FC236}">
-                <a16:creationId xmlns:a16="http://schemas.microsoft.com/office/drawing/2014/main" id="{7AE9306F-9517-4424-B311-130691B31798}"/>
+                <a16:creationId xmlns:a16="http://schemas.microsoft.com/office/drawing/2014/main" id="{7C8EBC48-80CB-4929-B6CF-7F225CD6FCF7}"/>
               </a:ext>
             </a:extLst>
           </p:cNvPr>
@@ -4883,7 +4883,7 @@
           <p:cNvPr id="2" name="01">
             <a:extLst xmlns:a="http://schemas.openxmlformats.org/drawingml/2006/main">
               <a:ext uri="{FF2B5EF4-FFF2-40B4-BE49-F238E27FC236}">
-                <a16:creationId xmlns:a16="http://schemas.microsoft.com/office/drawing/2014/main" id="{6A10F5D1-BAF3-44DD-A24D-B7EDA3C25D5E}"/>
+                <a16:creationId xmlns:a16="http://schemas.microsoft.com/office/drawing/2014/main" id="{2541CC7F-7BEF-4B38-951C-2C03E13EDD07}"/>
               </a:ext>
             </a:extLst>
           </p:cNvPr>
@@ -5041,7 +5041,7 @@
           <p:cNvPr id="3" name="Cisco 7945G">
             <a:extLst xmlns:a="http://schemas.openxmlformats.org/drawingml/2006/main">
               <a:ext uri="{FF2B5EF4-FFF2-40B4-BE49-F238E27FC236}">
-                <a16:creationId xmlns:a16="http://schemas.microsoft.com/office/drawing/2014/main" id="{9B97AFDA-D9A2-4962-98F0-B484EB8BB564}"/>
+                <a16:creationId xmlns:a16="http://schemas.microsoft.com/office/drawing/2014/main" id="{1A889EAD-9F45-488B-BED6-F6DFA6BD848D}"/>
               </a:ext>
             </a:extLst>
           </p:cNvPr>
@@ -5199,7 +5199,7 @@
           <p:cNvPr id="4" name="Home telephony">
             <a:extLst xmlns:a="http://schemas.openxmlformats.org/drawingml/2006/main">
               <a:ext uri="{FF2B5EF4-FFF2-40B4-BE49-F238E27FC236}">
-                <a16:creationId xmlns:a16="http://schemas.microsoft.com/office/drawing/2014/main" id="{4ABC8F87-4959-4CA9-9D44-F5F61C56D544}"/>
+                <a16:creationId xmlns:a16="http://schemas.microsoft.com/office/drawing/2014/main" id="{32CCFCE1-DC68-4314-A8CC-08885F58BF96}"/>
               </a:ext>
             </a:extLst>
           </p:cNvPr>
@@ -5357,7 +5357,7 @@
           <p:cNvPr id="5" name="Asterisk in k3s + Home Assistant">
             <a:extLst xmlns:a="http://schemas.openxmlformats.org/drawingml/2006/main">
               <a:ext uri="{FF2B5EF4-FFF2-40B4-BE49-F238E27FC236}">
-                <a16:creationId xmlns:a16="http://schemas.microsoft.com/office/drawing/2014/main" id="{B8A9DE72-280F-44BA-9F1A-87B3CE8D9AF3}"/>
+                <a16:creationId xmlns:a16="http://schemas.microsoft.com/office/drawing/2014/main" id="{524CBB45-1AC0-4264-9193-9D52FFD455A4}"/>
               </a:ext>
             </a:extLst>
           </p:cNvPr>
@@ -5515,7 +5515,7 @@
           <p:cNvPr id="6" name="10 phones with color displays">
             <a:extLst xmlns:a="http://schemas.openxmlformats.org/drawingml/2006/main">
               <a:ext uri="{FF2B5EF4-FFF2-40B4-BE49-F238E27FC236}">
-                <a16:creationId xmlns:a16="http://schemas.microsoft.com/office/drawing/2014/main" id="{E599A5BC-472F-4603-8ADE-FA03E0A05D49}"/>
+                <a16:creationId xmlns:a16="http://schemas.microsoft.com/office/drawing/2014/main" id="{4C13FBAF-DDEA-4A4C-B48B-2F7F7B8EE1B0}"/>
               </a:ext>
             </a:extLst>
           </p:cNvPr>
@@ -5671,7 +5671,7 @@
     </p:spTree>
     <p:extLst>
       <p:ext uri="{BB962C8B-B14F-4D97-AF65-F5344CB8AC3E}">
-        <p14:creationId xmlns:p14="http://schemas.microsoft.com/office/powerpoint/2010/main" val="725406725"/>
+        <p14:creationId xmlns:p14="http://schemas.microsoft.com/office/powerpoint/2010/main" val="750955465"/>
       </p:ext>
     </p:extLst>
   </p:cSld>
@@ -5702,7 +5702,7 @@
           <p:cNvPr id="8" name="">
             <a:extLst xmlns:a="http://schemas.openxmlformats.org/drawingml/2006/main">
               <a:ext uri="{FF2B5EF4-FFF2-40B4-BE49-F238E27FC236}">
-                <a16:creationId xmlns:a16="http://schemas.microsoft.com/office/drawing/2014/main" id="{10D563FB-F8C6-452E-B285-A4D6F626C128}"/>
+                <a16:creationId xmlns:a16="http://schemas.microsoft.com/office/drawing/2014/main" id="{F488C894-9C9B-4837-A2DB-CD16A47A52E6}"/>
               </a:ext>
             </a:extLst>
           </p:cNvPr>
@@ -5734,7 +5734,7 @@
           <p:cNvPr id="6" name="">
             <a:extLst xmlns:a="http://schemas.openxmlformats.org/drawingml/2006/main">
               <a:ext uri="{FF2B5EF4-FFF2-40B4-BE49-F238E27FC236}">
-                <a16:creationId xmlns:a16="http://schemas.microsoft.com/office/drawing/2014/main" id="{4DF22F72-81D5-4529-824E-574CE6234572}"/>
+                <a16:creationId xmlns:a16="http://schemas.microsoft.com/office/drawing/2014/main" id="{BC5F423D-BB1C-4BF2-A2F3-ABD4D02E9194}"/>
               </a:ext>
             </a:extLst>
           </p:cNvPr>
@@ -5766,7 +5766,7 @@
           <p:cNvPr id="12" name="630: voice assistant on the phone">
             <a:extLst xmlns:a="http://schemas.openxmlformats.org/drawingml/2006/main">
               <a:ext uri="{FF2B5EF4-FFF2-40B4-BE49-F238E27FC236}">
-                <a16:creationId xmlns:a16="http://schemas.microsoft.com/office/drawing/2014/main" id="{8F49C05E-325B-48BF-BD1A-317D8869F744}"/>
+                <a16:creationId xmlns:a16="http://schemas.microsoft.com/office/drawing/2014/main" id="{2A14ED1B-3755-4C25-B907-973D3483BDC5}"/>
               </a:ext>
             </a:extLst>
           </p:cNvPr>
@@ -5924,7 +5924,7 @@
           <p:cNvPr id="2" name="10">
             <a:extLst xmlns:a="http://schemas.openxmlformats.org/drawingml/2006/main">
               <a:ext uri="{FF2B5EF4-FFF2-40B4-BE49-F238E27FC236}">
-                <a16:creationId xmlns:a16="http://schemas.microsoft.com/office/drawing/2014/main" id="{5FC536F3-53A0-4924-BD72-3AADBB8B1CED}"/>
+                <a16:creationId xmlns:a16="http://schemas.microsoft.com/office/drawing/2014/main" id="{5ADC4242-02E7-4E37-92A9-46D63C0F7E03}"/>
               </a:ext>
             </a:extLst>
           </p:cNvPr>
@@ -6082,7 +6082,7 @@
           <p:cNvPr id="3" name="cisco">
             <a:extLst xmlns:a="http://schemas.openxmlformats.org/drawingml/2006/main">
               <a:ext uri="{FF2B5EF4-FFF2-40B4-BE49-F238E27FC236}">
-                <a16:creationId xmlns:a16="http://schemas.microsoft.com/office/drawing/2014/main" id="{4A5A18E4-4101-4F31-B1DC-D1B323D14FD6}"/>
+                <a16:creationId xmlns:a16="http://schemas.microsoft.com/office/drawing/2014/main" id="{98BD7DE8-7124-4242-8866-FE4EFACF98B3}"/>
               </a:ext>
             </a:extLst>
           </p:cNvPr>
@@ -6292,7 +6292,7 @@
           <p:cNvPr id="4" name="codec">
             <a:extLst xmlns:a="http://schemas.openxmlformats.org/drawingml/2006/main">
               <a:ext uri="{FF2B5EF4-FFF2-40B4-BE49-F238E27FC236}">
-                <a16:creationId xmlns:a16="http://schemas.microsoft.com/office/drawing/2014/main" id="{77AFCB5E-B3DD-44FE-A55F-6BF19E02065A}"/>
+                <a16:creationId xmlns:a16="http://schemas.microsoft.com/office/drawing/2014/main" id="{96850ACD-1DD4-4EC3-9A58-2E0BEF594AFC}"/>
               </a:ext>
             </a:extLst>
           </p:cNvPr>
@@ -6502,7 +6502,7 @@
           <p:cNvPr id="5" name="assist">
             <a:extLst xmlns:a="http://schemas.openxmlformats.org/drawingml/2006/main">
               <a:ext uri="{FF2B5EF4-FFF2-40B4-BE49-F238E27FC236}">
-                <a16:creationId xmlns:a16="http://schemas.microsoft.com/office/drawing/2014/main" id="{D61D3749-C630-402A-847B-6A55A92E8377}"/>
+                <a16:creationId xmlns:a16="http://schemas.microsoft.com/office/drawing/2014/main" id="{D8C4A134-B44A-41DB-B4E1-737807D36A6F}"/>
               </a:ext>
             </a:extLst>
           </p:cNvPr>
@@ -6712,7 +6712,7 @@
           <p:cNvPr id="7" name="SIP TCP&#10;RTP">
             <a:extLst xmlns:a="http://schemas.openxmlformats.org/drawingml/2006/main">
               <a:ext uri="{FF2B5EF4-FFF2-40B4-BE49-F238E27FC236}">
-                <a16:creationId xmlns:a16="http://schemas.microsoft.com/office/drawing/2014/main" id="{455E7EB5-D454-4699-B144-5AB003BBAD93}"/>
+                <a16:creationId xmlns:a16="http://schemas.microsoft.com/office/drawing/2014/main" id="{73F96A49-028A-4802-BEDF-B155E75CA08A}"/>
               </a:ext>
             </a:extLst>
           </p:cNvPr>
@@ -6893,7 +6893,7 @@
           <p:cNvPr id="9" name="SIP UDP&#10;RTP">
             <a:extLst xmlns:a="http://schemas.openxmlformats.org/drawingml/2006/main">
               <a:ext uri="{FF2B5EF4-FFF2-40B4-BE49-F238E27FC236}">
-                <a16:creationId xmlns:a16="http://schemas.microsoft.com/office/drawing/2014/main" id="{651295FF-FEC5-47ED-B328-A678D4C1EB4E}"/>
+                <a16:creationId xmlns:a16="http://schemas.microsoft.com/office/drawing/2014/main" id="{5C5B67BF-C164-40B7-BE3D-BB941AE6E115}"/>
               </a:ext>
             </a:extLst>
           </p:cNvPr>
@@ -7074,7 +7074,7 @@
           <p:cNvPr id="10" name="First call: enable Allow calls and select a pipeline in HA.&#10;Then ">
             <a:extLst xmlns:a="http://schemas.openxmlformats.org/drawingml/2006/main">
               <a:ext uri="{FF2B5EF4-FFF2-40B4-BE49-F238E27FC236}">
-                <a16:creationId xmlns:a16="http://schemas.microsoft.com/office/drawing/2014/main" id="{4BB7A289-640B-4ADC-95EB-E279DD08E47C}"/>
+                <a16:creationId xmlns:a16="http://schemas.microsoft.com/office/drawing/2014/main" id="{07E209F2-BE8F-4045-8D2F-9F9C5BDFE7AC}"/>
               </a:ext>
             </a:extLst>
           </p:cNvPr>
@@ -7255,7 +7255,7 @@
           <p:cNvPr id="11" name="SIP From retains the phone extension. HA uses dynamic UDP ports f">
             <a:extLst xmlns:a="http://schemas.openxmlformats.org/drawingml/2006/main">
               <a:ext uri="{FF2B5EF4-FFF2-40B4-BE49-F238E27FC236}">
-                <a16:creationId xmlns:a16="http://schemas.microsoft.com/office/drawing/2014/main" id="{8BFB153B-3FB0-44BC-B260-2552DF6DD0DF}"/>
+                <a16:creationId xmlns:a16="http://schemas.microsoft.com/office/drawing/2014/main" id="{19E7FC60-419B-4AC2-B9AE-2F558E9AE395}"/>
               </a:ext>
             </a:extLst>
           </p:cNvPr>
@@ -7434,7 +7434,7 @@
     </p:spTree>
     <p:extLst>
       <p:ext uri="{BB962C8B-B14F-4D97-AF65-F5344CB8AC3E}">
-        <p14:creationId xmlns:p14="http://schemas.microsoft.com/office/powerpoint/2010/main" val="864769615"/>
+        <p14:creationId xmlns:p14="http://schemas.microsoft.com/office/powerpoint/2010/main" val="1758282477"/>
       </p:ext>
     </p:extLst>
   </p:cSld>
@@ -7465,7 +7465,7 @@
           <p:cNvPr id="15" name="Deployment and commissioning">
             <a:extLst xmlns:a="http://schemas.openxmlformats.org/drawingml/2006/main">
               <a:ext uri="{FF2B5EF4-FFF2-40B4-BE49-F238E27FC236}">
-                <a16:creationId xmlns:a16="http://schemas.microsoft.com/office/drawing/2014/main" id="{E8132D40-CB57-44DB-BA94-2A48743389DB}"/>
+                <a16:creationId xmlns:a16="http://schemas.microsoft.com/office/drawing/2014/main" id="{C58AA45C-7DFA-47F5-94A9-EADF9A3ED7F4}"/>
               </a:ext>
             </a:extLst>
           </p:cNvPr>
@@ -7623,7 +7623,7 @@
           <p:cNvPr id="2" name="11">
             <a:extLst xmlns:a="http://schemas.openxmlformats.org/drawingml/2006/main">
               <a:ext uri="{FF2B5EF4-FFF2-40B4-BE49-F238E27FC236}">
-                <a16:creationId xmlns:a16="http://schemas.microsoft.com/office/drawing/2014/main" id="{0B0F6691-FA0E-4CB1-AD44-A56163507F0E}"/>
+                <a16:creationId xmlns:a16="http://schemas.microsoft.com/office/drawing/2014/main" id="{590E6E3E-07A5-4FC8-8AB2-755D85ACD349}"/>
               </a:ext>
             </a:extLst>
           </p:cNvPr>
@@ -7781,7 +7781,7 @@
           <p:cNvPr id="3" name="01">
             <a:extLst xmlns:a="http://schemas.openxmlformats.org/drawingml/2006/main">
               <a:ext uri="{FF2B5EF4-FFF2-40B4-BE49-F238E27FC236}">
-                <a16:creationId xmlns:a16="http://schemas.microsoft.com/office/drawing/2014/main" id="{7BA7ECBF-C4AD-4945-A8A5-4654D841618B}"/>
+                <a16:creationId xmlns:a16="http://schemas.microsoft.com/office/drawing/2014/main" id="{8D63FE95-B6A5-46DD-B49D-2B7A35CD82C9}"/>
               </a:ext>
             </a:extLst>
           </p:cNvPr>
@@ -7939,7 +7939,7 @@
           <p:cNvPr id="4" name="Server bootstrap">
             <a:extLst xmlns:a="http://schemas.openxmlformats.org/drawingml/2006/main">
               <a:ext uri="{FF2B5EF4-FFF2-40B4-BE49-F238E27FC236}">
-                <a16:creationId xmlns:a16="http://schemas.microsoft.com/office/drawing/2014/main" id="{CBAB7A75-D842-4988-9B30-3E0476725870}"/>
+                <a16:creationId xmlns:a16="http://schemas.microsoft.com/office/drawing/2014/main" id="{3C20DC89-41BB-4F8E-A359-53545C8C36C3}"/>
               </a:ext>
             </a:extLst>
           </p:cNvPr>
@@ -8097,7 +8097,7 @@
           <p:cNvPr id="5" name="Images, static IP, firewall, Asterisk and Opus">
             <a:extLst xmlns:a="http://schemas.openxmlformats.org/drawingml/2006/main">
               <a:ext uri="{FF2B5EF4-FFF2-40B4-BE49-F238E27FC236}">
-                <a16:creationId xmlns:a16="http://schemas.microsoft.com/office/drawing/2014/main" id="{E1FA4BC8-C5B7-483C-B595-38687AD3A7D1}"/>
+                <a16:creationId xmlns:a16="http://schemas.microsoft.com/office/drawing/2014/main" id="{F7CF5DB1-6896-4F21-967A-CB0D24478B4C}"/>
               </a:ext>
             </a:extLst>
           </p:cNvPr>
@@ -8255,7 +8255,7 @@
           <p:cNvPr id="6" name="02">
             <a:extLst xmlns:a="http://schemas.openxmlformats.org/drawingml/2006/main">
               <a:ext uri="{FF2B5EF4-FFF2-40B4-BE49-F238E27FC236}">
-                <a16:creationId xmlns:a16="http://schemas.microsoft.com/office/drawing/2014/main" id="{11CF4403-8116-43ED-8DB1-94941DDE5A59}"/>
+                <a16:creationId xmlns:a16="http://schemas.microsoft.com/office/drawing/2014/main" id="{E1B92D30-136C-4719-8C18-1BD662FBA369}"/>
               </a:ext>
             </a:extLst>
           </p:cNvPr>
@@ -8413,7 +8413,7 @@
           <p:cNvPr id="7" name="Verified pilot phone">
             <a:extLst xmlns:a="http://schemas.openxmlformats.org/drawingml/2006/main">
               <a:ext uri="{FF2B5EF4-FFF2-40B4-BE49-F238E27FC236}">
-                <a16:creationId xmlns:a16="http://schemas.microsoft.com/office/drawing/2014/main" id="{A8048148-36E0-483F-8E53-BCE30ECBAC91}"/>
+                <a16:creationId xmlns:a16="http://schemas.microsoft.com/office/drawing/2014/main" id="{877E6FF2-557E-433E-A9BC-EF0AA497FDBF}"/>
               </a:ext>
             </a:extLst>
           </p:cNvPr>
@@ -8571,7 +8571,7 @@
           <p:cNvPr id="8" name="PID / HW / Load / MAC, SIP profile, temporary TFTP">
             <a:extLst xmlns:a="http://schemas.openxmlformats.org/drawingml/2006/main">
               <a:ext uri="{FF2B5EF4-FFF2-40B4-BE49-F238E27FC236}">
-                <a16:creationId xmlns:a16="http://schemas.microsoft.com/office/drawing/2014/main" id="{EEFE0C16-3C22-4080-B463-83528AA7AFF7}"/>
+                <a16:creationId xmlns:a16="http://schemas.microsoft.com/office/drawing/2014/main" id="{CAEA80FA-2FCD-4E66-8E3D-F219894DBA2C}"/>
               </a:ext>
             </a:extLst>
           </p:cNvPr>
@@ -8729,7 +8729,7 @@
           <p:cNvPr id="9" name="03">
             <a:extLst xmlns:a="http://schemas.openxmlformats.org/drawingml/2006/main">
               <a:ext uri="{FF2B5EF4-FFF2-40B4-BE49-F238E27FC236}">
-                <a16:creationId xmlns:a16="http://schemas.microsoft.com/office/drawing/2014/main" id="{98E62D10-3DD0-4194-841A-4155FC67E3A2}"/>
+                <a16:creationId xmlns:a16="http://schemas.microsoft.com/office/drawing/2014/main" id="{C8ED6196-B91F-4D23-AF8D-AAFACBAC2985}"/>
               </a:ext>
             </a:extLst>
           </p:cNvPr>
@@ -8887,7 +8887,7 @@
           <p:cNvPr id="10" name="Home Assistant setup">
             <a:extLst xmlns:a="http://schemas.openxmlformats.org/drawingml/2006/main">
               <a:ext uri="{FF2B5EF4-FFF2-40B4-BE49-F238E27FC236}">
-                <a16:creationId xmlns:a16="http://schemas.microsoft.com/office/drawing/2014/main" id="{2A069F76-C89D-4DCA-91E7-9698FFC04099}"/>
+                <a16:creationId xmlns:a16="http://schemas.microsoft.com/office/drawing/2014/main" id="{82A581E3-960B-45A8-B7EA-6A14A9E6494D}"/>
               </a:ext>
             </a:extLst>
           </p:cNvPr>
@@ -9045,7 +9045,7 @@
           <p:cNvPr id="11" name="AMI /32, secret, actual entity IDs and VoIP pipeline">
             <a:extLst xmlns:a="http://schemas.openxmlformats.org/drawingml/2006/main">
               <a:ext uri="{FF2B5EF4-FFF2-40B4-BE49-F238E27FC236}">
-                <a16:creationId xmlns:a16="http://schemas.microsoft.com/office/drawing/2014/main" id="{C494E040-BC69-4448-8CC8-E16EE991E40A}"/>
+                <a16:creationId xmlns:a16="http://schemas.microsoft.com/office/drawing/2014/main" id="{FD5476ED-EDF8-4298-815B-377229E2822A}"/>
               </a:ext>
             </a:extLst>
           </p:cNvPr>
@@ -9203,7 +9203,7 @@
           <p:cNvPr id="12" name="04">
             <a:extLst xmlns:a="http://schemas.openxmlformats.org/drawingml/2006/main">
               <a:ext uri="{FF2B5EF4-FFF2-40B4-BE49-F238E27FC236}">
-                <a16:creationId xmlns:a16="http://schemas.microsoft.com/office/drawing/2014/main" id="{AF46B131-7E4C-4081-B15A-448E765FC4AE}"/>
+                <a16:creationId xmlns:a16="http://schemas.microsoft.com/office/drawing/2014/main" id="{87F0EA83-9897-4B07-B72D-A0EA00AA9924}"/>
               </a:ext>
             </a:extLst>
           </p:cNvPr>
@@ -9361,7 +9361,7 @@
           <p:cNvPr id="13" name="Acceptance and rollout">
             <a:extLst xmlns:a="http://schemas.openxmlformats.org/drawingml/2006/main">
               <a:ext uri="{FF2B5EF4-FFF2-40B4-BE49-F238E27FC236}">
-                <a16:creationId xmlns:a16="http://schemas.microsoft.com/office/drawing/2014/main" id="{77F1B106-AC5D-4805-B292-39FD99392FEF}"/>
+                <a16:creationId xmlns:a16="http://schemas.microsoft.com/office/drawing/2014/main" id="{37DE7174-D6F9-44EC-B08D-E5932177CB68}"/>
               </a:ext>
             </a:extLst>
           </p:cNvPr>
@@ -9519,7 +9519,7 @@
           <p:cNvPr id="14" name="Two phones, a call to 630, then the remaining phones">
             <a:extLst xmlns:a="http://schemas.openxmlformats.org/drawingml/2006/main">
               <a:ext uri="{FF2B5EF4-FFF2-40B4-BE49-F238E27FC236}">
-                <a16:creationId xmlns:a16="http://schemas.microsoft.com/office/drawing/2014/main" id="{55DB505A-2288-40A5-A522-6310165FBA3D}"/>
+                <a16:creationId xmlns:a16="http://schemas.microsoft.com/office/drawing/2014/main" id="{81722C06-24C5-46FE-B8E1-A47AD803D67A}"/>
               </a:ext>
             </a:extLst>
           </p:cNvPr>
@@ -9675,7 +9675,7 @@
     </p:spTree>
     <p:extLst>
       <p:ext uri="{BB962C8B-B14F-4D97-AF65-F5344CB8AC3E}">
-        <p14:creationId xmlns:p14="http://schemas.microsoft.com/office/powerpoint/2010/main" val="1738679576"/>
+        <p14:creationId xmlns:p14="http://schemas.microsoft.com/office/powerpoint/2010/main" val="236585482"/>
       </p:ext>
     </p:extLst>
   </p:cSld>
@@ -9706,7 +9706,7 @@
           <p:cNvPr id="10" name="Acceptance tests on real phones">
             <a:extLst xmlns:a="http://schemas.openxmlformats.org/drawingml/2006/main">
               <a:ext uri="{FF2B5EF4-FFF2-40B4-BE49-F238E27FC236}">
-                <a16:creationId xmlns:a16="http://schemas.microsoft.com/office/drawing/2014/main" id="{145E89EB-AB45-4F49-98D0-1C4B535C253C}"/>
+                <a16:creationId xmlns:a16="http://schemas.microsoft.com/office/drawing/2014/main" id="{0813D1DE-6347-4B38-85F6-2E563E426959}"/>
               </a:ext>
             </a:extLst>
           </p:cNvPr>
@@ -9864,7 +9864,7 @@
           <p:cNvPr id="2" name="12">
             <a:extLst xmlns:a="http://schemas.openxmlformats.org/drawingml/2006/main">
               <a:ext uri="{FF2B5EF4-FFF2-40B4-BE49-F238E27FC236}">
-                <a16:creationId xmlns:a16="http://schemas.microsoft.com/office/drawing/2014/main" id="{E17EA55D-34FB-4A1B-BE7B-9EB338EED4CB}"/>
+                <a16:creationId xmlns:a16="http://schemas.microsoft.com/office/drawing/2014/main" id="{E760D1BB-7EA3-4C3E-B20F-497CB68DCDD9}"/>
               </a:ext>
             </a:extLst>
           </p:cNvPr>
@@ -10022,7 +10022,7 @@
           <p:cNvPr id="3" name="Telephony">
             <a:extLst xmlns:a="http://schemas.openxmlformats.org/drawingml/2006/main">
               <a:ext uri="{FF2B5EF4-FFF2-40B4-BE49-F238E27FC236}">
-                <a16:creationId xmlns:a16="http://schemas.microsoft.com/office/drawing/2014/main" id="{07F0A8E6-4A22-4FE6-A772-847AFB48C2E7}"/>
+                <a16:creationId xmlns:a16="http://schemas.microsoft.com/office/drawing/2014/main" id="{F970A5A6-D068-40C8-96DA-A61AD18ED71C}"/>
               </a:ext>
             </a:extLst>
           </p:cNvPr>
@@ -10180,7 +10180,7 @@
           <p:cNvPr id="4" name="201 and 203: cross-phone audio, hold / transfer">
             <a:extLst xmlns:a="http://schemas.openxmlformats.org/drawingml/2006/main">
               <a:ext uri="{FF2B5EF4-FFF2-40B4-BE49-F238E27FC236}">
-                <a16:creationId xmlns:a16="http://schemas.microsoft.com/office/drawing/2014/main" id="{F8CD80F7-EDD9-43B0-8EA7-20BD309EB7B3}"/>
+                <a16:creationId xmlns:a16="http://schemas.microsoft.com/office/drawing/2014/main" id="{F89D4367-192A-41CF-A527-F6B5DF969386}"/>
               </a:ext>
             </a:extLst>
           </p:cNvPr>
@@ -10338,7 +10338,7 @@
           <p:cNvPr id="5" name="Home Assistant">
             <a:extLst xmlns:a="http://schemas.openxmlformats.org/drawingml/2006/main">
               <a:ext uri="{FF2B5EF4-FFF2-40B4-BE49-F238E27FC236}">
-                <a16:creationId xmlns:a16="http://schemas.microsoft.com/office/drawing/2014/main" id="{44FE1A50-F676-470E-A996-5485B1CAA9A5}"/>
+                <a16:creationId xmlns:a16="http://schemas.microsoft.com/office/drawing/2014/main" id="{B06DD50A-9001-49C8-83E1-7D2A232380E3}"/>
               </a:ext>
             </a:extLst>
           </p:cNvPr>
@@ -10496,7 +10496,7 @@
           <p:cNvPr id="6" name="States, Originate, Hangup on the correct Channel, DTMF">
             <a:extLst xmlns:a="http://schemas.openxmlformats.org/drawingml/2006/main">
               <a:ext uri="{FF2B5EF4-FFF2-40B4-BE49-F238E27FC236}">
-                <a16:creationId xmlns:a16="http://schemas.microsoft.com/office/drawing/2014/main" id="{A08ABB71-DBD0-4E6F-9ADE-6AACF6C3571A}"/>
+                <a16:creationId xmlns:a16="http://schemas.microsoft.com/office/drawing/2014/main" id="{7420FEDD-3541-4648-984C-5A0A9529B6E8}"/>
               </a:ext>
             </a:extLst>
           </p:cNvPr>
@@ -10654,7 +10654,7 @@
           <p:cNvPr id="7" name="Assist 630">
             <a:extLst xmlns:a="http://schemas.openxmlformats.org/drawingml/2006/main">
               <a:ext uri="{FF2B5EF4-FFF2-40B4-BE49-F238E27FC236}">
-                <a16:creationId xmlns:a16="http://schemas.microsoft.com/office/drawing/2014/main" id="{D977814E-1669-4CC0-A4EC-587D4A49DD31}"/>
+                <a16:creationId xmlns:a16="http://schemas.microsoft.com/office/drawing/2014/main" id="{FC6A8BF8-BDCA-416B-821E-C6E5DC721CC7}"/>
               </a:ext>
             </a:extLst>
           </p:cNvPr>
@@ -10812,7 +10812,7 @@
           <p:cNvPr id="8" name="Speech recognition, spoken reply and hangup">
             <a:extLst xmlns:a="http://schemas.openxmlformats.org/drawingml/2006/main">
               <a:ext uri="{FF2B5EF4-FFF2-40B4-BE49-F238E27FC236}">
-                <a16:creationId xmlns:a16="http://schemas.microsoft.com/office/drawing/2014/main" id="{733D2F4A-1911-4EBD-A796-9032F2ADA7F7}"/>
+                <a16:creationId xmlns:a16="http://schemas.microsoft.com/office/drawing/2014/main" id="{AF09562B-6925-4B39-853A-32AA036CA69D}"/>
               </a:ext>
             </a:extLst>
           </p:cNvPr>
@@ -10970,7 +10970,7 @@
           <p:cNvPr id="9" name="Repeat after phone, PBX and HA restarts. Readiness does not verif">
             <a:extLst xmlns:a="http://schemas.openxmlformats.org/drawingml/2006/main">
               <a:ext uri="{FF2B5EF4-FFF2-40B4-BE49-F238E27FC236}">
-                <a16:creationId xmlns:a16="http://schemas.microsoft.com/office/drawing/2014/main" id="{C53D19CD-FF33-4913-B396-361FBD3636DF}"/>
+                <a16:creationId xmlns:a16="http://schemas.microsoft.com/office/drawing/2014/main" id="{0588556C-6052-42D3-9829-11048A8139A7}"/>
               </a:ext>
             </a:extLst>
           </p:cNvPr>
@@ -11126,7 +11126,7 @@
     </p:spTree>
     <p:extLst>
       <p:ext uri="{BB962C8B-B14F-4D97-AF65-F5344CB8AC3E}">
-        <p14:creationId xmlns:p14="http://schemas.microsoft.com/office/powerpoint/2010/main" val="1234310202"/>
+        <p14:creationId xmlns:p14="http://schemas.microsoft.com/office/powerpoint/2010/main" val="215596244"/>
       </p:ext>
     </p:extLst>
   </p:cSld>
@@ -11157,7 +11157,7 @@
           <p:cNvPr id="8" name="Operations and recovery">
             <a:extLst xmlns:a="http://schemas.openxmlformats.org/drawingml/2006/main">
               <a:ext uri="{FF2B5EF4-FFF2-40B4-BE49-F238E27FC236}">
-                <a16:creationId xmlns:a16="http://schemas.microsoft.com/office/drawing/2014/main" id="{66D9B554-33E0-4414-9F84-B8027E7DAC99}"/>
+                <a16:creationId xmlns:a16="http://schemas.microsoft.com/office/drawing/2014/main" id="{C24D2E1C-F15A-447D-9AAD-7AEAF6AB38B0}"/>
               </a:ext>
             </a:extLst>
           </p:cNvPr>
@@ -11315,7 +11315,7 @@
           <p:cNvPr id="2" name="13">
             <a:extLst xmlns:a="http://schemas.openxmlformats.org/drawingml/2006/main">
               <a:ext uri="{FF2B5EF4-FFF2-40B4-BE49-F238E27FC236}">
-                <a16:creationId xmlns:a16="http://schemas.microsoft.com/office/drawing/2014/main" id="{2BF3AC90-0E33-404B-AC19-B860382B1E5F}"/>
+                <a16:creationId xmlns:a16="http://schemas.microsoft.com/office/drawing/2014/main" id="{39CEA8A3-79EE-4E69-AAB5-BA61A215941A}"/>
               </a:ext>
             </a:extLst>
           </p:cNvPr>
@@ -11473,7 +11473,7 @@
           <p:cNvPr id="3" name="Private backups outside Git">
             <a:extLst xmlns:a="http://schemas.openxmlformats.org/drawingml/2006/main">
               <a:ext uri="{FF2B5EF4-FFF2-40B4-BE49-F238E27FC236}">
-                <a16:creationId xmlns:a16="http://schemas.microsoft.com/office/drawing/2014/main" id="{5A9CF2D9-37BC-422D-A738-D5F0B37A2420}"/>
+                <a16:creationId xmlns:a16="http://schemas.microsoft.com/office/drawing/2014/main" id="{4B7A7CB4-E4DD-47B9-991D-ACC292E7AEB9}"/>
               </a:ext>
             </a:extLst>
           </p:cNvPr>
@@ -11631,7 +11631,7 @@
           <p:cNvPr id="4" name="Inventory, SIP / AMI secrets and Asterisk data&#10;HA config / .stora">
             <a:extLst xmlns:a="http://schemas.openxmlformats.org/drawingml/2006/main">
               <a:ext uri="{FF2B5EF4-FFF2-40B4-BE49-F238E27FC236}">
-                <a16:creationId xmlns:a16="http://schemas.microsoft.com/office/drawing/2014/main" id="{B59560AA-F9E3-4312-AE1C-F7C65A0673EA}"/>
+                <a16:creationId xmlns:a16="http://schemas.microsoft.com/office/drawing/2014/main" id="{9F419D33-F43D-4120-BF4C-9B4507D27DD5}"/>
               </a:ext>
             </a:extLst>
           </p:cNvPr>
@@ -11812,7 +11812,7 @@
           <p:cNvPr id="5" name="One node is a single point of failure">
             <a:extLst xmlns:a="http://schemas.openxmlformats.org/drawingml/2006/main">
               <a:ext uri="{FF2B5EF4-FFF2-40B4-BE49-F238E27FC236}">
-                <a16:creationId xmlns:a16="http://schemas.microsoft.com/office/drawing/2014/main" id="{DCF8BF93-8947-4604-A201-01750FBCD1C0}"/>
+                <a16:creationId xmlns:a16="http://schemas.microsoft.com/office/drawing/2014/main" id="{A4AEF8FD-E48A-496C-A91D-F5D89E15992E}"/>
               </a:ext>
             </a:extLst>
           </p:cNvPr>
@@ -11970,7 +11970,7 @@
           <p:cNvPr id="6" name="UPS for network equipment and the k3s node&#10;A recovery plan that p">
             <a:extLst xmlns:a="http://schemas.openxmlformats.org/drawingml/2006/main">
               <a:ext uri="{FF2B5EF4-FFF2-40B4-BE49-F238E27FC236}">
-                <a16:creationId xmlns:a16="http://schemas.microsoft.com/office/drawing/2014/main" id="{F8994F72-6232-49E7-9594-3734895D6DD8}"/>
+                <a16:creationId xmlns:a16="http://schemas.microsoft.com/office/drawing/2014/main" id="{A6324C31-EC18-45A8-8031-0111A43DA4D1}"/>
               </a:ext>
             </a:extLst>
           </p:cNvPr>
@@ -12151,7 +12151,7 @@
           <p:cNvPr id="7" name="Exclude raw DTMF and connected-line data from Recorder. Review ex">
             <a:extLst xmlns:a="http://schemas.openxmlformats.org/drawingml/2006/main">
               <a:ext uri="{FF2B5EF4-FFF2-40B4-BE49-F238E27FC236}">
-                <a16:creationId xmlns:a16="http://schemas.microsoft.com/office/drawing/2014/main" id="{BD93447F-F793-4B27-B31B-56F5DE1CB9F0}"/>
+                <a16:creationId xmlns:a16="http://schemas.microsoft.com/office/drawing/2014/main" id="{6D2EF800-D559-4199-9C23-B457779F2C5C}"/>
               </a:ext>
             </a:extLst>
           </p:cNvPr>
@@ -12307,7 +12307,7 @@
     </p:spTree>
     <p:extLst>
       <p:ext uri="{BB962C8B-B14F-4D97-AF65-F5344CB8AC3E}">
-        <p14:creationId xmlns:p14="http://schemas.microsoft.com/office/powerpoint/2010/main" val="1087590109"/>
+        <p14:creationId xmlns:p14="http://schemas.microsoft.com/office/powerpoint/2010/main" val="2146920185"/>
       </p:ext>
     </p:extLst>
   </p:cSld>
@@ -12338,7 +12338,7 @@
           <p:cNvPr id="8" name="Server readiness and phone acceptance">
             <a:extLst xmlns:a="http://schemas.openxmlformats.org/drawingml/2006/main">
               <a:ext uri="{FF2B5EF4-FFF2-40B4-BE49-F238E27FC236}">
-                <a16:creationId xmlns:a16="http://schemas.microsoft.com/office/drawing/2014/main" id="{27F81A1C-0ADA-4712-9E36-50087E6CCC97}"/>
+                <a16:creationId xmlns:a16="http://schemas.microsoft.com/office/drawing/2014/main" id="{1D4EC317-8460-4BA4-B4F2-D6623A211ACD}"/>
               </a:ext>
             </a:extLst>
           </p:cNvPr>
@@ -12496,7 +12496,7 @@
           <p:cNvPr id="2" name="14">
             <a:extLst xmlns:a="http://schemas.openxmlformats.org/drawingml/2006/main">
               <a:ext uri="{FF2B5EF4-FFF2-40B4-BE49-F238E27FC236}">
-                <a16:creationId xmlns:a16="http://schemas.microsoft.com/office/drawing/2014/main" id="{7CA63ED7-672C-4D25-B596-8C93648AA8AD}"/>
+                <a16:creationId xmlns:a16="http://schemas.microsoft.com/office/drawing/2014/main" id="{B619D9D5-8BFF-4E2F-B251-97FCEA260E51}"/>
               </a:ext>
             </a:extLst>
           </p:cNvPr>
@@ -12654,7 +12654,7 @@
           <p:cNvPr id="3" name="Server preparation can come first">
             <a:extLst xmlns:a="http://schemas.openxmlformats.org/drawingml/2006/main">
               <a:ext uri="{FF2B5EF4-FFF2-40B4-BE49-F238E27FC236}">
-                <a16:creationId xmlns:a16="http://schemas.microsoft.com/office/drawing/2014/main" id="{0FC45210-693C-477C-8ABF-5B4706F2C365}"/>
+                <a16:creationId xmlns:a16="http://schemas.microsoft.com/office/drawing/2014/main" id="{BDB36C04-971E-4008-852B-670F62310EB0}"/>
               </a:ext>
             </a:extLst>
           </p:cNvPr>
@@ -12812,7 +12812,7 @@
           <p:cNvPr id="4" name="Images, configuration, AMI and Opus&#10;Tests verify the server compo">
             <a:extLst xmlns:a="http://schemas.openxmlformats.org/drawingml/2006/main">
               <a:ext uri="{FF2B5EF4-FFF2-40B4-BE49-F238E27FC236}">
-                <a16:creationId xmlns:a16="http://schemas.microsoft.com/office/drawing/2014/main" id="{3ED6EB5A-5C7A-4A44-AB90-24EDBC6A5FB4}"/>
+                <a16:creationId xmlns:a16="http://schemas.microsoft.com/office/drawing/2014/main" id="{4587F99D-5664-45C1-9A4E-D7D4BE8E2AFE}"/>
               </a:ext>
             </a:extLst>
           </p:cNvPr>
@@ -12993,7 +12993,7 @@
           <p:cNvPr id="5" name="A pilot verifies the phone experience">
             <a:extLst xmlns:a="http://schemas.openxmlformats.org/drawingml/2006/main">
               <a:ext uri="{FF2B5EF4-FFF2-40B4-BE49-F238E27FC236}">
-                <a16:creationId xmlns:a16="http://schemas.microsoft.com/office/drawing/2014/main" id="{957DCA45-2C48-4949-B9C9-1F2A357A5051}"/>
+                <a16:creationId xmlns:a16="http://schemas.microsoft.com/office/drawing/2014/main" id="{3C08A8C3-3654-4625-83F8-692593B1B16A}"/>
               </a:ext>
             </a:extLst>
           </p:cNvPr>
@@ -13151,7 +13151,7 @@
           <p:cNvPr id="6" name="Phone inventory, a two-party call and Assist&#10;Add the remaining ph">
             <a:extLst xmlns:a="http://schemas.openxmlformats.org/drawingml/2006/main">
               <a:ext uri="{FF2B5EF4-FFF2-40B4-BE49-F238E27FC236}">
-                <a16:creationId xmlns:a16="http://schemas.microsoft.com/office/drawing/2014/main" id="{B660A870-89C5-4485-82D6-210BA062A043}"/>
+                <a16:creationId xmlns:a16="http://schemas.microsoft.com/office/drawing/2014/main" id="{CE7DE7C2-0A9B-4C0B-8874-2390F1CCC80B}"/>
               </a:ext>
             </a:extLst>
           </p:cNvPr>
@@ -13332,7 +13332,7 @@
           <p:cNvPr id="7" name="Physical acceptance is a separate step. Keep the results in the p">
             <a:extLst xmlns:a="http://schemas.openxmlformats.org/drawingml/2006/main">
               <a:ext uri="{FF2B5EF4-FFF2-40B4-BE49-F238E27FC236}">
-                <a16:creationId xmlns:a16="http://schemas.microsoft.com/office/drawing/2014/main" id="{AB4BE523-9165-4CCE-89EF-911357150053}"/>
+                <a16:creationId xmlns:a16="http://schemas.microsoft.com/office/drawing/2014/main" id="{A3F5C605-D3FE-43A2-8888-4BADFB7FCE96}"/>
               </a:ext>
             </a:extLst>
           </p:cNvPr>
@@ -13488,7 +13488,7 @@
     </p:spTree>
     <p:extLst>
       <p:ext uri="{BB962C8B-B14F-4D97-AF65-F5344CB8AC3E}">
-        <p14:creationId xmlns:p14="http://schemas.microsoft.com/office/powerpoint/2010/main" val="1077921682"/>
+        <p14:creationId xmlns:p14="http://schemas.microsoft.com/office/powerpoint/2010/main" val="533164249"/>
       </p:ext>
     </p:extLst>
   </p:cSld>
@@ -13519,7 +13519,7 @@
           <p:cNvPr id="18" name="Four phones, eight independent lines">
             <a:extLst xmlns:a="http://schemas.openxmlformats.org/drawingml/2006/main">
               <a:ext uri="{FF2B5EF4-FFF2-40B4-BE49-F238E27FC236}">
-                <a16:creationId xmlns:a16="http://schemas.microsoft.com/office/drawing/2014/main" id="{747D527D-432F-4667-A6A8-E2328D8EBD72}"/>
+                <a16:creationId xmlns:a16="http://schemas.microsoft.com/office/drawing/2014/main" id="{92DE0B55-07F4-4F6F-9073-101EA5E54ECB}"/>
               </a:ext>
             </a:extLst>
           </p:cNvPr>
@@ -13677,7 +13677,7 @@
           <p:cNvPr id="2" name="15">
             <a:extLst xmlns:a="http://schemas.openxmlformats.org/drawingml/2006/main">
               <a:ext uri="{FF2B5EF4-FFF2-40B4-BE49-F238E27FC236}">
-                <a16:creationId xmlns:a16="http://schemas.microsoft.com/office/drawing/2014/main" id="{AAE457C8-3367-4130-9740-A49A9ECFACF9}"/>
+                <a16:creationId xmlns:a16="http://schemas.microsoft.com/office/drawing/2014/main" id="{6F28F66C-7D1C-4DFD-82F2-D559493F497B}"/>
               </a:ext>
             </a:extLst>
           </p:cNvPr>
@@ -13835,7 +13835,7 @@
           <p:cNvPr id="3" name="PHONE A">
             <a:extLst xmlns:a="http://schemas.openxmlformats.org/drawingml/2006/main">
               <a:ext uri="{FF2B5EF4-FFF2-40B4-BE49-F238E27FC236}">
-                <a16:creationId xmlns:a16="http://schemas.microsoft.com/office/drawing/2014/main" id="{FB219DBB-4F69-4314-A898-0FEBE9C764F9}"/>
+                <a16:creationId xmlns:a16="http://schemas.microsoft.com/office/drawing/2014/main" id="{4C1F95C6-2081-4256-A952-2FEFBF8380AB}"/>
               </a:ext>
             </a:extLst>
           </p:cNvPr>
@@ -13993,7 +13993,7 @@
           <p:cNvPr id="4" name="201">
             <a:extLst xmlns:a="http://schemas.openxmlformats.org/drawingml/2006/main">
               <a:ext uri="{FF2B5EF4-FFF2-40B4-BE49-F238E27FC236}">
-                <a16:creationId xmlns:a16="http://schemas.microsoft.com/office/drawing/2014/main" id="{3DD23062-F32B-46A5-B3E0-8D0A04689633}"/>
+                <a16:creationId xmlns:a16="http://schemas.microsoft.com/office/drawing/2014/main" id="{65C060EC-C8CE-47B9-9F62-3E6D9A783578}"/>
               </a:ext>
             </a:extLst>
           </p:cNvPr>
@@ -14151,7 +14151,7 @@
           <p:cNvPr id="5" name="202">
             <a:extLst xmlns:a="http://schemas.openxmlformats.org/drawingml/2006/main">
               <a:ext uri="{FF2B5EF4-FFF2-40B4-BE49-F238E27FC236}">
-                <a16:creationId xmlns:a16="http://schemas.microsoft.com/office/drawing/2014/main" id="{B17C04FC-AF24-4355-B645-B3F8EABA7A2B}"/>
+                <a16:creationId xmlns:a16="http://schemas.microsoft.com/office/drawing/2014/main" id="{266BC443-27EF-4597-9AF3-86FF0606F56C}"/>
               </a:ext>
             </a:extLst>
           </p:cNvPr>
@@ -14309,7 +14309,7 @@
           <p:cNvPr id="6" name="PHONE B">
             <a:extLst xmlns:a="http://schemas.openxmlformats.org/drawingml/2006/main">
               <a:ext uri="{FF2B5EF4-FFF2-40B4-BE49-F238E27FC236}">
-                <a16:creationId xmlns:a16="http://schemas.microsoft.com/office/drawing/2014/main" id="{AF6BCB42-3C65-49B2-980D-AE4F1A5F6AAF}"/>
+                <a16:creationId xmlns:a16="http://schemas.microsoft.com/office/drawing/2014/main" id="{8CED992B-42B6-4090-B588-83B6A98F8166}"/>
               </a:ext>
             </a:extLst>
           </p:cNvPr>
@@ -14467,7 +14467,7 @@
           <p:cNvPr id="7" name="203">
             <a:extLst xmlns:a="http://schemas.openxmlformats.org/drawingml/2006/main">
               <a:ext uri="{FF2B5EF4-FFF2-40B4-BE49-F238E27FC236}">
-                <a16:creationId xmlns:a16="http://schemas.microsoft.com/office/drawing/2014/main" id="{5CD603FC-6A7B-40C4-A365-403A8AEFF700}"/>
+                <a16:creationId xmlns:a16="http://schemas.microsoft.com/office/drawing/2014/main" id="{B8C81212-CCD8-47E0-9EBA-9648071DA55E}"/>
               </a:ext>
             </a:extLst>
           </p:cNvPr>
@@ -14625,7 +14625,7 @@
           <p:cNvPr id="8" name="204">
             <a:extLst xmlns:a="http://schemas.openxmlformats.org/drawingml/2006/main">
               <a:ext uri="{FF2B5EF4-FFF2-40B4-BE49-F238E27FC236}">
-                <a16:creationId xmlns:a16="http://schemas.microsoft.com/office/drawing/2014/main" id="{D61FC127-F71A-4EAB-ACA0-D29B6159D86B}"/>
+                <a16:creationId xmlns:a16="http://schemas.microsoft.com/office/drawing/2014/main" id="{8E504E36-2B64-4661-B86F-01894489F64C}"/>
               </a:ext>
             </a:extLst>
           </p:cNvPr>
@@ -14783,7 +14783,7 @@
           <p:cNvPr id="9" name="PHONE C">
             <a:extLst xmlns:a="http://schemas.openxmlformats.org/drawingml/2006/main">
               <a:ext uri="{FF2B5EF4-FFF2-40B4-BE49-F238E27FC236}">
-                <a16:creationId xmlns:a16="http://schemas.microsoft.com/office/drawing/2014/main" id="{258D6F67-9C5A-4D71-B8E8-45AAE0973C6A}"/>
+                <a16:creationId xmlns:a16="http://schemas.microsoft.com/office/drawing/2014/main" id="{2B73034C-F59B-4534-9AF6-83725E64A983}"/>
               </a:ext>
             </a:extLst>
           </p:cNvPr>
@@ -14941,7 +14941,7 @@
           <p:cNvPr id="10" name="205">
             <a:extLst xmlns:a="http://schemas.openxmlformats.org/drawingml/2006/main">
               <a:ext uri="{FF2B5EF4-FFF2-40B4-BE49-F238E27FC236}">
-                <a16:creationId xmlns:a16="http://schemas.microsoft.com/office/drawing/2014/main" id="{EB42C512-FA0C-4A9D-A388-BDDC679729AC}"/>
+                <a16:creationId xmlns:a16="http://schemas.microsoft.com/office/drawing/2014/main" id="{4A9775FA-AE2C-4BAD-ADF7-F281E9936932}"/>
               </a:ext>
             </a:extLst>
           </p:cNvPr>
@@ -15099,7 +15099,7 @@
           <p:cNvPr id="11" name="206">
             <a:extLst xmlns:a="http://schemas.openxmlformats.org/drawingml/2006/main">
               <a:ext uri="{FF2B5EF4-FFF2-40B4-BE49-F238E27FC236}">
-                <a16:creationId xmlns:a16="http://schemas.microsoft.com/office/drawing/2014/main" id="{0F81837F-FA0F-462F-944B-7695A7F1BD73}"/>
+                <a16:creationId xmlns:a16="http://schemas.microsoft.com/office/drawing/2014/main" id="{FB6EF497-BAC4-42BE-A94E-6AAAE8A91148}"/>
               </a:ext>
             </a:extLst>
           </p:cNvPr>
@@ -15257,7 +15257,7 @@
           <p:cNvPr id="12" name="PHONE D">
             <a:extLst xmlns:a="http://schemas.openxmlformats.org/drawingml/2006/main">
               <a:ext uri="{FF2B5EF4-FFF2-40B4-BE49-F238E27FC236}">
-                <a16:creationId xmlns:a16="http://schemas.microsoft.com/office/drawing/2014/main" id="{9AF870F0-56CB-4885-81EE-E078976DBC34}"/>
+                <a16:creationId xmlns:a16="http://schemas.microsoft.com/office/drawing/2014/main" id="{9FF49ACD-1BFA-4F7E-8A72-E25C4936FDE5}"/>
               </a:ext>
             </a:extLst>
           </p:cNvPr>
@@ -15415,7 +15415,7 @@
           <p:cNvPr id="13" name="207">
             <a:extLst xmlns:a="http://schemas.openxmlformats.org/drawingml/2006/main">
               <a:ext uri="{FF2B5EF4-FFF2-40B4-BE49-F238E27FC236}">
-                <a16:creationId xmlns:a16="http://schemas.microsoft.com/office/drawing/2014/main" id="{F413BDCD-4A1D-4707-89D8-B42D145D5624}"/>
+                <a16:creationId xmlns:a16="http://schemas.microsoft.com/office/drawing/2014/main" id="{741267F3-6078-4189-BCBB-4B6B4A9B8BEF}"/>
               </a:ext>
             </a:extLst>
           </p:cNvPr>
@@ -15573,7 +15573,7 @@
           <p:cNvPr id="14" name="208">
             <a:extLst xmlns:a="http://schemas.openxmlformats.org/drawingml/2006/main">
               <a:ext uri="{FF2B5EF4-FFF2-40B4-BE49-F238E27FC236}">
-                <a16:creationId xmlns:a16="http://schemas.microsoft.com/office/drawing/2014/main" id="{CF1F7962-A1EE-4CAD-AD41-42CF02C7CD51}"/>
+                <a16:creationId xmlns:a16="http://schemas.microsoft.com/office/drawing/2014/main" id="{5B797D5E-1BC1-4F62-915D-C1573602126D}"/>
               </a:ext>
             </a:extLst>
           </p:cNvPr>
@@ -15731,7 +15731,7 @@
           <p:cNvPr id="15" name="620 rings the primary line of each phone">
             <a:extLst xmlns:a="http://schemas.openxmlformats.org/drawingml/2006/main">
               <a:ext uri="{FF2B5EF4-FFF2-40B4-BE49-F238E27FC236}">
-                <a16:creationId xmlns:a16="http://schemas.microsoft.com/office/drawing/2014/main" id="{C6E49998-E763-4760-A036-CA4FFAB467DE}"/>
+                <a16:creationId xmlns:a16="http://schemas.microsoft.com/office/drawing/2014/main" id="{5827F399-1889-44AA-A44F-C58B675EAF4E}"/>
               </a:ext>
             </a:extLst>
           </p:cNvPr>
@@ -15889,7 +15889,7 @@
           <p:cNvPr id="16" name="201, 203, 205 and 207 share the group. DND skips that phone.">
             <a:extLst xmlns:a="http://schemas.openxmlformats.org/drawingml/2006/main">
               <a:ext uri="{FF2B5EF4-FFF2-40B4-BE49-F238E27FC236}">
-                <a16:creationId xmlns:a16="http://schemas.microsoft.com/office/drawing/2014/main" id="{21F63598-8156-4707-98A9-8DC93793ABEF}"/>
+                <a16:creationId xmlns:a16="http://schemas.microsoft.com/office/drawing/2014/main" id="{109A847C-3482-4979-BFB0-265FEB722652}"/>
               </a:ext>
             </a:extLst>
           </p:cNvPr>
@@ -16047,7 +16047,7 @@
           <p:cNvPr id="17" name="Eight registrations and local call checks passed. Broader accepta">
             <a:extLst xmlns:a="http://schemas.openxmlformats.org/drawingml/2006/main">
               <a:ext uri="{FF2B5EF4-FFF2-40B4-BE49-F238E27FC236}">
-                <a16:creationId xmlns:a16="http://schemas.microsoft.com/office/drawing/2014/main" id="{F4F02B15-BCB0-40E8-82B5-F8591EBB1776}"/>
+                <a16:creationId xmlns:a16="http://schemas.microsoft.com/office/drawing/2014/main" id="{B7599784-F8FE-4E02-91A5-C5E323882FE3}"/>
               </a:ext>
             </a:extLst>
           </p:cNvPr>
@@ -16203,7 +16203,7 @@
     </p:spTree>
     <p:extLst>
       <p:ext uri="{BB962C8B-B14F-4D97-AF65-F5344CB8AC3E}">
-        <p14:creationId xmlns:p14="http://schemas.microsoft.com/office/powerpoint/2010/main" val="1527900855"/>
+        <p14:creationId xmlns:p14="http://schemas.microsoft.com/office/powerpoint/2010/main" val="1684131079"/>
       </p:ext>
     </p:extLst>
   </p:cSld>
@@ -16234,7 +16234,7 @@
           <p:cNvPr id="14" name="Home Assistant phone controls">
             <a:extLst xmlns:a="http://schemas.openxmlformats.org/drawingml/2006/main">
               <a:ext uri="{FF2B5EF4-FFF2-40B4-BE49-F238E27FC236}">
-                <a16:creationId xmlns:a16="http://schemas.microsoft.com/office/drawing/2014/main" id="{F1EEDC7D-A2B7-403D-A507-E85E3E0D5F2C}"/>
+                <a16:creationId xmlns:a16="http://schemas.microsoft.com/office/drawing/2014/main" id="{28644324-7B9D-4D14-86D1-0A58BBBAD2A1}"/>
               </a:ext>
             </a:extLst>
           </p:cNvPr>
@@ -16392,7 +16392,7 @@
           <p:cNvPr id="2" name="16">
             <a:extLst xmlns:a="http://schemas.openxmlformats.org/drawingml/2006/main">
               <a:ext uri="{FF2B5EF4-FFF2-40B4-BE49-F238E27FC236}">
-                <a16:creationId xmlns:a16="http://schemas.microsoft.com/office/drawing/2014/main" id="{06C533A9-E065-46DE-9CAD-FADEAF95E508}"/>
+                <a16:creationId xmlns:a16="http://schemas.microsoft.com/office/drawing/2014/main" id="{15F6AA9C-8FC1-4A4D-9403-CD8B77CD6B5B}"/>
               </a:ext>
             </a:extLst>
           </p:cNvPr>
@@ -16550,7 +16550,7 @@
           <p:cNvPr id="3" name="120">
             <a:extLst xmlns:a="http://schemas.openxmlformats.org/drawingml/2006/main">
               <a:ext uri="{FF2B5EF4-FFF2-40B4-BE49-F238E27FC236}">
-                <a16:creationId xmlns:a16="http://schemas.microsoft.com/office/drawing/2014/main" id="{197DFAF6-F3F5-4DB5-B1EA-7A27DFCF1D2A}"/>
+                <a16:creationId xmlns:a16="http://schemas.microsoft.com/office/drawing/2014/main" id="{79B8E6BD-7875-46B2-B624-25559C27037C}"/>
               </a:ext>
             </a:extLst>
           </p:cNvPr>
@@ -16708,7 +16708,7 @@
           <p:cNvPr id="4" name="control entities">
             <a:extLst xmlns:a="http://schemas.openxmlformats.org/drawingml/2006/main">
               <a:ext uri="{FF2B5EF4-FFF2-40B4-BE49-F238E27FC236}">
-                <a16:creationId xmlns:a16="http://schemas.microsoft.com/office/drawing/2014/main" id="{0BD76EA1-094C-4FF4-B5B2-49422E928A5D}"/>
+                <a16:creationId xmlns:a16="http://schemas.microsoft.com/office/drawing/2014/main" id="{A02195AA-96DF-40BD-8195-AAFD0E271115}"/>
               </a:ext>
             </a:extLst>
           </p:cNvPr>
@@ -16866,7 +16866,7 @@
           <p:cNvPr id="5" name="Call controls">
             <a:extLst xmlns:a="http://schemas.openxmlformats.org/drawingml/2006/main">
               <a:ext uri="{FF2B5EF4-FFF2-40B4-BE49-F238E27FC236}">
-                <a16:creationId xmlns:a16="http://schemas.microsoft.com/office/drawing/2014/main" id="{0D81A9BB-0BD7-4EAF-B500-1FEACA944D86}"/>
+                <a16:creationId xmlns:a16="http://schemas.microsoft.com/office/drawing/2014/main" id="{0EBF8A80-362D-4E66-AD24-3E95EB1AF420}"/>
               </a:ext>
             </a:extLst>
           </p:cNvPr>
@@ -17024,7 +17024,7 @@
           <p:cNvPr id="6" name="Line, dial, answer and exact-channel hangup">
             <a:extLst xmlns:a="http://schemas.openxmlformats.org/drawingml/2006/main">
               <a:ext uri="{FF2B5EF4-FFF2-40B4-BE49-F238E27FC236}">
-                <a16:creationId xmlns:a16="http://schemas.microsoft.com/office/drawing/2014/main" id="{B0E28669-BD1C-4456-900A-A02D16A3AA63}"/>
+                <a16:creationId xmlns:a16="http://schemas.microsoft.com/office/drawing/2014/main" id="{6638CFEA-10DA-4389-8968-B7E0C3D61041}"/>
               </a:ext>
             </a:extLst>
           </p:cNvPr>
@@ -17182,7 +17182,7 @@
           <p:cNvPr id="7" name="Personal settings">
             <a:extLst xmlns:a="http://schemas.openxmlformats.org/drawingml/2006/main">
               <a:ext uri="{FF2B5EF4-FFF2-40B4-BE49-F238E27FC236}">
-                <a16:creationId xmlns:a16="http://schemas.microsoft.com/office/drawing/2014/main" id="{2F4FF31A-C264-4BF9-B930-A159418F6914}"/>
+                <a16:creationId xmlns:a16="http://schemas.microsoft.com/office/drawing/2014/main" id="{F69BD520-71A4-4D54-BAB4-11B5D8A89682}"/>
               </a:ext>
             </a:extLst>
           </p:cNvPr>
@@ -17340,7 +17340,7 @@
           <p:cNvPr id="8" name="PBX DND and opt-in gateway auto-answer">
             <a:extLst xmlns:a="http://schemas.openxmlformats.org/drawingml/2006/main">
               <a:ext uri="{FF2B5EF4-FFF2-40B4-BE49-F238E27FC236}">
-                <a16:creationId xmlns:a16="http://schemas.microsoft.com/office/drawing/2014/main" id="{3076B0C3-1AFE-4159-92C7-B43F8A237577}"/>
+                <a16:creationId xmlns:a16="http://schemas.microsoft.com/office/drawing/2014/main" id="{9B106CB0-A83E-492A-8663-1CF42DFE459C}"/>
               </a:ext>
             </a:extLst>
           </p:cNvPr>
@@ -17498,7 +17498,7 @@
           <p:cNvPr id="9" name="Schedules">
             <a:extLst xmlns:a="http://schemas.openxmlformats.org/drawingml/2006/main">
               <a:ext uri="{FF2B5EF4-FFF2-40B4-BE49-F238E27FC236}">
-                <a16:creationId xmlns:a16="http://schemas.microsoft.com/office/drawing/2014/main" id="{D132E6A3-1442-44E4-A75B-B088B5D92484}"/>
+                <a16:creationId xmlns:a16="http://schemas.microsoft.com/office/drawing/2014/main" id="{D161E8CF-C32E-454B-812A-8DF88EA3823D}"/>
               </a:ext>
             </a:extLst>
           </p:cNvPr>
@@ -17656,7 +17656,7 @@
           <p:cNvPr id="10" name="Countdown timers and chosen weekdays">
             <a:extLst xmlns:a="http://schemas.openxmlformats.org/drawingml/2006/main">
               <a:ext uri="{FF2B5EF4-FFF2-40B4-BE49-F238E27FC236}">
-                <a16:creationId xmlns:a16="http://schemas.microsoft.com/office/drawing/2014/main" id="{55E1EC13-2947-4E0A-98C3-E3510D96D25B}"/>
+                <a16:creationId xmlns:a16="http://schemas.microsoft.com/office/drawing/2014/main" id="{9E6F3904-0B86-4A92-92D8-A2850A284335}"/>
               </a:ext>
             </a:extLst>
           </p:cNvPr>
@@ -17814,7 +17814,7 @@
           <p:cNvPr id="11" name="Phone screen">
             <a:extLst xmlns:a="http://schemas.openxmlformats.org/drawingml/2006/main">
               <a:ext uri="{FF2B5EF4-FFF2-40B4-BE49-F238E27FC236}">
-                <a16:creationId xmlns:a16="http://schemas.microsoft.com/office/drawing/2014/main" id="{FC9E81FD-92EA-4945-9B12-8D2D7D4327D7}"/>
+                <a16:creationId xmlns:a16="http://schemas.microsoft.com/office/drawing/2014/main" id="{E6EEE2C3-6CF7-4387-99AD-E35A849673DA}"/>
               </a:ext>
             </a:extLst>
           </p:cNvPr>
@@ -17972,7 +17972,7 @@
           <p:cNvPr id="12" name="Authenticated text and approved images">
             <a:extLst xmlns:a="http://schemas.openxmlformats.org/drawingml/2006/main">
               <a:ext uri="{FF2B5EF4-FFF2-40B4-BE49-F238E27FC236}">
-                <a16:creationId xmlns:a16="http://schemas.microsoft.com/office/drawing/2014/main" id="{18468E00-9279-43A0-8D7C-BCD1DA5C9042}"/>
+                <a16:creationId xmlns:a16="http://schemas.microsoft.com/office/drawing/2014/main" id="{590D4A54-E437-47B5-A7D1-B5C0F8E5D38E}"/>
               </a:ext>
             </a:extLst>
           </p:cNvPr>
@@ -18130,7 +18130,7 @@
           <p:cNvPr id="13" name="Fresh call-state checks protect active calls. Live feature accept">
             <a:extLst xmlns:a="http://schemas.openxmlformats.org/drawingml/2006/main">
               <a:ext uri="{FF2B5EF4-FFF2-40B4-BE49-F238E27FC236}">
-                <a16:creationId xmlns:a16="http://schemas.microsoft.com/office/drawing/2014/main" id="{1411F88B-6FCC-47AC-9CCB-AEFFDE73DC9B}"/>
+                <a16:creationId xmlns:a16="http://schemas.microsoft.com/office/drawing/2014/main" id="{11D10C55-AD3E-4495-8E60-686CEB7F7B3B}"/>
               </a:ext>
             </a:extLst>
           </p:cNvPr>
@@ -18286,7 +18286,7 @@
     </p:spTree>
     <p:extLst>
       <p:ext uri="{BB962C8B-B14F-4D97-AF65-F5344CB8AC3E}">
-        <p14:creationId xmlns:p14="http://schemas.microsoft.com/office/powerpoint/2010/main" val="248565774"/>
+        <p14:creationId xmlns:p14="http://schemas.microsoft.com/office/powerpoint/2010/main" val="2027182359"/>
       </p:ext>
     </p:extLst>
   </p:cSld>
@@ -18317,7 +18317,7 @@
           <p:cNvPr id="22" name="Radio and scheduled calls">
             <a:extLst xmlns:a="http://schemas.openxmlformats.org/drawingml/2006/main">
               <a:ext uri="{FF2B5EF4-FFF2-40B4-BE49-F238E27FC236}">
-                <a16:creationId xmlns:a16="http://schemas.microsoft.com/office/drawing/2014/main" id="{452AE017-3F92-4468-9429-37E61EDC6A15}"/>
+                <a16:creationId xmlns:a16="http://schemas.microsoft.com/office/drawing/2014/main" id="{D035768D-6740-448F-BA32-71976397E813}"/>
               </a:ext>
             </a:extLst>
           </p:cNvPr>
@@ -18475,7 +18475,7 @@
           <p:cNvPr id="2" name="17">
             <a:extLst xmlns:a="http://schemas.openxmlformats.org/drawingml/2006/main">
               <a:ext uri="{FF2B5EF4-FFF2-40B4-BE49-F238E27FC236}">
-                <a16:creationId xmlns:a16="http://schemas.microsoft.com/office/drawing/2014/main" id="{802ECCDA-3B08-471B-ABC4-EBA233C61585}"/>
+                <a16:creationId xmlns:a16="http://schemas.microsoft.com/office/drawing/2014/main" id="{A0EF1DD5-3CFA-49A9-BB1B-16D4C65382C0}"/>
               </a:ext>
             </a:extLst>
           </p:cNvPr>
@@ -18633,7 +18633,7 @@
           <p:cNvPr id="3" name="640">
             <a:extLst xmlns:a="http://schemas.openxmlformats.org/drawingml/2006/main">
               <a:ext uri="{FF2B5EF4-FFF2-40B4-BE49-F238E27FC236}">
-                <a16:creationId xmlns:a16="http://schemas.microsoft.com/office/drawing/2014/main" id="{296F091D-BA7A-4F47-8BAA-54B2380C01B7}"/>
+                <a16:creationId xmlns:a16="http://schemas.microsoft.com/office/drawing/2014/main" id="{72805B55-24BF-47FC-9981-9C503513616A}"/>
               </a:ext>
             </a:extLst>
           </p:cNvPr>
@@ -18791,7 +18791,7 @@
           <p:cNvPr id="4" name="Alarm tone">
             <a:extLst xmlns:a="http://schemas.openxmlformats.org/drawingml/2006/main">
               <a:ext uri="{FF2B5EF4-FFF2-40B4-BE49-F238E27FC236}">
-                <a16:creationId xmlns:a16="http://schemas.microsoft.com/office/drawing/2014/main" id="{0E8D01B1-4DC1-4159-9149-744EC828EEC4}"/>
+                <a16:creationId xmlns:a16="http://schemas.microsoft.com/office/drawing/2014/main" id="{53FAE97A-7022-4C25-AA4F-D211BC20AB3D}"/>
               </a:ext>
             </a:extLst>
           </p:cNvPr>
@@ -18949,7 +18949,7 @@
           <p:cNvPr id="5" name="Up to 30 seconds&#10;Ends after playback">
             <a:extLst xmlns:a="http://schemas.openxmlformats.org/drawingml/2006/main">
               <a:ext uri="{FF2B5EF4-FFF2-40B4-BE49-F238E27FC236}">
-                <a16:creationId xmlns:a16="http://schemas.microsoft.com/office/drawing/2014/main" id="{BC9BB4CD-B142-4FAA-ABF6-B409A28B7242}"/>
+                <a16:creationId xmlns:a16="http://schemas.microsoft.com/office/drawing/2014/main" id="{0C192520-3D40-4882-B0A5-8CDC1E62D4BB}"/>
               </a:ext>
             </a:extLst>
           </p:cNvPr>
@@ -19130,7 +19130,7 @@
           <p:cNvPr id="6" name="Radio fetches only&#10;during an active call">
             <a:extLst xmlns:a="http://schemas.openxmlformats.org/drawingml/2006/main">
               <a:ext uri="{FF2B5EF4-FFF2-40B4-BE49-F238E27FC236}">
-                <a16:creationId xmlns:a16="http://schemas.microsoft.com/office/drawing/2014/main" id="{64207CBA-38D8-4439-90A6-8F33AB7AC76D}"/>
+                <a16:creationId xmlns:a16="http://schemas.microsoft.com/office/drawing/2014/main" id="{F638EE0F-AAA4-4DA7-A20C-62941903FCB0}"/>
               </a:ext>
             </a:extLst>
           </p:cNvPr>
@@ -19311,7 +19311,7 @@
           <p:cNvPr id="7" name="701">
             <a:extLst xmlns:a="http://schemas.openxmlformats.org/drawingml/2006/main">
               <a:ext uri="{FF2B5EF4-FFF2-40B4-BE49-F238E27FC236}">
-                <a16:creationId xmlns:a16="http://schemas.microsoft.com/office/drawing/2014/main" id="{1EE1A28A-4514-4B32-9879-BD27B9AAB192}"/>
+                <a16:creationId xmlns:a16="http://schemas.microsoft.com/office/drawing/2014/main" id="{F3F07658-52B5-4475-BAF7-B18C6584199B}"/>
               </a:ext>
             </a:extLst>
           </p:cNvPr>
@@ -19469,7 +19469,7 @@
           <p:cNvPr id="8" name="Matryoshka Radio">
             <a:extLst xmlns:a="http://schemas.openxmlformats.org/drawingml/2006/main">
               <a:ext uri="{FF2B5EF4-FFF2-40B4-BE49-F238E27FC236}">
-                <a16:creationId xmlns:a16="http://schemas.microsoft.com/office/drawing/2014/main" id="{E9AB9DEF-E16B-4FDE-98C9-CF0D70123491}"/>
+                <a16:creationId xmlns:a16="http://schemas.microsoft.com/office/drawing/2014/main" id="{3BD1E7F5-3342-4FDF-8231-ECAC9FE947BD}"/>
               </a:ext>
             </a:extLst>
           </p:cNvPr>
@@ -19627,7 +19627,7 @@
           <p:cNvPr id="9" name="702">
             <a:extLst xmlns:a="http://schemas.openxmlformats.org/drawingml/2006/main">
               <a:ext uri="{FF2B5EF4-FFF2-40B4-BE49-F238E27FC236}">
-                <a16:creationId xmlns:a16="http://schemas.microsoft.com/office/drawing/2014/main" id="{35C8FA89-5C16-493E-B34F-7C44A9088B88}"/>
+                <a16:creationId xmlns:a16="http://schemas.microsoft.com/office/drawing/2014/main" id="{B605D583-7831-4A66-A976-E9CE7AEB6FAA}"/>
               </a:ext>
             </a:extLst>
           </p:cNvPr>
@@ -19785,7 +19785,7 @@
           <p:cNvPr id="10" name="Echo online">
             <a:extLst xmlns:a="http://schemas.openxmlformats.org/drawingml/2006/main">
               <a:ext uri="{FF2B5EF4-FFF2-40B4-BE49-F238E27FC236}">
-                <a16:creationId xmlns:a16="http://schemas.microsoft.com/office/drawing/2014/main" id="{1167695B-40D5-4049-B7FF-D86D8A11D113}"/>
+                <a16:creationId xmlns:a16="http://schemas.microsoft.com/office/drawing/2014/main" id="{4D71E6D1-49C2-4ABE-B958-A6472BA39C82}"/>
               </a:ext>
             </a:extLst>
           </p:cNvPr>
@@ -19943,7 +19943,7 @@
           <p:cNvPr id="11" name="703">
             <a:extLst xmlns:a="http://schemas.openxmlformats.org/drawingml/2006/main">
               <a:ext uri="{FF2B5EF4-FFF2-40B4-BE49-F238E27FC236}">
-                <a16:creationId xmlns:a16="http://schemas.microsoft.com/office/drawing/2014/main" id="{0711F97F-2408-4D7E-B89B-4EEBCE112492}"/>
+                <a16:creationId xmlns:a16="http://schemas.microsoft.com/office/drawing/2014/main" id="{D4E68F28-4B0E-45A6-A0C4-6050888E2655}"/>
               </a:ext>
             </a:extLst>
           </p:cNvPr>
@@ -20101,7 +20101,7 @@
           <p:cNvPr id="12" name="RADIO BOB! Rock">
             <a:extLst xmlns:a="http://schemas.openxmlformats.org/drawingml/2006/main">
               <a:ext uri="{FF2B5EF4-FFF2-40B4-BE49-F238E27FC236}">
-                <a16:creationId xmlns:a16="http://schemas.microsoft.com/office/drawing/2014/main" id="{F194194D-6BAF-4055-B290-E29A6B7B3C97}"/>
+                <a16:creationId xmlns:a16="http://schemas.microsoft.com/office/drawing/2014/main" id="{D8C7ACD4-4132-435B-8341-995FFB13FF8F}"/>
               </a:ext>
             </a:extLst>
           </p:cNvPr>
@@ -20259,7 +20259,7 @@
           <p:cNvPr id="13" name="704">
             <a:extLst xmlns:a="http://schemas.openxmlformats.org/drawingml/2006/main">
               <a:ext uri="{FF2B5EF4-FFF2-40B4-BE49-F238E27FC236}">
-                <a16:creationId xmlns:a16="http://schemas.microsoft.com/office/drawing/2014/main" id="{2D4293F1-3AF2-44E5-8AD7-0CF660BB0379}"/>
+                <a16:creationId xmlns:a16="http://schemas.microsoft.com/office/drawing/2014/main" id="{55B181AB-55A7-4807-93A5-C892ABDAF286}"/>
               </a:ext>
             </a:extLst>
           </p:cNvPr>
@@ -20417,7 +20417,7 @@
           <p:cNvPr id="14" name="RADIO BOB! Metal">
             <a:extLst xmlns:a="http://schemas.openxmlformats.org/drawingml/2006/main">
               <a:ext uri="{FF2B5EF4-FFF2-40B4-BE49-F238E27FC236}">
-                <a16:creationId xmlns:a16="http://schemas.microsoft.com/office/drawing/2014/main" id="{510F2BCA-995B-4D6E-A1C8-14CB20A0A177}"/>
+                <a16:creationId xmlns:a16="http://schemas.microsoft.com/office/drawing/2014/main" id="{AF6FBB85-D39C-4414-A862-4E46B253CDC1}"/>
               </a:ext>
             </a:extLst>
           </p:cNvPr>
@@ -20575,7 +20575,7 @@
           <p:cNvPr id="15" name="705">
             <a:extLst xmlns:a="http://schemas.openxmlformats.org/drawingml/2006/main">
               <a:ext uri="{FF2B5EF4-FFF2-40B4-BE49-F238E27FC236}">
-                <a16:creationId xmlns:a16="http://schemas.microsoft.com/office/drawing/2014/main" id="{817005B0-3A9F-42E6-B503-D2F2B253DDBF}"/>
+                <a16:creationId xmlns:a16="http://schemas.microsoft.com/office/drawing/2014/main" id="{1024FEBF-3033-4230-9865-C7AB5EA7C7C2}"/>
               </a:ext>
             </a:extLst>
           </p:cNvPr>
@@ -20733,7 +20733,7 @@
           <p:cNvPr id="16" name="RADIO BOB! Gothic">
             <a:extLst xmlns:a="http://schemas.openxmlformats.org/drawingml/2006/main">
               <a:ext uri="{FF2B5EF4-FFF2-40B4-BE49-F238E27FC236}">
-                <a16:creationId xmlns:a16="http://schemas.microsoft.com/office/drawing/2014/main" id="{34D6686F-C23D-4F8D-817D-622872EDD7B7}"/>
+                <a16:creationId xmlns:a16="http://schemas.microsoft.com/office/drawing/2014/main" id="{218B0684-2BB5-4187-9C00-D304099AA120}"/>
               </a:ext>
             </a:extLst>
           </p:cNvPr>
@@ -20891,7 +20891,7 @@
           <p:cNvPr id="17" name="706">
             <a:extLst xmlns:a="http://schemas.openxmlformats.org/drawingml/2006/main">
               <a:ext uri="{FF2B5EF4-FFF2-40B4-BE49-F238E27FC236}">
-                <a16:creationId xmlns:a16="http://schemas.microsoft.com/office/drawing/2014/main" id="{75890F9C-B604-4D85-A554-152CFA492B12}"/>
+                <a16:creationId xmlns:a16="http://schemas.microsoft.com/office/drawing/2014/main" id="{5F43D29D-1D79-45C4-A54C-A6390E6055D6}"/>
               </a:ext>
             </a:extLst>
           </p:cNvPr>
@@ -21049,7 +21049,7 @@
           <p:cNvPr id="18" name="SomaFM PopTron">
             <a:extLst xmlns:a="http://schemas.openxmlformats.org/drawingml/2006/main">
               <a:ext uri="{FF2B5EF4-FFF2-40B4-BE49-F238E27FC236}">
-                <a16:creationId xmlns:a16="http://schemas.microsoft.com/office/drawing/2014/main" id="{0068DF96-5700-480F-9BA3-BF2EF6A6DE2E}"/>
+                <a16:creationId xmlns:a16="http://schemas.microsoft.com/office/drawing/2014/main" id="{CBE1AE80-3101-4B8C-887B-5A090D79BADC}"/>
               </a:ext>
             </a:extLst>
           </p:cNvPr>
@@ -21207,7 +21207,7 @@
           <p:cNvPr id="19" name="707">
             <a:extLst xmlns:a="http://schemas.openxmlformats.org/drawingml/2006/main">
               <a:ext uri="{FF2B5EF4-FFF2-40B4-BE49-F238E27FC236}">
-                <a16:creationId xmlns:a16="http://schemas.microsoft.com/office/drawing/2014/main" id="{893FAF3E-14C5-482C-A8E5-A645F87A2CF2}"/>
+                <a16:creationId xmlns:a16="http://schemas.microsoft.com/office/drawing/2014/main" id="{005D21B9-F37A-4F40-B4CC-BF5D7C5660B4}"/>
               </a:ext>
             </a:extLst>
           </p:cNvPr>
@@ -21365,7 +21365,7 @@
           <p:cNvPr id="20" name="Radyo Viva / Turkish">
             <a:extLst xmlns:a="http://schemas.openxmlformats.org/drawingml/2006/main">
               <a:ext uri="{FF2B5EF4-FFF2-40B4-BE49-F238E27FC236}">
-                <a16:creationId xmlns:a16="http://schemas.microsoft.com/office/drawing/2014/main" id="{BDA89A4B-9235-403D-98A1-54F1AAB721BA}"/>
+                <a16:creationId xmlns:a16="http://schemas.microsoft.com/office/drawing/2014/main" id="{C7507CE6-530A-4696-AF3B-B43B5CDC50EF}"/>
               </a:ext>
             </a:extLst>
           </p:cNvPr>
@@ -21523,7 +21523,7 @@
           <p:cNvPr id="21" name="Official streams decoded successfully. Handset radio and alarm te">
             <a:extLst xmlns:a="http://schemas.openxmlformats.org/drawingml/2006/main">
               <a:ext uri="{FF2B5EF4-FFF2-40B4-BE49-F238E27FC236}">
-                <a16:creationId xmlns:a16="http://schemas.microsoft.com/office/drawing/2014/main" id="{569BA18C-BBDA-420C-8DAD-CC8EE7385B8B}"/>
+                <a16:creationId xmlns:a16="http://schemas.microsoft.com/office/drawing/2014/main" id="{C56628E3-1936-4FFA-924A-553DD71EC30C}"/>
               </a:ext>
             </a:extLst>
           </p:cNvPr>
@@ -21679,7 +21679,7 @@
     </p:spTree>
     <p:extLst>
       <p:ext uri="{BB962C8B-B14F-4D97-AF65-F5344CB8AC3E}">
-        <p14:creationId xmlns:p14="http://schemas.microsoft.com/office/powerpoint/2010/main" val="1179318966"/>
+        <p14:creationId xmlns:p14="http://schemas.microsoft.com/office/powerpoint/2010/main" val="2064023368"/>
       </p:ext>
     </p:extLst>
   </p:cSld>
@@ -21710,7 +21710,7 @@
           <p:cNvPr id="14" name="Free SIP account status">
             <a:extLst xmlns:a="http://schemas.openxmlformats.org/drawingml/2006/main">
               <a:ext uri="{FF2B5EF4-FFF2-40B4-BE49-F238E27FC236}">
-                <a16:creationId xmlns:a16="http://schemas.microsoft.com/office/drawing/2014/main" id="{46B94495-CE8E-41D1-AE33-667FDB755DB6}"/>
+                <a16:creationId xmlns:a16="http://schemas.microsoft.com/office/drawing/2014/main" id="{AB75C41D-7D05-41B3-A731-0A5AF0499436}"/>
               </a:ext>
             </a:extLst>
           </p:cNvPr>
@@ -21868,7 +21868,7 @@
           <p:cNvPr id="2" name="18">
             <a:extLst xmlns:a="http://schemas.openxmlformats.org/drawingml/2006/main">
               <a:ext uri="{FF2B5EF4-FFF2-40B4-BE49-F238E27FC236}">
-                <a16:creationId xmlns:a16="http://schemas.microsoft.com/office/drawing/2014/main" id="{94908625-0EBA-475A-964B-98601E3AD81C}"/>
+                <a16:creationId xmlns:a16="http://schemas.microsoft.com/office/drawing/2014/main" id="{D10A52C8-A56E-4899-ADD8-F97DB0942B1C}"/>
               </a:ext>
             </a:extLst>
           </p:cNvPr>
@@ -22026,7 +22026,7 @@
           <p:cNvPr id="3" name="SIP2SIP">
             <a:extLst xmlns:a="http://schemas.openxmlformats.org/drawingml/2006/main">
               <a:ext uri="{FF2B5EF4-FFF2-40B4-BE49-F238E27FC236}">
-                <a16:creationId xmlns:a16="http://schemas.microsoft.com/office/drawing/2014/main" id="{7A2F4B31-94FE-4460-ACEA-2EFA8017EB82}"/>
+                <a16:creationId xmlns:a16="http://schemas.microsoft.com/office/drawing/2014/main" id="{8C99E4F2-EC92-44CF-9194-40DFCAA4D237}"/>
               </a:ext>
             </a:extLst>
           </p:cNvPr>
@@ -22181,10 +22181,10 @@
       </p:sp>
       <p:sp>
         <p:nvSpPr>
-          <p:cNvPr id="4" name="Account active, 802 echo checks underway">
+          <p:cNvPr id="4" name="Registered; 802 audio test deferred">
             <a:extLst xmlns:a="http://schemas.openxmlformats.org/drawingml/2006/main">
               <a:ext uri="{FF2B5EF4-FFF2-40B4-BE49-F238E27FC236}">
-                <a16:creationId xmlns:a16="http://schemas.microsoft.com/office/drawing/2014/main" id="{83BB0960-C8B3-422B-A547-2573A5C2544F}"/>
+                <a16:creationId xmlns:a16="http://schemas.microsoft.com/office/drawing/2014/main" id="{5CD1A6CF-0854-441B-A040-2CA370522F86}"/>
               </a:ext>
             </a:extLst>
           </p:cNvPr>
@@ -22332,7 +22332,7 @@
                 <a:ea typeface="Arial"/>
                 <a:cs typeface="Arial"/>
               </a:rPr>
-              <a:t>Account active, 802 echo checks underway</a:t>
+              <a:t>Registered; 802 audio test deferred</a:t>
             </a:r>
           </a:p>
         </p:txBody>
@@ -22342,7 +22342,7 @@
           <p:cNvPr id="5" name="Callcentric">
             <a:extLst xmlns:a="http://schemas.openxmlformats.org/drawingml/2006/main">
               <a:ext uri="{FF2B5EF4-FFF2-40B4-BE49-F238E27FC236}">
-                <a16:creationId xmlns:a16="http://schemas.microsoft.com/office/drawing/2014/main" id="{2D6AEED1-26BA-47CE-94F7-773EE9C0D261}"/>
+                <a16:creationId xmlns:a16="http://schemas.microsoft.com/office/drawing/2014/main" id="{93C4F66D-DA57-419F-928B-136B2F1FB8C7}"/>
               </a:ext>
             </a:extLst>
           </p:cNvPr>
@@ -22497,10 +22497,10 @@
       </p:sp>
       <p:sp>
         <p:nvSpPr>
-          <p:cNvPr id="6" name="Account active, outbound review required">
+          <p:cNvPr id="6" name="Registered; outbound review required">
             <a:extLst xmlns:a="http://schemas.openxmlformats.org/drawingml/2006/main">
               <a:ext uri="{FF2B5EF4-FFF2-40B4-BE49-F238E27FC236}">
-                <a16:creationId xmlns:a16="http://schemas.microsoft.com/office/drawing/2014/main" id="{564F9B2C-0629-485A-9708-0BA7C30F333B}"/>
+                <a16:creationId xmlns:a16="http://schemas.microsoft.com/office/drawing/2014/main" id="{F5876147-BD2D-4E60-93D2-4E0504728D97}"/>
               </a:ext>
             </a:extLst>
           </p:cNvPr>
@@ -22648,7 +22648,7 @@
                 <a:ea typeface="Arial"/>
                 <a:cs typeface="Arial"/>
               </a:rPr>
-              <a:t>Account active, outbound review required</a:t>
+              <a:t>Registered; outbound review required</a:t>
             </a:r>
           </a:p>
         </p:txBody>
@@ -22658,7 +22658,7 @@
           <p:cNvPr id="7" name="Linphone">
             <a:extLst xmlns:a="http://schemas.openxmlformats.org/drawingml/2006/main">
               <a:ext uri="{FF2B5EF4-FFF2-40B4-BE49-F238E27FC236}">
-                <a16:creationId xmlns:a16="http://schemas.microsoft.com/office/drawing/2014/main" id="{D73A0080-316F-4FB4-8A86-4C981514CC27}"/>
+                <a16:creationId xmlns:a16="http://schemas.microsoft.com/office/drawing/2014/main" id="{1ADDCED0-A021-404B-99AC-554839AFF184}"/>
               </a:ext>
             </a:extLst>
           </p:cNvPr>
@@ -22813,10 +22813,10 @@
       </p:sp>
       <p:sp>
         <p:nvSpPr>
-          <p:cNvPr id="8" name="Account active, verified peer still needed">
+          <p:cNvPr id="8" name="Registered; verified peer still needed">
             <a:extLst xmlns:a="http://schemas.openxmlformats.org/drawingml/2006/main">
               <a:ext uri="{FF2B5EF4-FFF2-40B4-BE49-F238E27FC236}">
-                <a16:creationId xmlns:a16="http://schemas.microsoft.com/office/drawing/2014/main" id="{2D1E03A5-C91F-472D-AAD6-8141922D1AD2}"/>
+                <a16:creationId xmlns:a16="http://schemas.microsoft.com/office/drawing/2014/main" id="{CA15DC05-1B75-44F5-8C88-22B5561A8AE2}"/>
               </a:ext>
             </a:extLst>
           </p:cNvPr>
@@ -22964,7 +22964,7 @@
                 <a:ea typeface="Arial"/>
                 <a:cs typeface="Arial"/>
               </a:rPr>
-              <a:t>Account active, verified peer still needed</a:t>
+              <a:t>Registered; verified peer still needed</a:t>
             </a:r>
           </a:p>
         </p:txBody>
@@ -22974,7 +22974,7 @@
           <p:cNvPr id="9" name="FWD">
             <a:extLst xmlns:a="http://schemas.openxmlformats.org/drawingml/2006/main">
               <a:ext uri="{FF2B5EF4-FFF2-40B4-BE49-F238E27FC236}">
-                <a16:creationId xmlns:a16="http://schemas.microsoft.com/office/drawing/2014/main" id="{E749B63E-B634-445E-B12E-D13B37C1A8FB}"/>
+                <a16:creationId xmlns:a16="http://schemas.microsoft.com/office/drawing/2014/main" id="{CF1FC03C-BE24-47DA-A2A3-6B9D756612EC}"/>
               </a:ext>
             </a:extLst>
           </p:cNvPr>
@@ -23132,7 +23132,7 @@
           <p:cNvPr id="10" name="Stopped at mandatory Verification Fee">
             <a:extLst xmlns:a="http://schemas.openxmlformats.org/drawingml/2006/main">
               <a:ext uri="{FF2B5EF4-FFF2-40B4-BE49-F238E27FC236}">
-                <a16:creationId xmlns:a16="http://schemas.microsoft.com/office/drawing/2014/main" id="{1A21A9FF-51BD-48D7-9C40-9CA3AB4B0C4A}"/>
+                <a16:creationId xmlns:a16="http://schemas.microsoft.com/office/drawing/2014/main" id="{ACB6DF7C-9964-4D9A-9E6F-1114DCD89800}"/>
               </a:ext>
             </a:extLst>
           </p:cNvPr>
@@ -23290,7 +23290,7 @@
           <p:cNvPr id="11" name="Google Voice">
             <a:extLst xmlns:a="http://schemas.openxmlformats.org/drawingml/2006/main">
               <a:ext uri="{FF2B5EF4-FFF2-40B4-BE49-F238E27FC236}">
-                <a16:creationId xmlns:a16="http://schemas.microsoft.com/office/drawing/2014/main" id="{D57A962F-58AF-4AE1-918E-A484390448F4}"/>
+                <a16:creationId xmlns:a16="http://schemas.microsoft.com/office/drawing/2014/main" id="{953E0917-DBCA-4C4E-A015-ED141DD7CFFE}"/>
               </a:ext>
             </a:extLst>
           </p:cNvPr>
@@ -23448,7 +23448,7 @@
           <p:cNvPr id="12" name="No official free Asterisk SIP trunk">
             <a:extLst xmlns:a="http://schemas.openxmlformats.org/drawingml/2006/main">
               <a:ext uri="{FF2B5EF4-FFF2-40B4-BE49-F238E27FC236}">
-                <a16:creationId xmlns:a16="http://schemas.microsoft.com/office/drawing/2014/main" id="{50B9546D-D2F4-4BB3-BE6B-668F54A2F884}"/>
+                <a16:creationId xmlns:a16="http://schemas.microsoft.com/office/drawing/2014/main" id="{3FCE805B-C7DD-4006-AE9F-D47FE8D363F6}"/>
               </a:ext>
             </a:extLst>
           </p:cNvPr>
@@ -23603,10 +23603,10 @@
       </p:sp>
       <p:sp>
         <p:nvSpPr>
-          <p:cNvPr id="13" name="Account activation, SIP registration and a working audio call nee">
+          <p:cNvPr id="13" name="REGISTER succeeded for three providers. External audio remains un">
             <a:extLst xmlns:a="http://schemas.openxmlformats.org/drawingml/2006/main">
               <a:ext uri="{FF2B5EF4-FFF2-40B4-BE49-F238E27FC236}">
-                <a16:creationId xmlns:a16="http://schemas.microsoft.com/office/drawing/2014/main" id="{874DB959-EB6E-4496-9D53-C52763BEDCD7}"/>
+                <a16:creationId xmlns:a16="http://schemas.microsoft.com/office/drawing/2014/main" id="{1BF48E69-F87E-46F6-9467-57CBB39C0A43}"/>
               </a:ext>
             </a:extLst>
           </p:cNvPr>
@@ -23754,7 +23754,7 @@
                 <a:ea typeface="Arial"/>
                 <a:cs typeface="Arial"/>
               </a:rPr>
-              <a:t>Account activation, SIP registration and a working audio call need separate evidence.</a:t>
+              <a:t>REGISTER succeeded for three providers. External audio remains unverified.</a:t>
             </a:r>
           </a:p>
         </p:txBody>
@@ -23762,7 +23762,7 @@
     </p:spTree>
     <p:extLst>
       <p:ext uri="{BB962C8B-B14F-4D97-AF65-F5344CB8AC3E}">
-        <p14:creationId xmlns:p14="http://schemas.microsoft.com/office/powerpoint/2010/main" val="1050786795"/>
+        <p14:creationId xmlns:p14="http://schemas.microsoft.com/office/powerpoint/2010/main" val="842947939"/>
       </p:ext>
     </p:extLst>
   </p:cSld>
@@ -23793,7 +23793,7 @@
           <p:cNvPr id="9" name="Our lot: 10 Cisco 7945G phones">
             <a:extLst xmlns:a="http://schemas.openxmlformats.org/drawingml/2006/main">
               <a:ext uri="{FF2B5EF4-FFF2-40B4-BE49-F238E27FC236}">
-                <a16:creationId xmlns:a16="http://schemas.microsoft.com/office/drawing/2014/main" id="{103CBD91-B208-4392-B15D-BF4326E066D7}"/>
+                <a16:creationId xmlns:a16="http://schemas.microsoft.com/office/drawing/2014/main" id="{E7927487-16E0-4683-A1C6-B29856A52BD1}"/>
               </a:ext>
             </a:extLst>
           </p:cNvPr>
@@ -23951,7 +23951,7 @@
           <p:cNvPr id="2" name="02">
             <a:extLst xmlns:a="http://schemas.openxmlformats.org/drawingml/2006/main">
               <a:ext uri="{FF2B5EF4-FFF2-40B4-BE49-F238E27FC236}">
-                <a16:creationId xmlns:a16="http://schemas.microsoft.com/office/drawing/2014/main" id="{1D82F0D8-5886-4D71-B3FD-9D5EE9519B6F}"/>
+                <a16:creationId xmlns:a16="http://schemas.microsoft.com/office/drawing/2014/main" id="{FC0648A3-9C18-4C47-B95E-1B7D035E2FA4}"/>
               </a:ext>
             </a:extLst>
           </p:cNvPr>
@@ -24109,7 +24109,7 @@
           <p:cNvPr id="3" name="10">
             <a:extLst xmlns:a="http://schemas.openxmlformats.org/drawingml/2006/main">
               <a:ext uri="{FF2B5EF4-FFF2-40B4-BE49-F238E27FC236}">
-                <a16:creationId xmlns:a16="http://schemas.microsoft.com/office/drawing/2014/main" id="{C0B7C9C7-5718-4CCC-A71D-A7EAC25551E1}"/>
+                <a16:creationId xmlns:a16="http://schemas.microsoft.com/office/drawing/2014/main" id="{1F4EEE4D-2403-4504-A244-198547DBAFA7}"/>
               </a:ext>
             </a:extLst>
           </p:cNvPr>
@@ -24267,7 +24267,7 @@
           <p:cNvPr id="4" name="phones">
             <a:extLst xmlns:a="http://schemas.openxmlformats.org/drawingml/2006/main">
               <a:ext uri="{FF2B5EF4-FFF2-40B4-BE49-F238E27FC236}">
-                <a16:creationId xmlns:a16="http://schemas.microsoft.com/office/drawing/2014/main" id="{24BC7FDB-6987-488F-961A-31E85C14FDD8}"/>
+                <a16:creationId xmlns:a16="http://schemas.microsoft.com/office/drawing/2014/main" id="{2D6CD629-C482-4025-BC09-1BBB5954D603}"/>
               </a:ext>
             </a:extLst>
           </p:cNvPr>
@@ -24425,7 +24425,7 @@
           <p:cNvPr id="5" name="7945_7965 SIP firmware family">
             <a:extLst xmlns:a="http://schemas.openxmlformats.org/drawingml/2006/main">
               <a:ext uri="{FF2B5EF4-FFF2-40B4-BE49-F238E27FC236}">
-                <a16:creationId xmlns:a16="http://schemas.microsoft.com/office/drawing/2014/main" id="{7FB888B1-C44D-4833-B796-5A30C171BFA0}"/>
+                <a16:creationId xmlns:a16="http://schemas.microsoft.com/office/drawing/2014/main" id="{DFC131D0-7944-459A-8051-9D20444D6451}"/>
               </a:ext>
             </a:extLst>
           </p:cNvPr>
@@ -24583,7 +24583,7 @@
           <p:cNvPr id="6" name="A phone running SCCP needs SIP firmware.&#10;This model does not need">
             <a:extLst xmlns:a="http://schemas.openxmlformats.org/drawingml/2006/main">
               <a:ext uri="{FF2B5EF4-FFF2-40B4-BE49-F238E27FC236}">
-                <a16:creationId xmlns:a16="http://schemas.microsoft.com/office/drawing/2014/main" id="{A9D9C08A-2AFD-4BD6-8B75-0AF83AB2F5E7}"/>
+                <a16:creationId xmlns:a16="http://schemas.microsoft.com/office/drawing/2014/main" id="{0EF79E79-C4F3-4F8E-BAFD-073249D6BF7D}"/>
               </a:ext>
             </a:extLst>
           </p:cNvPr>
@@ -24764,7 +24764,7 @@
           <p:cNvPr id="7" name="Before starting">
             <a:extLst xmlns:a="http://schemas.openxmlformats.org/drawingml/2006/main">
               <a:ext uri="{FF2B5EF4-FFF2-40B4-BE49-F238E27FC236}">
-                <a16:creationId xmlns:a16="http://schemas.microsoft.com/office/drawing/2014/main" id="{4B24F2DE-2C98-452E-A579-71B1391D307D}"/>
+                <a16:creationId xmlns:a16="http://schemas.microsoft.com/office/drawing/2014/main" id="{6C02651A-89DB-4474-B1A2-56CD3E95B49A}"/>
               </a:ext>
             </a:extLst>
           </p:cNvPr>
@@ -24922,7 +24922,7 @@
           <p:cNvPr id="8" name="Record PID, VID/HW, MAC, App Load,&#10;Boot Load, IP and TFTP for eve">
             <a:extLst xmlns:a="http://schemas.openxmlformats.org/drawingml/2006/main">
               <a:ext uri="{FF2B5EF4-FFF2-40B4-BE49-F238E27FC236}">
-                <a16:creationId xmlns:a16="http://schemas.microsoft.com/office/drawing/2014/main" id="{24B474E1-8F56-4F4E-8A4C-187FD552C190}"/>
+                <a16:creationId xmlns:a16="http://schemas.microsoft.com/office/drawing/2014/main" id="{0FBAC547-9AA3-4D2D-88DA-09A576041A62}"/>
               </a:ext>
             </a:extLst>
           </p:cNvPr>
@@ -25101,7 +25101,7 @@
     </p:spTree>
     <p:extLst>
       <p:ext uri="{BB962C8B-B14F-4D97-AF65-F5344CB8AC3E}">
-        <p14:creationId xmlns:p14="http://schemas.microsoft.com/office/powerpoint/2010/main" val="521451717"/>
+        <p14:creationId xmlns:p14="http://schemas.microsoft.com/office/powerpoint/2010/main" val="978914116"/>
       </p:ext>
     </p:extLst>
   </p:cSld>
@@ -25132,7 +25132,7 @@
           <p:cNvPr id="17" name="">
             <a:extLst xmlns:a="http://schemas.openxmlformats.org/drawingml/2006/main">
               <a:ext uri="{FF2B5EF4-FFF2-40B4-BE49-F238E27FC236}">
-                <a16:creationId xmlns:a16="http://schemas.microsoft.com/office/drawing/2014/main" id="{317B4DA3-AF61-4684-8EBD-9CFD09EB1338}"/>
+                <a16:creationId xmlns:a16="http://schemas.microsoft.com/office/drawing/2014/main" id="{CE3982E9-2FE8-49B8-AED7-93424012679B}"/>
               </a:ext>
             </a:extLst>
           </p:cNvPr>
@@ -25164,7 +25164,7 @@
           <p:cNvPr id="15" name="">
             <a:extLst xmlns:a="http://schemas.openxmlformats.org/drawingml/2006/main">
               <a:ext uri="{FF2B5EF4-FFF2-40B4-BE49-F238E27FC236}">
-                <a16:creationId xmlns:a16="http://schemas.microsoft.com/office/drawing/2014/main" id="{FE898B9E-786A-49D2-A7D7-9702E46B16A4}"/>
+                <a16:creationId xmlns:a16="http://schemas.microsoft.com/office/drawing/2014/main" id="{9F4A4DEE-6822-46A7-B36F-760FF17F25A3}"/>
               </a:ext>
             </a:extLst>
           </p:cNvPr>
@@ -25195,7 +25195,7 @@
           <p:cNvPr id="13" name="">
             <a:extLst xmlns:a="http://schemas.openxmlformats.org/drawingml/2006/main">
               <a:ext uri="{FF2B5EF4-FFF2-40B4-BE49-F238E27FC236}">
-                <a16:creationId xmlns:a16="http://schemas.microsoft.com/office/drawing/2014/main" id="{8077D1F2-D9CC-4133-9762-20AA7B456351}"/>
+                <a16:creationId xmlns:a16="http://schemas.microsoft.com/office/drawing/2014/main" id="{D6ED84FD-EFFC-4344-98B3-298F0BF15A58}"/>
               </a:ext>
             </a:extLst>
           </p:cNvPr>
@@ -25226,7 +25226,7 @@
           <p:cNvPr id="11" name="">
             <a:extLst xmlns:a="http://schemas.openxmlformats.org/drawingml/2006/main">
               <a:ext uri="{FF2B5EF4-FFF2-40B4-BE49-F238E27FC236}">
-                <a16:creationId xmlns:a16="http://schemas.microsoft.com/office/drawing/2014/main" id="{5DB0174C-54DE-41AA-A769-CFF75C3C471C}"/>
+                <a16:creationId xmlns:a16="http://schemas.microsoft.com/office/drawing/2014/main" id="{32FCD77C-D8AC-4879-A753-7F26DC8DEA11}"/>
               </a:ext>
             </a:extLst>
           </p:cNvPr>
@@ -25258,7 +25258,7 @@
           <p:cNvPr id="9" name="">
             <a:extLst xmlns:a="http://schemas.openxmlformats.org/drawingml/2006/main">
               <a:ext uri="{FF2B5EF4-FFF2-40B4-BE49-F238E27FC236}">
-                <a16:creationId xmlns:a16="http://schemas.microsoft.com/office/drawing/2014/main" id="{95412C07-C4E2-497B-B5E0-00050A6A6C80}"/>
+                <a16:creationId xmlns:a16="http://schemas.microsoft.com/office/drawing/2014/main" id="{B86A86E2-8A9A-43F2-A361-4A03EAA38D26}"/>
               </a:ext>
             </a:extLst>
           </p:cNvPr>
@@ -25290,7 +25290,7 @@
           <p:cNvPr id="20" name="Cisco, Asterisk and Home Assistant">
             <a:extLst xmlns:a="http://schemas.openxmlformats.org/drawingml/2006/main">
               <a:ext uri="{FF2B5EF4-FFF2-40B4-BE49-F238E27FC236}">
-                <a16:creationId xmlns:a16="http://schemas.microsoft.com/office/drawing/2014/main" id="{B50144F7-FAB5-41C3-B32F-5FF0BD92A70F}"/>
+                <a16:creationId xmlns:a16="http://schemas.microsoft.com/office/drawing/2014/main" id="{BE3E1350-33A2-4F83-AB6F-B466435BD57F}"/>
               </a:ext>
             </a:extLst>
           </p:cNvPr>
@@ -25448,7 +25448,7 @@
           <p:cNvPr id="2" name="03">
             <a:extLst xmlns:a="http://schemas.openxmlformats.org/drawingml/2006/main">
               <a:ext uri="{FF2B5EF4-FFF2-40B4-BE49-F238E27FC236}">
-                <a16:creationId xmlns:a16="http://schemas.microsoft.com/office/drawing/2014/main" id="{9DC822DF-3C8B-490F-82F4-0A9A753DCF69}"/>
+                <a16:creationId xmlns:a16="http://schemas.microsoft.com/office/drawing/2014/main" id="{7350C261-1B32-4D4B-8F9D-6074B4214F6D}"/>
               </a:ext>
             </a:extLst>
           </p:cNvPr>
@@ -25606,7 +25606,7 @@
           <p:cNvPr id="3" name="phones">
             <a:extLst xmlns:a="http://schemas.openxmlformats.org/drawingml/2006/main">
               <a:ext uri="{FF2B5EF4-FFF2-40B4-BE49-F238E27FC236}">
-                <a16:creationId xmlns:a16="http://schemas.microsoft.com/office/drawing/2014/main" id="{E6E72A84-F46B-4E2C-9CFC-1D9CD6CCF1CB}"/>
+                <a16:creationId xmlns:a16="http://schemas.microsoft.com/office/drawing/2014/main" id="{4F85B5B7-6D2F-4D1C-B184-D3CA00E03F17}"/>
               </a:ext>
             </a:extLst>
           </p:cNvPr>
@@ -25793,7 +25793,7 @@
           <p:cNvPr id="4" name="switch">
             <a:extLst xmlns:a="http://schemas.openxmlformats.org/drawingml/2006/main">
               <a:ext uri="{FF2B5EF4-FFF2-40B4-BE49-F238E27FC236}">
-                <a16:creationId xmlns:a16="http://schemas.microsoft.com/office/drawing/2014/main" id="{D46879C5-91C1-4B0D-A056-6486CC1DC0B8}"/>
+                <a16:creationId xmlns:a16="http://schemas.microsoft.com/office/drawing/2014/main" id="{947B203D-4422-4F4D-B309-AE8D5AAE0793}"/>
               </a:ext>
             </a:extLst>
           </p:cNvPr>
@@ -25980,7 +25980,7 @@
           <p:cNvPr id="5" name="ast">
             <a:extLst xmlns:a="http://schemas.openxmlformats.org/drawingml/2006/main">
               <a:ext uri="{FF2B5EF4-FFF2-40B4-BE49-F238E27FC236}">
-                <a16:creationId xmlns:a16="http://schemas.microsoft.com/office/drawing/2014/main" id="{D24F5286-761B-4C19-BFB8-1B6ADCC65A3E}"/>
+                <a16:creationId xmlns:a16="http://schemas.microsoft.com/office/drawing/2014/main" id="{30CB5646-00D6-46E3-9598-613B5BF9A8C7}"/>
               </a:ext>
             </a:extLst>
           </p:cNvPr>
@@ -26167,7 +26167,7 @@
           <p:cNvPr id="6" name="router">
             <a:extLst xmlns:a="http://schemas.openxmlformats.org/drawingml/2006/main">
               <a:ext uri="{FF2B5EF4-FFF2-40B4-BE49-F238E27FC236}">
-                <a16:creationId xmlns:a16="http://schemas.microsoft.com/office/drawing/2014/main" id="{6DBF3684-A070-4044-B2CF-E884E1F56BFD}"/>
+                <a16:creationId xmlns:a16="http://schemas.microsoft.com/office/drawing/2014/main" id="{E52BA8DD-AC3E-447E-83AF-F497E2C1F784}"/>
               </a:ext>
             </a:extLst>
           </p:cNvPr>
@@ -26354,7 +26354,7 @@
           <p:cNvPr id="7" name="tftp">
             <a:extLst xmlns:a="http://schemas.openxmlformats.org/drawingml/2006/main">
               <a:ext uri="{FF2B5EF4-FFF2-40B4-BE49-F238E27FC236}">
-                <a16:creationId xmlns:a16="http://schemas.microsoft.com/office/drawing/2014/main" id="{EE7DDF17-D980-422B-AC5C-D71BEFE5103D}"/>
+                <a16:creationId xmlns:a16="http://schemas.microsoft.com/office/drawing/2014/main" id="{355C3591-FB26-413B-95F2-7185895F1680}"/>
               </a:ext>
             </a:extLst>
           </p:cNvPr>
@@ -26541,7 +26541,7 @@
           <p:cNvPr id="8" name="ha">
             <a:extLst xmlns:a="http://schemas.openxmlformats.org/drawingml/2006/main">
               <a:ext uri="{FF2B5EF4-FFF2-40B4-BE49-F238E27FC236}">
-                <a16:creationId xmlns:a16="http://schemas.microsoft.com/office/drawing/2014/main" id="{92852FC6-390E-4448-AA98-884BA6AEA1B5}"/>
+                <a16:creationId xmlns:a16="http://schemas.microsoft.com/office/drawing/2014/main" id="{3B947029-CA56-4245-874B-3DC06685C1C4}"/>
               </a:ext>
             </a:extLst>
           </p:cNvPr>
@@ -26728,7 +26728,7 @@
           <p:cNvPr id="10" name="Ethernet">
             <a:extLst xmlns:a="http://schemas.openxmlformats.org/drawingml/2006/main">
               <a:ext uri="{FF2B5EF4-FFF2-40B4-BE49-F238E27FC236}">
-                <a16:creationId xmlns:a16="http://schemas.microsoft.com/office/drawing/2014/main" id="{FADDABA4-2EBC-43F9-9669-CF955D1DD40E}"/>
+                <a16:creationId xmlns:a16="http://schemas.microsoft.com/office/drawing/2014/main" id="{7D9E3536-2CD2-4B27-B149-439E959C223A}"/>
               </a:ext>
             </a:extLst>
           </p:cNvPr>
@@ -26886,7 +26886,7 @@
           <p:cNvPr id="12" name="SIP / RTP">
             <a:extLst xmlns:a="http://schemas.openxmlformats.org/drawingml/2006/main">
               <a:ext uri="{FF2B5EF4-FFF2-40B4-BE49-F238E27FC236}">
-                <a16:creationId xmlns:a16="http://schemas.microsoft.com/office/drawing/2014/main" id="{01B2C562-7294-4BD4-BE2A-7DAF557184D4}"/>
+                <a16:creationId xmlns:a16="http://schemas.microsoft.com/office/drawing/2014/main" id="{E56B4EAF-0DFE-4BF2-8D5D-63F93088545F}"/>
               </a:ext>
             </a:extLst>
           </p:cNvPr>
@@ -27044,7 +27044,7 @@
           <p:cNvPr id="14" name="DHCP">
             <a:extLst xmlns:a="http://schemas.openxmlformats.org/drawingml/2006/main">
               <a:ext uri="{FF2B5EF4-FFF2-40B4-BE49-F238E27FC236}">
-                <a16:creationId xmlns:a16="http://schemas.microsoft.com/office/drawing/2014/main" id="{5D6336E4-27FA-4F9F-856B-6AC1CC49DCB4}"/>
+                <a16:creationId xmlns:a16="http://schemas.microsoft.com/office/drawing/2014/main" id="{5581DA60-A3F1-4952-B2AB-440A962E2404}"/>
               </a:ext>
             </a:extLst>
           </p:cNvPr>
@@ -27202,7 +27202,7 @@
           <p:cNvPr id="16" name="download">
             <a:extLst xmlns:a="http://schemas.openxmlformats.org/drawingml/2006/main">
               <a:ext uri="{FF2B5EF4-FFF2-40B4-BE49-F238E27FC236}">
-                <a16:creationId xmlns:a16="http://schemas.microsoft.com/office/drawing/2014/main" id="{C289AB31-3E68-4A41-9D7B-C22C60AED9F8}"/>
+                <a16:creationId xmlns:a16="http://schemas.microsoft.com/office/drawing/2014/main" id="{78831A5C-3D51-4C94-BDE7-75BEBB4CE5AC}"/>
               </a:ext>
             </a:extLst>
           </p:cNvPr>
@@ -27360,7 +27360,7 @@
           <p:cNvPr id="18" name="AMI&#10;SIP / RTP">
             <a:extLst xmlns:a="http://schemas.openxmlformats.org/drawingml/2006/main">
               <a:ext uri="{FF2B5EF4-FFF2-40B4-BE49-F238E27FC236}">
-                <a16:creationId xmlns:a16="http://schemas.microsoft.com/office/drawing/2014/main" id="{5BB30124-63DD-49B5-9770-0EC87DE915A2}"/>
+                <a16:creationId xmlns:a16="http://schemas.microsoft.com/office/drawing/2014/main" id="{EBA3D6E9-BF96-4257-A6B5-2399CF3ACF5F}"/>
               </a:ext>
             </a:extLst>
           </p:cNvPr>
@@ -27541,7 +27541,7 @@
           <p:cNvPr id="19" name="Asterisk uses hostNetwork and one replica. HA opens the AMI conne">
             <a:extLst xmlns:a="http://schemas.openxmlformats.org/drawingml/2006/main">
               <a:ext uri="{FF2B5EF4-FFF2-40B4-BE49-F238E27FC236}">
-                <a16:creationId xmlns:a16="http://schemas.microsoft.com/office/drawing/2014/main" id="{94DA5DB5-1BBE-4B4E-8C8E-B5E047C54074}"/>
+                <a16:creationId xmlns:a16="http://schemas.microsoft.com/office/drawing/2014/main" id="{7DB7ADF8-0514-4D18-B080-F70546D86ECF}"/>
               </a:ext>
             </a:extLst>
           </p:cNvPr>
@@ -27720,7 +27720,7 @@
     </p:spTree>
     <p:extLst>
       <p:ext uri="{BB962C8B-B14F-4D97-AF65-F5344CB8AC3E}">
-        <p14:creationId xmlns:p14="http://schemas.microsoft.com/office/powerpoint/2010/main" val="2093619344"/>
+        <p14:creationId xmlns:p14="http://schemas.microsoft.com/office/powerpoint/2010/main" val="626408807"/>
       </p:ext>
     </p:extLst>
   </p:cSld>
@@ -27751,7 +27751,7 @@
           <p:cNvPr id="16" name="Signaling and audio ports">
             <a:extLst xmlns:a="http://schemas.openxmlformats.org/drawingml/2006/main">
               <a:ext uri="{FF2B5EF4-FFF2-40B4-BE49-F238E27FC236}">
-                <a16:creationId xmlns:a16="http://schemas.microsoft.com/office/drawing/2014/main" id="{DA3841BB-A263-42A0-BC46-ED094CE74457}"/>
+                <a16:creationId xmlns:a16="http://schemas.microsoft.com/office/drawing/2014/main" id="{36DA5A74-F7C9-4831-986C-598D316E263B}"/>
               </a:ext>
             </a:extLst>
           </p:cNvPr>
@@ -27909,7 +27909,7 @@
           <p:cNvPr id="2" name="04">
             <a:extLst xmlns:a="http://schemas.openxmlformats.org/drawingml/2006/main">
               <a:ext uri="{FF2B5EF4-FFF2-40B4-BE49-F238E27FC236}">
-                <a16:creationId xmlns:a16="http://schemas.microsoft.com/office/drawing/2014/main" id="{DC3557F0-29E6-44F7-A75B-3D98FF20A981}"/>
+                <a16:creationId xmlns:a16="http://schemas.microsoft.com/office/drawing/2014/main" id="{31254EAB-A7A8-44D8-874F-87D692A32EE7}"/>
               </a:ext>
             </a:extLst>
           </p:cNvPr>
@@ -28067,7 +28067,7 @@
           <p:cNvPr id="3" name="5060">
             <a:extLst xmlns:a="http://schemas.openxmlformats.org/drawingml/2006/main">
               <a:ext uri="{FF2B5EF4-FFF2-40B4-BE49-F238E27FC236}">
-                <a16:creationId xmlns:a16="http://schemas.microsoft.com/office/drawing/2014/main" id="{8A78CB2E-5993-47A9-870D-164206419942}"/>
+                <a16:creationId xmlns:a16="http://schemas.microsoft.com/office/drawing/2014/main" id="{7B5BCFFA-1FA1-4554-AEE2-098AB73DAA42}"/>
               </a:ext>
             </a:extLst>
           </p:cNvPr>
@@ -28225,7 +28225,7 @@
           <p:cNvPr id="4" name="TCP / UDP">
             <a:extLst xmlns:a="http://schemas.openxmlformats.org/drawingml/2006/main">
               <a:ext uri="{FF2B5EF4-FFF2-40B4-BE49-F238E27FC236}">
-                <a16:creationId xmlns:a16="http://schemas.microsoft.com/office/drawing/2014/main" id="{7AA26A26-5B46-4A82-A311-D65811D3261E}"/>
+                <a16:creationId xmlns:a16="http://schemas.microsoft.com/office/drawing/2014/main" id="{C1B70CEA-FD12-40CB-87E9-014DBA4B4140}"/>
               </a:ext>
             </a:extLst>
           </p:cNvPr>
@@ -28383,7 +28383,7 @@
           <p:cNvPr id="5" name="SIP: Cisco TCP, HA UDP">
             <a:extLst xmlns:a="http://schemas.openxmlformats.org/drawingml/2006/main">
               <a:ext uri="{FF2B5EF4-FFF2-40B4-BE49-F238E27FC236}">
-                <a16:creationId xmlns:a16="http://schemas.microsoft.com/office/drawing/2014/main" id="{F7EE262F-EE91-4B38-AB2C-AD5455B41355}"/>
+                <a16:creationId xmlns:a16="http://schemas.microsoft.com/office/drawing/2014/main" id="{E53B88CA-0B2B-4B40-8C1B-B79672486930}"/>
               </a:ext>
             </a:extLst>
           </p:cNvPr>
@@ -28541,7 +28541,7 @@
           <p:cNvPr id="6" name="10000–10199">
             <a:extLst xmlns:a="http://schemas.openxmlformats.org/drawingml/2006/main">
               <a:ext uri="{FF2B5EF4-FFF2-40B4-BE49-F238E27FC236}">
-                <a16:creationId xmlns:a16="http://schemas.microsoft.com/office/drawing/2014/main" id="{B719EDF1-B4FC-4842-AB02-D7CB350CEA76}"/>
+                <a16:creationId xmlns:a16="http://schemas.microsoft.com/office/drawing/2014/main" id="{DAE76A24-A57E-4A59-A031-7EFC64216EF7}"/>
               </a:ext>
             </a:extLst>
           </p:cNvPr>
@@ -28699,7 +28699,7 @@
           <p:cNvPr id="7" name="UDP on PBX">
             <a:extLst xmlns:a="http://schemas.openxmlformats.org/drawingml/2006/main">
               <a:ext uri="{FF2B5EF4-FFF2-40B4-BE49-F238E27FC236}">
-                <a16:creationId xmlns:a16="http://schemas.microsoft.com/office/drawing/2014/main" id="{3AE5AB31-ED9C-4FFB-A84F-CA716183DB97}"/>
+                <a16:creationId xmlns:a16="http://schemas.microsoft.com/office/drawing/2014/main" id="{757BE8FF-0FA1-48A4-A0F1-754FA758B3F3}"/>
               </a:ext>
             </a:extLst>
           </p:cNvPr>
@@ -28857,7 +28857,7 @@
           <p:cNvPr id="8" name="RTP / audio">
             <a:extLst xmlns:a="http://schemas.openxmlformats.org/drawingml/2006/main">
               <a:ext uri="{FF2B5EF4-FFF2-40B4-BE49-F238E27FC236}">
-                <a16:creationId xmlns:a16="http://schemas.microsoft.com/office/drawing/2014/main" id="{39A80282-4F63-44AE-8CD2-512395870BB9}"/>
+                <a16:creationId xmlns:a16="http://schemas.microsoft.com/office/drawing/2014/main" id="{35040A92-170C-4206-A0E5-D516BEF68DC3}"/>
               </a:ext>
             </a:extLst>
           </p:cNvPr>
@@ -29015,7 +29015,7 @@
           <p:cNvPr id="9" name="5038">
             <a:extLst xmlns:a="http://schemas.openxmlformats.org/drawingml/2006/main">
               <a:ext uri="{FF2B5EF4-FFF2-40B4-BE49-F238E27FC236}">
-                <a16:creationId xmlns:a16="http://schemas.microsoft.com/office/drawing/2014/main" id="{046FBF1F-BFDB-4AD4-8024-56FAA532592E}"/>
+                <a16:creationId xmlns:a16="http://schemas.microsoft.com/office/drawing/2014/main" id="{7BE7FC2E-1768-4045-89C5-83BCB17EF66F}"/>
               </a:ext>
             </a:extLst>
           </p:cNvPr>
@@ -29173,7 +29173,7 @@
           <p:cNvPr id="10" name="TCP on PBX">
             <a:extLst xmlns:a="http://schemas.openxmlformats.org/drawingml/2006/main">
               <a:ext uri="{FF2B5EF4-FFF2-40B4-BE49-F238E27FC236}">
-                <a16:creationId xmlns:a16="http://schemas.microsoft.com/office/drawing/2014/main" id="{99192404-F171-41F1-B30A-B7FFEABD29C8}"/>
+                <a16:creationId xmlns:a16="http://schemas.microsoft.com/office/drawing/2014/main" id="{5209D094-91F8-4082-AC31-F8920FC2B282}"/>
               </a:ext>
             </a:extLst>
           </p:cNvPr>
@@ -29331,7 +29331,7 @@
           <p:cNvPr id="11" name="AMI: HA / gateway /32">
             <a:extLst xmlns:a="http://schemas.openxmlformats.org/drawingml/2006/main">
               <a:ext uri="{FF2B5EF4-FFF2-40B4-BE49-F238E27FC236}">
-                <a16:creationId xmlns:a16="http://schemas.microsoft.com/office/drawing/2014/main" id="{D8C89334-A0A5-4441-8B9F-DBCE4D4C9CCF}"/>
+                <a16:creationId xmlns:a16="http://schemas.microsoft.com/office/drawing/2014/main" id="{CEA40994-49E2-490F-AEA0-6EFD3286B5EE}"/>
               </a:ext>
             </a:extLst>
           </p:cNvPr>
@@ -29489,7 +29489,7 @@
           <p:cNvPr id="12" name="69 + 20000–20031">
             <a:extLst xmlns:a="http://schemas.openxmlformats.org/drawingml/2006/main">
               <a:ext uri="{FF2B5EF4-FFF2-40B4-BE49-F238E27FC236}">
-                <a16:creationId xmlns:a16="http://schemas.microsoft.com/office/drawing/2014/main" id="{096CD57B-8E60-4C77-9F31-C033F947D0AD}"/>
+                <a16:creationId xmlns:a16="http://schemas.microsoft.com/office/drawing/2014/main" id="{D3AC3EFD-9C3D-4ED0-B93A-ED37CF2508ED}"/>
               </a:ext>
             </a:extLst>
           </p:cNvPr>
@@ -29647,7 +29647,7 @@
           <p:cNvPr id="13" name="UDP on PBX">
             <a:extLst xmlns:a="http://schemas.openxmlformats.org/drawingml/2006/main">
               <a:ext uri="{FF2B5EF4-FFF2-40B4-BE49-F238E27FC236}">
-                <a16:creationId xmlns:a16="http://schemas.microsoft.com/office/drawing/2014/main" id="{948631FD-098E-468C-A1B7-BBB0330274FC}"/>
+                <a16:creationId xmlns:a16="http://schemas.microsoft.com/office/drawing/2014/main" id="{EA88BE0B-076C-472E-A790-37A9E5D22145}"/>
               </a:ext>
             </a:extLst>
           </p:cNvPr>
@@ -29805,7 +29805,7 @@
           <p:cNvPr id="14" name="Temporary TFTP">
             <a:extLst xmlns:a="http://schemas.openxmlformats.org/drawingml/2006/main">
               <a:ext uri="{FF2B5EF4-FFF2-40B4-BE49-F238E27FC236}">
-                <a16:creationId xmlns:a16="http://schemas.microsoft.com/office/drawing/2014/main" id="{66C04D71-EEB3-48BA-A091-5472DFFE7680}"/>
+                <a16:creationId xmlns:a16="http://schemas.microsoft.com/office/drawing/2014/main" id="{D44B2D7E-27FC-449E-AC81-C2D3056DD4AF}"/>
               </a:ext>
             </a:extLst>
           </p:cNvPr>
@@ -29963,7 +29963,7 @@
           <p:cNvPr id="15" name="HA uses dynamic RTP / RTCP ports. Restrict firewall rules to the ">
             <a:extLst xmlns:a="http://schemas.openxmlformats.org/drawingml/2006/main">
               <a:ext uri="{FF2B5EF4-FFF2-40B4-BE49-F238E27FC236}">
-                <a16:creationId xmlns:a16="http://schemas.microsoft.com/office/drawing/2014/main" id="{A40B4816-FDF1-4B5E-A0D1-AF2DDCCBA6D5}"/>
+                <a16:creationId xmlns:a16="http://schemas.microsoft.com/office/drawing/2014/main" id="{865F9729-059C-42EF-AABF-E8D65AB74C3F}"/>
               </a:ext>
             </a:extLst>
           </p:cNvPr>
@@ -30119,7 +30119,7 @@
     </p:spTree>
     <p:extLst>
       <p:ext uri="{BB962C8B-B14F-4D97-AF65-F5344CB8AC3E}">
-        <p14:creationId xmlns:p14="http://schemas.microsoft.com/office/powerpoint/2010/main" val="1899970596"/>
+        <p14:creationId xmlns:p14="http://schemas.microsoft.com/office/powerpoint/2010/main" val="2062194378"/>
       </p:ext>
     </p:extLst>
   </p:cSld>
@@ -30150,7 +30150,7 @@
           <p:cNvPr id="12" name="">
             <a:extLst xmlns:a="http://schemas.openxmlformats.org/drawingml/2006/main">
               <a:ext uri="{FF2B5EF4-FFF2-40B4-BE49-F238E27FC236}">
-                <a16:creationId xmlns:a16="http://schemas.microsoft.com/office/drawing/2014/main" id="{1E13E860-EC1C-42D5-8423-275D3D7739FB}"/>
+                <a16:creationId xmlns:a16="http://schemas.microsoft.com/office/drawing/2014/main" id="{123C9C0D-ECFB-4D4F-A9DD-546F778B8AC0}"/>
               </a:ext>
             </a:extLst>
           </p:cNvPr>
@@ -30181,7 +30181,7 @@
           <p:cNvPr id="10" name="">
             <a:extLst xmlns:a="http://schemas.openxmlformats.org/drawingml/2006/main">
               <a:ext uri="{FF2B5EF4-FFF2-40B4-BE49-F238E27FC236}">
-                <a16:creationId xmlns:a16="http://schemas.microsoft.com/office/drawing/2014/main" id="{A22BCC19-463D-4283-86A1-44482825C899}"/>
+                <a16:creationId xmlns:a16="http://schemas.microsoft.com/office/drawing/2014/main" id="{D3B8E16B-97AD-475E-BFC7-AFE38991F3DC}"/>
               </a:ext>
             </a:extLst>
           </p:cNvPr>
@@ -30212,7 +30212,7 @@
           <p:cNvPr id="8" name="">
             <a:extLst xmlns:a="http://schemas.openxmlformats.org/drawingml/2006/main">
               <a:ext uri="{FF2B5EF4-FFF2-40B4-BE49-F238E27FC236}">
-                <a16:creationId xmlns:a16="http://schemas.microsoft.com/office/drawing/2014/main" id="{96FA15F4-566C-4D58-81FB-4663EDC1CE23}"/>
+                <a16:creationId xmlns:a16="http://schemas.microsoft.com/office/drawing/2014/main" id="{72BF1FC1-EC3F-40EA-B0FF-4D6D69E6BC83}"/>
               </a:ext>
             </a:extLst>
           </p:cNvPr>
@@ -30243,7 +30243,7 @@
           <p:cNvPr id="15" name="7945G has built-in PoE support">
             <a:extLst xmlns:a="http://schemas.openxmlformats.org/drawingml/2006/main">
               <a:ext uri="{FF2B5EF4-FFF2-40B4-BE49-F238E27FC236}">
-                <a16:creationId xmlns:a16="http://schemas.microsoft.com/office/drawing/2014/main" id="{B9A3D916-4B6D-4BEB-B452-0C55939D2EC8}"/>
+                <a16:creationId xmlns:a16="http://schemas.microsoft.com/office/drawing/2014/main" id="{E63E84E4-DBBD-4E6C-AE94-619DE9480D95}"/>
               </a:ext>
             </a:extLst>
           </p:cNvPr>
@@ -30401,7 +30401,7 @@
           <p:cNvPr id="2" name="05">
             <a:extLst xmlns:a="http://schemas.openxmlformats.org/drawingml/2006/main">
               <a:ext uri="{FF2B5EF4-FFF2-40B4-BE49-F238E27FC236}">
-                <a16:creationId xmlns:a16="http://schemas.microsoft.com/office/drawing/2014/main" id="{F0816E23-3B3E-4264-A0E7-E27D86516D14}"/>
+                <a16:creationId xmlns:a16="http://schemas.microsoft.com/office/drawing/2014/main" id="{F7EB0D69-20D1-4987-922F-C275DF5F751F}"/>
               </a:ext>
             </a:extLst>
           </p:cNvPr>
@@ -30559,7 +30559,7 @@
           <p:cNvPr id="3" name="poe">
             <a:extLst xmlns:a="http://schemas.openxmlformats.org/drawingml/2006/main">
               <a:ext uri="{FF2B5EF4-FFF2-40B4-BE49-F238E27FC236}">
-                <a16:creationId xmlns:a16="http://schemas.microsoft.com/office/drawing/2014/main" id="{B9E012EC-43D1-44B2-9FC7-11EBC05668D5}"/>
+                <a16:creationId xmlns:a16="http://schemas.microsoft.com/office/drawing/2014/main" id="{1561CBD6-8354-49B0-A782-E642A38D7EDA}"/>
               </a:ext>
             </a:extLst>
           </p:cNvPr>
@@ -30746,7 +30746,7 @@
           <p:cNvPr id="4" name="phone1">
             <a:extLst xmlns:a="http://schemas.openxmlformats.org/drawingml/2006/main">
               <a:ext uri="{FF2B5EF4-FFF2-40B4-BE49-F238E27FC236}">
-                <a16:creationId xmlns:a16="http://schemas.microsoft.com/office/drawing/2014/main" id="{F1E3CADD-AC55-4F92-8D17-D21DFA2C93D9}"/>
+                <a16:creationId xmlns:a16="http://schemas.microsoft.com/office/drawing/2014/main" id="{64985894-9E18-4A0C-91FA-910F2A1242E9}"/>
               </a:ext>
             </a:extLst>
           </p:cNvPr>
@@ -30933,7 +30933,7 @@
           <p:cNvPr id="5" name="lan">
             <a:extLst xmlns:a="http://schemas.openxmlformats.org/drawingml/2006/main">
               <a:ext uri="{FF2B5EF4-FFF2-40B4-BE49-F238E27FC236}">
-                <a16:creationId xmlns:a16="http://schemas.microsoft.com/office/drawing/2014/main" id="{DEEEA451-D819-4D60-A1C9-04B57D9CC7BE}"/>
+                <a16:creationId xmlns:a16="http://schemas.microsoft.com/office/drawing/2014/main" id="{93A3454E-EE51-4693-83F4-E26019D86E2B}"/>
               </a:ext>
             </a:extLst>
           </p:cNvPr>
@@ -31120,7 +31120,7 @@
           <p:cNvPr id="6" name="injector">
             <a:extLst xmlns:a="http://schemas.openxmlformats.org/drawingml/2006/main">
               <a:ext uri="{FF2B5EF4-FFF2-40B4-BE49-F238E27FC236}">
-                <a16:creationId xmlns:a16="http://schemas.microsoft.com/office/drawing/2014/main" id="{2DD20694-B1CD-4CDC-B029-9128F9DA542F}"/>
+                <a16:creationId xmlns:a16="http://schemas.microsoft.com/office/drawing/2014/main" id="{01EE1972-9FD7-407C-9635-26D1AB3696E0}"/>
               </a:ext>
             </a:extLst>
           </p:cNvPr>
@@ -31307,7 +31307,7 @@
           <p:cNvPr id="7" name="phone2">
             <a:extLst xmlns:a="http://schemas.openxmlformats.org/drawingml/2006/main">
               <a:ext uri="{FF2B5EF4-FFF2-40B4-BE49-F238E27FC236}">
-                <a16:creationId xmlns:a16="http://schemas.microsoft.com/office/drawing/2014/main" id="{F76D44A5-31F5-436B-B194-ED3A1165109E}"/>
+                <a16:creationId xmlns:a16="http://schemas.microsoft.com/office/drawing/2014/main" id="{3556FE2F-EF4A-4C3A-AA64-2C117239CCCC}"/>
               </a:ext>
             </a:extLst>
           </p:cNvPr>
@@ -31494,7 +31494,7 @@
           <p:cNvPr id="9" name="data + power">
             <a:extLst xmlns:a="http://schemas.openxmlformats.org/drawingml/2006/main">
               <a:ext uri="{FF2B5EF4-FFF2-40B4-BE49-F238E27FC236}">
-                <a16:creationId xmlns:a16="http://schemas.microsoft.com/office/drawing/2014/main" id="{966CB941-CFE0-431F-B776-E620ACA2846F}"/>
+                <a16:creationId xmlns:a16="http://schemas.microsoft.com/office/drawing/2014/main" id="{323846DB-A2C7-4D04-90EB-2284D1BEC20E}"/>
               </a:ext>
             </a:extLst>
           </p:cNvPr>
@@ -31652,7 +31652,7 @@
           <p:cNvPr id="11" name="data">
             <a:extLst xmlns:a="http://schemas.openxmlformats.org/drawingml/2006/main">
               <a:ext uri="{FF2B5EF4-FFF2-40B4-BE49-F238E27FC236}">
-                <a16:creationId xmlns:a16="http://schemas.microsoft.com/office/drawing/2014/main" id="{167B680B-9F9D-4A60-973F-0E132B5E96F1}"/>
+                <a16:creationId xmlns:a16="http://schemas.microsoft.com/office/drawing/2014/main" id="{EFCF0623-DB06-45D8-9A3B-0390A6B0F723}"/>
               </a:ext>
             </a:extLst>
           </p:cNvPr>
@@ -31810,7 +31810,7 @@
           <p:cNvPr id="13" name="PoE">
             <a:extLst xmlns:a="http://schemas.openxmlformats.org/drawingml/2006/main">
               <a:ext uri="{FF2B5EF4-FFF2-40B4-BE49-F238E27FC236}">
-                <a16:creationId xmlns:a16="http://schemas.microsoft.com/office/drawing/2014/main" id="{01FF36A6-680D-41D8-AA7C-68EF79E7247C}"/>
+                <a16:creationId xmlns:a16="http://schemas.microsoft.com/office/drawing/2014/main" id="{9B8BB2C4-A6FE-44BC-B52B-0A74599BF581}"/>
               </a:ext>
             </a:extLst>
           </p:cNvPr>
@@ -31968,7 +31968,7 @@
           <p:cNvPr id="14" name="A passive 24 V injector is unsuitable. The UPS also needs to powe">
             <a:extLst xmlns:a="http://schemas.openxmlformats.org/drawingml/2006/main">
               <a:ext uri="{FF2B5EF4-FFF2-40B4-BE49-F238E27FC236}">
-                <a16:creationId xmlns:a16="http://schemas.microsoft.com/office/drawing/2014/main" id="{40EE6EFE-D81F-4288-9CB4-77F944FAE048}"/>
+                <a16:creationId xmlns:a16="http://schemas.microsoft.com/office/drawing/2014/main" id="{6A3D1533-7F25-4FC3-93A5-F0C882E295D4}"/>
               </a:ext>
             </a:extLst>
           </p:cNvPr>
@@ -32124,7 +32124,7 @@
     </p:spTree>
     <p:extLst>
       <p:ext uri="{BB962C8B-B14F-4D97-AF65-F5344CB8AC3E}">
-        <p14:creationId xmlns:p14="http://schemas.microsoft.com/office/powerpoint/2010/main" val="438418735"/>
+        <p14:creationId xmlns:p14="http://schemas.microsoft.com/office/powerpoint/2010/main" val="1986188370"/>
       </p:ext>
     </p:extLst>
   </p:cSld>
@@ -32155,7 +32155,7 @@
           <p:cNvPr id="13" name="">
             <a:extLst xmlns:a="http://schemas.openxmlformats.org/drawingml/2006/main">
               <a:ext uri="{FF2B5EF4-FFF2-40B4-BE49-F238E27FC236}">
-                <a16:creationId xmlns:a16="http://schemas.microsoft.com/office/drawing/2014/main" id="{3AE26BB7-F6E9-467B-99FB-4957138A2710}"/>
+                <a16:creationId xmlns:a16="http://schemas.microsoft.com/office/drawing/2014/main" id="{8CB7EFBA-BEAD-4DFF-905E-E388173AA0C3}"/>
               </a:ext>
             </a:extLst>
           </p:cNvPr>
@@ -32186,7 +32186,7 @@
           <p:cNvPr id="12" name="">
             <a:extLst xmlns:a="http://schemas.openxmlformats.org/drawingml/2006/main">
               <a:ext uri="{FF2B5EF4-FFF2-40B4-BE49-F238E27FC236}">
-                <a16:creationId xmlns:a16="http://schemas.microsoft.com/office/drawing/2014/main" id="{FBE081B2-D08E-4833-8218-DEEBCA0AC092}"/>
+                <a16:creationId xmlns:a16="http://schemas.microsoft.com/office/drawing/2014/main" id="{4848B036-E6B4-43F8-9BA2-CFBFBE2374B1}"/>
               </a:ext>
             </a:extLst>
           </p:cNvPr>
@@ -32217,7 +32217,7 @@
           <p:cNvPr id="11" name="">
             <a:extLst xmlns:a="http://schemas.openxmlformats.org/drawingml/2006/main">
               <a:ext uri="{FF2B5EF4-FFF2-40B4-BE49-F238E27FC236}">
-                <a16:creationId xmlns:a16="http://schemas.microsoft.com/office/drawing/2014/main" id="{82BE0346-D970-40FA-9327-84510F47FEB2}"/>
+                <a16:creationId xmlns:a16="http://schemas.microsoft.com/office/drawing/2014/main" id="{28AF98C0-C452-43AE-B5AA-287547D48C5F}"/>
               </a:ext>
             </a:extLst>
           </p:cNvPr>
@@ -32248,7 +32248,7 @@
           <p:cNvPr id="10" name="">
             <a:extLst xmlns:a="http://schemas.openxmlformats.org/drawingml/2006/main">
               <a:ext uri="{FF2B5EF4-FFF2-40B4-BE49-F238E27FC236}">
-                <a16:creationId xmlns:a16="http://schemas.microsoft.com/office/drawing/2014/main" id="{0B70BB1C-9645-43C0-9A2A-6662B06CC306}"/>
+                <a16:creationId xmlns:a16="http://schemas.microsoft.com/office/drawing/2014/main" id="{D74320BE-3AC7-450B-A274-080CF50CF77E}"/>
               </a:ext>
             </a:extLst>
           </p:cNvPr>
@@ -32279,7 +32279,7 @@
           <p:cNvPr id="9" name="">
             <a:extLst xmlns:a="http://schemas.openxmlformats.org/drawingml/2006/main">
               <a:ext uri="{FF2B5EF4-FFF2-40B4-BE49-F238E27FC236}">
-                <a16:creationId xmlns:a16="http://schemas.microsoft.com/office/drawing/2014/main" id="{8A7898F4-47F6-460F-AEA4-74F053E376B5}"/>
+                <a16:creationId xmlns:a16="http://schemas.microsoft.com/office/drawing/2014/main" id="{A1B9A0BE-5FA5-4ED1-94C7-99EF42E7BCDA}"/>
               </a:ext>
             </a:extLst>
           </p:cNvPr>
@@ -32310,7 +32310,7 @@
           <p:cNvPr id="15" name="One pilot phone before the full fleet">
             <a:extLst xmlns:a="http://schemas.openxmlformats.org/drawingml/2006/main">
               <a:ext uri="{FF2B5EF4-FFF2-40B4-BE49-F238E27FC236}">
-                <a16:creationId xmlns:a16="http://schemas.microsoft.com/office/drawing/2014/main" id="{FD2EA523-187F-43BC-9A12-3F1D4AAAC924}"/>
+                <a16:creationId xmlns:a16="http://schemas.microsoft.com/office/drawing/2014/main" id="{D381A7D3-4468-4982-B3B2-A1E0287B7226}"/>
               </a:ext>
             </a:extLst>
           </p:cNvPr>
@@ -32468,7 +32468,7 @@
           <p:cNvPr id="2" name="06">
             <a:extLst xmlns:a="http://schemas.openxmlformats.org/drawingml/2006/main">
               <a:ext uri="{FF2B5EF4-FFF2-40B4-BE49-F238E27FC236}">
-                <a16:creationId xmlns:a16="http://schemas.microsoft.com/office/drawing/2014/main" id="{8DC054FA-556C-42AF-88F6-DFF419291E85}"/>
+                <a16:creationId xmlns:a16="http://schemas.microsoft.com/office/drawing/2014/main" id="{D8A479D8-7178-4245-B385-9D37465D935D}"/>
               </a:ext>
             </a:extLst>
           </p:cNvPr>
@@ -32626,7 +32626,7 @@
           <p:cNvPr id="3" name="inventory">
             <a:extLst xmlns:a="http://schemas.openxmlformats.org/drawingml/2006/main">
               <a:ext uri="{FF2B5EF4-FFF2-40B4-BE49-F238E27FC236}">
-                <a16:creationId xmlns:a16="http://schemas.microsoft.com/office/drawing/2014/main" id="{4B458B6F-C648-4A4D-87AA-D14A93D58FE9}"/>
+                <a16:creationId xmlns:a16="http://schemas.microsoft.com/office/drawing/2014/main" id="{DCFF4C67-5C57-4E1D-80A8-7FD7810E508F}"/>
               </a:ext>
             </a:extLst>
           </p:cNvPr>
@@ -32813,7 +32813,7 @@
           <p:cNvPr id="4" name="firmware">
             <a:extLst xmlns:a="http://schemas.openxmlformats.org/drawingml/2006/main">
               <a:ext uri="{FF2B5EF4-FFF2-40B4-BE49-F238E27FC236}">
-                <a16:creationId xmlns:a16="http://schemas.microsoft.com/office/drawing/2014/main" id="{01A9BC1E-5626-40D6-B85C-1EE895DE0930}"/>
+                <a16:creationId xmlns:a16="http://schemas.microsoft.com/office/drawing/2014/main" id="{E6AA1520-2849-4183-A8F4-969924D561FB}"/>
               </a:ext>
             </a:extLst>
           </p:cNvPr>
@@ -33000,7 +33000,7 @@
           <p:cNvPr id="5" name="tftp">
             <a:extLst xmlns:a="http://schemas.openxmlformats.org/drawingml/2006/main">
               <a:ext uri="{FF2B5EF4-FFF2-40B4-BE49-F238E27FC236}">
-                <a16:creationId xmlns:a16="http://schemas.microsoft.com/office/drawing/2014/main" id="{A10F8696-AA28-454B-AADF-32C632749725}"/>
+                <a16:creationId xmlns:a16="http://schemas.microsoft.com/office/drawing/2014/main" id="{CA43B387-5D5A-4C76-BB51-7FAB3B42242A}"/>
               </a:ext>
             </a:extLst>
           </p:cNvPr>
@@ -33187,7 +33187,7 @@
           <p:cNvPr id="6" name="pilot">
             <a:extLst xmlns:a="http://schemas.openxmlformats.org/drawingml/2006/main">
               <a:ext uri="{FF2B5EF4-FFF2-40B4-BE49-F238E27FC236}">
-                <a16:creationId xmlns:a16="http://schemas.microsoft.com/office/drawing/2014/main" id="{DAEC2F56-7F06-43DA-B3F2-6571D1D41806}"/>
+                <a16:creationId xmlns:a16="http://schemas.microsoft.com/office/drawing/2014/main" id="{4994A53E-DCDE-45EC-BF61-D561D281F2A3}"/>
               </a:ext>
             </a:extLst>
           </p:cNvPr>
@@ -33374,7 +33374,7 @@
           <p:cNvPr id="7" name="accept">
             <a:extLst xmlns:a="http://schemas.openxmlformats.org/drawingml/2006/main">
               <a:ext uri="{FF2B5EF4-FFF2-40B4-BE49-F238E27FC236}">
-                <a16:creationId xmlns:a16="http://schemas.microsoft.com/office/drawing/2014/main" id="{DE441AC1-3F46-468B-8F7F-20757000E49A}"/>
+                <a16:creationId xmlns:a16="http://schemas.microsoft.com/office/drawing/2014/main" id="{8181EA64-6DB4-43A9-89BD-66B1C44A549F}"/>
               </a:ext>
             </a:extLst>
           </p:cNvPr>
@@ -33561,7 +33561,7 @@
           <p:cNvPr id="8" name="fleet">
             <a:extLst xmlns:a="http://schemas.openxmlformats.org/drawingml/2006/main">
               <a:ext uri="{FF2B5EF4-FFF2-40B4-BE49-F238E27FC236}">
-                <a16:creationId xmlns:a16="http://schemas.microsoft.com/office/drawing/2014/main" id="{7E54E41F-2031-41E7-9463-EFBEB93DEE0A}"/>
+                <a16:creationId xmlns:a16="http://schemas.microsoft.com/office/drawing/2014/main" id="{CD1F521C-7015-4895-9BB6-FB54656BAA10}"/>
               </a:ext>
             </a:extLst>
           </p:cNvPr>
@@ -33748,7 +33748,7 @@
           <p:cNvPr id="14" name="HW 13.0+ requires at least 9.3(1)SR3. The upgrade path depends on">
             <a:extLst xmlns:a="http://schemas.openxmlformats.org/drawingml/2006/main">
               <a:ext uri="{FF2B5EF4-FFF2-40B4-BE49-F238E27FC236}">
-                <a16:creationId xmlns:a16="http://schemas.microsoft.com/office/drawing/2014/main" id="{7657AF4C-D3E2-4183-B4A0-3451A7EB5AAD}"/>
+                <a16:creationId xmlns:a16="http://schemas.microsoft.com/office/drawing/2014/main" id="{D0DFA3DE-2911-47C0-B948-B13580D0A967}"/>
               </a:ext>
             </a:extLst>
           </p:cNvPr>
@@ -33927,7 +33927,7 @@
     </p:spTree>
     <p:extLst>
       <p:ext uri="{BB962C8B-B14F-4D97-AF65-F5344CB8AC3E}">
-        <p14:creationId xmlns:p14="http://schemas.microsoft.com/office/powerpoint/2010/main" val="1991470394"/>
+        <p14:creationId xmlns:p14="http://schemas.microsoft.com/office/powerpoint/2010/main" val="1012363617"/>
       </p:ext>
     </p:extLst>
   </p:cSld>
@@ -33958,7 +33958,7 @@
           <p:cNvPr id="8" name="TFTP preparation before restart">
             <a:extLst xmlns:a="http://schemas.openxmlformats.org/drawingml/2006/main">
               <a:ext uri="{FF2B5EF4-FFF2-40B4-BE49-F238E27FC236}">
-                <a16:creationId xmlns:a16="http://schemas.microsoft.com/office/drawing/2014/main" id="{BA5F6F6E-B424-41C6-BFDD-274CF08C30EE}"/>
+                <a16:creationId xmlns:a16="http://schemas.microsoft.com/office/drawing/2014/main" id="{D121789E-9C8C-4042-BC6C-F6D1893FEEE4}"/>
               </a:ext>
             </a:extLst>
           </p:cNvPr>
@@ -34116,7 +34116,7 @@
           <p:cNvPr id="2" name="07">
             <a:extLst xmlns:a="http://schemas.openxmlformats.org/drawingml/2006/main">
               <a:ext uri="{FF2B5EF4-FFF2-40B4-BE49-F238E27FC236}">
-                <a16:creationId xmlns:a16="http://schemas.microsoft.com/office/drawing/2014/main" id="{21FCB8D7-5F0C-4E20-95C7-491BA6A1F06D}"/>
+                <a16:creationId xmlns:a16="http://schemas.microsoft.com/office/drawing/2014/main" id="{0422F7D5-2F0F-4C4D-BBA2-F123595AA4A3}"/>
               </a:ext>
             </a:extLst>
           </p:cNvPr>
@@ -34274,7 +34274,7 @@
           <p:cNvPr id="3" name="Complete official firmware bundle">
             <a:extLst xmlns:a="http://schemas.openxmlformats.org/drawingml/2006/main">
               <a:ext uri="{FF2B5EF4-FFF2-40B4-BE49-F238E27FC236}">
-                <a16:creationId xmlns:a16="http://schemas.microsoft.com/office/drawing/2014/main" id="{6CD1B4C3-BC4E-4949-B308-FDB1D9A22727}"/>
+                <a16:creationId xmlns:a16="http://schemas.microsoft.com/office/drawing/2014/main" id="{73BCE527-9339-4709-9B5C-357571F04536}"/>
               </a:ext>
             </a:extLst>
           </p:cNvPr>
@@ -34432,7 +34432,7 @@
           <p:cNvPr id="4" name=".loads and every referenced binary file&#10;with the original filenam">
             <a:extLst xmlns:a="http://schemas.openxmlformats.org/drawingml/2006/main">
               <a:ext uri="{FF2B5EF4-FFF2-40B4-BE49-F238E27FC236}">
-                <a16:creationId xmlns:a16="http://schemas.microsoft.com/office/drawing/2014/main" id="{3C25F913-3545-4315-9851-45BD96677D06}"/>
+                <a16:creationId xmlns:a16="http://schemas.microsoft.com/office/drawing/2014/main" id="{3DD0297D-0441-4EBB-BFFF-C459A5D759D3}"/>
               </a:ext>
             </a:extLst>
           </p:cNvPr>
@@ -34613,7 +34613,7 @@
           <p:cNvPr id="5" name="SEP&lt;MAC&gt;.cnf.xml">
             <a:extLst xmlns:a="http://schemas.openxmlformats.org/drawingml/2006/main">
               <a:ext uri="{FF2B5EF4-FFF2-40B4-BE49-F238E27FC236}">
-                <a16:creationId xmlns:a16="http://schemas.microsoft.com/office/drawing/2014/main" id="{0E64AC24-2C8F-4CA8-BA5D-15B815E9D651}"/>
+                <a16:creationId xmlns:a16="http://schemas.microsoft.com/office/drawing/2014/main" id="{8A2D981F-2F1A-433F-963D-8EEC6014DC50}"/>
               </a:ext>
             </a:extLst>
           </p:cNvPr>
@@ -34771,7 +34771,7 @@
           <p:cNvPr id="6" name="SIP server, extension and a unique password&#10;Load ID from the sele">
             <a:extLst xmlns:a="http://schemas.openxmlformats.org/drawingml/2006/main">
               <a:ext uri="{FF2B5EF4-FFF2-40B4-BE49-F238E27FC236}">
-                <a16:creationId xmlns:a16="http://schemas.microsoft.com/office/drawing/2014/main" id="{FC52C4CF-2906-42AC-A729-FD64EF4216C7}"/>
+                <a16:creationId xmlns:a16="http://schemas.microsoft.com/office/drawing/2014/main" id="{6F753FE9-998C-450C-A05E-50153A02BD7D}"/>
               </a:ext>
             </a:extLst>
           </p:cNvPr>
@@ -34952,7 +34952,7 @@
           <p:cNvPr id="7" name="Use DHCP option 150 on the home router or Alternate TFTP on the p">
             <a:extLst xmlns:a="http://schemas.openxmlformats.org/drawingml/2006/main">
               <a:ext uri="{FF2B5EF4-FFF2-40B4-BE49-F238E27FC236}">
-                <a16:creationId xmlns:a16="http://schemas.microsoft.com/office/drawing/2014/main" id="{F0023F81-85A3-47BB-8685-0CF9714AA1FF}"/>
+                <a16:creationId xmlns:a16="http://schemas.microsoft.com/office/drawing/2014/main" id="{C8289C49-7291-4E53-87A1-6C5032EF6104}"/>
               </a:ext>
             </a:extLst>
           </p:cNvPr>
@@ -35108,7 +35108,7 @@
     </p:spTree>
     <p:extLst>
       <p:ext uri="{BB962C8B-B14F-4D97-AF65-F5344CB8AC3E}">
-        <p14:creationId xmlns:p14="http://schemas.microsoft.com/office/powerpoint/2010/main" val="2018942248"/>
+        <p14:creationId xmlns:p14="http://schemas.microsoft.com/office/powerpoint/2010/main" val="2056708704"/>
       </p:ext>
     </p:extLst>
   </p:cSld>
@@ -35139,7 +35139,7 @@
           <p:cNvPr id="8" name="Asterisk: independent SIP lines">
             <a:extLst xmlns:a="http://schemas.openxmlformats.org/drawingml/2006/main">
               <a:ext uri="{FF2B5EF4-FFF2-40B4-BE49-F238E27FC236}">
-                <a16:creationId xmlns:a16="http://schemas.microsoft.com/office/drawing/2014/main" id="{C4C9C4D3-558D-486C-AF19-906FB52D2B0B}"/>
+                <a16:creationId xmlns:a16="http://schemas.microsoft.com/office/drawing/2014/main" id="{A55D4030-EE85-4A4D-9C97-9321FD56CD4A}"/>
               </a:ext>
             </a:extLst>
           </p:cNvPr>
@@ -35297,7 +35297,7 @@
           <p:cNvPr id="2" name="08">
             <a:extLst xmlns:a="http://schemas.openxmlformats.org/drawingml/2006/main">
               <a:ext uri="{FF2B5EF4-FFF2-40B4-BE49-F238E27FC236}">
-                <a16:creationId xmlns:a16="http://schemas.microsoft.com/office/drawing/2014/main" id="{F5FEFFE2-C7C4-4981-9167-37E1CD15B756}"/>
+                <a16:creationId xmlns:a16="http://schemas.microsoft.com/office/drawing/2014/main" id="{BB51C624-FEEC-499E-A6C7-93607785DA9F}"/>
               </a:ext>
             </a:extLst>
           </p:cNvPr>
@@ -35455,7 +35455,7 @@
           <p:cNvPr id="3" name="201 / 202">
             <a:extLst xmlns:a="http://schemas.openxmlformats.org/drawingml/2006/main">
               <a:ext uri="{FF2B5EF4-FFF2-40B4-BE49-F238E27FC236}">
-                <a16:creationId xmlns:a16="http://schemas.microsoft.com/office/drawing/2014/main" id="{22E53C16-E913-411E-A67D-166199E8C556}"/>
+                <a16:creationId xmlns:a16="http://schemas.microsoft.com/office/drawing/2014/main" id="{D6609192-D19B-4BF2-B266-E5E2709AF5B1}"/>
               </a:ext>
             </a:extLst>
           </p:cNvPr>
@@ -35613,7 +35613,7 @@
           <p:cNvPr id="4" name="one phone">
             <a:extLst xmlns:a="http://schemas.openxmlformats.org/drawingml/2006/main">
               <a:ext uri="{FF2B5EF4-FFF2-40B4-BE49-F238E27FC236}">
-                <a16:creationId xmlns:a16="http://schemas.microsoft.com/office/drawing/2014/main" id="{E81BAD60-550A-4F22-A315-5ADB489FE3E3}"/>
+                <a16:creationId xmlns:a16="http://schemas.microsoft.com/office/drawing/2014/main" id="{D2149388-87DE-4035-8819-E1059B7794EF}"/>
               </a:ext>
             </a:extLst>
           </p:cNvPr>
@@ -35771,7 +35771,7 @@
           <p:cNvPr id="5" name="One endpoint, auth and AOR per line&#10;A unique password for each li">
             <a:extLst xmlns:a="http://schemas.openxmlformats.org/drawingml/2006/main">
               <a:ext uri="{FF2B5EF4-FFF2-40B4-BE49-F238E27FC236}">
-                <a16:creationId xmlns:a16="http://schemas.microsoft.com/office/drawing/2014/main" id="{430CE8A9-AA7F-477A-A487-29C33944C4BF}"/>
+                <a16:creationId xmlns:a16="http://schemas.microsoft.com/office/drawing/2014/main" id="{B7240942-777C-472A-864D-2E252CD84B26}"/>
               </a:ext>
             </a:extLst>
           </p:cNvPr>
@@ -35952,7 +35952,7 @@
           <p:cNvPr id="6" name="G.711 ulaw / alaw&#10;direct_media=no keeps RTP on Asterisk">
             <a:extLst xmlns:a="http://schemas.openxmlformats.org/drawingml/2006/main">
               <a:ext uri="{FF2B5EF4-FFF2-40B4-BE49-F238E27FC236}">
-                <a16:creationId xmlns:a16="http://schemas.microsoft.com/office/drawing/2014/main" id="{FCDDCAD0-92B5-4B2D-91CF-EF32AD52E544}"/>
+                <a16:creationId xmlns:a16="http://schemas.microsoft.com/office/drawing/2014/main" id="{17A1816F-6485-4E83-B6A4-FFCC54C34D61}"/>
               </a:ext>
             </a:extLst>
           </p:cNvPr>
@@ -36133,7 +36133,7 @@
           <p:cNvPr id="7" name="600 echo, 601 tone, 620 ring group. Extension 630 requires Assist">
             <a:extLst xmlns:a="http://schemas.openxmlformats.org/drawingml/2006/main">
               <a:ext uri="{FF2B5EF4-FFF2-40B4-BE49-F238E27FC236}">
-                <a16:creationId xmlns:a16="http://schemas.microsoft.com/office/drawing/2014/main" id="{AFF78423-FDAB-4CFD-9FF3-5CEA09162914}"/>
+                <a16:creationId xmlns:a16="http://schemas.microsoft.com/office/drawing/2014/main" id="{C1F2ECFD-52B7-4668-A8BF-30B68D02044F}"/>
               </a:ext>
             </a:extLst>
           </p:cNvPr>
@@ -36289,7 +36289,7 @@
     </p:spTree>
     <p:extLst>
       <p:ext uri="{BB962C8B-B14F-4D97-AF65-F5344CB8AC3E}">
-        <p14:creationId xmlns:p14="http://schemas.microsoft.com/office/powerpoint/2010/main" val="1282098564"/>
+        <p14:creationId xmlns:p14="http://schemas.microsoft.com/office/powerpoint/2010/main" val="2084766836"/>
       </p:ext>
     </p:extLst>
   </p:cSld>
@@ -36320,7 +36320,7 @@
           <p:cNvPr id="8" name="AMI: status and call control">
             <a:extLst xmlns:a="http://schemas.openxmlformats.org/drawingml/2006/main">
               <a:ext uri="{FF2B5EF4-FFF2-40B4-BE49-F238E27FC236}">
-                <a16:creationId xmlns:a16="http://schemas.microsoft.com/office/drawing/2014/main" id="{FC7B78A1-008A-418F-9962-D09DB2E583A7}"/>
+                <a16:creationId xmlns:a16="http://schemas.microsoft.com/office/drawing/2014/main" id="{BA971710-F646-4791-9A08-479A5F72824C}"/>
               </a:ext>
             </a:extLst>
           </p:cNvPr>
@@ -36478,7 +36478,7 @@
           <p:cNvPr id="2" name="09">
             <a:extLst xmlns:a="http://schemas.openxmlformats.org/drawingml/2006/main">
               <a:ext uri="{FF2B5EF4-FFF2-40B4-BE49-F238E27FC236}">
-                <a16:creationId xmlns:a16="http://schemas.microsoft.com/office/drawing/2014/main" id="{90AC7923-4663-4EE6-99FF-37687135F54E}"/>
+                <a16:creationId xmlns:a16="http://schemas.microsoft.com/office/drawing/2014/main" id="{466F114C-89BF-49B7-A46E-56A8F450787C}"/>
               </a:ext>
             </a:extLst>
           </p:cNvPr>
@@ -36636,7 +36636,7 @@
           <p:cNvPr id="3" name="Home Assistant connects to PBX:5038">
             <a:extLst xmlns:a="http://schemas.openxmlformats.org/drawingml/2006/main">
               <a:ext uri="{FF2B5EF4-FFF2-40B4-BE49-F238E27FC236}">
-                <a16:creationId xmlns:a16="http://schemas.microsoft.com/office/drawing/2014/main" id="{A51954D8-7D0E-4F16-815A-048DD8E19D01}"/>
+                <a16:creationId xmlns:a16="http://schemas.microsoft.com/office/drawing/2014/main" id="{5E67E888-C76C-44B2-A6BB-B82DEEB5AEFC}"/>
               </a:ext>
             </a:extLst>
           </p:cNvPr>
@@ -36794,7 +36794,7 @@
           <p:cNvPr id="4" name="Status, connected line and DTMF&#10;Actual entity IDs from your HA in">
             <a:extLst xmlns:a="http://schemas.openxmlformats.org/drawingml/2006/main">
               <a:ext uri="{FF2B5EF4-FFF2-40B4-BE49-F238E27FC236}">
-                <a16:creationId xmlns:a16="http://schemas.microsoft.com/office/drawing/2014/main" id="{712E1CFD-5512-4235-8644-6518B50D6237}"/>
+                <a16:creationId xmlns:a16="http://schemas.microsoft.com/office/drawing/2014/main" id="{B466EF99-84A6-43D4-8B68-702795F8B347}"/>
               </a:ext>
             </a:extLst>
           </p:cNvPr>
@@ -36975,7 +36975,7 @@
           <p:cNvPr id="5" name="Place calls and hang up a specific channel">
             <a:extLst xmlns:a="http://schemas.openxmlformats.org/drawingml/2006/main">
               <a:ext uri="{FF2B5EF4-FFF2-40B4-BE49-F238E27FC236}">
-                <a16:creationId xmlns:a16="http://schemas.microsoft.com/office/drawing/2014/main" id="{D678AF2D-6ABD-4BD4-8A73-FFFBA836629C}"/>
+                <a16:creationId xmlns:a16="http://schemas.microsoft.com/office/drawing/2014/main" id="{A45D67E9-A117-4F23-BCFE-A4C8BF6A3834}"/>
               </a:ext>
             </a:extLst>
           </p:cNvPr>
@@ -37133,7 +37133,7 @@
           <p:cNvPr id="6" name="asterisk.send_action: Originate / Hangup&#10;The DTMF example sends a">
             <a:extLst xmlns:a="http://schemas.openxmlformats.org/drawingml/2006/main">
               <a:ext uri="{FF2B5EF4-FFF2-40B4-BE49-F238E27FC236}">
-                <a16:creationId xmlns:a16="http://schemas.microsoft.com/office/drawing/2014/main" id="{793AC797-B6C1-4B83-B111-2BBBAB84AC4B}"/>
+                <a16:creationId xmlns:a16="http://schemas.microsoft.com/office/drawing/2014/main" id="{D9CE9CAA-C411-4148-BA15-F94545993208}"/>
               </a:ext>
             </a:extLst>
           </p:cNvPr>
@@ -37314,7 +37314,7 @@
           <p:cNvPr id="7" name="Use a separate secret and a /32 ACL. The system permission allows">
             <a:extLst xmlns:a="http://schemas.openxmlformats.org/drawingml/2006/main">
               <a:ext uri="{FF2B5EF4-FFF2-40B4-BE49-F238E27FC236}">
-                <a16:creationId xmlns:a16="http://schemas.microsoft.com/office/drawing/2014/main" id="{0913D359-75D6-4CA2-BA40-0DB67ED196A7}"/>
+                <a16:creationId xmlns:a16="http://schemas.microsoft.com/office/drawing/2014/main" id="{2E546900-950C-42E4-BD85-51449C192582}"/>
               </a:ext>
             </a:extLst>
           </p:cNvPr>
@@ -37470,7 +37470,7 @@
     </p:spTree>
     <p:extLst>
       <p:ext uri="{BB962C8B-B14F-4D97-AF65-F5344CB8AC3E}">
-        <p14:creationId xmlns:p14="http://schemas.microsoft.com/office/powerpoint/2010/main" val="1482419160"/>
+        <p14:creationId xmlns:p14="http://schemas.microsoft.com/office/powerpoint/2010/main" val="1676028873"/>
       </p:ext>
     </p:extLst>
   </p:cSld>

</xml_diff>

<commit_message>
Keep timers and alarms ringing until manually dismissed
</commit_message>
<xml_diff>
--- a/docs/slides/cisco-home-telephony.pptx
+++ b/docs/slides/cisco-home-telephony.pptx
@@ -2,30 +2,30 @@
 <file path=ppt/presentation.xml><?xml version="1.0" encoding="utf-8"?>
 <p:presentation xmlns:p="http://schemas.openxmlformats.org/presentationml/2006/main">
   <p:sldMasterIdLst>
-    <p:sldMasterId xmlns:r="http://schemas.openxmlformats.org/officeDocument/2006/relationships" id="2147483648" r:id="Rc60615b1ea994c6e"/>
+    <p:sldMasterId xmlns:r="http://schemas.openxmlformats.org/officeDocument/2006/relationships" id="2147483648" r:id="R6b1d9439fcfc432d"/>
   </p:sldMasterIdLst>
   <p:notesMasterIdLst>
-    <p:notesMasterId xmlns:r="http://schemas.openxmlformats.org/officeDocument/2006/relationships" r:id="Red0308d7f24a42f7"/>
+    <p:notesMasterId xmlns:r="http://schemas.openxmlformats.org/officeDocument/2006/relationships" r:id="Re762431093b2428b"/>
   </p:notesMasterIdLst>
   <p:sldIdLst>
-    <p:sldId xmlns:r="http://schemas.openxmlformats.org/officeDocument/2006/relationships" id="256" r:id="Rf680a2e95ae44a2a"/>
-    <p:sldId xmlns:r="http://schemas.openxmlformats.org/officeDocument/2006/relationships" id="257" r:id="Rbe3a4dbc74da42eb"/>
-    <p:sldId xmlns:r="http://schemas.openxmlformats.org/officeDocument/2006/relationships" id="258" r:id="R9a56e51a9a1b4c92"/>
-    <p:sldId xmlns:r="http://schemas.openxmlformats.org/officeDocument/2006/relationships" id="259" r:id="R4a6853c181ec49b7"/>
-    <p:sldId xmlns:r="http://schemas.openxmlformats.org/officeDocument/2006/relationships" id="260" r:id="R6ac73f7ae48948dd"/>
-    <p:sldId xmlns:r="http://schemas.openxmlformats.org/officeDocument/2006/relationships" id="261" r:id="R13a62048ce3d49fb"/>
-    <p:sldId xmlns:r="http://schemas.openxmlformats.org/officeDocument/2006/relationships" id="262" r:id="Rb1a076189df7400c"/>
-    <p:sldId xmlns:r="http://schemas.openxmlformats.org/officeDocument/2006/relationships" id="263" r:id="R8f46d56bf77c408b"/>
-    <p:sldId xmlns:r="http://schemas.openxmlformats.org/officeDocument/2006/relationships" id="264" r:id="Rbc4d8875a1f14856"/>
-    <p:sldId xmlns:r="http://schemas.openxmlformats.org/officeDocument/2006/relationships" id="265" r:id="Re916562666994f3b"/>
-    <p:sldId xmlns:r="http://schemas.openxmlformats.org/officeDocument/2006/relationships" id="266" r:id="Re86db2a43cd44283"/>
-    <p:sldId xmlns:r="http://schemas.openxmlformats.org/officeDocument/2006/relationships" id="267" r:id="R0baad21cfc02454d"/>
-    <p:sldId xmlns:r="http://schemas.openxmlformats.org/officeDocument/2006/relationships" id="268" r:id="R011339494f074099"/>
-    <p:sldId xmlns:r="http://schemas.openxmlformats.org/officeDocument/2006/relationships" id="269" r:id="Rc421db799f6641b5"/>
-    <p:sldId xmlns:r="http://schemas.openxmlformats.org/officeDocument/2006/relationships" id="270" r:id="R70feb78dd01b4be6"/>
-    <p:sldId xmlns:r="http://schemas.openxmlformats.org/officeDocument/2006/relationships" id="271" r:id="Rdfaf4f82ae4b4d4a"/>
-    <p:sldId xmlns:r="http://schemas.openxmlformats.org/officeDocument/2006/relationships" id="272" r:id="R46fa2b66ee454dcb"/>
-    <p:sldId xmlns:r="http://schemas.openxmlformats.org/officeDocument/2006/relationships" id="273" r:id="Re798a9f0e11045da"/>
+    <p:sldId xmlns:r="http://schemas.openxmlformats.org/officeDocument/2006/relationships" id="256" r:id="R738a6ac365354f8f"/>
+    <p:sldId xmlns:r="http://schemas.openxmlformats.org/officeDocument/2006/relationships" id="257" r:id="R87a285ce105240d5"/>
+    <p:sldId xmlns:r="http://schemas.openxmlformats.org/officeDocument/2006/relationships" id="258" r:id="Rb05e1d6956c24400"/>
+    <p:sldId xmlns:r="http://schemas.openxmlformats.org/officeDocument/2006/relationships" id="259" r:id="R2eb1a21fe75c43e9"/>
+    <p:sldId xmlns:r="http://schemas.openxmlformats.org/officeDocument/2006/relationships" id="260" r:id="Rc6bb8c5a300446ff"/>
+    <p:sldId xmlns:r="http://schemas.openxmlformats.org/officeDocument/2006/relationships" id="261" r:id="R6acb425a66f64d77"/>
+    <p:sldId xmlns:r="http://schemas.openxmlformats.org/officeDocument/2006/relationships" id="262" r:id="R1974764f0de244d4"/>
+    <p:sldId xmlns:r="http://schemas.openxmlformats.org/officeDocument/2006/relationships" id="263" r:id="R5144dc86c67c4646"/>
+    <p:sldId xmlns:r="http://schemas.openxmlformats.org/officeDocument/2006/relationships" id="264" r:id="R9550e6cd3a8d435e"/>
+    <p:sldId xmlns:r="http://schemas.openxmlformats.org/officeDocument/2006/relationships" id="265" r:id="R3d13d94e4d4b41d0"/>
+    <p:sldId xmlns:r="http://schemas.openxmlformats.org/officeDocument/2006/relationships" id="266" r:id="Rb83da82ba9244179"/>
+    <p:sldId xmlns:r="http://schemas.openxmlformats.org/officeDocument/2006/relationships" id="267" r:id="R3c17022989f74b47"/>
+    <p:sldId xmlns:r="http://schemas.openxmlformats.org/officeDocument/2006/relationships" id="268" r:id="Rbbe016339ad74f1a"/>
+    <p:sldId xmlns:r="http://schemas.openxmlformats.org/officeDocument/2006/relationships" id="269" r:id="Rb701a190f29249da"/>
+    <p:sldId xmlns:r="http://schemas.openxmlformats.org/officeDocument/2006/relationships" id="270" r:id="Rbfea24c8d99a45c8"/>
+    <p:sldId xmlns:r="http://schemas.openxmlformats.org/officeDocument/2006/relationships" id="271" r:id="Rdde9d8f79934451a"/>
+    <p:sldId xmlns:r="http://schemas.openxmlformats.org/officeDocument/2006/relationships" id="272" r:id="Ree2640ddacdd424a"/>
+    <p:sldId xmlns:r="http://schemas.openxmlformats.org/officeDocument/2006/relationships" id="273" r:id="R8085a85832a94cb0"/>
   </p:sldIdLst>
   <p:sldSz cx="12192000" cy="6858000"/>
   <p:notesSz cx="6858000" cy="9144000"/>
@@ -459,7 +459,7 @@
           <a:lstStyle xmlns:a="http://schemas.openxmlformats.org/drawingml/2006/main"/>
           <a:p xmlns:a="http://schemas.openxmlformats.org/drawingml/2006/main">
             <a:r>
-              <a:t>The purchased lot contained 10 Cisco 7945G phones. The eBay delivery email dated December 1, 2022 confirms the model. Shipping and payment details are excluded from the repository. Inventory each remaining phone to establish its condition and firmware. Updated October 17, 2026. These slides describe the architecture and deployment process. Actual installation and call results belong in the separate acceptance record.</a:t>
+              <a:t>Cisco 7945G phones provide a color display, two line buttons and native IEEE 802.3af PoE. This project uses one or two independently authenticated SIP lines per phone, Asterisk in k3s and Home Assistant. Verify the model, hardware revision and installed firmware on each physical phone before generating its configuration. These slides describe the architecture and deployment process. The acceptance record separates component tests from actual call and audio results.</a:t>
             </a:r>
           </a:p>
         </p:txBody>
@@ -829,7 +829,7 @@
           <a:lstStyle xmlns:a="http://schemas.openxmlformats.org/drawingml/2006/main"/>
           <a:p xmlns:a="http://schemas.openxmlformats.org/drawingml/2006/main">
             <a:r>
-              <a:t>Record actual hardware results in a separate private acceptance log. These slides describe preparation and acceptance criteria. Inventory the surviving devices to record PID/HW/MAC, App Load, network addresses and power. Automated tests verify components and configuration. Physical acceptance covers audio, HA call control, DTMF and Assist on real phones. After the pilot passes, add the remaining phones one at a time.</a:t>
+              <a:t>Record actual hardware results in a separate private acceptance log. These slides describe preparation and acceptance criteria. Inventory each device to record PID/HW/MAC, App Load, network addresses and power. Automated tests verify components and configuration. Physical acceptance covers audio, HA call control, DTMF and Assist on real phones. After the pilot passes, add the remaining phones one at a time.</a:t>
             </a:r>
           </a:p>
         </p:txBody>
@@ -969,7 +969,7 @@
           <a:lstStyle xmlns:a="http://schemas.openxmlformats.org/drawingml/2006/main"/>
           <a:p xmlns:a="http://schemas.openxmlformats.org/drawingml/2006/main">
             <a:r>
-              <a:t>The four-phone control integration exposes 120 entities. It preserves the separate TECH7Fox Asterisk and native HA VoIP integrations. Timers and weekday alarms persist and record each occurrence before a single ring request. Missed events, busy phones, DND and ambiguous API results do not retry automatically. DND is a persistent gateway/PBX preference restored after Asterisk restart. Gateway auto-answer is opt-in, off by default, and acts only on one fresh incoming Ringing channel. Text and local approved images use authenticated phone CGI with short-lived source-restricted content. Exclude text and countdown entities from Recorder. Live feature acceptance remains underway. Sources: https://github.com/ha-homelab/asterisk-telephony/blob/main/docs/phone-controls.md and https://github.com/4alvit/cisco-home-telephony/blob/main/docs/phone-gateway.md</a:t>
+              <a:t>The updated four-phone integration defines 116 entities. Deployment and live acceptance of the revised alert contract are pending. It removes Alarm sound and Timer sound selectors and adds Stop alert. Timers and weekday alarms keep ringing until a person answers or rejects at the phone, presses Stop alert, cancels the active timer, or disables the active alarm. They never auto-answer and play no audio after answering. HA Answer is blocked for alert channels. The gateway persists alert identities and reconciles the same channels after a gateway restart without replaying events after PBX or power loss. Normal calls retain optional auto-answer, off by default. The separate TECH7Fox Asterisk and native HA VoIP integrations remain in use. Earlier finite-tone tests do not validate the new behavior. Existing saved pilot evidence covers normal gateway calls, exact-channel Hangup, DND and displayed text/PNG content. Sources: docs/server-validation.md, docs/phone-gateway.md and https://github.com/ha-homelab/asterisk-telephony/blob/main/docs/phone-controls.md .</a:t>
             </a:r>
           </a:p>
         </p:txBody>
@@ -1039,7 +1039,7 @@
           <a:lstStyle xmlns:a="http://schemas.openxmlformats.org/drawingml/2006/main"/>
           <a:p xmlns:a="http://schemas.openxmlformats.org/drawingml/2006/main">
             <a:r>
-              <a:t>Alarm640 plays a finite local tone on answer, capped at 30 seconds, then hangs up. HA rings for up to 20 seconds and does not retry busy, DND or missed events. Radio is opt-in and starts a bounded FFmpeg/AudioSocket worker only for the active call. The default limit is 30 minutes, with 2 concurrent streams. Stream host allowlists and network validation prevent arbitrary URL fetching. The seven official stream sources decoded successfully in the worker probe on October 17, 2026. That is distinct from each handset's live audio acceptance, which remains underway. Source documentation: https://github.com/4alvit/cisco-home-telephony/blob/main/docs/radio-and-alarms.md . Official stations: https://matryoshka.fm/ , https://echofm.online/ , https://streams.radiobob.de/ , https://somafm.com/poptron/directstreamlinks.html , https://www.radyoviva.com.tr/ .</a:t>
+              <a:t>The new timer/alarm contract rings until a person answers, rejects or stops the alert. It never auto-answers or plays after-answer audio. Deployment and live acceptance of that revised behavior are pending. A private Asterisk Local helper omits Dial timeout, ignores forwarding and uses WaitForSignal without an interval. The five-second AMI timeout bounds only the initial Local answer, not handset ringing. Manual 640 remains a finite tone test and the old 20-second ring API remains a legacy finite call, neither used by the new scheduler. Radio is unchanged: an opt-in FFmpeg/AudioSocket worker runs only for the active call, with a default 30-minute limit and two concurrent streams. All seven official streams decoded in the saved probe, and radio 701 reached Up with increasing bidirectional RTP counters and exact-channel cleanup. Human confirmation of radio audibility remains separate. Sources: docs/server-validation.md and docs/radio-and-alarms.md . Official stations: https://matryoshka.fm/ , https://echofm.online/ , https://streams.radiobob.de/ , https://somafm.com/poptron/directstreamlinks.html , https://www.radyoviva.com.tr/ .</a:t>
             </a:r>
           </a:p>
         </p:txBody>
@@ -1109,7 +1109,7 @@
           <a:lstStyle xmlns:a="http://schemas.openxmlformats.org/drawingml/2006/main"/>
           <a:p xmlns:a="http://schemas.openxmlformats.org/drawingml/2006/main">
             <a:r>
-              <a:t>Status snapshot: October 17, 2026. SIP2SIP, Callcentric and Linphone all reached Registered in the live Asterisk instance. Callcentric IP Freedom account activation completed with a $0 plan and $0 balance, but the provider dashboard blocks outbound calls pending risk review by support. Callcentric and Linphone are registration-only, with no active 801 or 803 dial route; Linphone still needs an explicitly verified free peer. SIP2SIP 802 targets the official 4444 echo destination. Its external audio pilot was deferred at the user's request, so registration is verified but external call media is not. Free accounts do not imply free PSTN calls. FWD issued credentials but its mandatory identity-verification flow opened a Verification Fee checkout, so activation stopped. Google Voice supplies no official free generic Asterisk SIP trunk. Working external calls require an answered call and bidirectional RTP evidence in addition to REGISTER. Sources: https://sip2sip.info/help/ ; https://www.callcentric.com/rate/plans/ip_freedom/ ; https://www.callcentric.com/support/device/asterisk/17_pjsip ; https://www.linphone.org/en/faq/ ; https://www.fwdialup.com/mission ; https://knowledge.workspace.google.com/admin/voice/sip-link-requirements ; docs/external-sip.md and docs/extended-services-research.md.</a:t>
+              <a:t>Status snapshot: October 17, 2026. SIP2SIP, Callcentric and Linphone all reached Registered in the live Asterisk instance. Callcentric IP Freedom has a $0 plan and $0 balance, but outbound calls require provider risk review. Callcentric and Linphone remain registration-only with no active 801/803 route, and Linphone needs a verified free peer. The bounded SIP2SIP 802 call to its fixed 4444 echo destination answered and exchanged RTP in both directions. Local receive-loss counts increased from 42 to 91 between samples, reporting 49 additional missing packets. These samples do not establish an exact overall loss percentage or cause. Reported RTT was about 155 ms. All eight local lines remained available and owned channels were cleaned up. Human listening and satisfactory external audio quality are not claimed. Free accounts do not imply free PSTN. FWD stopped at its mandatory Verification Fee checkout. Google Voice supplies no official free generic Asterisk SIP trunk. Sources: https://sip2sip.info/help/ ; https://www.callcentric.com/rate/plans/ip_freedom/ ; https://www.callcentric.com/support/device/asterisk/17_pjsip ; https://www.linphone.org/en/faq/ ; https://www.fwdialup.com/mission ; https://knowledge.workspace.google.com/admin/voice/sip-link-requirements ; docs/server-validation.md and docs/external-sip.md .</a:t>
             </a:r>
           </a:p>
         </p:txBody>
@@ -1179,7 +1179,7 @@
           <a:lstStyle xmlns:a="http://schemas.openxmlformats.org/drawingml/2006/main"/>
           <a:p xmlns:a="http://schemas.openxmlformats.org/drawingml/2006/main">
             <a:r>
-              <a:t>The eBay delivery email dated December 1, 2022 confirms the model and quantity. Cisco firmware family 7945_7965: https://www.cisco.com/web/software/282074288/128566/cmterm-7945_7965-sip.9-4-2SR2-2-readme.html</a:t>
+              <a:t>The Cisco 7945G has two line buttons, a color display and native IEEE 802.3af PoE. The generator supports one or two independent SIP lines with separate credentials, preserving existing passwords when another line is added. Confirm PID, VID/HW, MAC and firmware directly on each phone. Cisco firmware family 7945_7965: https://www.cisco.com/web/software/282074288/128566/cmterm-7945_7965-sip.9-4-2SR2-2-readme.html</a:t>
             </a:r>
           </a:p>
           <a:p xmlns:a="http://schemas.openxmlformats.org/drawingml/2006/main">
@@ -1791,7 +1791,7 @@
           <p:cNvPr id="3" name="Title">
             <a:extLst xmlns:a="http://schemas.openxmlformats.org/drawingml/2006/main">
               <a:ext uri="{FF2B5EF4-FFF2-40B4-BE49-F238E27FC236}">
-                <a16:creationId xmlns:a16="http://schemas.microsoft.com/office/drawing/2014/main" id="{1AD149AB-ABB9-4042-B0D9-2434C853CEDB}"/>
+                <a16:creationId xmlns:a16="http://schemas.microsoft.com/office/drawing/2014/main" id="{8A4AE083-E773-4FCA-9A3F-15379D621CE2}"/>
               </a:ext>
             </a:extLst>
           </p:cNvPr>
@@ -2020,7 +2020,7 @@
           <p:cNvPr id="2" name="Subtitle">
             <a:extLst xmlns:a="http://schemas.openxmlformats.org/drawingml/2006/main">
               <a:ext uri="{FF2B5EF4-FFF2-40B4-BE49-F238E27FC236}">
-                <a16:creationId xmlns:a16="http://schemas.microsoft.com/office/drawing/2014/main" id="{859D3B9E-F704-4EB2-9D99-7E8914737A18}"/>
+                <a16:creationId xmlns:a16="http://schemas.microsoft.com/office/drawing/2014/main" id="{CF51AB31-9FC6-4775-87A1-DE09FE35EFAE}"/>
               </a:ext>
             </a:extLst>
           </p:cNvPr>
@@ -2266,7 +2266,7 @@
           <p:cNvPr id="2" name="Section title">
             <a:extLst xmlns:a="http://schemas.openxmlformats.org/drawingml/2006/main">
               <a:ext uri="{FF2B5EF4-FFF2-40B4-BE49-F238E27FC236}">
-                <a16:creationId xmlns:a16="http://schemas.microsoft.com/office/drawing/2014/main" id="{7B1AEB8A-A6E4-4478-89DB-99E2D48075E1}"/>
+                <a16:creationId xmlns:a16="http://schemas.microsoft.com/office/drawing/2014/main" id="{C7FC7E64-167B-4C39-8671-F216B5DB5F20}"/>
               </a:ext>
             </a:extLst>
           </p:cNvPr>
@@ -2512,7 +2512,7 @@
           <p:cNvPr id="3" name="Title">
             <a:extLst xmlns:a="http://schemas.openxmlformats.org/drawingml/2006/main">
               <a:ext uri="{FF2B5EF4-FFF2-40B4-BE49-F238E27FC236}">
-                <a16:creationId xmlns:a16="http://schemas.microsoft.com/office/drawing/2014/main" id="{0A75401D-4611-4749-B64B-8A843DE419A1}"/>
+                <a16:creationId xmlns:a16="http://schemas.microsoft.com/office/drawing/2014/main" id="{87B066BE-A106-4BE0-BECA-D9927784AD6F}"/>
               </a:ext>
             </a:extLst>
           </p:cNvPr>
@@ -2741,7 +2741,7 @@
           <p:cNvPr id="2" name="Body">
             <a:extLst xmlns:a="http://schemas.openxmlformats.org/drawingml/2006/main">
               <a:ext uri="{FF2B5EF4-FFF2-40B4-BE49-F238E27FC236}">
-                <a16:creationId xmlns:a16="http://schemas.microsoft.com/office/drawing/2014/main" id="{7C5EEA92-2B24-4097-8B88-97478A0B1366}"/>
+                <a16:creationId xmlns:a16="http://schemas.microsoft.com/office/drawing/2014/main" id="{D594AE61-EE91-4925-BC7F-249734BA9D39}"/>
               </a:ext>
             </a:extLst>
           </p:cNvPr>
@@ -2987,7 +2987,7 @@
           <p:cNvPr id="4" name="Title">
             <a:extLst xmlns:a="http://schemas.openxmlformats.org/drawingml/2006/main">
               <a:ext uri="{FF2B5EF4-FFF2-40B4-BE49-F238E27FC236}">
-                <a16:creationId xmlns:a16="http://schemas.microsoft.com/office/drawing/2014/main" id="{2473EB3C-A760-4EB7-AF42-F1B00BA7BD91}"/>
+                <a16:creationId xmlns:a16="http://schemas.microsoft.com/office/drawing/2014/main" id="{B33D108E-1E13-49AA-82CC-2BE6928CBA43}"/>
               </a:ext>
             </a:extLst>
           </p:cNvPr>
@@ -3216,7 +3216,7 @@
           <p:cNvPr id="2" name="Left column">
             <a:extLst xmlns:a="http://schemas.openxmlformats.org/drawingml/2006/main">
               <a:ext uri="{FF2B5EF4-FFF2-40B4-BE49-F238E27FC236}">
-                <a16:creationId xmlns:a16="http://schemas.microsoft.com/office/drawing/2014/main" id="{1D21B46E-AE81-42D1-9624-ED0FDB6980B4}"/>
+                <a16:creationId xmlns:a16="http://schemas.microsoft.com/office/drawing/2014/main" id="{C68AC5DE-15F9-4A6D-B145-C2E0C7968C55}"/>
               </a:ext>
             </a:extLst>
           </p:cNvPr>
@@ -3445,7 +3445,7 @@
           <p:cNvPr id="3" name="Right column">
             <a:extLst xmlns:a="http://schemas.openxmlformats.org/drawingml/2006/main">
               <a:ext uri="{FF2B5EF4-FFF2-40B4-BE49-F238E27FC236}">
-                <a16:creationId xmlns:a16="http://schemas.microsoft.com/office/drawing/2014/main" id="{C374C08D-B727-44B9-97C1-47F34023BF58}"/>
+                <a16:creationId xmlns:a16="http://schemas.microsoft.com/office/drawing/2014/main" id="{AB9D3ADF-90C9-4962-93CB-C5E2688EE844}"/>
               </a:ext>
             </a:extLst>
           </p:cNvPr>
@@ -3691,7 +3691,7 @@
           <p:cNvPr id="3" name="Title">
             <a:extLst xmlns:a="http://schemas.openxmlformats.org/drawingml/2006/main">
               <a:ext uri="{FF2B5EF4-FFF2-40B4-BE49-F238E27FC236}">
-                <a16:creationId xmlns:a16="http://schemas.microsoft.com/office/drawing/2014/main" id="{83F6A7C2-853E-4B03-85E6-B862B4CBE038}"/>
+                <a16:creationId xmlns:a16="http://schemas.microsoft.com/office/drawing/2014/main" id="{D021B72D-7A9D-42FC-973F-E7EAD54C04FE}"/>
               </a:ext>
             </a:extLst>
           </p:cNvPr>
@@ -3920,7 +3920,7 @@
           <p:cNvPr id="2" name="Left column">
             <a:extLst xmlns:a="http://schemas.openxmlformats.org/drawingml/2006/main">
               <a:ext uri="{FF2B5EF4-FFF2-40B4-BE49-F238E27FC236}">
-                <a16:creationId xmlns:a16="http://schemas.microsoft.com/office/drawing/2014/main" id="{CE5044DC-D96E-4A6F-AD97-DBB76BB65751}"/>
+                <a16:creationId xmlns:a16="http://schemas.microsoft.com/office/drawing/2014/main" id="{D501A880-2006-4E84-9E45-6CD1C4F51D63}"/>
               </a:ext>
             </a:extLst>
           </p:cNvPr>
@@ -4187,12 +4187,12 @@
   </p:cSld>
   <p:clrMap bg1="lt1" tx1="dk1" bg2="lt2" tx2="dk2" accent1="accent1" accent2="accent2" accent3="accent3" accent4="accent4" accent5="accent5" accent6="accent6" hlink="hlink" folHlink="folHlink"/>
   <p:sldLayoutIdLst>
-    <p:sldLayoutId xmlns:r="http://schemas.openxmlformats.org/officeDocument/2006/relationships" id="2147483649" r:id="Rde5d239d68234a9b"/>
-    <p:sldLayoutId xmlns:r="http://schemas.openxmlformats.org/officeDocument/2006/relationships" id="2147483650" r:id="R5d3d64e130a84a15"/>
-    <p:sldLayoutId xmlns:r="http://schemas.openxmlformats.org/officeDocument/2006/relationships" id="2147483651" r:id="R15b2b6745c574089"/>
-    <p:sldLayoutId xmlns:r="http://schemas.openxmlformats.org/officeDocument/2006/relationships" id="2147483652" r:id="R870dc5cffd124297"/>
-    <p:sldLayoutId xmlns:r="http://schemas.openxmlformats.org/officeDocument/2006/relationships" id="2147483653" r:id="R656aacb3f90f4641"/>
-    <p:sldLayoutId xmlns:r="http://schemas.openxmlformats.org/officeDocument/2006/relationships" id="2147483654" r:id="Rbc1bb7cb833e491f"/>
+    <p:sldLayoutId xmlns:r="http://schemas.openxmlformats.org/officeDocument/2006/relationships" id="2147483649" r:id="R01bbb42a282b444a"/>
+    <p:sldLayoutId xmlns:r="http://schemas.openxmlformats.org/officeDocument/2006/relationships" id="2147483650" r:id="R17a9f149abda441d"/>
+    <p:sldLayoutId xmlns:r="http://schemas.openxmlformats.org/officeDocument/2006/relationships" id="2147483651" r:id="R7d05ba6bdf5e4253"/>
+    <p:sldLayoutId xmlns:r="http://schemas.openxmlformats.org/officeDocument/2006/relationships" id="2147483652" r:id="Rb4aa8b3c4d4e4f96"/>
+    <p:sldLayoutId xmlns:r="http://schemas.openxmlformats.org/officeDocument/2006/relationships" id="2147483653" r:id="R6b971fc6e0464367"/>
+    <p:sldLayoutId xmlns:r="http://schemas.openxmlformats.org/officeDocument/2006/relationships" id="2147483654" r:id="R7d2b9a81dbef4196"/>
   </p:sldLayoutIdLst>
   <p:txStyles>
     <p:titleStyle>
@@ -4743,7 +4743,7 @@
           <p:cNvPr id="7" name="">
             <a:extLst xmlns:a="http://schemas.openxmlformats.org/drawingml/2006/main">
               <a:ext uri="{FF2B5EF4-FFF2-40B4-BE49-F238E27FC236}">
-                <a16:creationId xmlns:a16="http://schemas.microsoft.com/office/drawing/2014/main" id="{7C8EBC48-80CB-4929-B6CF-7F225CD6FCF7}"/>
+                <a16:creationId xmlns:a16="http://schemas.microsoft.com/office/drawing/2014/main" id="{1AADA708-8FE7-423D-A0C5-594AC3A2771B}"/>
               </a:ext>
             </a:extLst>
           </p:cNvPr>
@@ -4883,7 +4883,7 @@
           <p:cNvPr id="2" name="01">
             <a:extLst xmlns:a="http://schemas.openxmlformats.org/drawingml/2006/main">
               <a:ext uri="{FF2B5EF4-FFF2-40B4-BE49-F238E27FC236}">
-                <a16:creationId xmlns:a16="http://schemas.microsoft.com/office/drawing/2014/main" id="{2541CC7F-7BEF-4B38-951C-2C03E13EDD07}"/>
+                <a16:creationId xmlns:a16="http://schemas.microsoft.com/office/drawing/2014/main" id="{C23F6607-E4A4-415C-85E2-59377A50D274}"/>
               </a:ext>
             </a:extLst>
           </p:cNvPr>
@@ -5041,7 +5041,7 @@
           <p:cNvPr id="3" name="Cisco 7945G">
             <a:extLst xmlns:a="http://schemas.openxmlformats.org/drawingml/2006/main">
               <a:ext uri="{FF2B5EF4-FFF2-40B4-BE49-F238E27FC236}">
-                <a16:creationId xmlns:a16="http://schemas.microsoft.com/office/drawing/2014/main" id="{1A889EAD-9F45-488B-BED6-F6DFA6BD848D}"/>
+                <a16:creationId xmlns:a16="http://schemas.microsoft.com/office/drawing/2014/main" id="{87F4F466-2743-4D70-88ED-BF900E44AD64}"/>
               </a:ext>
             </a:extLst>
           </p:cNvPr>
@@ -5199,7 +5199,7 @@
           <p:cNvPr id="4" name="Home telephony">
             <a:extLst xmlns:a="http://schemas.openxmlformats.org/drawingml/2006/main">
               <a:ext uri="{FF2B5EF4-FFF2-40B4-BE49-F238E27FC236}">
-                <a16:creationId xmlns:a16="http://schemas.microsoft.com/office/drawing/2014/main" id="{32CCFCE1-DC68-4314-A8CC-08885F58BF96}"/>
+                <a16:creationId xmlns:a16="http://schemas.microsoft.com/office/drawing/2014/main" id="{6C280C33-2E90-4A0A-8B4B-D0DBBC04FCDF}"/>
               </a:ext>
             </a:extLst>
           </p:cNvPr>
@@ -5357,7 +5357,7 @@
           <p:cNvPr id="5" name="Asterisk in k3s + Home Assistant">
             <a:extLst xmlns:a="http://schemas.openxmlformats.org/drawingml/2006/main">
               <a:ext uri="{FF2B5EF4-FFF2-40B4-BE49-F238E27FC236}">
-                <a16:creationId xmlns:a16="http://schemas.microsoft.com/office/drawing/2014/main" id="{524CBB45-1AC0-4264-9193-9D52FFD455A4}"/>
+                <a16:creationId xmlns:a16="http://schemas.microsoft.com/office/drawing/2014/main" id="{2F777557-8AB4-4258-A014-2239C4AD23A7}"/>
               </a:ext>
             </a:extLst>
           </p:cNvPr>
@@ -5512,10 +5512,10 @@
       </p:sp>
       <p:sp>
         <p:nvSpPr>
-          <p:cNvPr id="6" name="10 phones with color displays">
+          <p:cNvPr id="6" name="Two SIP lines, color display and native PoE">
             <a:extLst xmlns:a="http://schemas.openxmlformats.org/drawingml/2006/main">
               <a:ext uri="{FF2B5EF4-FFF2-40B4-BE49-F238E27FC236}">
-                <a16:creationId xmlns:a16="http://schemas.microsoft.com/office/drawing/2014/main" id="{4C13FBAF-DDEA-4A4C-B48B-2F7F7B8EE1B0}"/>
+                <a16:creationId xmlns:a16="http://schemas.microsoft.com/office/drawing/2014/main" id="{DF60E4C8-349D-4CAE-BE1D-3367BA7EB5E8}"/>
               </a:ext>
             </a:extLst>
           </p:cNvPr>
@@ -5663,7 +5663,7 @@
                 <a:ea typeface="Arial"/>
                 <a:cs typeface="Arial"/>
               </a:rPr>
-              <a:t>10 phones with color displays</a:t>
+              <a:t>Two SIP lines, color display and native PoE</a:t>
             </a:r>
           </a:p>
         </p:txBody>
@@ -5671,7 +5671,7 @@
     </p:spTree>
     <p:extLst>
       <p:ext uri="{BB962C8B-B14F-4D97-AF65-F5344CB8AC3E}">
-        <p14:creationId xmlns:p14="http://schemas.microsoft.com/office/powerpoint/2010/main" val="750955465"/>
+        <p14:creationId xmlns:p14="http://schemas.microsoft.com/office/powerpoint/2010/main" val="1876094407"/>
       </p:ext>
     </p:extLst>
   </p:cSld>
@@ -5702,7 +5702,7 @@
           <p:cNvPr id="8" name="">
             <a:extLst xmlns:a="http://schemas.openxmlformats.org/drawingml/2006/main">
               <a:ext uri="{FF2B5EF4-FFF2-40B4-BE49-F238E27FC236}">
-                <a16:creationId xmlns:a16="http://schemas.microsoft.com/office/drawing/2014/main" id="{F488C894-9C9B-4837-A2DB-CD16A47A52E6}"/>
+                <a16:creationId xmlns:a16="http://schemas.microsoft.com/office/drawing/2014/main" id="{71F3638D-5753-42B3-8776-ED988551E847}"/>
               </a:ext>
             </a:extLst>
           </p:cNvPr>
@@ -5734,7 +5734,7 @@
           <p:cNvPr id="6" name="">
             <a:extLst xmlns:a="http://schemas.openxmlformats.org/drawingml/2006/main">
               <a:ext uri="{FF2B5EF4-FFF2-40B4-BE49-F238E27FC236}">
-                <a16:creationId xmlns:a16="http://schemas.microsoft.com/office/drawing/2014/main" id="{BC5F423D-BB1C-4BF2-A2F3-ABD4D02E9194}"/>
+                <a16:creationId xmlns:a16="http://schemas.microsoft.com/office/drawing/2014/main" id="{87AD7674-32BD-49C4-9460-A4B70BA207B5}"/>
               </a:ext>
             </a:extLst>
           </p:cNvPr>
@@ -5766,7 +5766,7 @@
           <p:cNvPr id="12" name="630: voice assistant on the phone">
             <a:extLst xmlns:a="http://schemas.openxmlformats.org/drawingml/2006/main">
               <a:ext uri="{FF2B5EF4-FFF2-40B4-BE49-F238E27FC236}">
-                <a16:creationId xmlns:a16="http://schemas.microsoft.com/office/drawing/2014/main" id="{2A14ED1B-3755-4C25-B907-973D3483BDC5}"/>
+                <a16:creationId xmlns:a16="http://schemas.microsoft.com/office/drawing/2014/main" id="{5FE4BFFD-0EF3-42D9-A183-8DBD38FF9272}"/>
               </a:ext>
             </a:extLst>
           </p:cNvPr>
@@ -5924,7 +5924,7 @@
           <p:cNvPr id="2" name="10">
             <a:extLst xmlns:a="http://schemas.openxmlformats.org/drawingml/2006/main">
               <a:ext uri="{FF2B5EF4-FFF2-40B4-BE49-F238E27FC236}">
-                <a16:creationId xmlns:a16="http://schemas.microsoft.com/office/drawing/2014/main" id="{5ADC4242-02E7-4E37-92A9-46D63C0F7E03}"/>
+                <a16:creationId xmlns:a16="http://schemas.microsoft.com/office/drawing/2014/main" id="{9740FD00-D03A-45E3-8CA8-053867DF616E}"/>
               </a:ext>
             </a:extLst>
           </p:cNvPr>
@@ -6082,7 +6082,7 @@
           <p:cNvPr id="3" name="cisco">
             <a:extLst xmlns:a="http://schemas.openxmlformats.org/drawingml/2006/main">
               <a:ext uri="{FF2B5EF4-FFF2-40B4-BE49-F238E27FC236}">
-                <a16:creationId xmlns:a16="http://schemas.microsoft.com/office/drawing/2014/main" id="{98BD7DE8-7124-4242-8866-FE4EFACF98B3}"/>
+                <a16:creationId xmlns:a16="http://schemas.microsoft.com/office/drawing/2014/main" id="{4EB28B63-AC93-483B-824F-43D7C661192E}"/>
               </a:ext>
             </a:extLst>
           </p:cNvPr>
@@ -6292,7 +6292,7 @@
           <p:cNvPr id="4" name="codec">
             <a:extLst xmlns:a="http://schemas.openxmlformats.org/drawingml/2006/main">
               <a:ext uri="{FF2B5EF4-FFF2-40B4-BE49-F238E27FC236}">
-                <a16:creationId xmlns:a16="http://schemas.microsoft.com/office/drawing/2014/main" id="{96850ACD-1DD4-4EC3-9A58-2E0BEF594AFC}"/>
+                <a16:creationId xmlns:a16="http://schemas.microsoft.com/office/drawing/2014/main" id="{70F68679-3C4B-4584-9F54-D356C659CB82}"/>
               </a:ext>
             </a:extLst>
           </p:cNvPr>
@@ -6502,7 +6502,7 @@
           <p:cNvPr id="5" name="assist">
             <a:extLst xmlns:a="http://schemas.openxmlformats.org/drawingml/2006/main">
               <a:ext uri="{FF2B5EF4-FFF2-40B4-BE49-F238E27FC236}">
-                <a16:creationId xmlns:a16="http://schemas.microsoft.com/office/drawing/2014/main" id="{D8C4A134-B44A-41DB-B4E1-737807D36A6F}"/>
+                <a16:creationId xmlns:a16="http://schemas.microsoft.com/office/drawing/2014/main" id="{C0155203-9CA4-4810-A946-56093ADF57C0}"/>
               </a:ext>
             </a:extLst>
           </p:cNvPr>
@@ -6712,7 +6712,7 @@
           <p:cNvPr id="7" name="SIP TCP&#10;RTP">
             <a:extLst xmlns:a="http://schemas.openxmlformats.org/drawingml/2006/main">
               <a:ext uri="{FF2B5EF4-FFF2-40B4-BE49-F238E27FC236}">
-                <a16:creationId xmlns:a16="http://schemas.microsoft.com/office/drawing/2014/main" id="{73F96A49-028A-4802-BEDF-B155E75CA08A}"/>
+                <a16:creationId xmlns:a16="http://schemas.microsoft.com/office/drawing/2014/main" id="{868EF98B-507F-4F1C-BC62-C8A15671FF85}"/>
               </a:ext>
             </a:extLst>
           </p:cNvPr>
@@ -6893,7 +6893,7 @@
           <p:cNvPr id="9" name="SIP UDP&#10;RTP">
             <a:extLst xmlns:a="http://schemas.openxmlformats.org/drawingml/2006/main">
               <a:ext uri="{FF2B5EF4-FFF2-40B4-BE49-F238E27FC236}">
-                <a16:creationId xmlns:a16="http://schemas.microsoft.com/office/drawing/2014/main" id="{5C5B67BF-C164-40B7-BE3D-BB941AE6E115}"/>
+                <a16:creationId xmlns:a16="http://schemas.microsoft.com/office/drawing/2014/main" id="{A8752E6B-6565-48A5-AE03-3C113E9C6AB4}"/>
               </a:ext>
             </a:extLst>
           </p:cNvPr>
@@ -7074,7 +7074,7 @@
           <p:cNvPr id="10" name="First call: enable Allow calls and select a pipeline in HA.&#10;Then ">
             <a:extLst xmlns:a="http://schemas.openxmlformats.org/drawingml/2006/main">
               <a:ext uri="{FF2B5EF4-FFF2-40B4-BE49-F238E27FC236}">
-                <a16:creationId xmlns:a16="http://schemas.microsoft.com/office/drawing/2014/main" id="{07E209F2-BE8F-4045-8D2F-9F9C5BDFE7AC}"/>
+                <a16:creationId xmlns:a16="http://schemas.microsoft.com/office/drawing/2014/main" id="{435155FB-E3C8-4C79-BF45-9FA0290FF0D9}"/>
               </a:ext>
             </a:extLst>
           </p:cNvPr>
@@ -7255,7 +7255,7 @@
           <p:cNvPr id="11" name="SIP From retains the phone extension. HA uses dynamic UDP ports f">
             <a:extLst xmlns:a="http://schemas.openxmlformats.org/drawingml/2006/main">
               <a:ext uri="{FF2B5EF4-FFF2-40B4-BE49-F238E27FC236}">
-                <a16:creationId xmlns:a16="http://schemas.microsoft.com/office/drawing/2014/main" id="{19E7FC60-419B-4AC2-B9AE-2F558E9AE395}"/>
+                <a16:creationId xmlns:a16="http://schemas.microsoft.com/office/drawing/2014/main" id="{C5A084BC-1C04-4056-8857-E19B62C5DC38}"/>
               </a:ext>
             </a:extLst>
           </p:cNvPr>
@@ -7434,7 +7434,7 @@
     </p:spTree>
     <p:extLst>
       <p:ext uri="{BB962C8B-B14F-4D97-AF65-F5344CB8AC3E}">
-        <p14:creationId xmlns:p14="http://schemas.microsoft.com/office/powerpoint/2010/main" val="1758282477"/>
+        <p14:creationId xmlns:p14="http://schemas.microsoft.com/office/powerpoint/2010/main" val="2051003519"/>
       </p:ext>
     </p:extLst>
   </p:cSld>
@@ -7465,7 +7465,7 @@
           <p:cNvPr id="15" name="Deployment and commissioning">
             <a:extLst xmlns:a="http://schemas.openxmlformats.org/drawingml/2006/main">
               <a:ext uri="{FF2B5EF4-FFF2-40B4-BE49-F238E27FC236}">
-                <a16:creationId xmlns:a16="http://schemas.microsoft.com/office/drawing/2014/main" id="{C58AA45C-7DFA-47F5-94A9-EADF9A3ED7F4}"/>
+                <a16:creationId xmlns:a16="http://schemas.microsoft.com/office/drawing/2014/main" id="{71D6346B-3382-4CD1-90CC-4F08C4F72840}"/>
               </a:ext>
             </a:extLst>
           </p:cNvPr>
@@ -7623,7 +7623,7 @@
           <p:cNvPr id="2" name="11">
             <a:extLst xmlns:a="http://schemas.openxmlformats.org/drawingml/2006/main">
               <a:ext uri="{FF2B5EF4-FFF2-40B4-BE49-F238E27FC236}">
-                <a16:creationId xmlns:a16="http://schemas.microsoft.com/office/drawing/2014/main" id="{590E6E3E-07A5-4FC8-8AB2-755D85ACD349}"/>
+                <a16:creationId xmlns:a16="http://schemas.microsoft.com/office/drawing/2014/main" id="{90BF3AE8-0BDC-4EFE-98D6-085E428FFAD9}"/>
               </a:ext>
             </a:extLst>
           </p:cNvPr>
@@ -7781,7 +7781,7 @@
           <p:cNvPr id="3" name="01">
             <a:extLst xmlns:a="http://schemas.openxmlformats.org/drawingml/2006/main">
               <a:ext uri="{FF2B5EF4-FFF2-40B4-BE49-F238E27FC236}">
-                <a16:creationId xmlns:a16="http://schemas.microsoft.com/office/drawing/2014/main" id="{8D63FE95-B6A5-46DD-B49D-2B7A35CD82C9}"/>
+                <a16:creationId xmlns:a16="http://schemas.microsoft.com/office/drawing/2014/main" id="{16DE0BCF-CCFD-40EA-9C25-3398219AE48E}"/>
               </a:ext>
             </a:extLst>
           </p:cNvPr>
@@ -7939,7 +7939,7 @@
           <p:cNvPr id="4" name="Server bootstrap">
             <a:extLst xmlns:a="http://schemas.openxmlformats.org/drawingml/2006/main">
               <a:ext uri="{FF2B5EF4-FFF2-40B4-BE49-F238E27FC236}">
-                <a16:creationId xmlns:a16="http://schemas.microsoft.com/office/drawing/2014/main" id="{3C20DC89-41BB-4F8E-A359-53545C8C36C3}"/>
+                <a16:creationId xmlns:a16="http://schemas.microsoft.com/office/drawing/2014/main" id="{99EFD531-EBD8-4973-A047-500EFAFCD4D2}"/>
               </a:ext>
             </a:extLst>
           </p:cNvPr>
@@ -8097,7 +8097,7 @@
           <p:cNvPr id="5" name="Images, static IP, firewall, Asterisk and Opus">
             <a:extLst xmlns:a="http://schemas.openxmlformats.org/drawingml/2006/main">
               <a:ext uri="{FF2B5EF4-FFF2-40B4-BE49-F238E27FC236}">
-                <a16:creationId xmlns:a16="http://schemas.microsoft.com/office/drawing/2014/main" id="{F7CF5DB1-6896-4F21-967A-CB0D24478B4C}"/>
+                <a16:creationId xmlns:a16="http://schemas.microsoft.com/office/drawing/2014/main" id="{4F737562-E2E1-487B-98A5-4A09DA45AC59}"/>
               </a:ext>
             </a:extLst>
           </p:cNvPr>
@@ -8255,7 +8255,7 @@
           <p:cNvPr id="6" name="02">
             <a:extLst xmlns:a="http://schemas.openxmlformats.org/drawingml/2006/main">
               <a:ext uri="{FF2B5EF4-FFF2-40B4-BE49-F238E27FC236}">
-                <a16:creationId xmlns:a16="http://schemas.microsoft.com/office/drawing/2014/main" id="{E1B92D30-136C-4719-8C18-1BD662FBA369}"/>
+                <a16:creationId xmlns:a16="http://schemas.microsoft.com/office/drawing/2014/main" id="{716EB2A6-5F64-4B02-A3A1-B758036FBA2C}"/>
               </a:ext>
             </a:extLst>
           </p:cNvPr>
@@ -8413,7 +8413,7 @@
           <p:cNvPr id="7" name="Verified pilot phone">
             <a:extLst xmlns:a="http://schemas.openxmlformats.org/drawingml/2006/main">
               <a:ext uri="{FF2B5EF4-FFF2-40B4-BE49-F238E27FC236}">
-                <a16:creationId xmlns:a16="http://schemas.microsoft.com/office/drawing/2014/main" id="{877E6FF2-557E-433E-A9BC-EF0AA497FDBF}"/>
+                <a16:creationId xmlns:a16="http://schemas.microsoft.com/office/drawing/2014/main" id="{48012EB7-E2A9-496F-88E2-D6632F6F7B18}"/>
               </a:ext>
             </a:extLst>
           </p:cNvPr>
@@ -8571,7 +8571,7 @@
           <p:cNvPr id="8" name="PID / HW / Load / MAC, SIP profile, temporary TFTP">
             <a:extLst xmlns:a="http://schemas.openxmlformats.org/drawingml/2006/main">
               <a:ext uri="{FF2B5EF4-FFF2-40B4-BE49-F238E27FC236}">
-                <a16:creationId xmlns:a16="http://schemas.microsoft.com/office/drawing/2014/main" id="{CAEA80FA-2FCD-4E66-8E3D-F219894DBA2C}"/>
+                <a16:creationId xmlns:a16="http://schemas.microsoft.com/office/drawing/2014/main" id="{678C2B8B-103E-4EF0-8841-821F5E39EF0C}"/>
               </a:ext>
             </a:extLst>
           </p:cNvPr>
@@ -8729,7 +8729,7 @@
           <p:cNvPr id="9" name="03">
             <a:extLst xmlns:a="http://schemas.openxmlformats.org/drawingml/2006/main">
               <a:ext uri="{FF2B5EF4-FFF2-40B4-BE49-F238E27FC236}">
-                <a16:creationId xmlns:a16="http://schemas.microsoft.com/office/drawing/2014/main" id="{C8ED6196-B91F-4D23-AF8D-AAFACBAC2985}"/>
+                <a16:creationId xmlns:a16="http://schemas.microsoft.com/office/drawing/2014/main" id="{515E78CA-AD00-4EAF-841D-1ABE86EA68C3}"/>
               </a:ext>
             </a:extLst>
           </p:cNvPr>
@@ -8887,7 +8887,7 @@
           <p:cNvPr id="10" name="Home Assistant setup">
             <a:extLst xmlns:a="http://schemas.openxmlformats.org/drawingml/2006/main">
               <a:ext uri="{FF2B5EF4-FFF2-40B4-BE49-F238E27FC236}">
-                <a16:creationId xmlns:a16="http://schemas.microsoft.com/office/drawing/2014/main" id="{82A581E3-960B-45A8-B7EA-6A14A9E6494D}"/>
+                <a16:creationId xmlns:a16="http://schemas.microsoft.com/office/drawing/2014/main" id="{7EFBAFF6-7093-4666-957B-FB96B56C60B8}"/>
               </a:ext>
             </a:extLst>
           </p:cNvPr>
@@ -9045,7 +9045,7 @@
           <p:cNvPr id="11" name="AMI /32, secret, actual entity IDs and VoIP pipeline">
             <a:extLst xmlns:a="http://schemas.openxmlformats.org/drawingml/2006/main">
               <a:ext uri="{FF2B5EF4-FFF2-40B4-BE49-F238E27FC236}">
-                <a16:creationId xmlns:a16="http://schemas.microsoft.com/office/drawing/2014/main" id="{FD5476ED-EDF8-4298-815B-377229E2822A}"/>
+                <a16:creationId xmlns:a16="http://schemas.microsoft.com/office/drawing/2014/main" id="{5AEF5BA0-5439-4EE8-9878-6CCCC6E55A56}"/>
               </a:ext>
             </a:extLst>
           </p:cNvPr>
@@ -9203,7 +9203,7 @@
           <p:cNvPr id="12" name="04">
             <a:extLst xmlns:a="http://schemas.openxmlformats.org/drawingml/2006/main">
               <a:ext uri="{FF2B5EF4-FFF2-40B4-BE49-F238E27FC236}">
-                <a16:creationId xmlns:a16="http://schemas.microsoft.com/office/drawing/2014/main" id="{87F0EA83-9897-4B07-B72D-A0EA00AA9924}"/>
+                <a16:creationId xmlns:a16="http://schemas.microsoft.com/office/drawing/2014/main" id="{5A4FEDDE-0432-4BF7-852B-8E90E73337BB}"/>
               </a:ext>
             </a:extLst>
           </p:cNvPr>
@@ -9361,7 +9361,7 @@
           <p:cNvPr id="13" name="Acceptance and rollout">
             <a:extLst xmlns:a="http://schemas.openxmlformats.org/drawingml/2006/main">
               <a:ext uri="{FF2B5EF4-FFF2-40B4-BE49-F238E27FC236}">
-                <a16:creationId xmlns:a16="http://schemas.microsoft.com/office/drawing/2014/main" id="{37DE7174-D6F9-44EC-B08D-E5932177CB68}"/>
+                <a16:creationId xmlns:a16="http://schemas.microsoft.com/office/drawing/2014/main" id="{53F4B4A8-3A34-4A06-A068-F969553D73AF}"/>
               </a:ext>
             </a:extLst>
           </p:cNvPr>
@@ -9519,7 +9519,7 @@
           <p:cNvPr id="14" name="Two phones, a call to 630, then the remaining phones">
             <a:extLst xmlns:a="http://schemas.openxmlformats.org/drawingml/2006/main">
               <a:ext uri="{FF2B5EF4-FFF2-40B4-BE49-F238E27FC236}">
-                <a16:creationId xmlns:a16="http://schemas.microsoft.com/office/drawing/2014/main" id="{81722C06-24C5-46FE-B8E1-A47AD803D67A}"/>
+                <a16:creationId xmlns:a16="http://schemas.microsoft.com/office/drawing/2014/main" id="{CC185171-23F3-4D7D-9AF3-9FECDF803581}"/>
               </a:ext>
             </a:extLst>
           </p:cNvPr>
@@ -9675,7 +9675,7 @@
     </p:spTree>
     <p:extLst>
       <p:ext uri="{BB962C8B-B14F-4D97-AF65-F5344CB8AC3E}">
-        <p14:creationId xmlns:p14="http://schemas.microsoft.com/office/powerpoint/2010/main" val="236585482"/>
+        <p14:creationId xmlns:p14="http://schemas.microsoft.com/office/powerpoint/2010/main" val="574822645"/>
       </p:ext>
     </p:extLst>
   </p:cSld>
@@ -9706,7 +9706,7 @@
           <p:cNvPr id="10" name="Acceptance tests on real phones">
             <a:extLst xmlns:a="http://schemas.openxmlformats.org/drawingml/2006/main">
               <a:ext uri="{FF2B5EF4-FFF2-40B4-BE49-F238E27FC236}">
-                <a16:creationId xmlns:a16="http://schemas.microsoft.com/office/drawing/2014/main" id="{0813D1DE-6347-4B38-85F6-2E563E426959}"/>
+                <a16:creationId xmlns:a16="http://schemas.microsoft.com/office/drawing/2014/main" id="{0B3864ED-B5B2-4F87-A015-89F180A20480}"/>
               </a:ext>
             </a:extLst>
           </p:cNvPr>
@@ -9864,7 +9864,7 @@
           <p:cNvPr id="2" name="12">
             <a:extLst xmlns:a="http://schemas.openxmlformats.org/drawingml/2006/main">
               <a:ext uri="{FF2B5EF4-FFF2-40B4-BE49-F238E27FC236}">
-                <a16:creationId xmlns:a16="http://schemas.microsoft.com/office/drawing/2014/main" id="{E760D1BB-7EA3-4C3E-B20F-497CB68DCDD9}"/>
+                <a16:creationId xmlns:a16="http://schemas.microsoft.com/office/drawing/2014/main" id="{E5568135-B418-4692-8188-6DD2B9C8F804}"/>
               </a:ext>
             </a:extLst>
           </p:cNvPr>
@@ -10022,7 +10022,7 @@
           <p:cNvPr id="3" name="Telephony">
             <a:extLst xmlns:a="http://schemas.openxmlformats.org/drawingml/2006/main">
               <a:ext uri="{FF2B5EF4-FFF2-40B4-BE49-F238E27FC236}">
-                <a16:creationId xmlns:a16="http://schemas.microsoft.com/office/drawing/2014/main" id="{F970A5A6-D068-40C8-96DA-A61AD18ED71C}"/>
+                <a16:creationId xmlns:a16="http://schemas.microsoft.com/office/drawing/2014/main" id="{FE10E025-C93B-4053-8569-DFEFF7DA80E1}"/>
               </a:ext>
             </a:extLst>
           </p:cNvPr>
@@ -10180,7 +10180,7 @@
           <p:cNvPr id="4" name="201 and 203: cross-phone audio, hold / transfer">
             <a:extLst xmlns:a="http://schemas.openxmlformats.org/drawingml/2006/main">
               <a:ext uri="{FF2B5EF4-FFF2-40B4-BE49-F238E27FC236}">
-                <a16:creationId xmlns:a16="http://schemas.microsoft.com/office/drawing/2014/main" id="{F89D4367-192A-41CF-A527-F6B5DF969386}"/>
+                <a16:creationId xmlns:a16="http://schemas.microsoft.com/office/drawing/2014/main" id="{4D0FF99A-E008-4BF3-86A2-547F3D198CA4}"/>
               </a:ext>
             </a:extLst>
           </p:cNvPr>
@@ -10338,7 +10338,7 @@
           <p:cNvPr id="5" name="Home Assistant">
             <a:extLst xmlns:a="http://schemas.openxmlformats.org/drawingml/2006/main">
               <a:ext uri="{FF2B5EF4-FFF2-40B4-BE49-F238E27FC236}">
-                <a16:creationId xmlns:a16="http://schemas.microsoft.com/office/drawing/2014/main" id="{B06DD50A-9001-49C8-83E1-7D2A232380E3}"/>
+                <a16:creationId xmlns:a16="http://schemas.microsoft.com/office/drawing/2014/main" id="{121A8BCE-B7FB-40D2-892B-0175D7A34055}"/>
               </a:ext>
             </a:extLst>
           </p:cNvPr>
@@ -10496,7 +10496,7 @@
           <p:cNvPr id="6" name="States, Originate, Hangup on the correct Channel, DTMF">
             <a:extLst xmlns:a="http://schemas.openxmlformats.org/drawingml/2006/main">
               <a:ext uri="{FF2B5EF4-FFF2-40B4-BE49-F238E27FC236}">
-                <a16:creationId xmlns:a16="http://schemas.microsoft.com/office/drawing/2014/main" id="{7420FEDD-3541-4648-984C-5A0A9529B6E8}"/>
+                <a16:creationId xmlns:a16="http://schemas.microsoft.com/office/drawing/2014/main" id="{A7C0760D-7A0C-4AA5-A1EC-1AF608FF716E}"/>
               </a:ext>
             </a:extLst>
           </p:cNvPr>
@@ -10654,7 +10654,7 @@
           <p:cNvPr id="7" name="Assist 630">
             <a:extLst xmlns:a="http://schemas.openxmlformats.org/drawingml/2006/main">
               <a:ext uri="{FF2B5EF4-FFF2-40B4-BE49-F238E27FC236}">
-                <a16:creationId xmlns:a16="http://schemas.microsoft.com/office/drawing/2014/main" id="{FC6A8BF8-BDCA-416B-821E-C6E5DC721CC7}"/>
+                <a16:creationId xmlns:a16="http://schemas.microsoft.com/office/drawing/2014/main" id="{C538B1E4-A492-4898-9174-CF6CCAC41ACF}"/>
               </a:ext>
             </a:extLst>
           </p:cNvPr>
@@ -10812,7 +10812,7 @@
           <p:cNvPr id="8" name="Speech recognition, spoken reply and hangup">
             <a:extLst xmlns:a="http://schemas.openxmlformats.org/drawingml/2006/main">
               <a:ext uri="{FF2B5EF4-FFF2-40B4-BE49-F238E27FC236}">
-                <a16:creationId xmlns:a16="http://schemas.microsoft.com/office/drawing/2014/main" id="{AF09562B-6925-4B39-853A-32AA036CA69D}"/>
+                <a16:creationId xmlns:a16="http://schemas.microsoft.com/office/drawing/2014/main" id="{F31C0FCD-8443-41F7-8EBC-355551556AAA}"/>
               </a:ext>
             </a:extLst>
           </p:cNvPr>
@@ -10970,7 +10970,7 @@
           <p:cNvPr id="9" name="Repeat after phone, PBX and HA restarts. Readiness does not verif">
             <a:extLst xmlns:a="http://schemas.openxmlformats.org/drawingml/2006/main">
               <a:ext uri="{FF2B5EF4-FFF2-40B4-BE49-F238E27FC236}">
-                <a16:creationId xmlns:a16="http://schemas.microsoft.com/office/drawing/2014/main" id="{0588556C-6052-42D3-9829-11048A8139A7}"/>
+                <a16:creationId xmlns:a16="http://schemas.microsoft.com/office/drawing/2014/main" id="{F52AE53E-C6AB-42B6-A156-E6457895ADFC}"/>
               </a:ext>
             </a:extLst>
           </p:cNvPr>
@@ -11126,7 +11126,7 @@
     </p:spTree>
     <p:extLst>
       <p:ext uri="{BB962C8B-B14F-4D97-AF65-F5344CB8AC3E}">
-        <p14:creationId xmlns:p14="http://schemas.microsoft.com/office/powerpoint/2010/main" val="215596244"/>
+        <p14:creationId xmlns:p14="http://schemas.microsoft.com/office/powerpoint/2010/main" val="1030009289"/>
       </p:ext>
     </p:extLst>
   </p:cSld>
@@ -11157,7 +11157,7 @@
           <p:cNvPr id="8" name="Operations and recovery">
             <a:extLst xmlns:a="http://schemas.openxmlformats.org/drawingml/2006/main">
               <a:ext uri="{FF2B5EF4-FFF2-40B4-BE49-F238E27FC236}">
-                <a16:creationId xmlns:a16="http://schemas.microsoft.com/office/drawing/2014/main" id="{C24D2E1C-F15A-447D-9AAD-7AEAF6AB38B0}"/>
+                <a16:creationId xmlns:a16="http://schemas.microsoft.com/office/drawing/2014/main" id="{3617DF14-0C1F-47C5-84EA-9CD60E2464DF}"/>
               </a:ext>
             </a:extLst>
           </p:cNvPr>
@@ -11315,7 +11315,7 @@
           <p:cNvPr id="2" name="13">
             <a:extLst xmlns:a="http://schemas.openxmlformats.org/drawingml/2006/main">
               <a:ext uri="{FF2B5EF4-FFF2-40B4-BE49-F238E27FC236}">
-                <a16:creationId xmlns:a16="http://schemas.microsoft.com/office/drawing/2014/main" id="{39CEA8A3-79EE-4E69-AAB5-BA61A215941A}"/>
+                <a16:creationId xmlns:a16="http://schemas.microsoft.com/office/drawing/2014/main" id="{E3B6D3B1-D62B-482A-A82C-5E99FF62D3A3}"/>
               </a:ext>
             </a:extLst>
           </p:cNvPr>
@@ -11473,7 +11473,7 @@
           <p:cNvPr id="3" name="Private backups outside Git">
             <a:extLst xmlns:a="http://schemas.openxmlformats.org/drawingml/2006/main">
               <a:ext uri="{FF2B5EF4-FFF2-40B4-BE49-F238E27FC236}">
-                <a16:creationId xmlns:a16="http://schemas.microsoft.com/office/drawing/2014/main" id="{4B7A7CB4-E4DD-47B9-991D-ACC292E7AEB9}"/>
+                <a16:creationId xmlns:a16="http://schemas.microsoft.com/office/drawing/2014/main" id="{65D9903D-1E90-41C9-8276-B850F06C9BFA}"/>
               </a:ext>
             </a:extLst>
           </p:cNvPr>
@@ -11631,7 +11631,7 @@
           <p:cNvPr id="4" name="Inventory, SIP / AMI secrets and Asterisk data&#10;HA config / .stora">
             <a:extLst xmlns:a="http://schemas.openxmlformats.org/drawingml/2006/main">
               <a:ext uri="{FF2B5EF4-FFF2-40B4-BE49-F238E27FC236}">
-                <a16:creationId xmlns:a16="http://schemas.microsoft.com/office/drawing/2014/main" id="{9F419D33-F43D-4120-BF4C-9B4507D27DD5}"/>
+                <a16:creationId xmlns:a16="http://schemas.microsoft.com/office/drawing/2014/main" id="{8F2FEF72-3639-4D41-9030-CB53878C1573}"/>
               </a:ext>
             </a:extLst>
           </p:cNvPr>
@@ -11812,7 +11812,7 @@
           <p:cNvPr id="5" name="One node is a single point of failure">
             <a:extLst xmlns:a="http://schemas.openxmlformats.org/drawingml/2006/main">
               <a:ext uri="{FF2B5EF4-FFF2-40B4-BE49-F238E27FC236}">
-                <a16:creationId xmlns:a16="http://schemas.microsoft.com/office/drawing/2014/main" id="{A4AEF8FD-E48A-496C-A91D-F5D89E15992E}"/>
+                <a16:creationId xmlns:a16="http://schemas.microsoft.com/office/drawing/2014/main" id="{A4062DAE-9F02-4180-AD9D-392572F9915A}"/>
               </a:ext>
             </a:extLst>
           </p:cNvPr>
@@ -11970,7 +11970,7 @@
           <p:cNvPr id="6" name="UPS for network equipment and the k3s node&#10;A recovery plan that p">
             <a:extLst xmlns:a="http://schemas.openxmlformats.org/drawingml/2006/main">
               <a:ext uri="{FF2B5EF4-FFF2-40B4-BE49-F238E27FC236}">
-                <a16:creationId xmlns:a16="http://schemas.microsoft.com/office/drawing/2014/main" id="{A6324C31-EC18-45A8-8031-0111A43DA4D1}"/>
+                <a16:creationId xmlns:a16="http://schemas.microsoft.com/office/drawing/2014/main" id="{EACF9DF1-CF73-4262-BCFE-A3CE2C18BC22}"/>
               </a:ext>
             </a:extLst>
           </p:cNvPr>
@@ -12151,7 +12151,7 @@
           <p:cNvPr id="7" name="Exclude raw DTMF and connected-line data from Recorder. Review ex">
             <a:extLst xmlns:a="http://schemas.openxmlformats.org/drawingml/2006/main">
               <a:ext uri="{FF2B5EF4-FFF2-40B4-BE49-F238E27FC236}">
-                <a16:creationId xmlns:a16="http://schemas.microsoft.com/office/drawing/2014/main" id="{6D2EF800-D559-4199-9C23-B457779F2C5C}"/>
+                <a16:creationId xmlns:a16="http://schemas.microsoft.com/office/drawing/2014/main" id="{36AA9368-4C64-4660-A614-18E80191D9AC}"/>
               </a:ext>
             </a:extLst>
           </p:cNvPr>
@@ -12307,7 +12307,7 @@
     </p:spTree>
     <p:extLst>
       <p:ext uri="{BB962C8B-B14F-4D97-AF65-F5344CB8AC3E}">
-        <p14:creationId xmlns:p14="http://schemas.microsoft.com/office/powerpoint/2010/main" val="2146920185"/>
+        <p14:creationId xmlns:p14="http://schemas.microsoft.com/office/powerpoint/2010/main" val="1048075586"/>
       </p:ext>
     </p:extLst>
   </p:cSld>
@@ -12338,7 +12338,7 @@
           <p:cNvPr id="8" name="Server readiness and phone acceptance">
             <a:extLst xmlns:a="http://schemas.openxmlformats.org/drawingml/2006/main">
               <a:ext uri="{FF2B5EF4-FFF2-40B4-BE49-F238E27FC236}">
-                <a16:creationId xmlns:a16="http://schemas.microsoft.com/office/drawing/2014/main" id="{1D4EC317-8460-4BA4-B4F2-D6623A211ACD}"/>
+                <a16:creationId xmlns:a16="http://schemas.microsoft.com/office/drawing/2014/main" id="{B8460912-EAB3-449A-B7AC-0E27622B5487}"/>
               </a:ext>
             </a:extLst>
           </p:cNvPr>
@@ -12496,7 +12496,7 @@
           <p:cNvPr id="2" name="14">
             <a:extLst xmlns:a="http://schemas.openxmlformats.org/drawingml/2006/main">
               <a:ext uri="{FF2B5EF4-FFF2-40B4-BE49-F238E27FC236}">
-                <a16:creationId xmlns:a16="http://schemas.microsoft.com/office/drawing/2014/main" id="{B619D9D5-8BFF-4E2F-B251-97FCEA260E51}"/>
+                <a16:creationId xmlns:a16="http://schemas.microsoft.com/office/drawing/2014/main" id="{9EFAAB93-DD54-4F4C-A9C6-68ADDCDAC458}"/>
               </a:ext>
             </a:extLst>
           </p:cNvPr>
@@ -12654,7 +12654,7 @@
           <p:cNvPr id="3" name="Server preparation can come first">
             <a:extLst xmlns:a="http://schemas.openxmlformats.org/drawingml/2006/main">
               <a:ext uri="{FF2B5EF4-FFF2-40B4-BE49-F238E27FC236}">
-                <a16:creationId xmlns:a16="http://schemas.microsoft.com/office/drawing/2014/main" id="{BDB36C04-971E-4008-852B-670F62310EB0}"/>
+                <a16:creationId xmlns:a16="http://schemas.microsoft.com/office/drawing/2014/main" id="{99AFC3E5-DEAF-49E5-B97B-08686116525B}"/>
               </a:ext>
             </a:extLst>
           </p:cNvPr>
@@ -12812,7 +12812,7 @@
           <p:cNvPr id="4" name="Images, configuration, AMI and Opus&#10;Tests verify the server compo">
             <a:extLst xmlns:a="http://schemas.openxmlformats.org/drawingml/2006/main">
               <a:ext uri="{FF2B5EF4-FFF2-40B4-BE49-F238E27FC236}">
-                <a16:creationId xmlns:a16="http://schemas.microsoft.com/office/drawing/2014/main" id="{4587F99D-5664-45C1-9A4E-D7D4BE8E2AFE}"/>
+                <a16:creationId xmlns:a16="http://schemas.microsoft.com/office/drawing/2014/main" id="{68671710-7B58-4C64-9607-A00F361E2B6E}"/>
               </a:ext>
             </a:extLst>
           </p:cNvPr>
@@ -12993,7 +12993,7 @@
           <p:cNvPr id="5" name="A pilot verifies the phone experience">
             <a:extLst xmlns:a="http://schemas.openxmlformats.org/drawingml/2006/main">
               <a:ext uri="{FF2B5EF4-FFF2-40B4-BE49-F238E27FC236}">
-                <a16:creationId xmlns:a16="http://schemas.microsoft.com/office/drawing/2014/main" id="{3C08A8C3-3654-4625-83F8-692593B1B16A}"/>
+                <a16:creationId xmlns:a16="http://schemas.microsoft.com/office/drawing/2014/main" id="{DF27BBE3-CE78-4B8A-BF02-D113EA79E56E}"/>
               </a:ext>
             </a:extLst>
           </p:cNvPr>
@@ -13151,7 +13151,7 @@
           <p:cNvPr id="6" name="Phone inventory, a two-party call and Assist&#10;Add the remaining ph">
             <a:extLst xmlns:a="http://schemas.openxmlformats.org/drawingml/2006/main">
               <a:ext uri="{FF2B5EF4-FFF2-40B4-BE49-F238E27FC236}">
-                <a16:creationId xmlns:a16="http://schemas.microsoft.com/office/drawing/2014/main" id="{CE7DE7C2-0A9B-4C0B-8874-2390F1CCC80B}"/>
+                <a16:creationId xmlns:a16="http://schemas.microsoft.com/office/drawing/2014/main" id="{2BBB6678-AFC4-4708-9C99-2F0721E7BB19}"/>
               </a:ext>
             </a:extLst>
           </p:cNvPr>
@@ -13332,7 +13332,7 @@
           <p:cNvPr id="7" name="Physical acceptance is a separate step. Keep the results in the p">
             <a:extLst xmlns:a="http://schemas.openxmlformats.org/drawingml/2006/main">
               <a:ext uri="{FF2B5EF4-FFF2-40B4-BE49-F238E27FC236}">
-                <a16:creationId xmlns:a16="http://schemas.microsoft.com/office/drawing/2014/main" id="{A3F5C605-D3FE-43A2-8888-4BADFB7FCE96}"/>
+                <a16:creationId xmlns:a16="http://schemas.microsoft.com/office/drawing/2014/main" id="{55EE1244-065D-4904-AB30-9A6EF6457CEE}"/>
               </a:ext>
             </a:extLst>
           </p:cNvPr>
@@ -13488,7 +13488,7 @@
     </p:spTree>
     <p:extLst>
       <p:ext uri="{BB962C8B-B14F-4D97-AF65-F5344CB8AC3E}">
-        <p14:creationId xmlns:p14="http://schemas.microsoft.com/office/powerpoint/2010/main" val="533164249"/>
+        <p14:creationId xmlns:p14="http://schemas.microsoft.com/office/powerpoint/2010/main" val="1263947407"/>
       </p:ext>
     </p:extLst>
   </p:cSld>
@@ -13519,7 +13519,7 @@
           <p:cNvPr id="18" name="Four phones, eight independent lines">
             <a:extLst xmlns:a="http://schemas.openxmlformats.org/drawingml/2006/main">
               <a:ext uri="{FF2B5EF4-FFF2-40B4-BE49-F238E27FC236}">
-                <a16:creationId xmlns:a16="http://schemas.microsoft.com/office/drawing/2014/main" id="{92DE0B55-07F4-4F6F-9073-101EA5E54ECB}"/>
+                <a16:creationId xmlns:a16="http://schemas.microsoft.com/office/drawing/2014/main" id="{715582E9-6622-4467-A6EB-E35D81300FD5}"/>
               </a:ext>
             </a:extLst>
           </p:cNvPr>
@@ -13677,7 +13677,7 @@
           <p:cNvPr id="2" name="15">
             <a:extLst xmlns:a="http://schemas.openxmlformats.org/drawingml/2006/main">
               <a:ext uri="{FF2B5EF4-FFF2-40B4-BE49-F238E27FC236}">
-                <a16:creationId xmlns:a16="http://schemas.microsoft.com/office/drawing/2014/main" id="{6F28F66C-7D1C-4DFD-82F2-D559493F497B}"/>
+                <a16:creationId xmlns:a16="http://schemas.microsoft.com/office/drawing/2014/main" id="{53258F1E-9423-4A14-9CD2-7A455985C414}"/>
               </a:ext>
             </a:extLst>
           </p:cNvPr>
@@ -13835,7 +13835,7 @@
           <p:cNvPr id="3" name="PHONE A">
             <a:extLst xmlns:a="http://schemas.openxmlformats.org/drawingml/2006/main">
               <a:ext uri="{FF2B5EF4-FFF2-40B4-BE49-F238E27FC236}">
-                <a16:creationId xmlns:a16="http://schemas.microsoft.com/office/drawing/2014/main" id="{4C1F95C6-2081-4256-A952-2FEFBF8380AB}"/>
+                <a16:creationId xmlns:a16="http://schemas.microsoft.com/office/drawing/2014/main" id="{7A0AB815-2A94-4423-8CCA-3AADD64CA312}"/>
               </a:ext>
             </a:extLst>
           </p:cNvPr>
@@ -13993,7 +13993,7 @@
           <p:cNvPr id="4" name="201">
             <a:extLst xmlns:a="http://schemas.openxmlformats.org/drawingml/2006/main">
               <a:ext uri="{FF2B5EF4-FFF2-40B4-BE49-F238E27FC236}">
-                <a16:creationId xmlns:a16="http://schemas.microsoft.com/office/drawing/2014/main" id="{65C060EC-C8CE-47B9-9F62-3E6D9A783578}"/>
+                <a16:creationId xmlns:a16="http://schemas.microsoft.com/office/drawing/2014/main" id="{5A5FF80A-0703-4A87-BF96-6651D637F322}"/>
               </a:ext>
             </a:extLst>
           </p:cNvPr>
@@ -14151,7 +14151,7 @@
           <p:cNvPr id="5" name="202">
             <a:extLst xmlns:a="http://schemas.openxmlformats.org/drawingml/2006/main">
               <a:ext uri="{FF2B5EF4-FFF2-40B4-BE49-F238E27FC236}">
-                <a16:creationId xmlns:a16="http://schemas.microsoft.com/office/drawing/2014/main" id="{266BC443-27EF-4597-9AF3-86FF0606F56C}"/>
+                <a16:creationId xmlns:a16="http://schemas.microsoft.com/office/drawing/2014/main" id="{3EB389CE-757C-4C13-9D76-B3C91766C12F}"/>
               </a:ext>
             </a:extLst>
           </p:cNvPr>
@@ -14309,7 +14309,7 @@
           <p:cNvPr id="6" name="PHONE B">
             <a:extLst xmlns:a="http://schemas.openxmlformats.org/drawingml/2006/main">
               <a:ext uri="{FF2B5EF4-FFF2-40B4-BE49-F238E27FC236}">
-                <a16:creationId xmlns:a16="http://schemas.microsoft.com/office/drawing/2014/main" id="{8CED992B-42B6-4090-B588-83B6A98F8166}"/>
+                <a16:creationId xmlns:a16="http://schemas.microsoft.com/office/drawing/2014/main" id="{252675E0-72ED-4679-ACA4-C8B9750D7577}"/>
               </a:ext>
             </a:extLst>
           </p:cNvPr>
@@ -14467,7 +14467,7 @@
           <p:cNvPr id="7" name="203">
             <a:extLst xmlns:a="http://schemas.openxmlformats.org/drawingml/2006/main">
               <a:ext uri="{FF2B5EF4-FFF2-40B4-BE49-F238E27FC236}">
-                <a16:creationId xmlns:a16="http://schemas.microsoft.com/office/drawing/2014/main" id="{B8C81212-CCD8-47E0-9EBA-9648071DA55E}"/>
+                <a16:creationId xmlns:a16="http://schemas.microsoft.com/office/drawing/2014/main" id="{9B36E4D8-2641-4516-A7B9-E3B7B2E39CFB}"/>
               </a:ext>
             </a:extLst>
           </p:cNvPr>
@@ -14625,7 +14625,7 @@
           <p:cNvPr id="8" name="204">
             <a:extLst xmlns:a="http://schemas.openxmlformats.org/drawingml/2006/main">
               <a:ext uri="{FF2B5EF4-FFF2-40B4-BE49-F238E27FC236}">
-                <a16:creationId xmlns:a16="http://schemas.microsoft.com/office/drawing/2014/main" id="{8E504E36-2B64-4661-B86F-01894489F64C}"/>
+                <a16:creationId xmlns:a16="http://schemas.microsoft.com/office/drawing/2014/main" id="{C5B072E6-A391-4AD9-A979-6A232CC0529E}"/>
               </a:ext>
             </a:extLst>
           </p:cNvPr>
@@ -14783,7 +14783,7 @@
           <p:cNvPr id="9" name="PHONE C">
             <a:extLst xmlns:a="http://schemas.openxmlformats.org/drawingml/2006/main">
               <a:ext uri="{FF2B5EF4-FFF2-40B4-BE49-F238E27FC236}">
-                <a16:creationId xmlns:a16="http://schemas.microsoft.com/office/drawing/2014/main" id="{2B73034C-F59B-4534-9AF6-83725E64A983}"/>
+                <a16:creationId xmlns:a16="http://schemas.microsoft.com/office/drawing/2014/main" id="{9FA2A778-0409-4E00-9DA7-F4635D79DA6F}"/>
               </a:ext>
             </a:extLst>
           </p:cNvPr>
@@ -14941,7 +14941,7 @@
           <p:cNvPr id="10" name="205">
             <a:extLst xmlns:a="http://schemas.openxmlformats.org/drawingml/2006/main">
               <a:ext uri="{FF2B5EF4-FFF2-40B4-BE49-F238E27FC236}">
-                <a16:creationId xmlns:a16="http://schemas.microsoft.com/office/drawing/2014/main" id="{4A9775FA-AE2C-4BAD-ADF7-F281E9936932}"/>
+                <a16:creationId xmlns:a16="http://schemas.microsoft.com/office/drawing/2014/main" id="{AD5D6962-B72E-48D5-8FC5-CFB6F071B0D4}"/>
               </a:ext>
             </a:extLst>
           </p:cNvPr>
@@ -15099,7 +15099,7 @@
           <p:cNvPr id="11" name="206">
             <a:extLst xmlns:a="http://schemas.openxmlformats.org/drawingml/2006/main">
               <a:ext uri="{FF2B5EF4-FFF2-40B4-BE49-F238E27FC236}">
-                <a16:creationId xmlns:a16="http://schemas.microsoft.com/office/drawing/2014/main" id="{FB6EF497-BAC4-42BE-A94E-6AAAE8A91148}"/>
+                <a16:creationId xmlns:a16="http://schemas.microsoft.com/office/drawing/2014/main" id="{C50481F3-B843-46EA-96E9-7F08C55677BB}"/>
               </a:ext>
             </a:extLst>
           </p:cNvPr>
@@ -15257,7 +15257,7 @@
           <p:cNvPr id="12" name="PHONE D">
             <a:extLst xmlns:a="http://schemas.openxmlformats.org/drawingml/2006/main">
               <a:ext uri="{FF2B5EF4-FFF2-40B4-BE49-F238E27FC236}">
-                <a16:creationId xmlns:a16="http://schemas.microsoft.com/office/drawing/2014/main" id="{9FF49ACD-1BFA-4F7E-8A72-E25C4936FDE5}"/>
+                <a16:creationId xmlns:a16="http://schemas.microsoft.com/office/drawing/2014/main" id="{97A495A3-78FC-4BAA-AB7F-46443791709D}"/>
               </a:ext>
             </a:extLst>
           </p:cNvPr>
@@ -15415,7 +15415,7 @@
           <p:cNvPr id="13" name="207">
             <a:extLst xmlns:a="http://schemas.openxmlformats.org/drawingml/2006/main">
               <a:ext uri="{FF2B5EF4-FFF2-40B4-BE49-F238E27FC236}">
-                <a16:creationId xmlns:a16="http://schemas.microsoft.com/office/drawing/2014/main" id="{741267F3-6078-4189-BCBB-4B6B4A9B8BEF}"/>
+                <a16:creationId xmlns:a16="http://schemas.microsoft.com/office/drawing/2014/main" id="{76FF8D3D-E9FE-4A69-ABE1-A451D0C724FB}"/>
               </a:ext>
             </a:extLst>
           </p:cNvPr>
@@ -15573,7 +15573,7 @@
           <p:cNvPr id="14" name="208">
             <a:extLst xmlns:a="http://schemas.openxmlformats.org/drawingml/2006/main">
               <a:ext uri="{FF2B5EF4-FFF2-40B4-BE49-F238E27FC236}">
-                <a16:creationId xmlns:a16="http://schemas.microsoft.com/office/drawing/2014/main" id="{5B797D5E-1BC1-4F62-915D-C1573602126D}"/>
+                <a16:creationId xmlns:a16="http://schemas.microsoft.com/office/drawing/2014/main" id="{3099E1AD-CB7A-4312-B4ED-31F5EA65C518}"/>
               </a:ext>
             </a:extLst>
           </p:cNvPr>
@@ -15731,7 +15731,7 @@
           <p:cNvPr id="15" name="620 rings the primary line of each phone">
             <a:extLst xmlns:a="http://schemas.openxmlformats.org/drawingml/2006/main">
               <a:ext uri="{FF2B5EF4-FFF2-40B4-BE49-F238E27FC236}">
-                <a16:creationId xmlns:a16="http://schemas.microsoft.com/office/drawing/2014/main" id="{5827F399-1889-44AA-A44F-C58B675EAF4E}"/>
+                <a16:creationId xmlns:a16="http://schemas.microsoft.com/office/drawing/2014/main" id="{C4CA8DF7-A0DB-443A-B92D-53AD3509AF9C}"/>
               </a:ext>
             </a:extLst>
           </p:cNvPr>
@@ -15889,7 +15889,7 @@
           <p:cNvPr id="16" name="201, 203, 205 and 207 share the group. DND skips that phone.">
             <a:extLst xmlns:a="http://schemas.openxmlformats.org/drawingml/2006/main">
               <a:ext uri="{FF2B5EF4-FFF2-40B4-BE49-F238E27FC236}">
-                <a16:creationId xmlns:a16="http://schemas.microsoft.com/office/drawing/2014/main" id="{109A847C-3482-4979-BFB0-265FEB722652}"/>
+                <a16:creationId xmlns:a16="http://schemas.microsoft.com/office/drawing/2014/main" id="{AC80570C-E62B-4C93-93E5-4D77455596EE}"/>
               </a:ext>
             </a:extLst>
           </p:cNvPr>
@@ -16044,10 +16044,10 @@
       </p:sp>
       <p:sp>
         <p:nvSpPr>
-          <p:cNvPr id="17" name="Eight registrations and local call checks passed. Broader accepta">
+          <p:cNvPr id="17" name="Eight registrations and local call checks passed. Cross-phone tes">
             <a:extLst xmlns:a="http://schemas.openxmlformats.org/drawingml/2006/main">
               <a:ext uri="{FF2B5EF4-FFF2-40B4-BE49-F238E27FC236}">
-                <a16:creationId xmlns:a16="http://schemas.microsoft.com/office/drawing/2014/main" id="{B7599784-F8FE-4E02-91A5-C5E323882FE3}"/>
+                <a16:creationId xmlns:a16="http://schemas.microsoft.com/office/drawing/2014/main" id="{ECC84B2D-9B5D-475B-B220-0AEB5A028975}"/>
               </a:ext>
             </a:extLst>
           </p:cNvPr>
@@ -16195,7 +16195,7 @@
                 <a:ea typeface="Arial"/>
                 <a:cs typeface="Arial"/>
               </a:rPr>
-              <a:t>Eight registrations and local call checks passed. Broader acceptance continues.</a:t>
+              <a:t>Eight registrations and local call checks passed. Cross-phone tests remain separate.</a:t>
             </a:r>
           </a:p>
         </p:txBody>
@@ -16203,7 +16203,7 @@
     </p:spTree>
     <p:extLst>
       <p:ext uri="{BB962C8B-B14F-4D97-AF65-F5344CB8AC3E}">
-        <p14:creationId xmlns:p14="http://schemas.microsoft.com/office/powerpoint/2010/main" val="1684131079"/>
+        <p14:creationId xmlns:p14="http://schemas.microsoft.com/office/powerpoint/2010/main" val="1990192390"/>
       </p:ext>
     </p:extLst>
   </p:cSld>
@@ -16234,7 +16234,7 @@
           <p:cNvPr id="14" name="Home Assistant phone controls">
             <a:extLst xmlns:a="http://schemas.openxmlformats.org/drawingml/2006/main">
               <a:ext uri="{FF2B5EF4-FFF2-40B4-BE49-F238E27FC236}">
-                <a16:creationId xmlns:a16="http://schemas.microsoft.com/office/drawing/2014/main" id="{28644324-7B9D-4D14-86D1-0A58BBBAD2A1}"/>
+                <a16:creationId xmlns:a16="http://schemas.microsoft.com/office/drawing/2014/main" id="{3A91B740-6F4E-4E3C-8CED-A12D4CEE83E8}"/>
               </a:ext>
             </a:extLst>
           </p:cNvPr>
@@ -16392,7 +16392,7 @@
           <p:cNvPr id="2" name="16">
             <a:extLst xmlns:a="http://schemas.openxmlformats.org/drawingml/2006/main">
               <a:ext uri="{FF2B5EF4-FFF2-40B4-BE49-F238E27FC236}">
-                <a16:creationId xmlns:a16="http://schemas.microsoft.com/office/drawing/2014/main" id="{15F6AA9C-8FC1-4A4D-9403-CD8B77CD6B5B}"/>
+                <a16:creationId xmlns:a16="http://schemas.microsoft.com/office/drawing/2014/main" id="{BA606C63-00B3-40C6-95A0-E3C6B4ABB3A0}"/>
               </a:ext>
             </a:extLst>
           </p:cNvPr>
@@ -16547,10 +16547,10 @@
       </p:sp>
       <p:sp>
         <p:nvSpPr>
-          <p:cNvPr id="3" name="120">
+          <p:cNvPr id="3" name="116">
             <a:extLst xmlns:a="http://schemas.openxmlformats.org/drawingml/2006/main">
               <a:ext uri="{FF2B5EF4-FFF2-40B4-BE49-F238E27FC236}">
-                <a16:creationId xmlns:a16="http://schemas.microsoft.com/office/drawing/2014/main" id="{79B8E6BD-7875-46B2-B624-25559C27037C}"/>
+                <a16:creationId xmlns:a16="http://schemas.microsoft.com/office/drawing/2014/main" id="{CE523432-D045-4212-AE35-019B91964C4A}"/>
               </a:ext>
             </a:extLst>
           </p:cNvPr>
@@ -16698,7 +16698,7 @@
                 <a:ea typeface="Arial"/>
                 <a:cs typeface="Arial"/>
               </a:rPr>
-              <a:t>120</a:t>
+              <a:t>116</a:t>
             </a:r>
           </a:p>
         </p:txBody>
@@ -16708,7 +16708,7 @@
           <p:cNvPr id="4" name="control entities">
             <a:extLst xmlns:a="http://schemas.openxmlformats.org/drawingml/2006/main">
               <a:ext uri="{FF2B5EF4-FFF2-40B4-BE49-F238E27FC236}">
-                <a16:creationId xmlns:a16="http://schemas.microsoft.com/office/drawing/2014/main" id="{A02195AA-96DF-40BD-8195-AAFD0E271115}"/>
+                <a16:creationId xmlns:a16="http://schemas.microsoft.com/office/drawing/2014/main" id="{E5FFD2B9-94C1-4364-8EB8-AC63BBABAC13}"/>
               </a:ext>
             </a:extLst>
           </p:cNvPr>
@@ -16866,7 +16866,7 @@
           <p:cNvPr id="5" name="Call controls">
             <a:extLst xmlns:a="http://schemas.openxmlformats.org/drawingml/2006/main">
               <a:ext uri="{FF2B5EF4-FFF2-40B4-BE49-F238E27FC236}">
-                <a16:creationId xmlns:a16="http://schemas.microsoft.com/office/drawing/2014/main" id="{0EBF8A80-362D-4E66-AD24-3E95EB1AF420}"/>
+                <a16:creationId xmlns:a16="http://schemas.microsoft.com/office/drawing/2014/main" id="{A23B0723-44B6-42E7-8248-8BDF1C70EEB2}"/>
               </a:ext>
             </a:extLst>
           </p:cNvPr>
@@ -17024,7 +17024,7 @@
           <p:cNvPr id="6" name="Line, dial, answer and exact-channel hangup">
             <a:extLst xmlns:a="http://schemas.openxmlformats.org/drawingml/2006/main">
               <a:ext uri="{FF2B5EF4-FFF2-40B4-BE49-F238E27FC236}">
-                <a16:creationId xmlns:a16="http://schemas.microsoft.com/office/drawing/2014/main" id="{6638CFEA-10DA-4389-8968-B7E0C3D61041}"/>
+                <a16:creationId xmlns:a16="http://schemas.microsoft.com/office/drawing/2014/main" id="{5E4C5AB1-3189-483B-84C8-F5B30BB25C6F}"/>
               </a:ext>
             </a:extLst>
           </p:cNvPr>
@@ -17182,7 +17182,7 @@
           <p:cNvPr id="7" name="Personal settings">
             <a:extLst xmlns:a="http://schemas.openxmlformats.org/drawingml/2006/main">
               <a:ext uri="{FF2B5EF4-FFF2-40B4-BE49-F238E27FC236}">
-                <a16:creationId xmlns:a16="http://schemas.microsoft.com/office/drawing/2014/main" id="{F69BD520-71A4-4D54-BAB4-11B5D8A89682}"/>
+                <a16:creationId xmlns:a16="http://schemas.microsoft.com/office/drawing/2014/main" id="{30D88A6F-E57A-433F-A162-38108A56941F}"/>
               </a:ext>
             </a:extLst>
           </p:cNvPr>
@@ -17337,10 +17337,10 @@
       </p:sp>
       <p:sp>
         <p:nvSpPr>
-          <p:cNvPr id="8" name="PBX DND and opt-in gateway auto-answer">
+          <p:cNvPr id="8" name="PBX DND and optional normal-call auto-answer">
             <a:extLst xmlns:a="http://schemas.openxmlformats.org/drawingml/2006/main">
               <a:ext uri="{FF2B5EF4-FFF2-40B4-BE49-F238E27FC236}">
-                <a16:creationId xmlns:a16="http://schemas.microsoft.com/office/drawing/2014/main" id="{9B106CB0-A83E-492A-8663-1CF42DFE459C}"/>
+                <a16:creationId xmlns:a16="http://schemas.microsoft.com/office/drawing/2014/main" id="{C7D1A554-6EC3-4105-9281-C4E68C2018B4}"/>
               </a:ext>
             </a:extLst>
           </p:cNvPr>
@@ -17488,7 +17488,7 @@
                 <a:ea typeface="Arial"/>
                 <a:cs typeface="Arial"/>
               </a:rPr>
-              <a:t>PBX DND and opt-in gateway auto-answer</a:t>
+              <a:t>PBX DND and optional normal-call auto-answer</a:t>
             </a:r>
           </a:p>
         </p:txBody>
@@ -17498,7 +17498,7 @@
           <p:cNvPr id="9" name="Schedules">
             <a:extLst xmlns:a="http://schemas.openxmlformats.org/drawingml/2006/main">
               <a:ext uri="{FF2B5EF4-FFF2-40B4-BE49-F238E27FC236}">
-                <a16:creationId xmlns:a16="http://schemas.microsoft.com/office/drawing/2014/main" id="{D161E8CF-C32E-454B-812A-8DF88EA3823D}"/>
+                <a16:creationId xmlns:a16="http://schemas.microsoft.com/office/drawing/2014/main" id="{AB52DBF3-4716-4C98-BBC3-F305EF1CDB56}"/>
               </a:ext>
             </a:extLst>
           </p:cNvPr>
@@ -17653,10 +17653,10 @@
       </p:sp>
       <p:sp>
         <p:nvSpPr>
-          <p:cNvPr id="10" name="Countdown timers and chosen weekdays">
+          <p:cNvPr id="10" name="Timers and weekdays with a Stop alert control">
             <a:extLst xmlns:a="http://schemas.openxmlformats.org/drawingml/2006/main">
               <a:ext uri="{FF2B5EF4-FFF2-40B4-BE49-F238E27FC236}">
-                <a16:creationId xmlns:a16="http://schemas.microsoft.com/office/drawing/2014/main" id="{9E6F3904-0B86-4A92-92D8-A2850A284335}"/>
+                <a16:creationId xmlns:a16="http://schemas.microsoft.com/office/drawing/2014/main" id="{18D52542-F49C-4543-A443-D179BC43A4FD}"/>
               </a:ext>
             </a:extLst>
           </p:cNvPr>
@@ -17804,7 +17804,7 @@
                 <a:ea typeface="Arial"/>
                 <a:cs typeface="Arial"/>
               </a:rPr>
-              <a:t>Countdown timers and chosen weekdays</a:t>
+              <a:t>Timers and weekdays with a Stop alert control</a:t>
             </a:r>
           </a:p>
         </p:txBody>
@@ -17814,7 +17814,7 @@
           <p:cNvPr id="11" name="Phone screen">
             <a:extLst xmlns:a="http://schemas.openxmlformats.org/drawingml/2006/main">
               <a:ext uri="{FF2B5EF4-FFF2-40B4-BE49-F238E27FC236}">
-                <a16:creationId xmlns:a16="http://schemas.microsoft.com/office/drawing/2014/main" id="{E6EEE2C3-6CF7-4387-99AD-E35A849673DA}"/>
+                <a16:creationId xmlns:a16="http://schemas.microsoft.com/office/drawing/2014/main" id="{D0571B3B-79BD-4BAE-A075-B1AEFB85A3C6}"/>
               </a:ext>
             </a:extLst>
           </p:cNvPr>
@@ -17972,7 +17972,7 @@
           <p:cNvPr id="12" name="Authenticated text and approved images">
             <a:extLst xmlns:a="http://schemas.openxmlformats.org/drawingml/2006/main">
               <a:ext uri="{FF2B5EF4-FFF2-40B4-BE49-F238E27FC236}">
-                <a16:creationId xmlns:a16="http://schemas.microsoft.com/office/drawing/2014/main" id="{590D4A54-E437-47B5-A7D1-B5C0F8E5D38E}"/>
+                <a16:creationId xmlns:a16="http://schemas.microsoft.com/office/drawing/2014/main" id="{8EAD403B-283A-4A5F-BBDC-CF66510AE4F5}"/>
               </a:ext>
             </a:extLst>
           </p:cNvPr>
@@ -18127,10 +18127,10 @@
       </p:sp>
       <p:sp>
         <p:nvSpPr>
-          <p:cNvPr id="13" name="Fresh call-state checks protect active calls. Live feature accept">
+          <p:cNvPr id="13" name="New alert controls await deployment and live acceptance.">
             <a:extLst xmlns:a="http://schemas.openxmlformats.org/drawingml/2006/main">
               <a:ext uri="{FF2B5EF4-FFF2-40B4-BE49-F238E27FC236}">
-                <a16:creationId xmlns:a16="http://schemas.microsoft.com/office/drawing/2014/main" id="{11D10C55-AD3E-4495-8E60-686CEB7F7B3B}"/>
+                <a16:creationId xmlns:a16="http://schemas.microsoft.com/office/drawing/2014/main" id="{87A6F19F-4606-41A3-9A69-98CB3397EC96}"/>
               </a:ext>
             </a:extLst>
           </p:cNvPr>
@@ -18278,7 +18278,7 @@
                 <a:ea typeface="Arial"/>
                 <a:cs typeface="Arial"/>
               </a:rPr>
-              <a:t>Fresh call-state checks protect active calls. Live feature acceptance remains underway.</a:t>
+              <a:t>New alert controls await deployment and live acceptance.</a:t>
             </a:r>
           </a:p>
         </p:txBody>
@@ -18286,7 +18286,7 @@
     </p:spTree>
     <p:extLst>
       <p:ext uri="{BB962C8B-B14F-4D97-AF65-F5344CB8AC3E}">
-        <p14:creationId xmlns:p14="http://schemas.microsoft.com/office/powerpoint/2010/main" val="2027182359"/>
+        <p14:creationId xmlns:p14="http://schemas.microsoft.com/office/powerpoint/2010/main" val="695774530"/>
       </p:ext>
     </p:extLst>
   </p:cSld>
@@ -18314,10 +18314,10 @@
       </p:grpSpPr>
       <p:sp>
         <p:nvSpPr>
-          <p:cNvPr id="22" name="Radio and scheduled calls">
+          <p:cNvPr id="22" name="Radio and scheduled alerts">
             <a:extLst xmlns:a="http://schemas.openxmlformats.org/drawingml/2006/main">
               <a:ext uri="{FF2B5EF4-FFF2-40B4-BE49-F238E27FC236}">
-                <a16:creationId xmlns:a16="http://schemas.microsoft.com/office/drawing/2014/main" id="{D035768D-6740-448F-BA32-71976397E813}"/>
+                <a16:creationId xmlns:a16="http://schemas.microsoft.com/office/drawing/2014/main" id="{B81178FB-1116-4785-9BB5-F9EC27D6C809}"/>
               </a:ext>
             </a:extLst>
           </p:cNvPr>
@@ -18465,7 +18465,7 @@
                 <a:ea typeface="Arial"/>
                 <a:cs typeface="Arial"/>
               </a:rPr>
-              <a:t>Radio and scheduled calls</a:t>
+              <a:t>Radio and scheduled alerts</a:t>
             </a:r>
           </a:p>
         </p:txBody>
@@ -18475,7 +18475,7 @@
           <p:cNvPr id="2" name="17">
             <a:extLst xmlns:a="http://schemas.openxmlformats.org/drawingml/2006/main">
               <a:ext uri="{FF2B5EF4-FFF2-40B4-BE49-F238E27FC236}">
-                <a16:creationId xmlns:a16="http://schemas.microsoft.com/office/drawing/2014/main" id="{A0EF1DD5-3CFA-49A9-BB1B-16D4C65382C0}"/>
+                <a16:creationId xmlns:a16="http://schemas.microsoft.com/office/drawing/2014/main" id="{34163F6C-A776-4248-A35A-F487C1344B95}"/>
               </a:ext>
             </a:extLst>
           </p:cNvPr>
@@ -18630,10 +18630,10 @@
       </p:sp>
       <p:sp>
         <p:nvSpPr>
-          <p:cNvPr id="3" name="640">
+          <p:cNvPr id="3" name="RING">
             <a:extLst xmlns:a="http://schemas.openxmlformats.org/drawingml/2006/main">
               <a:ext uri="{FF2B5EF4-FFF2-40B4-BE49-F238E27FC236}">
-                <a16:creationId xmlns:a16="http://schemas.microsoft.com/office/drawing/2014/main" id="{72805B55-24BF-47FC-9981-9C503513616A}"/>
+                <a16:creationId xmlns:a16="http://schemas.microsoft.com/office/drawing/2014/main" id="{1BEFDFEB-AA97-4A92-B2E8-1BFB945F5B31}"/>
               </a:ext>
             </a:extLst>
           </p:cNvPr>
@@ -18781,17 +18781,17 @@
                 <a:ea typeface="Arial"/>
                 <a:cs typeface="Arial"/>
               </a:rPr>
-              <a:t>640</a:t>
+              <a:t>RING</a:t>
             </a:r>
           </a:p>
         </p:txBody>
       </p:sp>
       <p:sp>
         <p:nvSpPr>
-          <p:cNvPr id="4" name="Alarm tone">
+          <p:cNvPr id="4" name="Until you stop it">
             <a:extLst xmlns:a="http://schemas.openxmlformats.org/drawingml/2006/main">
               <a:ext uri="{FF2B5EF4-FFF2-40B4-BE49-F238E27FC236}">
-                <a16:creationId xmlns:a16="http://schemas.microsoft.com/office/drawing/2014/main" id="{53FAE97A-7022-4C25-AA4F-D211BC20AB3D}"/>
+                <a16:creationId xmlns:a16="http://schemas.microsoft.com/office/drawing/2014/main" id="{A878FFAE-C628-4FA7-AC52-FA6911F6F3FB}"/>
               </a:ext>
             </a:extLst>
           </p:cNvPr>
@@ -18939,17 +18939,17 @@
                 <a:ea typeface="Arial"/>
                 <a:cs typeface="Arial"/>
               </a:rPr>
-              <a:t>Alarm tone</a:t>
+              <a:t>Until you stop it</a:t>
             </a:r>
           </a:p>
         </p:txBody>
       </p:sp>
       <p:sp>
         <p:nvSpPr>
-          <p:cNvPr id="5" name="Up to 30 seconds&#10;Ends after playback">
+          <p:cNvPr id="5" name="Answer / reject&#10;or press Stop alert">
             <a:extLst xmlns:a="http://schemas.openxmlformats.org/drawingml/2006/main">
               <a:ext uri="{FF2B5EF4-FFF2-40B4-BE49-F238E27FC236}">
-                <a16:creationId xmlns:a16="http://schemas.microsoft.com/office/drawing/2014/main" id="{0C192520-3D40-4882-B0A5-8CDC1E62D4BB}"/>
+                <a16:creationId xmlns:a16="http://schemas.microsoft.com/office/drawing/2014/main" id="{2358550B-1FCB-4083-9B5E-31A614C0955B}"/>
               </a:ext>
             </a:extLst>
           </p:cNvPr>
@@ -19097,7 +19097,7 @@
                 <a:ea typeface="Arial"/>
                 <a:cs typeface="Arial"/>
               </a:rPr>
-              <a:t>Up to 30 seconds</a:t>
+              <a:t>Answer / reject</a:t>
             </a:r>
           </a:p>
           <a:p xmlns:a="http://schemas.openxmlformats.org/drawingml/2006/main">
@@ -19120,17 +19120,17 @@
                 <a:ea typeface="Arial"/>
                 <a:cs typeface="Arial"/>
               </a:rPr>
-              <a:t>Ends after playback</a:t>
+              <a:t>or press Stop alert</a:t>
             </a:r>
           </a:p>
         </p:txBody>
       </p:sp>
       <p:sp>
         <p:nvSpPr>
-          <p:cNvPr id="6" name="Radio fetches only&#10;during an active call">
+          <p:cNvPr id="6" name="No auto-answer&#10;No after-answer audio">
             <a:extLst xmlns:a="http://schemas.openxmlformats.org/drawingml/2006/main">
               <a:ext uri="{FF2B5EF4-FFF2-40B4-BE49-F238E27FC236}">
-                <a16:creationId xmlns:a16="http://schemas.microsoft.com/office/drawing/2014/main" id="{F638EE0F-AAA4-4DA7-A20C-62941903FCB0}"/>
+                <a16:creationId xmlns:a16="http://schemas.microsoft.com/office/drawing/2014/main" id="{FF721422-B5B4-4A08-8C4E-D7D84E5CF695}"/>
               </a:ext>
             </a:extLst>
           </p:cNvPr>
@@ -19278,7 +19278,7 @@
                 <a:ea typeface="Arial"/>
                 <a:cs typeface="Arial"/>
               </a:rPr>
-              <a:t>Radio fetches only</a:t>
+              <a:t>No auto-answer</a:t>
             </a:r>
           </a:p>
           <a:p xmlns:a="http://schemas.openxmlformats.org/drawingml/2006/main">
@@ -19301,7 +19301,7 @@
                 <a:ea typeface="Arial"/>
                 <a:cs typeface="Arial"/>
               </a:rPr>
-              <a:t>during an active call</a:t>
+              <a:t>No after-answer audio</a:t>
             </a:r>
           </a:p>
         </p:txBody>
@@ -19311,7 +19311,7 @@
           <p:cNvPr id="7" name="701">
             <a:extLst xmlns:a="http://schemas.openxmlformats.org/drawingml/2006/main">
               <a:ext uri="{FF2B5EF4-FFF2-40B4-BE49-F238E27FC236}">
-                <a16:creationId xmlns:a16="http://schemas.microsoft.com/office/drawing/2014/main" id="{F3F07658-52B5-4475-BAF7-B18C6584199B}"/>
+                <a16:creationId xmlns:a16="http://schemas.microsoft.com/office/drawing/2014/main" id="{2493BAA6-7778-4724-832E-83FE0F20069C}"/>
               </a:ext>
             </a:extLst>
           </p:cNvPr>
@@ -19469,7 +19469,7 @@
           <p:cNvPr id="8" name="Matryoshka Radio">
             <a:extLst xmlns:a="http://schemas.openxmlformats.org/drawingml/2006/main">
               <a:ext uri="{FF2B5EF4-FFF2-40B4-BE49-F238E27FC236}">
-                <a16:creationId xmlns:a16="http://schemas.microsoft.com/office/drawing/2014/main" id="{3BD1E7F5-3342-4FDF-8231-ECAC9FE947BD}"/>
+                <a16:creationId xmlns:a16="http://schemas.microsoft.com/office/drawing/2014/main" id="{4449D4E5-3372-4A8B-A665-9ACE4848A053}"/>
               </a:ext>
             </a:extLst>
           </p:cNvPr>
@@ -19627,7 +19627,7 @@
           <p:cNvPr id="9" name="702">
             <a:extLst xmlns:a="http://schemas.openxmlformats.org/drawingml/2006/main">
               <a:ext uri="{FF2B5EF4-FFF2-40B4-BE49-F238E27FC236}">
-                <a16:creationId xmlns:a16="http://schemas.microsoft.com/office/drawing/2014/main" id="{B605D583-7831-4A66-A976-E9CE7AEB6FAA}"/>
+                <a16:creationId xmlns:a16="http://schemas.microsoft.com/office/drawing/2014/main" id="{EF407A98-762C-430A-A3F8-783BAF62CCB2}"/>
               </a:ext>
             </a:extLst>
           </p:cNvPr>
@@ -19785,7 +19785,7 @@
           <p:cNvPr id="10" name="Echo online">
             <a:extLst xmlns:a="http://schemas.openxmlformats.org/drawingml/2006/main">
               <a:ext uri="{FF2B5EF4-FFF2-40B4-BE49-F238E27FC236}">
-                <a16:creationId xmlns:a16="http://schemas.microsoft.com/office/drawing/2014/main" id="{4D71E6D1-49C2-4ABE-B958-A6472BA39C82}"/>
+                <a16:creationId xmlns:a16="http://schemas.microsoft.com/office/drawing/2014/main" id="{5D80B8FD-A2B1-4F00-A7F7-9412093764CE}"/>
               </a:ext>
             </a:extLst>
           </p:cNvPr>
@@ -19943,7 +19943,7 @@
           <p:cNvPr id="11" name="703">
             <a:extLst xmlns:a="http://schemas.openxmlformats.org/drawingml/2006/main">
               <a:ext uri="{FF2B5EF4-FFF2-40B4-BE49-F238E27FC236}">
-                <a16:creationId xmlns:a16="http://schemas.microsoft.com/office/drawing/2014/main" id="{D4E68F28-4B0E-45A6-A0C4-6050888E2655}"/>
+                <a16:creationId xmlns:a16="http://schemas.microsoft.com/office/drawing/2014/main" id="{49533832-32BF-4065-80C2-40C3289E03D3}"/>
               </a:ext>
             </a:extLst>
           </p:cNvPr>
@@ -20101,7 +20101,7 @@
           <p:cNvPr id="12" name="RADIO BOB! Rock">
             <a:extLst xmlns:a="http://schemas.openxmlformats.org/drawingml/2006/main">
               <a:ext uri="{FF2B5EF4-FFF2-40B4-BE49-F238E27FC236}">
-                <a16:creationId xmlns:a16="http://schemas.microsoft.com/office/drawing/2014/main" id="{D8C7ACD4-4132-435B-8341-995FFB13FF8F}"/>
+                <a16:creationId xmlns:a16="http://schemas.microsoft.com/office/drawing/2014/main" id="{5D611BF4-4F4D-4DC8-8C55-67762B47EEB4}"/>
               </a:ext>
             </a:extLst>
           </p:cNvPr>
@@ -20259,7 +20259,7 @@
           <p:cNvPr id="13" name="704">
             <a:extLst xmlns:a="http://schemas.openxmlformats.org/drawingml/2006/main">
               <a:ext uri="{FF2B5EF4-FFF2-40B4-BE49-F238E27FC236}">
-                <a16:creationId xmlns:a16="http://schemas.microsoft.com/office/drawing/2014/main" id="{55B181AB-55A7-4807-93A5-C892ABDAF286}"/>
+                <a16:creationId xmlns:a16="http://schemas.microsoft.com/office/drawing/2014/main" id="{99AF90E4-B08C-4C32-889D-926F9B04C9F5}"/>
               </a:ext>
             </a:extLst>
           </p:cNvPr>
@@ -20417,7 +20417,7 @@
           <p:cNvPr id="14" name="RADIO BOB! Metal">
             <a:extLst xmlns:a="http://schemas.openxmlformats.org/drawingml/2006/main">
               <a:ext uri="{FF2B5EF4-FFF2-40B4-BE49-F238E27FC236}">
-                <a16:creationId xmlns:a16="http://schemas.microsoft.com/office/drawing/2014/main" id="{AF6FBB85-D39C-4414-A862-4E46B253CDC1}"/>
+                <a16:creationId xmlns:a16="http://schemas.microsoft.com/office/drawing/2014/main" id="{0F094306-08CC-4C86-A96F-84E6796A9C9A}"/>
               </a:ext>
             </a:extLst>
           </p:cNvPr>
@@ -20575,7 +20575,7 @@
           <p:cNvPr id="15" name="705">
             <a:extLst xmlns:a="http://schemas.openxmlformats.org/drawingml/2006/main">
               <a:ext uri="{FF2B5EF4-FFF2-40B4-BE49-F238E27FC236}">
-                <a16:creationId xmlns:a16="http://schemas.microsoft.com/office/drawing/2014/main" id="{1024FEBF-3033-4230-9865-C7AB5EA7C7C2}"/>
+                <a16:creationId xmlns:a16="http://schemas.microsoft.com/office/drawing/2014/main" id="{1D256B4C-47FC-4AE5-ACA0-56575CE995E8}"/>
               </a:ext>
             </a:extLst>
           </p:cNvPr>
@@ -20733,7 +20733,7 @@
           <p:cNvPr id="16" name="RADIO BOB! Gothic">
             <a:extLst xmlns:a="http://schemas.openxmlformats.org/drawingml/2006/main">
               <a:ext uri="{FF2B5EF4-FFF2-40B4-BE49-F238E27FC236}">
-                <a16:creationId xmlns:a16="http://schemas.microsoft.com/office/drawing/2014/main" id="{218B0684-2BB5-4187-9C00-D304099AA120}"/>
+                <a16:creationId xmlns:a16="http://schemas.microsoft.com/office/drawing/2014/main" id="{33D51150-CCC3-4F74-8A9C-641F3089823D}"/>
               </a:ext>
             </a:extLst>
           </p:cNvPr>
@@ -20891,7 +20891,7 @@
           <p:cNvPr id="17" name="706">
             <a:extLst xmlns:a="http://schemas.openxmlformats.org/drawingml/2006/main">
               <a:ext uri="{FF2B5EF4-FFF2-40B4-BE49-F238E27FC236}">
-                <a16:creationId xmlns:a16="http://schemas.microsoft.com/office/drawing/2014/main" id="{5F43D29D-1D79-45C4-A54C-A6390E6055D6}"/>
+                <a16:creationId xmlns:a16="http://schemas.microsoft.com/office/drawing/2014/main" id="{4B4831E2-C979-456D-ADF8-F27F61C5A766}"/>
               </a:ext>
             </a:extLst>
           </p:cNvPr>
@@ -21049,7 +21049,7 @@
           <p:cNvPr id="18" name="SomaFM PopTron">
             <a:extLst xmlns:a="http://schemas.openxmlformats.org/drawingml/2006/main">
               <a:ext uri="{FF2B5EF4-FFF2-40B4-BE49-F238E27FC236}">
-                <a16:creationId xmlns:a16="http://schemas.microsoft.com/office/drawing/2014/main" id="{CBE1AE80-3101-4B8C-887B-5A090D79BADC}"/>
+                <a16:creationId xmlns:a16="http://schemas.microsoft.com/office/drawing/2014/main" id="{5B2CDE62-82A5-40B3-A58F-6E1C8B231440}"/>
               </a:ext>
             </a:extLst>
           </p:cNvPr>
@@ -21207,7 +21207,7 @@
           <p:cNvPr id="19" name="707">
             <a:extLst xmlns:a="http://schemas.openxmlformats.org/drawingml/2006/main">
               <a:ext uri="{FF2B5EF4-FFF2-40B4-BE49-F238E27FC236}">
-                <a16:creationId xmlns:a16="http://schemas.microsoft.com/office/drawing/2014/main" id="{005D21B9-F37A-4F40-B4CC-BF5D7C5660B4}"/>
+                <a16:creationId xmlns:a16="http://schemas.microsoft.com/office/drawing/2014/main" id="{EE8BE85C-2D99-4A4C-9669-CB1F911C8200}"/>
               </a:ext>
             </a:extLst>
           </p:cNvPr>
@@ -21365,7 +21365,7 @@
           <p:cNvPr id="20" name="Radyo Viva / Turkish">
             <a:extLst xmlns:a="http://schemas.openxmlformats.org/drawingml/2006/main">
               <a:ext uri="{FF2B5EF4-FFF2-40B4-BE49-F238E27FC236}">
-                <a16:creationId xmlns:a16="http://schemas.microsoft.com/office/drawing/2014/main" id="{C7507CE6-530A-4696-AF3B-B43B5CDC50EF}"/>
+                <a16:creationId xmlns:a16="http://schemas.microsoft.com/office/drawing/2014/main" id="{61B9343B-9FBB-4492-9D63-9CD8D2D84A33}"/>
               </a:ext>
             </a:extLst>
           </p:cNvPr>
@@ -21520,10 +21520,10 @@
       </p:sp>
       <p:sp>
         <p:nvSpPr>
-          <p:cNvPr id="21" name="Official streams decoded successfully. Handset radio and alarm te">
+          <p:cNvPr id="21" name="640 remains a manual tone test. New alert behavior awaits deploym">
             <a:extLst xmlns:a="http://schemas.openxmlformats.org/drawingml/2006/main">
               <a:ext uri="{FF2B5EF4-FFF2-40B4-BE49-F238E27FC236}">
-                <a16:creationId xmlns:a16="http://schemas.microsoft.com/office/drawing/2014/main" id="{C56628E3-1936-4FFA-924A-553DD71EC30C}"/>
+                <a16:creationId xmlns:a16="http://schemas.microsoft.com/office/drawing/2014/main" id="{7F112327-5FB4-469D-81A2-9A1D3FCCF767}"/>
               </a:ext>
             </a:extLst>
           </p:cNvPr>
@@ -21671,7 +21671,7 @@
                 <a:ea typeface="Arial"/>
                 <a:cs typeface="Arial"/>
               </a:rPr>
-              <a:t>Official streams decoded successfully. Handset radio and alarm tests continue.</a:t>
+              <a:t>640 remains a manual tone test. New alert behavior awaits deployment and live acceptance.</a:t>
             </a:r>
           </a:p>
         </p:txBody>
@@ -21679,7 +21679,7 @@
     </p:spTree>
     <p:extLst>
       <p:ext uri="{BB962C8B-B14F-4D97-AF65-F5344CB8AC3E}">
-        <p14:creationId xmlns:p14="http://schemas.microsoft.com/office/powerpoint/2010/main" val="2064023368"/>
+        <p14:creationId xmlns:p14="http://schemas.microsoft.com/office/powerpoint/2010/main" val="492685547"/>
       </p:ext>
     </p:extLst>
   </p:cSld>
@@ -21710,7 +21710,7 @@
           <p:cNvPr id="14" name="Free SIP account status">
             <a:extLst xmlns:a="http://schemas.openxmlformats.org/drawingml/2006/main">
               <a:ext uri="{FF2B5EF4-FFF2-40B4-BE49-F238E27FC236}">
-                <a16:creationId xmlns:a16="http://schemas.microsoft.com/office/drawing/2014/main" id="{AB75C41D-7D05-41B3-A731-0A5AF0499436}"/>
+                <a16:creationId xmlns:a16="http://schemas.microsoft.com/office/drawing/2014/main" id="{10CA7F7D-D3F8-4249-B599-51575CA32150}"/>
               </a:ext>
             </a:extLst>
           </p:cNvPr>
@@ -21868,7 +21868,7 @@
           <p:cNvPr id="2" name="18">
             <a:extLst xmlns:a="http://schemas.openxmlformats.org/drawingml/2006/main">
               <a:ext uri="{FF2B5EF4-FFF2-40B4-BE49-F238E27FC236}">
-                <a16:creationId xmlns:a16="http://schemas.microsoft.com/office/drawing/2014/main" id="{D10A52C8-A56E-4899-ADD8-F97DB0942B1C}"/>
+                <a16:creationId xmlns:a16="http://schemas.microsoft.com/office/drawing/2014/main" id="{8A08B38D-A66C-42F0-898A-A150F07B787D}"/>
               </a:ext>
             </a:extLst>
           </p:cNvPr>
@@ -22026,7 +22026,7 @@
           <p:cNvPr id="3" name="SIP2SIP">
             <a:extLst xmlns:a="http://schemas.openxmlformats.org/drawingml/2006/main">
               <a:ext uri="{FF2B5EF4-FFF2-40B4-BE49-F238E27FC236}">
-                <a16:creationId xmlns:a16="http://schemas.microsoft.com/office/drawing/2014/main" id="{8C99E4F2-EC92-44CF-9194-40DFCAA4D237}"/>
+                <a16:creationId xmlns:a16="http://schemas.microsoft.com/office/drawing/2014/main" id="{2A51D442-9F07-4033-8DE7-BB3C57AB885E}"/>
               </a:ext>
             </a:extLst>
           </p:cNvPr>
@@ -22056,7 +22056,7 @@
             <a:defPPr algn="l">
               <a:defRPr sz="2250" b="1">
                 <a:solidFill>
-                  <a:srgbClr val="48DDCC"/>
+                  <a:srgbClr val="F7CB64"/>
                 </a:solidFill>
                 <a:latin typeface="Arial"/>
                 <a:ea typeface="Arial"/>
@@ -22066,7 +22066,7 @@
             <a:lvl1pPr algn="l">
               <a:defRPr sz="2250" b="1">
                 <a:solidFill>
-                  <a:srgbClr val="48DDCC"/>
+                  <a:srgbClr val="F7CB64"/>
                 </a:solidFill>
                 <a:latin typeface="Arial"/>
                 <a:ea typeface="Arial"/>
@@ -22076,7 +22076,7 @@
             <a:lvl2pPr algn="l">
               <a:defRPr sz="2250" b="1">
                 <a:solidFill>
-                  <a:srgbClr val="48DDCC"/>
+                  <a:srgbClr val="F7CB64"/>
                 </a:solidFill>
                 <a:latin typeface="Arial"/>
                 <a:ea typeface="Arial"/>
@@ -22086,7 +22086,7 @@
             <a:lvl3pPr algn="l">
               <a:defRPr sz="2250" b="1">
                 <a:solidFill>
-                  <a:srgbClr val="48DDCC"/>
+                  <a:srgbClr val="F7CB64"/>
                 </a:solidFill>
                 <a:latin typeface="Arial"/>
                 <a:ea typeface="Arial"/>
@@ -22096,7 +22096,7 @@
             <a:lvl4pPr algn="l">
               <a:defRPr sz="2250" b="1">
                 <a:solidFill>
-                  <a:srgbClr val="48DDCC"/>
+                  <a:srgbClr val="F7CB64"/>
                 </a:solidFill>
                 <a:latin typeface="Arial"/>
                 <a:ea typeface="Arial"/>
@@ -22106,7 +22106,7 @@
             <a:lvl5pPr algn="l">
               <a:defRPr sz="2250" b="1">
                 <a:solidFill>
-                  <a:srgbClr val="48DDCC"/>
+                  <a:srgbClr val="F7CB64"/>
                 </a:solidFill>
                 <a:latin typeface="Arial"/>
                 <a:ea typeface="Arial"/>
@@ -22116,7 +22116,7 @@
             <a:lvl6pPr algn="l">
               <a:defRPr sz="2250" b="1">
                 <a:solidFill>
-                  <a:srgbClr val="48DDCC"/>
+                  <a:srgbClr val="F7CB64"/>
                 </a:solidFill>
                 <a:latin typeface="Arial"/>
                 <a:ea typeface="Arial"/>
@@ -22126,7 +22126,7 @@
             <a:lvl7pPr algn="l">
               <a:defRPr sz="2250" b="1">
                 <a:solidFill>
-                  <a:srgbClr val="48DDCC"/>
+                  <a:srgbClr val="F7CB64"/>
                 </a:solidFill>
                 <a:latin typeface="Arial"/>
                 <a:ea typeface="Arial"/>
@@ -22136,7 +22136,7 @@
             <a:lvl8pPr algn="l">
               <a:defRPr sz="2250" b="1">
                 <a:solidFill>
-                  <a:srgbClr val="48DDCC"/>
+                  <a:srgbClr val="F7CB64"/>
                 </a:solidFill>
                 <a:latin typeface="Arial"/>
                 <a:ea typeface="Arial"/>
@@ -22146,7 +22146,7 @@
             <a:lvl9pPr algn="l">
               <a:defRPr sz="2250" b="1">
                 <a:solidFill>
-                  <a:srgbClr val="48DDCC"/>
+                  <a:srgbClr val="F7CB64"/>
                 </a:solidFill>
                 <a:latin typeface="Arial"/>
                 <a:ea typeface="Arial"/>
@@ -22158,7 +22158,7 @@
             <a:pPr algn="l">
               <a:defRPr sz="2250" b="1">
                 <a:solidFill>
-                  <a:srgbClr val="48DDCC"/>
+                  <a:srgbClr val="F7CB64"/>
                 </a:solidFill>
                 <a:latin typeface="Arial"/>
                 <a:ea typeface="Arial"/>
@@ -22168,7 +22168,7 @@
             <a:r>
               <a:rPr sz="2250" b="1">
                 <a:solidFill>
-                  <a:srgbClr val="48DDCC"/>
+                  <a:srgbClr val="F7CB64"/>
                 </a:solidFill>
                 <a:latin typeface="Arial"/>
                 <a:ea typeface="Arial"/>
@@ -22181,10 +22181,10 @@
       </p:sp>
       <p:sp>
         <p:nvSpPr>
-          <p:cNvPr id="4" name="Registered; 802 audio test deferred">
+          <p:cNvPr id="4" name="Echo answered, RTP loss observed">
             <a:extLst xmlns:a="http://schemas.openxmlformats.org/drawingml/2006/main">
               <a:ext uri="{FF2B5EF4-FFF2-40B4-BE49-F238E27FC236}">
-                <a16:creationId xmlns:a16="http://schemas.microsoft.com/office/drawing/2014/main" id="{5CD1A6CF-0854-441B-A040-2CA370522F86}"/>
+                <a16:creationId xmlns:a16="http://schemas.microsoft.com/office/drawing/2014/main" id="{8A94B71F-7B66-4ECA-B9FF-EECF89BDCBA1}"/>
               </a:ext>
             </a:extLst>
           </p:cNvPr>
@@ -22332,7 +22332,7 @@
                 <a:ea typeface="Arial"/>
                 <a:cs typeface="Arial"/>
               </a:rPr>
-              <a:t>Registered; 802 audio test deferred</a:t>
+              <a:t>Echo answered, RTP loss observed</a:t>
             </a:r>
           </a:p>
         </p:txBody>
@@ -22342,7 +22342,7 @@
           <p:cNvPr id="5" name="Callcentric">
             <a:extLst xmlns:a="http://schemas.openxmlformats.org/drawingml/2006/main">
               <a:ext uri="{FF2B5EF4-FFF2-40B4-BE49-F238E27FC236}">
-                <a16:creationId xmlns:a16="http://schemas.microsoft.com/office/drawing/2014/main" id="{93C4F66D-DA57-419F-928B-136B2F1FB8C7}"/>
+                <a16:creationId xmlns:a16="http://schemas.microsoft.com/office/drawing/2014/main" id="{54EEFE34-3C33-4D4F-82CC-832650836B9C}"/>
               </a:ext>
             </a:extLst>
           </p:cNvPr>
@@ -22497,10 +22497,10 @@
       </p:sp>
       <p:sp>
         <p:nvSpPr>
-          <p:cNvPr id="6" name="Registered; outbound review required">
+          <p:cNvPr id="6" name="Registered, outbound review required">
             <a:extLst xmlns:a="http://schemas.openxmlformats.org/drawingml/2006/main">
               <a:ext uri="{FF2B5EF4-FFF2-40B4-BE49-F238E27FC236}">
-                <a16:creationId xmlns:a16="http://schemas.microsoft.com/office/drawing/2014/main" id="{F5876147-BD2D-4E60-93D2-4E0504728D97}"/>
+                <a16:creationId xmlns:a16="http://schemas.microsoft.com/office/drawing/2014/main" id="{55ACC906-0FF8-40B4-B38A-D62E34FC447F}"/>
               </a:ext>
             </a:extLst>
           </p:cNvPr>
@@ -22648,7 +22648,7 @@
                 <a:ea typeface="Arial"/>
                 <a:cs typeface="Arial"/>
               </a:rPr>
-              <a:t>Registered; outbound review required</a:t>
+              <a:t>Registered, outbound review required</a:t>
             </a:r>
           </a:p>
         </p:txBody>
@@ -22658,7 +22658,7 @@
           <p:cNvPr id="7" name="Linphone">
             <a:extLst xmlns:a="http://schemas.openxmlformats.org/drawingml/2006/main">
               <a:ext uri="{FF2B5EF4-FFF2-40B4-BE49-F238E27FC236}">
-                <a16:creationId xmlns:a16="http://schemas.microsoft.com/office/drawing/2014/main" id="{1ADDCED0-A021-404B-99AC-554839AFF184}"/>
+                <a16:creationId xmlns:a16="http://schemas.microsoft.com/office/drawing/2014/main" id="{5CBC1CC4-5B72-4CBB-BF97-862A3C6D16B1}"/>
               </a:ext>
             </a:extLst>
           </p:cNvPr>
@@ -22813,10 +22813,10 @@
       </p:sp>
       <p:sp>
         <p:nvSpPr>
-          <p:cNvPr id="8" name="Registered; verified peer still needed">
+          <p:cNvPr id="8" name="Registered, verified peer still needed">
             <a:extLst xmlns:a="http://schemas.openxmlformats.org/drawingml/2006/main">
               <a:ext uri="{FF2B5EF4-FFF2-40B4-BE49-F238E27FC236}">
-                <a16:creationId xmlns:a16="http://schemas.microsoft.com/office/drawing/2014/main" id="{CA15DC05-1B75-44F5-8C88-22B5561A8AE2}"/>
+                <a16:creationId xmlns:a16="http://schemas.microsoft.com/office/drawing/2014/main" id="{F45F6876-940D-4EB6-9DBC-CE71014ECA5B}"/>
               </a:ext>
             </a:extLst>
           </p:cNvPr>
@@ -22964,7 +22964,7 @@
                 <a:ea typeface="Arial"/>
                 <a:cs typeface="Arial"/>
               </a:rPr>
-              <a:t>Registered; verified peer still needed</a:t>
+              <a:t>Registered, verified peer still needed</a:t>
             </a:r>
           </a:p>
         </p:txBody>
@@ -22974,7 +22974,7 @@
           <p:cNvPr id="9" name="FWD">
             <a:extLst xmlns:a="http://schemas.openxmlformats.org/drawingml/2006/main">
               <a:ext uri="{FF2B5EF4-FFF2-40B4-BE49-F238E27FC236}">
-                <a16:creationId xmlns:a16="http://schemas.microsoft.com/office/drawing/2014/main" id="{CF1FC03C-BE24-47DA-A2A3-6B9D756612EC}"/>
+                <a16:creationId xmlns:a16="http://schemas.microsoft.com/office/drawing/2014/main" id="{1A8858C2-30A1-4E06-8DDA-39D4660791B2}"/>
               </a:ext>
             </a:extLst>
           </p:cNvPr>
@@ -23132,7 +23132,7 @@
           <p:cNvPr id="10" name="Stopped at mandatory Verification Fee">
             <a:extLst xmlns:a="http://schemas.openxmlformats.org/drawingml/2006/main">
               <a:ext uri="{FF2B5EF4-FFF2-40B4-BE49-F238E27FC236}">
-                <a16:creationId xmlns:a16="http://schemas.microsoft.com/office/drawing/2014/main" id="{ACB6DF7C-9964-4D9A-9E6F-1114DCD89800}"/>
+                <a16:creationId xmlns:a16="http://schemas.microsoft.com/office/drawing/2014/main" id="{2ACAF121-710A-4DB6-BCE8-5F1107C72B57}"/>
               </a:ext>
             </a:extLst>
           </p:cNvPr>
@@ -23290,7 +23290,7 @@
           <p:cNvPr id="11" name="Google Voice">
             <a:extLst xmlns:a="http://schemas.openxmlformats.org/drawingml/2006/main">
               <a:ext uri="{FF2B5EF4-FFF2-40B4-BE49-F238E27FC236}">
-                <a16:creationId xmlns:a16="http://schemas.microsoft.com/office/drawing/2014/main" id="{953E0917-DBCA-4C4E-A015-ED141DD7CFFE}"/>
+                <a16:creationId xmlns:a16="http://schemas.microsoft.com/office/drawing/2014/main" id="{FA599304-FBBD-4765-B09B-C2B228B4C6FE}"/>
               </a:ext>
             </a:extLst>
           </p:cNvPr>
@@ -23448,7 +23448,7 @@
           <p:cNvPr id="12" name="No official free Asterisk SIP trunk">
             <a:extLst xmlns:a="http://schemas.openxmlformats.org/drawingml/2006/main">
               <a:ext uri="{FF2B5EF4-FFF2-40B4-BE49-F238E27FC236}">
-                <a16:creationId xmlns:a16="http://schemas.microsoft.com/office/drawing/2014/main" id="{3FCE805B-C7DD-4006-AE9F-D47FE8D363F6}"/>
+                <a16:creationId xmlns:a16="http://schemas.microsoft.com/office/drawing/2014/main" id="{2D3E0154-72DF-4FC3-832F-900D7ED0B921}"/>
               </a:ext>
             </a:extLst>
           </p:cNvPr>
@@ -23603,10 +23603,10 @@
       </p:sp>
       <p:sp>
         <p:nvSpPr>
-          <p:cNvPr id="13" name="REGISTER succeeded for three providers. External audio remains un">
+          <p:cNvPr id="13" name="Three providers registered. External media quality still needs ve">
             <a:extLst xmlns:a="http://schemas.openxmlformats.org/drawingml/2006/main">
               <a:ext uri="{FF2B5EF4-FFF2-40B4-BE49-F238E27FC236}">
-                <a16:creationId xmlns:a16="http://schemas.microsoft.com/office/drawing/2014/main" id="{1BF48E69-F87E-46F6-9467-57CBB39C0A43}"/>
+                <a16:creationId xmlns:a16="http://schemas.microsoft.com/office/drawing/2014/main" id="{1D5C1C08-452F-4CF3-AA34-49628FDC1344}"/>
               </a:ext>
             </a:extLst>
           </p:cNvPr>
@@ -23754,7 +23754,7 @@
                 <a:ea typeface="Arial"/>
                 <a:cs typeface="Arial"/>
               </a:rPr>
-              <a:t>REGISTER succeeded for three providers. External audio remains unverified.</a:t>
+              <a:t>Three providers registered. External media quality still needs verification.</a:t>
             </a:r>
           </a:p>
         </p:txBody>
@@ -23762,7 +23762,7 @@
     </p:spTree>
     <p:extLst>
       <p:ext uri="{BB962C8B-B14F-4D97-AF65-F5344CB8AC3E}">
-        <p14:creationId xmlns:p14="http://schemas.microsoft.com/office/powerpoint/2010/main" val="842947939"/>
+        <p14:creationId xmlns:p14="http://schemas.microsoft.com/office/powerpoint/2010/main" val="1544945871"/>
       </p:ext>
     </p:extLst>
   </p:cSld>
@@ -23790,10 +23790,10 @@
       </p:grpSpPr>
       <p:sp>
         <p:nvSpPr>
-          <p:cNvPr id="9" name="Our lot: 10 Cisco 7945G phones">
+          <p:cNvPr id="10" name="Cisco 7945G: model and inventory">
             <a:extLst xmlns:a="http://schemas.openxmlformats.org/drawingml/2006/main">
               <a:ext uri="{FF2B5EF4-FFF2-40B4-BE49-F238E27FC236}">
-                <a16:creationId xmlns:a16="http://schemas.microsoft.com/office/drawing/2014/main" id="{E7927487-16E0-4683-A1C6-B29856A52BD1}"/>
+                <a16:creationId xmlns:a16="http://schemas.microsoft.com/office/drawing/2014/main" id="{EA7F30C2-ADBC-4599-AE0B-993411115035}"/>
               </a:ext>
             </a:extLst>
           </p:cNvPr>
@@ -23941,7 +23941,7 @@
                 <a:ea typeface="Arial"/>
                 <a:cs typeface="Arial"/>
               </a:rPr>
-              <a:t>Our lot: 10 Cisco 7945G phones</a:t>
+              <a:t>Cisco 7945G: model and inventory</a:t>
             </a:r>
           </a:p>
         </p:txBody>
@@ -23951,7 +23951,7 @@
           <p:cNvPr id="2" name="02">
             <a:extLst xmlns:a="http://schemas.openxmlformats.org/drawingml/2006/main">
               <a:ext uri="{FF2B5EF4-FFF2-40B4-BE49-F238E27FC236}">
-                <a16:creationId xmlns:a16="http://schemas.microsoft.com/office/drawing/2014/main" id="{FC0648A3-9C18-4C47-B95E-1B7D035E2FA4}"/>
+                <a16:creationId xmlns:a16="http://schemas.microsoft.com/office/drawing/2014/main" id="{565E4BBB-1CD7-4B7F-93CE-3A9C84123272}"/>
               </a:ext>
             </a:extLst>
           </p:cNvPr>
@@ -24106,10 +24106,10 @@
       </p:sp>
       <p:sp>
         <p:nvSpPr>
-          <p:cNvPr id="3" name="10">
+          <p:cNvPr id="3" name="2">
             <a:extLst xmlns:a="http://schemas.openxmlformats.org/drawingml/2006/main">
               <a:ext uri="{FF2B5EF4-FFF2-40B4-BE49-F238E27FC236}">
-                <a16:creationId xmlns:a16="http://schemas.microsoft.com/office/drawing/2014/main" id="{1F4EEE4D-2403-4504-A244-198547DBAFA7}"/>
+                <a16:creationId xmlns:a16="http://schemas.microsoft.com/office/drawing/2014/main" id="{087518B4-AB4F-43CD-87A2-21D30B17C945}"/>
               </a:ext>
             </a:extLst>
           </p:cNvPr>
@@ -24257,17 +24257,17 @@
                 <a:ea typeface="Arial"/>
                 <a:cs typeface="Arial"/>
               </a:rPr>
-              <a:t>10</a:t>
+              <a:t>2</a:t>
             </a:r>
           </a:p>
         </p:txBody>
       </p:sp>
       <p:sp>
         <p:nvSpPr>
-          <p:cNvPr id="4" name="phones">
+          <p:cNvPr id="4" name="SIP lines">
             <a:extLst xmlns:a="http://schemas.openxmlformats.org/drawingml/2006/main">
               <a:ext uri="{FF2B5EF4-FFF2-40B4-BE49-F238E27FC236}">
-                <a16:creationId xmlns:a16="http://schemas.microsoft.com/office/drawing/2014/main" id="{2D6CD629-C482-4025-BC09-1BBB5954D603}"/>
+                <a16:creationId xmlns:a16="http://schemas.microsoft.com/office/drawing/2014/main" id="{B959A578-D332-415D-9B6B-C2E11175144C}"/>
               </a:ext>
             </a:extLst>
           </p:cNvPr>
@@ -24415,17 +24415,175 @@
                 <a:ea typeface="Arial"/>
                 <a:cs typeface="Arial"/>
               </a:rPr>
-              <a:t>phones</a:t>
+              <a:t>SIP lines</a:t>
             </a:r>
           </a:p>
         </p:txBody>
       </p:sp>
       <p:sp>
         <p:nvSpPr>
-          <p:cNvPr id="5" name="7945_7965 SIP firmware family">
+          <p:cNvPr id="5" name="Native 802.3af">
             <a:extLst xmlns:a="http://schemas.openxmlformats.org/drawingml/2006/main">
               <a:ext uri="{FF2B5EF4-FFF2-40B4-BE49-F238E27FC236}">
-                <a16:creationId xmlns:a16="http://schemas.microsoft.com/office/drawing/2014/main" id="{DFC131D0-7944-459A-8051-9D20444D6451}"/>
+                <a16:creationId xmlns:a16="http://schemas.microsoft.com/office/drawing/2014/main" id="{42CEB3B2-BBD5-49B6-BE2A-1CE4E6574E69}"/>
+              </a:ext>
+            </a:extLst>
+          </p:cNvPr>
+          <p:cNvSpPr>
+            <a:spLocks xmlns:a="http://schemas.openxmlformats.org/drawingml/2006/main" noGrp="1"/>
+          </p:cNvSpPr>
+          <p:nvPr/>
+        </p:nvSpPr>
+        <p:spPr>
+          <a:xfrm xmlns:a="http://schemas.openxmlformats.org/drawingml/2006/main">
+            <a:off x="666750" y="4429125"/>
+            <a:ext cx="2524125" cy="523875"/>
+          </a:xfrm>
+          <a:prstGeom xmlns:a="http://schemas.openxmlformats.org/drawingml/2006/main" prst="rect">
+            <a:avLst/>
+          </a:prstGeom>
+          <a:noFill xmlns:a="http://schemas.openxmlformats.org/drawingml/2006/main"/>
+          <a:ln xmlns:a="http://schemas.openxmlformats.org/drawingml/2006/main" w="0">
+            <a:noFill/>
+          </a:ln>
+        </p:spPr>
+        <p:txBody>
+          <a:bodyPr xmlns:a="http://schemas.openxmlformats.org/drawingml/2006/main" wrap="square" lIns="0" tIns="0" rIns="0" bIns="0" anchor="t">
+            <a:noAutofit/>
+          </a:bodyPr>
+          <a:lstStyle xmlns:a="http://schemas.openxmlformats.org/drawingml/2006/main">
+            <a:defPPr algn="l">
+              <a:defRPr sz="1875" b="0">
+                <a:solidFill>
+                  <a:srgbClr val="48DDCC"/>
+                </a:solidFill>
+                <a:latin typeface="Arial"/>
+                <a:ea typeface="Arial"/>
+                <a:cs typeface="Arial"/>
+              </a:defRPr>
+            </a:defPPr>
+            <a:lvl1pPr algn="l">
+              <a:defRPr sz="1875" b="0">
+                <a:solidFill>
+                  <a:srgbClr val="48DDCC"/>
+                </a:solidFill>
+                <a:latin typeface="Arial"/>
+                <a:ea typeface="Arial"/>
+                <a:cs typeface="Arial"/>
+              </a:defRPr>
+            </a:lvl1pPr>
+            <a:lvl2pPr algn="l">
+              <a:defRPr sz="1875" b="0">
+                <a:solidFill>
+                  <a:srgbClr val="48DDCC"/>
+                </a:solidFill>
+                <a:latin typeface="Arial"/>
+                <a:ea typeface="Arial"/>
+                <a:cs typeface="Arial"/>
+              </a:defRPr>
+            </a:lvl2pPr>
+            <a:lvl3pPr algn="l">
+              <a:defRPr sz="1875" b="0">
+                <a:solidFill>
+                  <a:srgbClr val="48DDCC"/>
+                </a:solidFill>
+                <a:latin typeface="Arial"/>
+                <a:ea typeface="Arial"/>
+                <a:cs typeface="Arial"/>
+              </a:defRPr>
+            </a:lvl3pPr>
+            <a:lvl4pPr algn="l">
+              <a:defRPr sz="1875" b="0">
+                <a:solidFill>
+                  <a:srgbClr val="48DDCC"/>
+                </a:solidFill>
+                <a:latin typeface="Arial"/>
+                <a:ea typeface="Arial"/>
+                <a:cs typeface="Arial"/>
+              </a:defRPr>
+            </a:lvl4pPr>
+            <a:lvl5pPr algn="l">
+              <a:defRPr sz="1875" b="0">
+                <a:solidFill>
+                  <a:srgbClr val="48DDCC"/>
+                </a:solidFill>
+                <a:latin typeface="Arial"/>
+                <a:ea typeface="Arial"/>
+                <a:cs typeface="Arial"/>
+              </a:defRPr>
+            </a:lvl5pPr>
+            <a:lvl6pPr algn="l">
+              <a:defRPr sz="1875" b="0">
+                <a:solidFill>
+                  <a:srgbClr val="48DDCC"/>
+                </a:solidFill>
+                <a:latin typeface="Arial"/>
+                <a:ea typeface="Arial"/>
+                <a:cs typeface="Arial"/>
+              </a:defRPr>
+            </a:lvl6pPr>
+            <a:lvl7pPr algn="l">
+              <a:defRPr sz="1875" b="0">
+                <a:solidFill>
+                  <a:srgbClr val="48DDCC"/>
+                </a:solidFill>
+                <a:latin typeface="Arial"/>
+                <a:ea typeface="Arial"/>
+                <a:cs typeface="Arial"/>
+              </a:defRPr>
+            </a:lvl7pPr>
+            <a:lvl8pPr algn="l">
+              <a:defRPr sz="1875" b="0">
+                <a:solidFill>
+                  <a:srgbClr val="48DDCC"/>
+                </a:solidFill>
+                <a:latin typeface="Arial"/>
+                <a:ea typeface="Arial"/>
+                <a:cs typeface="Arial"/>
+              </a:defRPr>
+            </a:lvl8pPr>
+            <a:lvl9pPr algn="l">
+              <a:defRPr sz="1875" b="0">
+                <a:solidFill>
+                  <a:srgbClr val="48DDCC"/>
+                </a:solidFill>
+                <a:latin typeface="Arial"/>
+                <a:ea typeface="Arial"/>
+                <a:cs typeface="Arial"/>
+              </a:defRPr>
+            </a:lvl9pPr>
+          </a:lstStyle>
+          <a:p xmlns:a="http://schemas.openxmlformats.org/drawingml/2006/main">
+            <a:pPr algn="l">
+              <a:defRPr sz="1875" b="0">
+                <a:solidFill>
+                  <a:srgbClr val="48DDCC"/>
+                </a:solidFill>
+                <a:latin typeface="Arial"/>
+                <a:ea typeface="Arial"/>
+                <a:cs typeface="Arial"/>
+              </a:defRPr>
+            </a:pPr>
+            <a:r>
+              <a:rPr sz="1875" b="0">
+                <a:solidFill>
+                  <a:srgbClr val="48DDCC"/>
+                </a:solidFill>
+                <a:latin typeface="Arial"/>
+                <a:ea typeface="Arial"/>
+                <a:cs typeface="Arial"/>
+              </a:rPr>
+              <a:t>Native 802.3af</a:t>
+            </a:r>
+          </a:p>
+        </p:txBody>
+      </p:sp>
+      <p:sp>
+        <p:nvSpPr>
+          <p:cNvPr id="6" name="7945_7965 SIP firmware family">
+            <a:extLst xmlns:a="http://schemas.openxmlformats.org/drawingml/2006/main">
+              <a:ext uri="{FF2B5EF4-FFF2-40B4-BE49-F238E27FC236}">
+                <a16:creationId xmlns:a16="http://schemas.microsoft.com/office/drawing/2014/main" id="{255DE698-683F-4948-9E97-510EA7839021}"/>
               </a:ext>
             </a:extLst>
           </p:cNvPr>
@@ -24580,10 +24738,10 @@
       </p:sp>
       <p:sp>
         <p:nvSpPr>
-          <p:cNvPr id="6" name="A phone running SCCP needs SIP firmware.&#10;This model does not need">
+          <p:cNvPr id="7" name="A phone running SCCP needs SIP firmware.&#10;This model does not need">
             <a:extLst xmlns:a="http://schemas.openxmlformats.org/drawingml/2006/main">
               <a:ext uri="{FF2B5EF4-FFF2-40B4-BE49-F238E27FC236}">
-                <a16:creationId xmlns:a16="http://schemas.microsoft.com/office/drawing/2014/main" id="{0EF79E79-C4F3-4F8E-BAFD-073249D6BF7D}"/>
+                <a16:creationId xmlns:a16="http://schemas.microsoft.com/office/drawing/2014/main" id="{54F53E53-68DF-4A7D-96D4-D4D9FC598245}"/>
               </a:ext>
             </a:extLst>
           </p:cNvPr>
@@ -24761,10 +24919,10 @@
       </p:sp>
       <p:sp>
         <p:nvSpPr>
-          <p:cNvPr id="7" name="Before starting">
+          <p:cNvPr id="8" name="Before starting">
             <a:extLst xmlns:a="http://schemas.openxmlformats.org/drawingml/2006/main">
               <a:ext uri="{FF2B5EF4-FFF2-40B4-BE49-F238E27FC236}">
-                <a16:creationId xmlns:a16="http://schemas.microsoft.com/office/drawing/2014/main" id="{6C02651A-89DB-4474-B1A2-56CD3E95B49A}"/>
+                <a16:creationId xmlns:a16="http://schemas.microsoft.com/office/drawing/2014/main" id="{FE2BBD6F-C1B7-474A-A072-03AE8AC9979C}"/>
               </a:ext>
             </a:extLst>
           </p:cNvPr>
@@ -24919,10 +25077,10 @@
       </p:sp>
       <p:sp>
         <p:nvSpPr>
-          <p:cNvPr id="8" name="Record PID, VID/HW, MAC, App Load,&#10;Boot Load, IP and TFTP for eve">
+          <p:cNvPr id="9" name="Record PID, VID/HW, MAC, App Load,&#10;Boot Load, IP and TFTP for eve">
             <a:extLst xmlns:a="http://schemas.openxmlformats.org/drawingml/2006/main">
               <a:ext uri="{FF2B5EF4-FFF2-40B4-BE49-F238E27FC236}">
-                <a16:creationId xmlns:a16="http://schemas.microsoft.com/office/drawing/2014/main" id="{0FBAC547-9AA3-4D2D-88DA-09A576041A62}"/>
+                <a16:creationId xmlns:a16="http://schemas.microsoft.com/office/drawing/2014/main" id="{9C6FDD4E-A84F-49F6-9440-F577C78B4D21}"/>
               </a:ext>
             </a:extLst>
           </p:cNvPr>
@@ -25101,7 +25259,7 @@
     </p:spTree>
     <p:extLst>
       <p:ext uri="{BB962C8B-B14F-4D97-AF65-F5344CB8AC3E}">
-        <p14:creationId xmlns:p14="http://schemas.microsoft.com/office/powerpoint/2010/main" val="978914116"/>
+        <p14:creationId xmlns:p14="http://schemas.microsoft.com/office/powerpoint/2010/main" val="2049865143"/>
       </p:ext>
     </p:extLst>
   </p:cSld>
@@ -25132,7 +25290,7 @@
           <p:cNvPr id="17" name="">
             <a:extLst xmlns:a="http://schemas.openxmlformats.org/drawingml/2006/main">
               <a:ext uri="{FF2B5EF4-FFF2-40B4-BE49-F238E27FC236}">
-                <a16:creationId xmlns:a16="http://schemas.microsoft.com/office/drawing/2014/main" id="{CE3982E9-2FE8-49B8-AED7-93424012679B}"/>
+                <a16:creationId xmlns:a16="http://schemas.microsoft.com/office/drawing/2014/main" id="{E86DB7DF-B13D-4F73-BE32-FB84E9AC6CF3}"/>
               </a:ext>
             </a:extLst>
           </p:cNvPr>
@@ -25164,7 +25322,7 @@
           <p:cNvPr id="15" name="">
             <a:extLst xmlns:a="http://schemas.openxmlformats.org/drawingml/2006/main">
               <a:ext uri="{FF2B5EF4-FFF2-40B4-BE49-F238E27FC236}">
-                <a16:creationId xmlns:a16="http://schemas.microsoft.com/office/drawing/2014/main" id="{9F4A4DEE-6822-46A7-B36F-760FF17F25A3}"/>
+                <a16:creationId xmlns:a16="http://schemas.microsoft.com/office/drawing/2014/main" id="{00CB4E05-E778-4B7A-9BE6-43D8E4414E89}"/>
               </a:ext>
             </a:extLst>
           </p:cNvPr>
@@ -25195,7 +25353,7 @@
           <p:cNvPr id="13" name="">
             <a:extLst xmlns:a="http://schemas.openxmlformats.org/drawingml/2006/main">
               <a:ext uri="{FF2B5EF4-FFF2-40B4-BE49-F238E27FC236}">
-                <a16:creationId xmlns:a16="http://schemas.microsoft.com/office/drawing/2014/main" id="{D6ED84FD-EFFC-4344-98B3-298F0BF15A58}"/>
+                <a16:creationId xmlns:a16="http://schemas.microsoft.com/office/drawing/2014/main" id="{40E763BD-0F50-436A-8C26-F3ACCC23C7B1}"/>
               </a:ext>
             </a:extLst>
           </p:cNvPr>
@@ -25226,7 +25384,7 @@
           <p:cNvPr id="11" name="">
             <a:extLst xmlns:a="http://schemas.openxmlformats.org/drawingml/2006/main">
               <a:ext uri="{FF2B5EF4-FFF2-40B4-BE49-F238E27FC236}">
-                <a16:creationId xmlns:a16="http://schemas.microsoft.com/office/drawing/2014/main" id="{32FCD77C-D8AC-4879-A753-7F26DC8DEA11}"/>
+                <a16:creationId xmlns:a16="http://schemas.microsoft.com/office/drawing/2014/main" id="{13F66212-6E94-4910-9FA9-8B3A32DFB782}"/>
               </a:ext>
             </a:extLst>
           </p:cNvPr>
@@ -25258,7 +25416,7 @@
           <p:cNvPr id="9" name="">
             <a:extLst xmlns:a="http://schemas.openxmlformats.org/drawingml/2006/main">
               <a:ext uri="{FF2B5EF4-FFF2-40B4-BE49-F238E27FC236}">
-                <a16:creationId xmlns:a16="http://schemas.microsoft.com/office/drawing/2014/main" id="{B86A86E2-8A9A-43F2-A361-4A03EAA38D26}"/>
+                <a16:creationId xmlns:a16="http://schemas.microsoft.com/office/drawing/2014/main" id="{7351127B-A954-4213-81DE-BB77D7A4B9F8}"/>
               </a:ext>
             </a:extLst>
           </p:cNvPr>
@@ -25290,7 +25448,7 @@
           <p:cNvPr id="20" name="Cisco, Asterisk and Home Assistant">
             <a:extLst xmlns:a="http://schemas.openxmlformats.org/drawingml/2006/main">
               <a:ext uri="{FF2B5EF4-FFF2-40B4-BE49-F238E27FC236}">
-                <a16:creationId xmlns:a16="http://schemas.microsoft.com/office/drawing/2014/main" id="{BE3E1350-33A2-4F83-AB6F-B466435BD57F}"/>
+                <a16:creationId xmlns:a16="http://schemas.microsoft.com/office/drawing/2014/main" id="{A7A35E63-F20A-41FF-9BA1-DB971B388669}"/>
               </a:ext>
             </a:extLst>
           </p:cNvPr>
@@ -25448,7 +25606,7 @@
           <p:cNvPr id="2" name="03">
             <a:extLst xmlns:a="http://schemas.openxmlformats.org/drawingml/2006/main">
               <a:ext uri="{FF2B5EF4-FFF2-40B4-BE49-F238E27FC236}">
-                <a16:creationId xmlns:a16="http://schemas.microsoft.com/office/drawing/2014/main" id="{7350C261-1B32-4D4B-8F9D-6074B4214F6D}"/>
+                <a16:creationId xmlns:a16="http://schemas.microsoft.com/office/drawing/2014/main" id="{682B9FA1-2276-425E-A6E7-65EF69AD8636}"/>
               </a:ext>
             </a:extLst>
           </p:cNvPr>
@@ -25606,7 +25764,7 @@
           <p:cNvPr id="3" name="phones">
             <a:extLst xmlns:a="http://schemas.openxmlformats.org/drawingml/2006/main">
               <a:ext uri="{FF2B5EF4-FFF2-40B4-BE49-F238E27FC236}">
-                <a16:creationId xmlns:a16="http://schemas.microsoft.com/office/drawing/2014/main" id="{4F85B5B7-6D2F-4D1C-B184-D3CA00E03F17}"/>
+                <a16:creationId xmlns:a16="http://schemas.microsoft.com/office/drawing/2014/main" id="{AE5DAFC7-6E32-4C3B-9978-FC2913A03536}"/>
               </a:ext>
             </a:extLst>
           </p:cNvPr>
@@ -25793,7 +25951,7 @@
           <p:cNvPr id="4" name="switch">
             <a:extLst xmlns:a="http://schemas.openxmlformats.org/drawingml/2006/main">
               <a:ext uri="{FF2B5EF4-FFF2-40B4-BE49-F238E27FC236}">
-                <a16:creationId xmlns:a16="http://schemas.microsoft.com/office/drawing/2014/main" id="{947B203D-4422-4F4D-B309-AE8D5AAE0793}"/>
+                <a16:creationId xmlns:a16="http://schemas.microsoft.com/office/drawing/2014/main" id="{97E1CB08-C1A9-4809-946D-C7463329BAE8}"/>
               </a:ext>
             </a:extLst>
           </p:cNvPr>
@@ -25980,7 +26138,7 @@
           <p:cNvPr id="5" name="ast">
             <a:extLst xmlns:a="http://schemas.openxmlformats.org/drawingml/2006/main">
               <a:ext uri="{FF2B5EF4-FFF2-40B4-BE49-F238E27FC236}">
-                <a16:creationId xmlns:a16="http://schemas.microsoft.com/office/drawing/2014/main" id="{30CB5646-00D6-46E3-9598-613B5BF9A8C7}"/>
+                <a16:creationId xmlns:a16="http://schemas.microsoft.com/office/drawing/2014/main" id="{3E2F9064-05C9-4169-BB8C-AF9BB3E0C162}"/>
               </a:ext>
             </a:extLst>
           </p:cNvPr>
@@ -26167,7 +26325,7 @@
           <p:cNvPr id="6" name="router">
             <a:extLst xmlns:a="http://schemas.openxmlformats.org/drawingml/2006/main">
               <a:ext uri="{FF2B5EF4-FFF2-40B4-BE49-F238E27FC236}">
-                <a16:creationId xmlns:a16="http://schemas.microsoft.com/office/drawing/2014/main" id="{E52BA8DD-AC3E-447E-83AF-F497E2C1F784}"/>
+                <a16:creationId xmlns:a16="http://schemas.microsoft.com/office/drawing/2014/main" id="{9B7DB5F8-289F-4732-B41E-E4DAEFB88ACB}"/>
               </a:ext>
             </a:extLst>
           </p:cNvPr>
@@ -26354,7 +26512,7 @@
           <p:cNvPr id="7" name="tftp">
             <a:extLst xmlns:a="http://schemas.openxmlformats.org/drawingml/2006/main">
               <a:ext uri="{FF2B5EF4-FFF2-40B4-BE49-F238E27FC236}">
-                <a16:creationId xmlns:a16="http://schemas.microsoft.com/office/drawing/2014/main" id="{355C3591-FB26-413B-95F2-7185895F1680}"/>
+                <a16:creationId xmlns:a16="http://schemas.microsoft.com/office/drawing/2014/main" id="{80BF09A9-EBD2-4A75-AE2D-E3580104F179}"/>
               </a:ext>
             </a:extLst>
           </p:cNvPr>
@@ -26541,7 +26699,7 @@
           <p:cNvPr id="8" name="ha">
             <a:extLst xmlns:a="http://schemas.openxmlformats.org/drawingml/2006/main">
               <a:ext uri="{FF2B5EF4-FFF2-40B4-BE49-F238E27FC236}">
-                <a16:creationId xmlns:a16="http://schemas.microsoft.com/office/drawing/2014/main" id="{3B947029-CA56-4245-874B-3DC06685C1C4}"/>
+                <a16:creationId xmlns:a16="http://schemas.microsoft.com/office/drawing/2014/main" id="{A7F2B192-4303-4EC5-8659-102619F62562}"/>
               </a:ext>
             </a:extLst>
           </p:cNvPr>
@@ -26728,7 +26886,7 @@
           <p:cNvPr id="10" name="Ethernet">
             <a:extLst xmlns:a="http://schemas.openxmlformats.org/drawingml/2006/main">
               <a:ext uri="{FF2B5EF4-FFF2-40B4-BE49-F238E27FC236}">
-                <a16:creationId xmlns:a16="http://schemas.microsoft.com/office/drawing/2014/main" id="{7D9E3536-2CD2-4B27-B149-439E959C223A}"/>
+                <a16:creationId xmlns:a16="http://schemas.microsoft.com/office/drawing/2014/main" id="{C66D65B0-C2C7-46CE-8570-0BCA75B4E338}"/>
               </a:ext>
             </a:extLst>
           </p:cNvPr>
@@ -26886,7 +27044,7 @@
           <p:cNvPr id="12" name="SIP / RTP">
             <a:extLst xmlns:a="http://schemas.openxmlformats.org/drawingml/2006/main">
               <a:ext uri="{FF2B5EF4-FFF2-40B4-BE49-F238E27FC236}">
-                <a16:creationId xmlns:a16="http://schemas.microsoft.com/office/drawing/2014/main" id="{E56B4EAF-0DFE-4BF2-8D5D-63F93088545F}"/>
+                <a16:creationId xmlns:a16="http://schemas.microsoft.com/office/drawing/2014/main" id="{F4A547C8-C861-4D77-A4FE-F802F4D01A5C}"/>
               </a:ext>
             </a:extLst>
           </p:cNvPr>
@@ -27044,7 +27202,7 @@
           <p:cNvPr id="14" name="DHCP">
             <a:extLst xmlns:a="http://schemas.openxmlformats.org/drawingml/2006/main">
               <a:ext uri="{FF2B5EF4-FFF2-40B4-BE49-F238E27FC236}">
-                <a16:creationId xmlns:a16="http://schemas.microsoft.com/office/drawing/2014/main" id="{5581DA60-A3F1-4952-B2AB-440A962E2404}"/>
+                <a16:creationId xmlns:a16="http://schemas.microsoft.com/office/drawing/2014/main" id="{FF09364D-0C91-469E-8C46-1A76DCF79064}"/>
               </a:ext>
             </a:extLst>
           </p:cNvPr>
@@ -27202,7 +27360,7 @@
           <p:cNvPr id="16" name="download">
             <a:extLst xmlns:a="http://schemas.openxmlformats.org/drawingml/2006/main">
               <a:ext uri="{FF2B5EF4-FFF2-40B4-BE49-F238E27FC236}">
-                <a16:creationId xmlns:a16="http://schemas.microsoft.com/office/drawing/2014/main" id="{78831A5C-3D51-4C94-BDE7-75BEBB4CE5AC}"/>
+                <a16:creationId xmlns:a16="http://schemas.microsoft.com/office/drawing/2014/main" id="{799002A5-DEEE-452B-9DA2-B9B69640AE0C}"/>
               </a:ext>
             </a:extLst>
           </p:cNvPr>
@@ -27360,7 +27518,7 @@
           <p:cNvPr id="18" name="AMI&#10;SIP / RTP">
             <a:extLst xmlns:a="http://schemas.openxmlformats.org/drawingml/2006/main">
               <a:ext uri="{FF2B5EF4-FFF2-40B4-BE49-F238E27FC236}">
-                <a16:creationId xmlns:a16="http://schemas.microsoft.com/office/drawing/2014/main" id="{EBA3D6E9-BF96-4257-A6B5-2399CF3ACF5F}"/>
+                <a16:creationId xmlns:a16="http://schemas.microsoft.com/office/drawing/2014/main" id="{94DAD719-22D0-49F8-9F4A-F3B818EBE3CB}"/>
               </a:ext>
             </a:extLst>
           </p:cNvPr>
@@ -27541,7 +27699,7 @@
           <p:cNvPr id="19" name="Asterisk uses hostNetwork and one replica. HA opens the AMI conne">
             <a:extLst xmlns:a="http://schemas.openxmlformats.org/drawingml/2006/main">
               <a:ext uri="{FF2B5EF4-FFF2-40B4-BE49-F238E27FC236}">
-                <a16:creationId xmlns:a16="http://schemas.microsoft.com/office/drawing/2014/main" id="{7DB7ADF8-0514-4D18-B080-F70546D86ECF}"/>
+                <a16:creationId xmlns:a16="http://schemas.microsoft.com/office/drawing/2014/main" id="{FE9D1086-E38F-4AD5-B814-E8648DC18CFB}"/>
               </a:ext>
             </a:extLst>
           </p:cNvPr>
@@ -27720,7 +27878,7 @@
     </p:spTree>
     <p:extLst>
       <p:ext uri="{BB962C8B-B14F-4D97-AF65-F5344CB8AC3E}">
-        <p14:creationId xmlns:p14="http://schemas.microsoft.com/office/powerpoint/2010/main" val="626408807"/>
+        <p14:creationId xmlns:p14="http://schemas.microsoft.com/office/powerpoint/2010/main" val="1064215380"/>
       </p:ext>
     </p:extLst>
   </p:cSld>
@@ -27751,7 +27909,7 @@
           <p:cNvPr id="16" name="Signaling and audio ports">
             <a:extLst xmlns:a="http://schemas.openxmlformats.org/drawingml/2006/main">
               <a:ext uri="{FF2B5EF4-FFF2-40B4-BE49-F238E27FC236}">
-                <a16:creationId xmlns:a16="http://schemas.microsoft.com/office/drawing/2014/main" id="{36DA5A74-F7C9-4831-986C-598D316E263B}"/>
+                <a16:creationId xmlns:a16="http://schemas.microsoft.com/office/drawing/2014/main" id="{F12C7EB6-E970-489C-A22B-CE9FF39542E6}"/>
               </a:ext>
             </a:extLst>
           </p:cNvPr>
@@ -27909,7 +28067,7 @@
           <p:cNvPr id="2" name="04">
             <a:extLst xmlns:a="http://schemas.openxmlformats.org/drawingml/2006/main">
               <a:ext uri="{FF2B5EF4-FFF2-40B4-BE49-F238E27FC236}">
-                <a16:creationId xmlns:a16="http://schemas.microsoft.com/office/drawing/2014/main" id="{31254EAB-A7A8-44D8-874F-87D692A32EE7}"/>
+                <a16:creationId xmlns:a16="http://schemas.microsoft.com/office/drawing/2014/main" id="{7F3C645E-7D2D-4E34-B5F2-86E54B85A82D}"/>
               </a:ext>
             </a:extLst>
           </p:cNvPr>
@@ -28067,7 +28225,7 @@
           <p:cNvPr id="3" name="5060">
             <a:extLst xmlns:a="http://schemas.openxmlformats.org/drawingml/2006/main">
               <a:ext uri="{FF2B5EF4-FFF2-40B4-BE49-F238E27FC236}">
-                <a16:creationId xmlns:a16="http://schemas.microsoft.com/office/drawing/2014/main" id="{7B5BCFFA-1FA1-4554-AEE2-098AB73DAA42}"/>
+                <a16:creationId xmlns:a16="http://schemas.microsoft.com/office/drawing/2014/main" id="{BE4A8CC0-E1CE-4B0F-AD0C-1E6A09711F1D}"/>
               </a:ext>
             </a:extLst>
           </p:cNvPr>
@@ -28225,7 +28383,7 @@
           <p:cNvPr id="4" name="TCP / UDP">
             <a:extLst xmlns:a="http://schemas.openxmlformats.org/drawingml/2006/main">
               <a:ext uri="{FF2B5EF4-FFF2-40B4-BE49-F238E27FC236}">
-                <a16:creationId xmlns:a16="http://schemas.microsoft.com/office/drawing/2014/main" id="{C1B70CEA-FD12-40CB-87E9-014DBA4B4140}"/>
+                <a16:creationId xmlns:a16="http://schemas.microsoft.com/office/drawing/2014/main" id="{6CD45949-9727-4966-8A88-BF69D8F37E49}"/>
               </a:ext>
             </a:extLst>
           </p:cNvPr>
@@ -28383,7 +28541,7 @@
           <p:cNvPr id="5" name="SIP: Cisco TCP, HA UDP">
             <a:extLst xmlns:a="http://schemas.openxmlformats.org/drawingml/2006/main">
               <a:ext uri="{FF2B5EF4-FFF2-40B4-BE49-F238E27FC236}">
-                <a16:creationId xmlns:a16="http://schemas.microsoft.com/office/drawing/2014/main" id="{E53B88CA-0B2B-4B40-8C1B-B79672486930}"/>
+                <a16:creationId xmlns:a16="http://schemas.microsoft.com/office/drawing/2014/main" id="{C10CEA2F-9B76-4706-AB13-297FE688CF73}"/>
               </a:ext>
             </a:extLst>
           </p:cNvPr>
@@ -28541,7 +28699,7 @@
           <p:cNvPr id="6" name="10000–10199">
             <a:extLst xmlns:a="http://schemas.openxmlformats.org/drawingml/2006/main">
               <a:ext uri="{FF2B5EF4-FFF2-40B4-BE49-F238E27FC236}">
-                <a16:creationId xmlns:a16="http://schemas.microsoft.com/office/drawing/2014/main" id="{DAE76A24-A57E-4A59-A031-7EFC64216EF7}"/>
+                <a16:creationId xmlns:a16="http://schemas.microsoft.com/office/drawing/2014/main" id="{4E0C6152-026E-4A38-8B3D-633618611CB9}"/>
               </a:ext>
             </a:extLst>
           </p:cNvPr>
@@ -28699,7 +28857,7 @@
           <p:cNvPr id="7" name="UDP on PBX">
             <a:extLst xmlns:a="http://schemas.openxmlformats.org/drawingml/2006/main">
               <a:ext uri="{FF2B5EF4-FFF2-40B4-BE49-F238E27FC236}">
-                <a16:creationId xmlns:a16="http://schemas.microsoft.com/office/drawing/2014/main" id="{757BE8FF-0FA1-48A4-A0F1-754FA758B3F3}"/>
+                <a16:creationId xmlns:a16="http://schemas.microsoft.com/office/drawing/2014/main" id="{327FD561-462D-4741-AC08-6A4EED63A815}"/>
               </a:ext>
             </a:extLst>
           </p:cNvPr>
@@ -28857,7 +29015,7 @@
           <p:cNvPr id="8" name="RTP / audio">
             <a:extLst xmlns:a="http://schemas.openxmlformats.org/drawingml/2006/main">
               <a:ext uri="{FF2B5EF4-FFF2-40B4-BE49-F238E27FC236}">
-                <a16:creationId xmlns:a16="http://schemas.microsoft.com/office/drawing/2014/main" id="{35040A92-170C-4206-A0E5-D516BEF68DC3}"/>
+                <a16:creationId xmlns:a16="http://schemas.microsoft.com/office/drawing/2014/main" id="{A72DE1A6-08C3-4380-B1A3-E2F4D8B6966F}"/>
               </a:ext>
             </a:extLst>
           </p:cNvPr>
@@ -29015,7 +29173,7 @@
           <p:cNvPr id="9" name="5038">
             <a:extLst xmlns:a="http://schemas.openxmlformats.org/drawingml/2006/main">
               <a:ext uri="{FF2B5EF4-FFF2-40B4-BE49-F238E27FC236}">
-                <a16:creationId xmlns:a16="http://schemas.microsoft.com/office/drawing/2014/main" id="{7BE7FC2E-1768-4045-89C5-83BCB17EF66F}"/>
+                <a16:creationId xmlns:a16="http://schemas.microsoft.com/office/drawing/2014/main" id="{5FDEF7B1-E64F-425A-90B1-A28A069FBAA1}"/>
               </a:ext>
             </a:extLst>
           </p:cNvPr>
@@ -29173,7 +29331,7 @@
           <p:cNvPr id="10" name="TCP on PBX">
             <a:extLst xmlns:a="http://schemas.openxmlformats.org/drawingml/2006/main">
               <a:ext uri="{FF2B5EF4-FFF2-40B4-BE49-F238E27FC236}">
-                <a16:creationId xmlns:a16="http://schemas.microsoft.com/office/drawing/2014/main" id="{5209D094-91F8-4082-AC31-F8920FC2B282}"/>
+                <a16:creationId xmlns:a16="http://schemas.microsoft.com/office/drawing/2014/main" id="{53664C19-1262-4CF0-89CE-67A053357FC8}"/>
               </a:ext>
             </a:extLst>
           </p:cNvPr>
@@ -29331,7 +29489,7 @@
           <p:cNvPr id="11" name="AMI: HA / gateway /32">
             <a:extLst xmlns:a="http://schemas.openxmlformats.org/drawingml/2006/main">
               <a:ext uri="{FF2B5EF4-FFF2-40B4-BE49-F238E27FC236}">
-                <a16:creationId xmlns:a16="http://schemas.microsoft.com/office/drawing/2014/main" id="{CEA40994-49E2-490F-AEA0-6EFD3286B5EE}"/>
+                <a16:creationId xmlns:a16="http://schemas.microsoft.com/office/drawing/2014/main" id="{81665BAD-00AF-4283-914B-174E6BB6FF36}"/>
               </a:ext>
             </a:extLst>
           </p:cNvPr>
@@ -29489,7 +29647,7 @@
           <p:cNvPr id="12" name="69 + 20000–20031">
             <a:extLst xmlns:a="http://schemas.openxmlformats.org/drawingml/2006/main">
               <a:ext uri="{FF2B5EF4-FFF2-40B4-BE49-F238E27FC236}">
-                <a16:creationId xmlns:a16="http://schemas.microsoft.com/office/drawing/2014/main" id="{D3AC3EFD-9C3D-4ED0-B93A-ED37CF2508ED}"/>
+                <a16:creationId xmlns:a16="http://schemas.microsoft.com/office/drawing/2014/main" id="{00956BAF-7761-4C90-AF51-27ED5E9F6821}"/>
               </a:ext>
             </a:extLst>
           </p:cNvPr>
@@ -29647,7 +29805,7 @@
           <p:cNvPr id="13" name="UDP on PBX">
             <a:extLst xmlns:a="http://schemas.openxmlformats.org/drawingml/2006/main">
               <a:ext uri="{FF2B5EF4-FFF2-40B4-BE49-F238E27FC236}">
-                <a16:creationId xmlns:a16="http://schemas.microsoft.com/office/drawing/2014/main" id="{EA88BE0B-076C-472E-A790-37A9E5D22145}"/>
+                <a16:creationId xmlns:a16="http://schemas.microsoft.com/office/drawing/2014/main" id="{285391E9-961C-4773-9F9B-734E71CD3BE7}"/>
               </a:ext>
             </a:extLst>
           </p:cNvPr>
@@ -29805,7 +29963,7 @@
           <p:cNvPr id="14" name="Temporary TFTP">
             <a:extLst xmlns:a="http://schemas.openxmlformats.org/drawingml/2006/main">
               <a:ext uri="{FF2B5EF4-FFF2-40B4-BE49-F238E27FC236}">
-                <a16:creationId xmlns:a16="http://schemas.microsoft.com/office/drawing/2014/main" id="{D44B2D7E-27FC-449E-AC81-C2D3056DD4AF}"/>
+                <a16:creationId xmlns:a16="http://schemas.microsoft.com/office/drawing/2014/main" id="{ACCC779C-A5A3-44D7-B288-E66A8C0E1CB9}"/>
               </a:ext>
             </a:extLst>
           </p:cNvPr>
@@ -29963,7 +30121,7 @@
           <p:cNvPr id="15" name="HA uses dynamic RTP / RTCP ports. Restrict firewall rules to the ">
             <a:extLst xmlns:a="http://schemas.openxmlformats.org/drawingml/2006/main">
               <a:ext uri="{FF2B5EF4-FFF2-40B4-BE49-F238E27FC236}">
-                <a16:creationId xmlns:a16="http://schemas.microsoft.com/office/drawing/2014/main" id="{865F9729-059C-42EF-AABF-E8D65AB74C3F}"/>
+                <a16:creationId xmlns:a16="http://schemas.microsoft.com/office/drawing/2014/main" id="{5FB3D40E-2810-4113-8FAD-87E20CD6A740}"/>
               </a:ext>
             </a:extLst>
           </p:cNvPr>
@@ -30119,7 +30277,7 @@
     </p:spTree>
     <p:extLst>
       <p:ext uri="{BB962C8B-B14F-4D97-AF65-F5344CB8AC3E}">
-        <p14:creationId xmlns:p14="http://schemas.microsoft.com/office/powerpoint/2010/main" val="2062194378"/>
+        <p14:creationId xmlns:p14="http://schemas.microsoft.com/office/powerpoint/2010/main" val="125822084"/>
       </p:ext>
     </p:extLst>
   </p:cSld>
@@ -30150,7 +30308,7 @@
           <p:cNvPr id="12" name="">
             <a:extLst xmlns:a="http://schemas.openxmlformats.org/drawingml/2006/main">
               <a:ext uri="{FF2B5EF4-FFF2-40B4-BE49-F238E27FC236}">
-                <a16:creationId xmlns:a16="http://schemas.microsoft.com/office/drawing/2014/main" id="{123C9C0D-ECFB-4D4F-A9DD-546F778B8AC0}"/>
+                <a16:creationId xmlns:a16="http://schemas.microsoft.com/office/drawing/2014/main" id="{470723C9-52E5-4D41-9FB0-302C4867D07E}"/>
               </a:ext>
             </a:extLst>
           </p:cNvPr>
@@ -30181,7 +30339,7 @@
           <p:cNvPr id="10" name="">
             <a:extLst xmlns:a="http://schemas.openxmlformats.org/drawingml/2006/main">
               <a:ext uri="{FF2B5EF4-FFF2-40B4-BE49-F238E27FC236}">
-                <a16:creationId xmlns:a16="http://schemas.microsoft.com/office/drawing/2014/main" id="{D3B8E16B-97AD-475E-BFC7-AFE38991F3DC}"/>
+                <a16:creationId xmlns:a16="http://schemas.microsoft.com/office/drawing/2014/main" id="{9B9B164F-EF6F-42CB-85A2-40814F5B09E5}"/>
               </a:ext>
             </a:extLst>
           </p:cNvPr>
@@ -30212,7 +30370,7 @@
           <p:cNvPr id="8" name="">
             <a:extLst xmlns:a="http://schemas.openxmlformats.org/drawingml/2006/main">
               <a:ext uri="{FF2B5EF4-FFF2-40B4-BE49-F238E27FC236}">
-                <a16:creationId xmlns:a16="http://schemas.microsoft.com/office/drawing/2014/main" id="{72BF1FC1-EC3F-40EA-B0FF-4D6D69E6BC83}"/>
+                <a16:creationId xmlns:a16="http://schemas.microsoft.com/office/drawing/2014/main" id="{2F4F6D93-D97B-4189-9F03-116B41E0A846}"/>
               </a:ext>
             </a:extLst>
           </p:cNvPr>
@@ -30243,7 +30401,7 @@
           <p:cNvPr id="15" name="7945G has built-in PoE support">
             <a:extLst xmlns:a="http://schemas.openxmlformats.org/drawingml/2006/main">
               <a:ext uri="{FF2B5EF4-FFF2-40B4-BE49-F238E27FC236}">
-                <a16:creationId xmlns:a16="http://schemas.microsoft.com/office/drawing/2014/main" id="{E63E84E4-DBBD-4E6C-AE94-619DE9480D95}"/>
+                <a16:creationId xmlns:a16="http://schemas.microsoft.com/office/drawing/2014/main" id="{25E92350-28A6-4A3F-B110-3D14E69AD991}"/>
               </a:ext>
             </a:extLst>
           </p:cNvPr>
@@ -30401,7 +30559,7 @@
           <p:cNvPr id="2" name="05">
             <a:extLst xmlns:a="http://schemas.openxmlformats.org/drawingml/2006/main">
               <a:ext uri="{FF2B5EF4-FFF2-40B4-BE49-F238E27FC236}">
-                <a16:creationId xmlns:a16="http://schemas.microsoft.com/office/drawing/2014/main" id="{F7EB0D69-20D1-4987-922F-C275DF5F751F}"/>
+                <a16:creationId xmlns:a16="http://schemas.microsoft.com/office/drawing/2014/main" id="{0AD09B6E-ABFC-4DBF-A247-8C309F3EEDBE}"/>
               </a:ext>
             </a:extLst>
           </p:cNvPr>
@@ -30559,7 +30717,7 @@
           <p:cNvPr id="3" name="poe">
             <a:extLst xmlns:a="http://schemas.openxmlformats.org/drawingml/2006/main">
               <a:ext uri="{FF2B5EF4-FFF2-40B4-BE49-F238E27FC236}">
-                <a16:creationId xmlns:a16="http://schemas.microsoft.com/office/drawing/2014/main" id="{1561CBD6-8354-49B0-A782-E642A38D7EDA}"/>
+                <a16:creationId xmlns:a16="http://schemas.microsoft.com/office/drawing/2014/main" id="{5DDD99C8-317F-4EB9-84E0-A08698DD248D}"/>
               </a:ext>
             </a:extLst>
           </p:cNvPr>
@@ -30746,7 +30904,7 @@
           <p:cNvPr id="4" name="phone1">
             <a:extLst xmlns:a="http://schemas.openxmlformats.org/drawingml/2006/main">
               <a:ext uri="{FF2B5EF4-FFF2-40B4-BE49-F238E27FC236}">
-                <a16:creationId xmlns:a16="http://schemas.microsoft.com/office/drawing/2014/main" id="{64985894-9E18-4A0C-91FA-910F2A1242E9}"/>
+                <a16:creationId xmlns:a16="http://schemas.microsoft.com/office/drawing/2014/main" id="{1A8EAE15-35E3-48DD-BE08-68ABFBDE0734}"/>
               </a:ext>
             </a:extLst>
           </p:cNvPr>
@@ -30933,7 +31091,7 @@
           <p:cNvPr id="5" name="lan">
             <a:extLst xmlns:a="http://schemas.openxmlformats.org/drawingml/2006/main">
               <a:ext uri="{FF2B5EF4-FFF2-40B4-BE49-F238E27FC236}">
-                <a16:creationId xmlns:a16="http://schemas.microsoft.com/office/drawing/2014/main" id="{93A3454E-EE51-4693-83F4-E26019D86E2B}"/>
+                <a16:creationId xmlns:a16="http://schemas.microsoft.com/office/drawing/2014/main" id="{161BF4AA-5B71-43AC-B552-0BFD745788B5}"/>
               </a:ext>
             </a:extLst>
           </p:cNvPr>
@@ -31120,7 +31278,7 @@
           <p:cNvPr id="6" name="injector">
             <a:extLst xmlns:a="http://schemas.openxmlformats.org/drawingml/2006/main">
               <a:ext uri="{FF2B5EF4-FFF2-40B4-BE49-F238E27FC236}">
-                <a16:creationId xmlns:a16="http://schemas.microsoft.com/office/drawing/2014/main" id="{01EE1972-9FD7-407C-9635-26D1AB3696E0}"/>
+                <a16:creationId xmlns:a16="http://schemas.microsoft.com/office/drawing/2014/main" id="{103C1527-2E6F-4BDD-900D-FD5606731BF7}"/>
               </a:ext>
             </a:extLst>
           </p:cNvPr>
@@ -31307,7 +31465,7 @@
           <p:cNvPr id="7" name="phone2">
             <a:extLst xmlns:a="http://schemas.openxmlformats.org/drawingml/2006/main">
               <a:ext uri="{FF2B5EF4-FFF2-40B4-BE49-F238E27FC236}">
-                <a16:creationId xmlns:a16="http://schemas.microsoft.com/office/drawing/2014/main" id="{3556FE2F-EF4A-4C3A-AA64-2C117239CCCC}"/>
+                <a16:creationId xmlns:a16="http://schemas.microsoft.com/office/drawing/2014/main" id="{3CC7C9F5-C085-4564-BF4A-178C3785C0DF}"/>
               </a:ext>
             </a:extLst>
           </p:cNvPr>
@@ -31494,7 +31652,7 @@
           <p:cNvPr id="9" name="data + power">
             <a:extLst xmlns:a="http://schemas.openxmlformats.org/drawingml/2006/main">
               <a:ext uri="{FF2B5EF4-FFF2-40B4-BE49-F238E27FC236}">
-                <a16:creationId xmlns:a16="http://schemas.microsoft.com/office/drawing/2014/main" id="{323846DB-A2C7-4D04-90EB-2284D1BEC20E}"/>
+                <a16:creationId xmlns:a16="http://schemas.microsoft.com/office/drawing/2014/main" id="{00BC1690-D782-42AB-BBAB-64B32D79D477}"/>
               </a:ext>
             </a:extLst>
           </p:cNvPr>
@@ -31652,7 +31810,7 @@
           <p:cNvPr id="11" name="data">
             <a:extLst xmlns:a="http://schemas.openxmlformats.org/drawingml/2006/main">
               <a:ext uri="{FF2B5EF4-FFF2-40B4-BE49-F238E27FC236}">
-                <a16:creationId xmlns:a16="http://schemas.microsoft.com/office/drawing/2014/main" id="{EFCF0623-DB06-45D8-9A3B-0390A6B0F723}"/>
+                <a16:creationId xmlns:a16="http://schemas.microsoft.com/office/drawing/2014/main" id="{59C4AD76-DA18-41B1-8834-F6E6F4A9AAAD}"/>
               </a:ext>
             </a:extLst>
           </p:cNvPr>
@@ -31810,7 +31968,7 @@
           <p:cNvPr id="13" name="PoE">
             <a:extLst xmlns:a="http://schemas.openxmlformats.org/drawingml/2006/main">
               <a:ext uri="{FF2B5EF4-FFF2-40B4-BE49-F238E27FC236}">
-                <a16:creationId xmlns:a16="http://schemas.microsoft.com/office/drawing/2014/main" id="{9B8BB2C4-A6FE-44BC-B52B-0A74599BF581}"/>
+                <a16:creationId xmlns:a16="http://schemas.microsoft.com/office/drawing/2014/main" id="{93704B26-982E-400A-AFD6-92CB597BFCBB}"/>
               </a:ext>
             </a:extLst>
           </p:cNvPr>
@@ -31968,7 +32126,7 @@
           <p:cNvPr id="14" name="A passive 24 V injector is unsuitable. The UPS also needs to powe">
             <a:extLst xmlns:a="http://schemas.openxmlformats.org/drawingml/2006/main">
               <a:ext uri="{FF2B5EF4-FFF2-40B4-BE49-F238E27FC236}">
-                <a16:creationId xmlns:a16="http://schemas.microsoft.com/office/drawing/2014/main" id="{6A3D1533-7F25-4FC3-93A5-F0C882E295D4}"/>
+                <a16:creationId xmlns:a16="http://schemas.microsoft.com/office/drawing/2014/main" id="{DA99D0A5-2E1C-499C-A38D-004D5E0CF536}"/>
               </a:ext>
             </a:extLst>
           </p:cNvPr>
@@ -32124,7 +32282,7 @@
     </p:spTree>
     <p:extLst>
       <p:ext uri="{BB962C8B-B14F-4D97-AF65-F5344CB8AC3E}">
-        <p14:creationId xmlns:p14="http://schemas.microsoft.com/office/powerpoint/2010/main" val="1986188370"/>
+        <p14:creationId xmlns:p14="http://schemas.microsoft.com/office/powerpoint/2010/main" val="413904961"/>
       </p:ext>
     </p:extLst>
   </p:cSld>
@@ -32155,7 +32313,7 @@
           <p:cNvPr id="13" name="">
             <a:extLst xmlns:a="http://schemas.openxmlformats.org/drawingml/2006/main">
               <a:ext uri="{FF2B5EF4-FFF2-40B4-BE49-F238E27FC236}">
-                <a16:creationId xmlns:a16="http://schemas.microsoft.com/office/drawing/2014/main" id="{8CB7EFBA-BEAD-4DFF-905E-E388173AA0C3}"/>
+                <a16:creationId xmlns:a16="http://schemas.microsoft.com/office/drawing/2014/main" id="{9D6E3503-FEA0-47A7-857F-9503DC7CCCCB}"/>
               </a:ext>
             </a:extLst>
           </p:cNvPr>
@@ -32186,7 +32344,7 @@
           <p:cNvPr id="12" name="">
             <a:extLst xmlns:a="http://schemas.openxmlformats.org/drawingml/2006/main">
               <a:ext uri="{FF2B5EF4-FFF2-40B4-BE49-F238E27FC236}">
-                <a16:creationId xmlns:a16="http://schemas.microsoft.com/office/drawing/2014/main" id="{4848B036-E6B4-43F8-9BA2-CFBFBE2374B1}"/>
+                <a16:creationId xmlns:a16="http://schemas.microsoft.com/office/drawing/2014/main" id="{626BF1DA-1F29-4906-819B-29BAB245E944}"/>
               </a:ext>
             </a:extLst>
           </p:cNvPr>
@@ -32217,7 +32375,7 @@
           <p:cNvPr id="11" name="">
             <a:extLst xmlns:a="http://schemas.openxmlformats.org/drawingml/2006/main">
               <a:ext uri="{FF2B5EF4-FFF2-40B4-BE49-F238E27FC236}">
-                <a16:creationId xmlns:a16="http://schemas.microsoft.com/office/drawing/2014/main" id="{28AF98C0-C452-43AE-B5AA-287547D48C5F}"/>
+                <a16:creationId xmlns:a16="http://schemas.microsoft.com/office/drawing/2014/main" id="{0F7CA408-425C-4902-B483-F38FC38FABE2}"/>
               </a:ext>
             </a:extLst>
           </p:cNvPr>
@@ -32248,7 +32406,7 @@
           <p:cNvPr id="10" name="">
             <a:extLst xmlns:a="http://schemas.openxmlformats.org/drawingml/2006/main">
               <a:ext uri="{FF2B5EF4-FFF2-40B4-BE49-F238E27FC236}">
-                <a16:creationId xmlns:a16="http://schemas.microsoft.com/office/drawing/2014/main" id="{D74320BE-3AC7-450B-A274-080CF50CF77E}"/>
+                <a16:creationId xmlns:a16="http://schemas.microsoft.com/office/drawing/2014/main" id="{1934FF84-6F55-47A9-96A9-6D76774DEC15}"/>
               </a:ext>
             </a:extLst>
           </p:cNvPr>
@@ -32279,7 +32437,7 @@
           <p:cNvPr id="9" name="">
             <a:extLst xmlns:a="http://schemas.openxmlformats.org/drawingml/2006/main">
               <a:ext uri="{FF2B5EF4-FFF2-40B4-BE49-F238E27FC236}">
-                <a16:creationId xmlns:a16="http://schemas.microsoft.com/office/drawing/2014/main" id="{A1B9A0BE-5FA5-4ED1-94C7-99EF42E7BCDA}"/>
+                <a16:creationId xmlns:a16="http://schemas.microsoft.com/office/drawing/2014/main" id="{AD602CDE-6679-4B1A-BEDB-33A3A0D68639}"/>
               </a:ext>
             </a:extLst>
           </p:cNvPr>
@@ -32310,7 +32468,7 @@
           <p:cNvPr id="15" name="One pilot phone before the full fleet">
             <a:extLst xmlns:a="http://schemas.openxmlformats.org/drawingml/2006/main">
               <a:ext uri="{FF2B5EF4-FFF2-40B4-BE49-F238E27FC236}">
-                <a16:creationId xmlns:a16="http://schemas.microsoft.com/office/drawing/2014/main" id="{D381A7D3-4468-4982-B3B2-A1E0287B7226}"/>
+                <a16:creationId xmlns:a16="http://schemas.microsoft.com/office/drawing/2014/main" id="{E4638FD7-DE33-4FA5-B8F2-EDEC83BD9F57}"/>
               </a:ext>
             </a:extLst>
           </p:cNvPr>
@@ -32468,7 +32626,7 @@
           <p:cNvPr id="2" name="06">
             <a:extLst xmlns:a="http://schemas.openxmlformats.org/drawingml/2006/main">
               <a:ext uri="{FF2B5EF4-FFF2-40B4-BE49-F238E27FC236}">
-                <a16:creationId xmlns:a16="http://schemas.microsoft.com/office/drawing/2014/main" id="{D8A479D8-7178-4245-B385-9D37465D935D}"/>
+                <a16:creationId xmlns:a16="http://schemas.microsoft.com/office/drawing/2014/main" id="{B6337A1A-4F90-480F-B75F-88F9280EE822}"/>
               </a:ext>
             </a:extLst>
           </p:cNvPr>
@@ -32626,7 +32784,7 @@
           <p:cNvPr id="3" name="inventory">
             <a:extLst xmlns:a="http://schemas.openxmlformats.org/drawingml/2006/main">
               <a:ext uri="{FF2B5EF4-FFF2-40B4-BE49-F238E27FC236}">
-                <a16:creationId xmlns:a16="http://schemas.microsoft.com/office/drawing/2014/main" id="{DCFF4C67-5C57-4E1D-80A8-7FD7810E508F}"/>
+                <a16:creationId xmlns:a16="http://schemas.microsoft.com/office/drawing/2014/main" id="{4290091A-F925-4621-BD6A-9F656A877C18}"/>
               </a:ext>
             </a:extLst>
           </p:cNvPr>
@@ -32813,7 +32971,7 @@
           <p:cNvPr id="4" name="firmware">
             <a:extLst xmlns:a="http://schemas.openxmlformats.org/drawingml/2006/main">
               <a:ext uri="{FF2B5EF4-FFF2-40B4-BE49-F238E27FC236}">
-                <a16:creationId xmlns:a16="http://schemas.microsoft.com/office/drawing/2014/main" id="{E6AA1520-2849-4183-A8F4-969924D561FB}"/>
+                <a16:creationId xmlns:a16="http://schemas.microsoft.com/office/drawing/2014/main" id="{5991694C-F123-40BB-86D2-1A1AE8F977F3}"/>
               </a:ext>
             </a:extLst>
           </p:cNvPr>
@@ -33000,7 +33158,7 @@
           <p:cNvPr id="5" name="tftp">
             <a:extLst xmlns:a="http://schemas.openxmlformats.org/drawingml/2006/main">
               <a:ext uri="{FF2B5EF4-FFF2-40B4-BE49-F238E27FC236}">
-                <a16:creationId xmlns:a16="http://schemas.microsoft.com/office/drawing/2014/main" id="{CA43B387-5D5A-4C76-BB51-7FAB3B42242A}"/>
+                <a16:creationId xmlns:a16="http://schemas.microsoft.com/office/drawing/2014/main" id="{A533AFB8-9D95-44EA-AB88-F975FA903148}"/>
               </a:ext>
             </a:extLst>
           </p:cNvPr>
@@ -33187,7 +33345,7 @@
           <p:cNvPr id="6" name="pilot">
             <a:extLst xmlns:a="http://schemas.openxmlformats.org/drawingml/2006/main">
               <a:ext uri="{FF2B5EF4-FFF2-40B4-BE49-F238E27FC236}">
-                <a16:creationId xmlns:a16="http://schemas.microsoft.com/office/drawing/2014/main" id="{4994A53E-DCDE-45EC-BF61-D561D281F2A3}"/>
+                <a16:creationId xmlns:a16="http://schemas.microsoft.com/office/drawing/2014/main" id="{EC51D0D1-93CD-4DCD-83CB-B14925A5206D}"/>
               </a:ext>
             </a:extLst>
           </p:cNvPr>
@@ -33374,7 +33532,7 @@
           <p:cNvPr id="7" name="accept">
             <a:extLst xmlns:a="http://schemas.openxmlformats.org/drawingml/2006/main">
               <a:ext uri="{FF2B5EF4-FFF2-40B4-BE49-F238E27FC236}">
-                <a16:creationId xmlns:a16="http://schemas.microsoft.com/office/drawing/2014/main" id="{8181EA64-6DB4-43A9-89BD-66B1C44A549F}"/>
+                <a16:creationId xmlns:a16="http://schemas.microsoft.com/office/drawing/2014/main" id="{ED967023-FBBE-4F2A-A61F-16529F9C7BE8}"/>
               </a:ext>
             </a:extLst>
           </p:cNvPr>
@@ -33561,7 +33719,7 @@
           <p:cNvPr id="8" name="fleet">
             <a:extLst xmlns:a="http://schemas.openxmlformats.org/drawingml/2006/main">
               <a:ext uri="{FF2B5EF4-FFF2-40B4-BE49-F238E27FC236}">
-                <a16:creationId xmlns:a16="http://schemas.microsoft.com/office/drawing/2014/main" id="{CD1F521C-7015-4895-9BB6-FB54656BAA10}"/>
+                <a16:creationId xmlns:a16="http://schemas.microsoft.com/office/drawing/2014/main" id="{4FDAF5B4-96E6-460E-8076-39D16F8905C7}"/>
               </a:ext>
             </a:extLst>
           </p:cNvPr>
@@ -33748,7 +33906,7 @@
           <p:cNvPr id="14" name="HW 13.0+ requires at least 9.3(1)SR3. The upgrade path depends on">
             <a:extLst xmlns:a="http://schemas.openxmlformats.org/drawingml/2006/main">
               <a:ext uri="{FF2B5EF4-FFF2-40B4-BE49-F238E27FC236}">
-                <a16:creationId xmlns:a16="http://schemas.microsoft.com/office/drawing/2014/main" id="{D0DFA3DE-2911-47C0-B948-B13580D0A967}"/>
+                <a16:creationId xmlns:a16="http://schemas.microsoft.com/office/drawing/2014/main" id="{C3D50131-89D8-45C5-9607-E3B09A9E402F}"/>
               </a:ext>
             </a:extLst>
           </p:cNvPr>
@@ -33927,7 +34085,7 @@
     </p:spTree>
     <p:extLst>
       <p:ext uri="{BB962C8B-B14F-4D97-AF65-F5344CB8AC3E}">
-        <p14:creationId xmlns:p14="http://schemas.microsoft.com/office/powerpoint/2010/main" val="1012363617"/>
+        <p14:creationId xmlns:p14="http://schemas.microsoft.com/office/powerpoint/2010/main" val="18881597"/>
       </p:ext>
     </p:extLst>
   </p:cSld>
@@ -33958,7 +34116,7 @@
           <p:cNvPr id="8" name="TFTP preparation before restart">
             <a:extLst xmlns:a="http://schemas.openxmlformats.org/drawingml/2006/main">
               <a:ext uri="{FF2B5EF4-FFF2-40B4-BE49-F238E27FC236}">
-                <a16:creationId xmlns:a16="http://schemas.microsoft.com/office/drawing/2014/main" id="{D121789E-9C8C-4042-BC6C-F6D1893FEEE4}"/>
+                <a16:creationId xmlns:a16="http://schemas.microsoft.com/office/drawing/2014/main" id="{B5BA7561-368D-400E-A8B5-230907F71132}"/>
               </a:ext>
             </a:extLst>
           </p:cNvPr>
@@ -34116,7 +34274,7 @@
           <p:cNvPr id="2" name="07">
             <a:extLst xmlns:a="http://schemas.openxmlformats.org/drawingml/2006/main">
               <a:ext uri="{FF2B5EF4-FFF2-40B4-BE49-F238E27FC236}">
-                <a16:creationId xmlns:a16="http://schemas.microsoft.com/office/drawing/2014/main" id="{0422F7D5-2F0F-4C4D-BBA2-F123595AA4A3}"/>
+                <a16:creationId xmlns:a16="http://schemas.microsoft.com/office/drawing/2014/main" id="{BAC5A828-03FB-450B-A2CB-3B7124D1CE2C}"/>
               </a:ext>
             </a:extLst>
           </p:cNvPr>
@@ -34274,7 +34432,7 @@
           <p:cNvPr id="3" name="Complete official firmware bundle">
             <a:extLst xmlns:a="http://schemas.openxmlformats.org/drawingml/2006/main">
               <a:ext uri="{FF2B5EF4-FFF2-40B4-BE49-F238E27FC236}">
-                <a16:creationId xmlns:a16="http://schemas.microsoft.com/office/drawing/2014/main" id="{73BCE527-9339-4709-9B5C-357571F04536}"/>
+                <a16:creationId xmlns:a16="http://schemas.microsoft.com/office/drawing/2014/main" id="{AAC40E24-F536-4E2A-BFB0-12C5F8C5434A}"/>
               </a:ext>
             </a:extLst>
           </p:cNvPr>
@@ -34432,7 +34590,7 @@
           <p:cNvPr id="4" name=".loads and every referenced binary file&#10;with the original filenam">
             <a:extLst xmlns:a="http://schemas.openxmlformats.org/drawingml/2006/main">
               <a:ext uri="{FF2B5EF4-FFF2-40B4-BE49-F238E27FC236}">
-                <a16:creationId xmlns:a16="http://schemas.microsoft.com/office/drawing/2014/main" id="{3DD0297D-0441-4EBB-BFFF-C459A5D759D3}"/>
+                <a16:creationId xmlns:a16="http://schemas.microsoft.com/office/drawing/2014/main" id="{714DEB71-9016-4CCA-874C-49C3EE3F3884}"/>
               </a:ext>
             </a:extLst>
           </p:cNvPr>
@@ -34613,7 +34771,7 @@
           <p:cNvPr id="5" name="SEP&lt;MAC&gt;.cnf.xml">
             <a:extLst xmlns:a="http://schemas.openxmlformats.org/drawingml/2006/main">
               <a:ext uri="{FF2B5EF4-FFF2-40B4-BE49-F238E27FC236}">
-                <a16:creationId xmlns:a16="http://schemas.microsoft.com/office/drawing/2014/main" id="{8A2D981F-2F1A-433F-963D-8EEC6014DC50}"/>
+                <a16:creationId xmlns:a16="http://schemas.microsoft.com/office/drawing/2014/main" id="{0DC2CFD1-28A1-45AD-A03F-CE80B0581FC9}"/>
               </a:ext>
             </a:extLst>
           </p:cNvPr>
@@ -34771,7 +34929,7 @@
           <p:cNvPr id="6" name="SIP server, extension and a unique password&#10;Load ID from the sele">
             <a:extLst xmlns:a="http://schemas.openxmlformats.org/drawingml/2006/main">
               <a:ext uri="{FF2B5EF4-FFF2-40B4-BE49-F238E27FC236}">
-                <a16:creationId xmlns:a16="http://schemas.microsoft.com/office/drawing/2014/main" id="{6F753FE9-998C-450C-A05E-50153A02BD7D}"/>
+                <a16:creationId xmlns:a16="http://schemas.microsoft.com/office/drawing/2014/main" id="{B204DC95-DAD5-4E66-BB9D-4CE68CA87DDC}"/>
               </a:ext>
             </a:extLst>
           </p:cNvPr>
@@ -34952,7 +35110,7 @@
           <p:cNvPr id="7" name="Use DHCP option 150 on the home router or Alternate TFTP on the p">
             <a:extLst xmlns:a="http://schemas.openxmlformats.org/drawingml/2006/main">
               <a:ext uri="{FF2B5EF4-FFF2-40B4-BE49-F238E27FC236}">
-                <a16:creationId xmlns:a16="http://schemas.microsoft.com/office/drawing/2014/main" id="{C8289C49-7291-4E53-87A1-6C5032EF6104}"/>
+                <a16:creationId xmlns:a16="http://schemas.microsoft.com/office/drawing/2014/main" id="{31B02B04-8DA9-4EE5-93B0-40F394865ECD}"/>
               </a:ext>
             </a:extLst>
           </p:cNvPr>
@@ -35108,7 +35266,7 @@
     </p:spTree>
     <p:extLst>
       <p:ext uri="{BB962C8B-B14F-4D97-AF65-F5344CB8AC3E}">
-        <p14:creationId xmlns:p14="http://schemas.microsoft.com/office/powerpoint/2010/main" val="2056708704"/>
+        <p14:creationId xmlns:p14="http://schemas.microsoft.com/office/powerpoint/2010/main" val="1621828081"/>
       </p:ext>
     </p:extLst>
   </p:cSld>
@@ -35139,7 +35297,7 @@
           <p:cNvPr id="8" name="Asterisk: independent SIP lines">
             <a:extLst xmlns:a="http://schemas.openxmlformats.org/drawingml/2006/main">
               <a:ext uri="{FF2B5EF4-FFF2-40B4-BE49-F238E27FC236}">
-                <a16:creationId xmlns:a16="http://schemas.microsoft.com/office/drawing/2014/main" id="{A55D4030-EE85-4A4D-9C97-9321FD56CD4A}"/>
+                <a16:creationId xmlns:a16="http://schemas.microsoft.com/office/drawing/2014/main" id="{608E5B06-B842-46BF-AFC6-873DBDF0E46A}"/>
               </a:ext>
             </a:extLst>
           </p:cNvPr>
@@ -35297,7 +35455,7 @@
           <p:cNvPr id="2" name="08">
             <a:extLst xmlns:a="http://schemas.openxmlformats.org/drawingml/2006/main">
               <a:ext uri="{FF2B5EF4-FFF2-40B4-BE49-F238E27FC236}">
-                <a16:creationId xmlns:a16="http://schemas.microsoft.com/office/drawing/2014/main" id="{BB51C624-FEEC-499E-A6C7-93607785DA9F}"/>
+                <a16:creationId xmlns:a16="http://schemas.microsoft.com/office/drawing/2014/main" id="{B5545F1B-8DC1-4F2E-8894-D4CF311063FC}"/>
               </a:ext>
             </a:extLst>
           </p:cNvPr>
@@ -35455,7 +35613,7 @@
           <p:cNvPr id="3" name="201 / 202">
             <a:extLst xmlns:a="http://schemas.openxmlformats.org/drawingml/2006/main">
               <a:ext uri="{FF2B5EF4-FFF2-40B4-BE49-F238E27FC236}">
-                <a16:creationId xmlns:a16="http://schemas.microsoft.com/office/drawing/2014/main" id="{D6609192-D19B-4BF2-B266-E5E2709AF5B1}"/>
+                <a16:creationId xmlns:a16="http://schemas.microsoft.com/office/drawing/2014/main" id="{212AE5D7-7CCD-46ED-B5CD-832B79E41103}"/>
               </a:ext>
             </a:extLst>
           </p:cNvPr>
@@ -35613,7 +35771,7 @@
           <p:cNvPr id="4" name="one phone">
             <a:extLst xmlns:a="http://schemas.openxmlformats.org/drawingml/2006/main">
               <a:ext uri="{FF2B5EF4-FFF2-40B4-BE49-F238E27FC236}">
-                <a16:creationId xmlns:a16="http://schemas.microsoft.com/office/drawing/2014/main" id="{D2149388-87DE-4035-8819-E1059B7794EF}"/>
+                <a16:creationId xmlns:a16="http://schemas.microsoft.com/office/drawing/2014/main" id="{986627FC-3FC4-4F00-869D-2FCF3C51977B}"/>
               </a:ext>
             </a:extLst>
           </p:cNvPr>
@@ -35771,7 +35929,7 @@
           <p:cNvPr id="5" name="One endpoint, auth and AOR per line&#10;A unique password for each li">
             <a:extLst xmlns:a="http://schemas.openxmlformats.org/drawingml/2006/main">
               <a:ext uri="{FF2B5EF4-FFF2-40B4-BE49-F238E27FC236}">
-                <a16:creationId xmlns:a16="http://schemas.microsoft.com/office/drawing/2014/main" id="{B7240942-777C-472A-864D-2E252CD84B26}"/>
+                <a16:creationId xmlns:a16="http://schemas.microsoft.com/office/drawing/2014/main" id="{99BACE1B-E4E5-46C5-9E54-DEACAC9FB9C1}"/>
               </a:ext>
             </a:extLst>
           </p:cNvPr>
@@ -35952,7 +36110,7 @@
           <p:cNvPr id="6" name="G.711 ulaw / alaw&#10;direct_media=no keeps RTP on Asterisk">
             <a:extLst xmlns:a="http://schemas.openxmlformats.org/drawingml/2006/main">
               <a:ext uri="{FF2B5EF4-FFF2-40B4-BE49-F238E27FC236}">
-                <a16:creationId xmlns:a16="http://schemas.microsoft.com/office/drawing/2014/main" id="{17A1816F-6485-4E83-B6A4-FFCC54C34D61}"/>
+                <a16:creationId xmlns:a16="http://schemas.microsoft.com/office/drawing/2014/main" id="{2DFAC767-DCBC-4467-8B5C-DDE70A3B25B4}"/>
               </a:ext>
             </a:extLst>
           </p:cNvPr>
@@ -36133,7 +36291,7 @@
           <p:cNvPr id="7" name="600 echo, 601 tone, 620 ring group. Extension 630 requires Assist">
             <a:extLst xmlns:a="http://schemas.openxmlformats.org/drawingml/2006/main">
               <a:ext uri="{FF2B5EF4-FFF2-40B4-BE49-F238E27FC236}">
-                <a16:creationId xmlns:a16="http://schemas.microsoft.com/office/drawing/2014/main" id="{C1F2ECFD-52B7-4668-A8BF-30B68D02044F}"/>
+                <a16:creationId xmlns:a16="http://schemas.microsoft.com/office/drawing/2014/main" id="{3C3F9DD3-C358-45D6-8AA3-B865096E47F3}"/>
               </a:ext>
             </a:extLst>
           </p:cNvPr>
@@ -36289,7 +36447,7 @@
     </p:spTree>
     <p:extLst>
       <p:ext uri="{BB962C8B-B14F-4D97-AF65-F5344CB8AC3E}">
-        <p14:creationId xmlns:p14="http://schemas.microsoft.com/office/powerpoint/2010/main" val="2084766836"/>
+        <p14:creationId xmlns:p14="http://schemas.microsoft.com/office/powerpoint/2010/main" val="415517682"/>
       </p:ext>
     </p:extLst>
   </p:cSld>
@@ -36320,7 +36478,7 @@
           <p:cNvPr id="8" name="AMI: status and call control">
             <a:extLst xmlns:a="http://schemas.openxmlformats.org/drawingml/2006/main">
               <a:ext uri="{FF2B5EF4-FFF2-40B4-BE49-F238E27FC236}">
-                <a16:creationId xmlns:a16="http://schemas.microsoft.com/office/drawing/2014/main" id="{BA971710-F646-4791-9A08-479A5F72824C}"/>
+                <a16:creationId xmlns:a16="http://schemas.microsoft.com/office/drawing/2014/main" id="{DDAA42A9-FB90-45E0-B812-C9FF85903315}"/>
               </a:ext>
             </a:extLst>
           </p:cNvPr>
@@ -36478,7 +36636,7 @@
           <p:cNvPr id="2" name="09">
             <a:extLst xmlns:a="http://schemas.openxmlformats.org/drawingml/2006/main">
               <a:ext uri="{FF2B5EF4-FFF2-40B4-BE49-F238E27FC236}">
-                <a16:creationId xmlns:a16="http://schemas.microsoft.com/office/drawing/2014/main" id="{466F114C-89BF-49B7-A46E-56A8F450787C}"/>
+                <a16:creationId xmlns:a16="http://schemas.microsoft.com/office/drawing/2014/main" id="{244C8CBB-9FC0-4028-8EDB-D8884A4A2994}"/>
               </a:ext>
             </a:extLst>
           </p:cNvPr>
@@ -36636,7 +36794,7 @@
           <p:cNvPr id="3" name="Home Assistant connects to PBX:5038">
             <a:extLst xmlns:a="http://schemas.openxmlformats.org/drawingml/2006/main">
               <a:ext uri="{FF2B5EF4-FFF2-40B4-BE49-F238E27FC236}">
-                <a16:creationId xmlns:a16="http://schemas.microsoft.com/office/drawing/2014/main" id="{5E67E888-C76C-44B2-A6BB-B82DEEB5AEFC}"/>
+                <a16:creationId xmlns:a16="http://schemas.microsoft.com/office/drawing/2014/main" id="{8B3E53F6-B9AC-4CE4-A475-0DD17ADBB503}"/>
               </a:ext>
             </a:extLst>
           </p:cNvPr>
@@ -36794,7 +36952,7 @@
           <p:cNvPr id="4" name="Status, connected line and DTMF&#10;Actual entity IDs from your HA in">
             <a:extLst xmlns:a="http://schemas.openxmlformats.org/drawingml/2006/main">
               <a:ext uri="{FF2B5EF4-FFF2-40B4-BE49-F238E27FC236}">
-                <a16:creationId xmlns:a16="http://schemas.microsoft.com/office/drawing/2014/main" id="{B466EF99-84A6-43D4-8B68-702795F8B347}"/>
+                <a16:creationId xmlns:a16="http://schemas.microsoft.com/office/drawing/2014/main" id="{D7A3C109-CE27-49CE-8160-5D30A9EA584B}"/>
               </a:ext>
             </a:extLst>
           </p:cNvPr>
@@ -36975,7 +37133,7 @@
           <p:cNvPr id="5" name="Place calls and hang up a specific channel">
             <a:extLst xmlns:a="http://schemas.openxmlformats.org/drawingml/2006/main">
               <a:ext uri="{FF2B5EF4-FFF2-40B4-BE49-F238E27FC236}">
-                <a16:creationId xmlns:a16="http://schemas.microsoft.com/office/drawing/2014/main" id="{A45D67E9-A117-4F23-BCFE-A4C8BF6A3834}"/>
+                <a16:creationId xmlns:a16="http://schemas.microsoft.com/office/drawing/2014/main" id="{608CBB0D-FB61-4B29-AF1E-5C5C9C581072}"/>
               </a:ext>
             </a:extLst>
           </p:cNvPr>
@@ -37133,7 +37291,7 @@
           <p:cNvPr id="6" name="asterisk.send_action: Originate / Hangup&#10;The DTMF example sends a">
             <a:extLst xmlns:a="http://schemas.openxmlformats.org/drawingml/2006/main">
               <a:ext uri="{FF2B5EF4-FFF2-40B4-BE49-F238E27FC236}">
-                <a16:creationId xmlns:a16="http://schemas.microsoft.com/office/drawing/2014/main" id="{D9CE9CAA-C411-4148-BA15-F94545993208}"/>
+                <a16:creationId xmlns:a16="http://schemas.microsoft.com/office/drawing/2014/main" id="{73F4417D-D030-49DE-BB15-278DBE0CCD49}"/>
               </a:ext>
             </a:extLst>
           </p:cNvPr>
@@ -37314,7 +37472,7 @@
           <p:cNvPr id="7" name="Use a separate secret and a /32 ACL. The system permission allows">
             <a:extLst xmlns:a="http://schemas.openxmlformats.org/drawingml/2006/main">
               <a:ext uri="{FF2B5EF4-FFF2-40B4-BE49-F238E27FC236}">
-                <a16:creationId xmlns:a16="http://schemas.microsoft.com/office/drawing/2014/main" id="{2E546900-950C-42E4-BD85-51449C192582}"/>
+                <a16:creationId xmlns:a16="http://schemas.microsoft.com/office/drawing/2014/main" id="{BB8A9C39-5D69-4B78-8833-AFB40839B946}"/>
               </a:ext>
             </a:extLst>
           </p:cNvPr>
@@ -37470,7 +37628,7 @@
     </p:spTree>
     <p:extLst>
       <p:ext uri="{BB962C8B-B14F-4D97-AF65-F5344CB8AC3E}">
-        <p14:creationId xmlns:p14="http://schemas.microsoft.com/office/powerpoint/2010/main" val="1676028873"/>
+        <p14:creationId xmlns:p14="http://schemas.microsoft.com/office/powerpoint/2010/main" val="582710453"/>
       </p:ext>
     </p:extLst>
   </p:cSld>

</xml_diff>

<commit_message>
Document verified phone services and external SIP outcomes
</commit_message>
<xml_diff>
--- a/docs/slides/cisco-home-telephony.pptx
+++ b/docs/slides/cisco-home-telephony.pptx
@@ -2,31 +2,31 @@
 <file path=ppt/presentation.xml><?xml version="1.0" encoding="utf-8"?>
 <p:presentation xmlns:p="http://schemas.openxmlformats.org/presentationml/2006/main">
   <p:sldMasterIdLst>
-    <p:sldMasterId xmlns:r="http://schemas.openxmlformats.org/officeDocument/2006/relationships" id="2147483648" r:id="R8c324fcf10bd4ed8"/>
+    <p:sldMasterId xmlns:r="http://schemas.openxmlformats.org/officeDocument/2006/relationships" id="2147483648" r:id="R4fbc7cc7224849d1"/>
   </p:sldMasterIdLst>
   <p:notesMasterIdLst>
-    <p:notesMasterId xmlns:r="http://schemas.openxmlformats.org/officeDocument/2006/relationships" r:id="R444cf0df1beb445f"/>
+    <p:notesMasterId xmlns:r="http://schemas.openxmlformats.org/officeDocument/2006/relationships" r:id="R5ce350475c304b3e"/>
   </p:notesMasterIdLst>
   <p:sldIdLst>
-    <p:sldId xmlns:r="http://schemas.openxmlformats.org/officeDocument/2006/relationships" id="256" r:id="R6940bb60118e4f8e"/>
-    <p:sldId xmlns:r="http://schemas.openxmlformats.org/officeDocument/2006/relationships" id="257" r:id="R95dc18e723374903"/>
-    <p:sldId xmlns:r="http://schemas.openxmlformats.org/officeDocument/2006/relationships" id="258" r:id="Ra31cf8cbabf44732"/>
-    <p:sldId xmlns:r="http://schemas.openxmlformats.org/officeDocument/2006/relationships" id="259" r:id="R8680956067dd4b0c"/>
-    <p:sldId xmlns:r="http://schemas.openxmlformats.org/officeDocument/2006/relationships" id="260" r:id="R8070d54cda70427b"/>
-    <p:sldId xmlns:r="http://schemas.openxmlformats.org/officeDocument/2006/relationships" id="261" r:id="R900b1c3daac44613"/>
-    <p:sldId xmlns:r="http://schemas.openxmlformats.org/officeDocument/2006/relationships" id="262" r:id="R8cdff775d05a47b8"/>
-    <p:sldId xmlns:r="http://schemas.openxmlformats.org/officeDocument/2006/relationships" id="263" r:id="R4a55eee7a7e44143"/>
-    <p:sldId xmlns:r="http://schemas.openxmlformats.org/officeDocument/2006/relationships" id="264" r:id="R1fa776a2db1f401e"/>
-    <p:sldId xmlns:r="http://schemas.openxmlformats.org/officeDocument/2006/relationships" id="265" r:id="R30638fd33e4244c8"/>
-    <p:sldId xmlns:r="http://schemas.openxmlformats.org/officeDocument/2006/relationships" id="266" r:id="R6b69584018274ba4"/>
-    <p:sldId xmlns:r="http://schemas.openxmlformats.org/officeDocument/2006/relationships" id="267" r:id="R9348e4e62b704aa5"/>
-    <p:sldId xmlns:r="http://schemas.openxmlformats.org/officeDocument/2006/relationships" id="268" r:id="R4ddd4551f2f6425e"/>
-    <p:sldId xmlns:r="http://schemas.openxmlformats.org/officeDocument/2006/relationships" id="269" r:id="R25bd3384ad7b44a4"/>
-    <p:sldId xmlns:r="http://schemas.openxmlformats.org/officeDocument/2006/relationships" id="270" r:id="Rfd3340a97a8c4599"/>
-    <p:sldId xmlns:r="http://schemas.openxmlformats.org/officeDocument/2006/relationships" id="271" r:id="Rc5abce227edf438d"/>
-    <p:sldId xmlns:r="http://schemas.openxmlformats.org/officeDocument/2006/relationships" id="272" r:id="R10951156fbe941f4"/>
-    <p:sldId xmlns:r="http://schemas.openxmlformats.org/officeDocument/2006/relationships" id="273" r:id="Rf850f92b3e6b4b54"/>
-    <p:sldId xmlns:r="http://schemas.openxmlformats.org/officeDocument/2006/relationships" id="274" r:id="R2b490160e3684e56"/>
+    <p:sldId xmlns:r="http://schemas.openxmlformats.org/officeDocument/2006/relationships" id="256" r:id="Red386c2da8c24505"/>
+    <p:sldId xmlns:r="http://schemas.openxmlformats.org/officeDocument/2006/relationships" id="257" r:id="R335f044b586444c8"/>
+    <p:sldId xmlns:r="http://schemas.openxmlformats.org/officeDocument/2006/relationships" id="258" r:id="R46e2264b22e24288"/>
+    <p:sldId xmlns:r="http://schemas.openxmlformats.org/officeDocument/2006/relationships" id="259" r:id="R22ae03e864784bcf"/>
+    <p:sldId xmlns:r="http://schemas.openxmlformats.org/officeDocument/2006/relationships" id="260" r:id="R0ee53d8b62e64515"/>
+    <p:sldId xmlns:r="http://schemas.openxmlformats.org/officeDocument/2006/relationships" id="261" r:id="Re7ac3fa008354b67"/>
+    <p:sldId xmlns:r="http://schemas.openxmlformats.org/officeDocument/2006/relationships" id="262" r:id="R6a613117d9c343d7"/>
+    <p:sldId xmlns:r="http://schemas.openxmlformats.org/officeDocument/2006/relationships" id="263" r:id="Rb2b329141e254b36"/>
+    <p:sldId xmlns:r="http://schemas.openxmlformats.org/officeDocument/2006/relationships" id="264" r:id="R8c1c68ba5a094325"/>
+    <p:sldId xmlns:r="http://schemas.openxmlformats.org/officeDocument/2006/relationships" id="265" r:id="R04f72f59ef8e4e73"/>
+    <p:sldId xmlns:r="http://schemas.openxmlformats.org/officeDocument/2006/relationships" id="266" r:id="R390a9dae28854831"/>
+    <p:sldId xmlns:r="http://schemas.openxmlformats.org/officeDocument/2006/relationships" id="267" r:id="R949df3a169da40c3"/>
+    <p:sldId xmlns:r="http://schemas.openxmlformats.org/officeDocument/2006/relationships" id="268" r:id="R3df9e6bd8bcb443d"/>
+    <p:sldId xmlns:r="http://schemas.openxmlformats.org/officeDocument/2006/relationships" id="269" r:id="Rc7267b4ab18f42a3"/>
+    <p:sldId xmlns:r="http://schemas.openxmlformats.org/officeDocument/2006/relationships" id="270" r:id="Rdb0010c170344030"/>
+    <p:sldId xmlns:r="http://schemas.openxmlformats.org/officeDocument/2006/relationships" id="271" r:id="R74e106278818460a"/>
+    <p:sldId xmlns:r="http://schemas.openxmlformats.org/officeDocument/2006/relationships" id="272" r:id="Rd639cdbb878f4676"/>
+    <p:sldId xmlns:r="http://schemas.openxmlformats.org/officeDocument/2006/relationships" id="273" r:id="R92089b7f29f14e53"/>
+    <p:sldId xmlns:r="http://schemas.openxmlformats.org/officeDocument/2006/relationships" id="274" r:id="R7c77d463c3e94153"/>
   </p:sldIdLst>
   <p:sldSz cx="12192000" cy="6858000"/>
   <p:notesSz cx="6858000" cy="9144000"/>
@@ -1110,7 +1110,7 @@
           <a:lstStyle xmlns:a="http://schemas.openxmlformats.org/drawingml/2006/main"/>
           <a:p xmlns:a="http://schemas.openxmlformats.org/drawingml/2006/main">
             <a:r>
-              <a:t>Status snapshot: October 17, 2026. SIP2SIP, Callcentric and the Linphone SIP provider account all reached Registered in the live Asterisk instance. That external Linphone account is separate from the Mac client on extension 209. Callcentric IP Freedom has a $0 plan and $0 balance, but outbound calls require provider risk review. Callcentric and Linphone remain registration-only with no active 801/803 route, and Linphone needs a verified free peer. The bounded SIP2SIP 802 call to its fixed 4444 echo destination answered and exchanged RTP in both directions. Local receive-loss counts increased from 42 to 91 between samples, reporting 49 additional missing packets. These samples do not establish an exact overall loss percentage or cause. Reported RTT was about 155 ms. All eight local lines remained available and owned channels were cleaned up. Human listening and satisfactory external audio quality are not claimed. Free accounts do not imply free PSTN. FWD stopped at its mandatory Verification Fee checkout. Google Voice supplies no official free generic Asterisk SIP trunk. Sources: https://sip2sip.info/help/ ; https://www.callcentric.com/rate/plans/ip_freedom/ ; https://www.callcentric.com/support/device/asterisk/17_pjsip ; https://www.linphone.org/en/faq/ ; https://www.fwdialup.com/mission ; https://knowledge.workspace.google.com/admin/voice/sip-link-requirements ; docs/server-validation.md and docs/external-sip.md .</a:t>
+              <a:t>Status snapshot: October 17, 2026. SIP2SIP, Callcentric and the Linphone SIP provider account all reached Registered in the live Asterisk instance. That external Linphone account is separate from the Mac client on extension 209. Callcentric IP Freedom has a $0 plan and $0 balance, but outbound calls require provider risk review. Callcentric remains registration-only with 801 withheld. The deployed Linphone profile uses the independently published The Test Call peer, sip:thetestcall@sip.linphone.org, for 803. A bounded live pilot answered and exchanged RTP in both directions: transmitted packets increased from 252 to 503 and received packets from 222 to 429, while locally reported receive loss stayed at zero in both samples. The latest bounded SIP2SIP 802 pilot to fixed echo destination 4444 also answered, with transmitted packets increasing from 260 to 510 and received packets from 214 to 416. Its local receive-loss counter increased from 44 to 91. These samples establish answered calls and packet exchange, not an exact overall loss percentage, cause, voice quality or working DTMF menu. Both tests ended with zero active channels after exact cleanup. Human listening and DTMF menu interaction remain untested. Free accounts do not imply free PSTN. FWD stopped at its mandatory Verification Fee checkout. Google Voice supplies no official free generic Asterisk SIP trunk. Sources: https://sip2sip.info/help/ ; https://www.callcentric.com/rate/plans/ip_freedom/ ; https://www.callcentric.com/support/device/asterisk/17_pjsip ; https://www.linphone.org/en/faq/ ; https://thetestcall.blogspot.com/ ; https://www.fwdialup.com/mission ; https://knowledge.workspace.google.com/admin/voice/sip-link-requirements ; docs/server-validation.md and docs/external-sip.md .</a:t>
             </a:r>
           </a:p>
         </p:txBody>
@@ -1180,7 +1180,7 @@
           <a:lstStyle xmlns:a="http://schemas.openxmlformats.org/drawingml/2006/main"/>
           <a:p xmlns:a="http://schemas.openxmlformats.org/drawingml/2006/main">
             <a:r>
-              <a:t>Extension 209 has a dedicated TCP/IPv4 account on the home PBX. Telephone registered, but numeric dialing stalled inside macOS Contacts authorization before any SIP call. Contacts access was not granted. The verified, notarized Linphone 6.2.3 app then registered over TCP using its documented local XML provisioning. A bounded 20-second 209-to-600 call reached Up/Echo with PCMU, increasing RTP in both directions and zero reported loss in the sampled counters. The owned call ended with zero channels. The user confirmed hearing the echo. A later PBX rollout briefly refused the connection; Linphone recovered through its normal registration retry without changing credentials. Later calls from 209 to 210 and 213 reached Ringing. Allow registration to recover after a restart before retrying. These ringing observations are not additional answered-media tests. The optional site.softphones entry has its own preserved secret and an exact source IPv4 ACL. It creates no Cisco XML, does not join ring group 620 and is not a Cisco gateway device. The three new radio definitions are official Deti FM channels: 708 toddler music (channel 327), 709 lullabies (channel 95), and 710 children’s songs (channel 93). All three passed bounded five-second stream decoding in the PBX namespace without calls. All three routes are deployed and produced PCM through the installed worker. A listener confirmed music on 708. With the handset down and speaker/headset off, type the full station number then press Dial, without first pressing a line key. This documented on-hook method can avoid a Cisco profile refresh or reboot; verify it on the installed firmware. No continuous download is required. Sources: https://www.linphone.org/en/docs/login-sip-account/ ; https://download.linphone.org/releases/macosx/app/ ; https://github.com/64characters/Telephone/blob/1.6/Telephone/ActiveAccountViewController.m ; https://detifm.ru/channel/327 ; https://detifm.ru/channel/95 ; https://detifm.ru/channel/93 ; docs/macos-softphone.md and docs/radio-and-alarms.md .</a:t>
+              <a:t>Extension 209 has a dedicated TCP/IPv4 account on the home PBX. Zoiper5 is the current compact Mac client, replacing the earlier Telephone and Linphone trials. Zoiper registration and an echo call to 600 passed, and the user confirmed audible echo. Earlier Linphone 6.2.3 tests reached Up/Echo with PCMU and increasing RTP in both directions; those are historical tests of the same independent PBX account. Allow registration to recover after a PBX restart before retrying a call. The optional site.softphones entry has its own preserved secret and an exact source IPv4 ACL. It creates no Cisco XML, does not join ring group 620 and is not a Cisco gateway device. The optional incoming group 621 can include this client through explicit private membership. The three Deti FM channels are 708 toddler music (channel 327), 709 lullabies (channel 95), and 710 children's songs (channel 93). All three passed bounded stream decoding in the PBX namespace and produced PCM through the installed worker. A listener confirmed music on 708; this does not establish human-audible playback for every station. With the Cisco handset down and speaker/headset off, type the full station number then press Dial, without first pressing a line key. No continuous download is required. Sources: https://www.zoiper.com/en/voip-softphone/download/current ; https://detifm.ru/channel/327 ; https://detifm.ru/channel/95 ; https://detifm.ru/channel/93 ; docs/macos-softphone.md and docs/radio-and-alarms.md .</a:t>
             </a:r>
           </a:p>
         </p:txBody>
@@ -1862,7 +1862,7 @@
           <p:cNvPr id="3" name="Title">
             <a:extLst xmlns:a="http://schemas.openxmlformats.org/drawingml/2006/main">
               <a:ext uri="{FF2B5EF4-FFF2-40B4-BE49-F238E27FC236}">
-                <a16:creationId xmlns:a16="http://schemas.microsoft.com/office/drawing/2014/main" id="{81C21CCA-EDD2-4E4F-84F4-C1A346832F07}"/>
+                <a16:creationId xmlns:a16="http://schemas.microsoft.com/office/drawing/2014/main" id="{22A01C0E-3CE8-4A60-83D1-3E2F86CE4F83}"/>
               </a:ext>
             </a:extLst>
           </p:cNvPr>
@@ -2091,7 +2091,7 @@
           <p:cNvPr id="2" name="Subtitle">
             <a:extLst xmlns:a="http://schemas.openxmlformats.org/drawingml/2006/main">
               <a:ext uri="{FF2B5EF4-FFF2-40B4-BE49-F238E27FC236}">
-                <a16:creationId xmlns:a16="http://schemas.microsoft.com/office/drawing/2014/main" id="{5AD15BE1-0700-4CA4-B398-EF08F9E64C57}"/>
+                <a16:creationId xmlns:a16="http://schemas.microsoft.com/office/drawing/2014/main" id="{D05D0ACD-E211-43A3-ABC2-E9542FA056DF}"/>
               </a:ext>
             </a:extLst>
           </p:cNvPr>
@@ -2337,7 +2337,7 @@
           <p:cNvPr id="2" name="Section title">
             <a:extLst xmlns:a="http://schemas.openxmlformats.org/drawingml/2006/main">
               <a:ext uri="{FF2B5EF4-FFF2-40B4-BE49-F238E27FC236}">
-                <a16:creationId xmlns:a16="http://schemas.microsoft.com/office/drawing/2014/main" id="{C9EFEFE7-F76B-431D-BAF9-E0D8AC7D91A5}"/>
+                <a16:creationId xmlns:a16="http://schemas.microsoft.com/office/drawing/2014/main" id="{3F488EBB-98C8-4228-BAE5-C22C0111A12A}"/>
               </a:ext>
             </a:extLst>
           </p:cNvPr>
@@ -2583,7 +2583,7 @@
           <p:cNvPr id="3" name="Title">
             <a:extLst xmlns:a="http://schemas.openxmlformats.org/drawingml/2006/main">
               <a:ext uri="{FF2B5EF4-FFF2-40B4-BE49-F238E27FC236}">
-                <a16:creationId xmlns:a16="http://schemas.microsoft.com/office/drawing/2014/main" id="{044E0FCD-764A-4C86-A1B8-39487E2D165F}"/>
+                <a16:creationId xmlns:a16="http://schemas.microsoft.com/office/drawing/2014/main" id="{BD4E175D-5311-4404-9752-C37B959BA1CC}"/>
               </a:ext>
             </a:extLst>
           </p:cNvPr>
@@ -2812,7 +2812,7 @@
           <p:cNvPr id="2" name="Body">
             <a:extLst xmlns:a="http://schemas.openxmlformats.org/drawingml/2006/main">
               <a:ext uri="{FF2B5EF4-FFF2-40B4-BE49-F238E27FC236}">
-                <a16:creationId xmlns:a16="http://schemas.microsoft.com/office/drawing/2014/main" id="{F43E20B6-B4AC-4325-A403-C717C1B88907}"/>
+                <a16:creationId xmlns:a16="http://schemas.microsoft.com/office/drawing/2014/main" id="{9D2598A3-AB05-45BB-AAFF-1B4E519A698C}"/>
               </a:ext>
             </a:extLst>
           </p:cNvPr>
@@ -3058,7 +3058,7 @@
           <p:cNvPr id="4" name="Title">
             <a:extLst xmlns:a="http://schemas.openxmlformats.org/drawingml/2006/main">
               <a:ext uri="{FF2B5EF4-FFF2-40B4-BE49-F238E27FC236}">
-                <a16:creationId xmlns:a16="http://schemas.microsoft.com/office/drawing/2014/main" id="{F723B87C-88ED-41FA-B34D-B78468EA2557}"/>
+                <a16:creationId xmlns:a16="http://schemas.microsoft.com/office/drawing/2014/main" id="{230495B7-694B-4C77-8372-627C28D05B51}"/>
               </a:ext>
             </a:extLst>
           </p:cNvPr>
@@ -3287,7 +3287,7 @@
           <p:cNvPr id="2" name="Left column">
             <a:extLst xmlns:a="http://schemas.openxmlformats.org/drawingml/2006/main">
               <a:ext uri="{FF2B5EF4-FFF2-40B4-BE49-F238E27FC236}">
-                <a16:creationId xmlns:a16="http://schemas.microsoft.com/office/drawing/2014/main" id="{111E49A8-275A-4032-8C96-824C28C5015F}"/>
+                <a16:creationId xmlns:a16="http://schemas.microsoft.com/office/drawing/2014/main" id="{4A39E6F3-AF8B-4D92-BAEB-CD8327871CD6}"/>
               </a:ext>
             </a:extLst>
           </p:cNvPr>
@@ -3516,7 +3516,7 @@
           <p:cNvPr id="3" name="Right column">
             <a:extLst xmlns:a="http://schemas.openxmlformats.org/drawingml/2006/main">
               <a:ext uri="{FF2B5EF4-FFF2-40B4-BE49-F238E27FC236}">
-                <a16:creationId xmlns:a16="http://schemas.microsoft.com/office/drawing/2014/main" id="{19104270-D40C-4456-A9C0-EF6D4FC1D6AE}"/>
+                <a16:creationId xmlns:a16="http://schemas.microsoft.com/office/drawing/2014/main" id="{9CBFF9DA-BC24-46C7-8577-DB772F7D9853}"/>
               </a:ext>
             </a:extLst>
           </p:cNvPr>
@@ -3762,7 +3762,7 @@
           <p:cNvPr id="3" name="Title">
             <a:extLst xmlns:a="http://schemas.openxmlformats.org/drawingml/2006/main">
               <a:ext uri="{FF2B5EF4-FFF2-40B4-BE49-F238E27FC236}">
-                <a16:creationId xmlns:a16="http://schemas.microsoft.com/office/drawing/2014/main" id="{4D8E9234-7903-427E-A721-2E8BE9050D81}"/>
+                <a16:creationId xmlns:a16="http://schemas.microsoft.com/office/drawing/2014/main" id="{71EE0351-D177-4E9F-B49E-6F17E3AC46CC}"/>
               </a:ext>
             </a:extLst>
           </p:cNvPr>
@@ -3991,7 +3991,7 @@
           <p:cNvPr id="2" name="Left column">
             <a:extLst xmlns:a="http://schemas.openxmlformats.org/drawingml/2006/main">
               <a:ext uri="{FF2B5EF4-FFF2-40B4-BE49-F238E27FC236}">
-                <a16:creationId xmlns:a16="http://schemas.microsoft.com/office/drawing/2014/main" id="{64FC12A3-A141-485C-A7DD-34B4084F22ED}"/>
+                <a16:creationId xmlns:a16="http://schemas.microsoft.com/office/drawing/2014/main" id="{BD8BFE7E-9CC7-41D0-939A-3640EAB43952}"/>
               </a:ext>
             </a:extLst>
           </p:cNvPr>
@@ -4258,12 +4258,12 @@
   </p:cSld>
   <p:clrMap bg1="lt1" tx1="dk1" bg2="lt2" tx2="dk2" accent1="accent1" accent2="accent2" accent3="accent3" accent4="accent4" accent5="accent5" accent6="accent6" hlink="hlink" folHlink="folHlink"/>
   <p:sldLayoutIdLst>
-    <p:sldLayoutId xmlns:r="http://schemas.openxmlformats.org/officeDocument/2006/relationships" id="2147483649" r:id="Rb195eb865b184a55"/>
-    <p:sldLayoutId xmlns:r="http://schemas.openxmlformats.org/officeDocument/2006/relationships" id="2147483650" r:id="Rde171a2522634bbd"/>
-    <p:sldLayoutId xmlns:r="http://schemas.openxmlformats.org/officeDocument/2006/relationships" id="2147483651" r:id="Rf3944d2dc74247ec"/>
-    <p:sldLayoutId xmlns:r="http://schemas.openxmlformats.org/officeDocument/2006/relationships" id="2147483652" r:id="Rb4679f3a993244af"/>
-    <p:sldLayoutId xmlns:r="http://schemas.openxmlformats.org/officeDocument/2006/relationships" id="2147483653" r:id="R0af6b452b9414a1f"/>
-    <p:sldLayoutId xmlns:r="http://schemas.openxmlformats.org/officeDocument/2006/relationships" id="2147483654" r:id="R44a1a2ecb7fb4ac9"/>
+    <p:sldLayoutId xmlns:r="http://schemas.openxmlformats.org/officeDocument/2006/relationships" id="2147483649" r:id="R33bec5f0cc4343cd"/>
+    <p:sldLayoutId xmlns:r="http://schemas.openxmlformats.org/officeDocument/2006/relationships" id="2147483650" r:id="R5486869e699446c9"/>
+    <p:sldLayoutId xmlns:r="http://schemas.openxmlformats.org/officeDocument/2006/relationships" id="2147483651" r:id="Rb8bd293f8ac44f93"/>
+    <p:sldLayoutId xmlns:r="http://schemas.openxmlformats.org/officeDocument/2006/relationships" id="2147483652" r:id="R3611584d22244f80"/>
+    <p:sldLayoutId xmlns:r="http://schemas.openxmlformats.org/officeDocument/2006/relationships" id="2147483653" r:id="R6ad9c7a75fc14f16"/>
+    <p:sldLayoutId xmlns:r="http://schemas.openxmlformats.org/officeDocument/2006/relationships" id="2147483654" r:id="R0c5386029a824baf"/>
   </p:sldLayoutIdLst>
   <p:txStyles>
     <p:titleStyle>
@@ -4814,7 +4814,7 @@
           <p:cNvPr id="7" name="">
             <a:extLst xmlns:a="http://schemas.openxmlformats.org/drawingml/2006/main">
               <a:ext uri="{FF2B5EF4-FFF2-40B4-BE49-F238E27FC236}">
-                <a16:creationId xmlns:a16="http://schemas.microsoft.com/office/drawing/2014/main" id="{D81C0469-AD99-457D-9EE0-EB7C7077C2CF}"/>
+                <a16:creationId xmlns:a16="http://schemas.microsoft.com/office/drawing/2014/main" id="{BB5E20A6-DE54-465A-BB8E-377EDA87CED2}"/>
               </a:ext>
             </a:extLst>
           </p:cNvPr>
@@ -4954,7 +4954,7 @@
           <p:cNvPr id="2" name="01">
             <a:extLst xmlns:a="http://schemas.openxmlformats.org/drawingml/2006/main">
               <a:ext uri="{FF2B5EF4-FFF2-40B4-BE49-F238E27FC236}">
-                <a16:creationId xmlns:a16="http://schemas.microsoft.com/office/drawing/2014/main" id="{24242900-1137-4043-9D29-34124124A5F3}"/>
+                <a16:creationId xmlns:a16="http://schemas.microsoft.com/office/drawing/2014/main" id="{E50B0C3C-5413-4B51-BB88-97743557FAC6}"/>
               </a:ext>
             </a:extLst>
           </p:cNvPr>
@@ -5112,7 +5112,7 @@
           <p:cNvPr id="3" name="Cisco 7945G">
             <a:extLst xmlns:a="http://schemas.openxmlformats.org/drawingml/2006/main">
               <a:ext uri="{FF2B5EF4-FFF2-40B4-BE49-F238E27FC236}">
-                <a16:creationId xmlns:a16="http://schemas.microsoft.com/office/drawing/2014/main" id="{034F0DE2-0C41-47C3-9C10-095D39666884}"/>
+                <a16:creationId xmlns:a16="http://schemas.microsoft.com/office/drawing/2014/main" id="{EFF3AAEF-92B6-4CAB-9FB5-F3A874F9E167}"/>
               </a:ext>
             </a:extLst>
           </p:cNvPr>
@@ -5270,7 +5270,7 @@
           <p:cNvPr id="4" name="Home telephony">
             <a:extLst xmlns:a="http://schemas.openxmlformats.org/drawingml/2006/main">
               <a:ext uri="{FF2B5EF4-FFF2-40B4-BE49-F238E27FC236}">
-                <a16:creationId xmlns:a16="http://schemas.microsoft.com/office/drawing/2014/main" id="{80EBAE96-649A-41FA-9E3A-CA18A7C48A99}"/>
+                <a16:creationId xmlns:a16="http://schemas.microsoft.com/office/drawing/2014/main" id="{B3BCE3E8-4C83-40BB-8BDA-95256F7AD5AE}"/>
               </a:ext>
             </a:extLst>
           </p:cNvPr>
@@ -5428,7 +5428,7 @@
           <p:cNvPr id="5" name="Asterisk in k3s + Home Assistant">
             <a:extLst xmlns:a="http://schemas.openxmlformats.org/drawingml/2006/main">
               <a:ext uri="{FF2B5EF4-FFF2-40B4-BE49-F238E27FC236}">
-                <a16:creationId xmlns:a16="http://schemas.microsoft.com/office/drawing/2014/main" id="{15C96055-C072-4C28-B55B-F630CE3750EC}"/>
+                <a16:creationId xmlns:a16="http://schemas.microsoft.com/office/drawing/2014/main" id="{F7662E04-DBE8-49AE-BBE1-6AF4B810BFAF}"/>
               </a:ext>
             </a:extLst>
           </p:cNvPr>
@@ -5586,7 +5586,7 @@
           <p:cNvPr id="6" name="Two SIP lines, color display and native PoE">
             <a:extLst xmlns:a="http://schemas.openxmlformats.org/drawingml/2006/main">
               <a:ext uri="{FF2B5EF4-FFF2-40B4-BE49-F238E27FC236}">
-                <a16:creationId xmlns:a16="http://schemas.microsoft.com/office/drawing/2014/main" id="{7244592F-CE5E-4882-9C01-BA45B25E7233}"/>
+                <a16:creationId xmlns:a16="http://schemas.microsoft.com/office/drawing/2014/main" id="{9DB5FC79-EC5C-4C14-8095-7B78F6997997}"/>
               </a:ext>
             </a:extLst>
           </p:cNvPr>
@@ -5742,7 +5742,7 @@
     </p:spTree>
     <p:extLst>
       <p:ext uri="{BB962C8B-B14F-4D97-AF65-F5344CB8AC3E}">
-        <p14:creationId xmlns:p14="http://schemas.microsoft.com/office/powerpoint/2010/main" val="2011763152"/>
+        <p14:creationId xmlns:p14="http://schemas.microsoft.com/office/powerpoint/2010/main" val="631718349"/>
       </p:ext>
     </p:extLst>
   </p:cSld>
@@ -5773,7 +5773,7 @@
           <p:cNvPr id="8" name="">
             <a:extLst xmlns:a="http://schemas.openxmlformats.org/drawingml/2006/main">
               <a:ext uri="{FF2B5EF4-FFF2-40B4-BE49-F238E27FC236}">
-                <a16:creationId xmlns:a16="http://schemas.microsoft.com/office/drawing/2014/main" id="{C9E72EFB-5E29-40BF-A384-1FAFF304F0B4}"/>
+                <a16:creationId xmlns:a16="http://schemas.microsoft.com/office/drawing/2014/main" id="{8ADB44BE-6D64-4308-8CA5-5C4DFEB543F2}"/>
               </a:ext>
             </a:extLst>
           </p:cNvPr>
@@ -5805,7 +5805,7 @@
           <p:cNvPr id="6" name="">
             <a:extLst xmlns:a="http://schemas.openxmlformats.org/drawingml/2006/main">
               <a:ext uri="{FF2B5EF4-FFF2-40B4-BE49-F238E27FC236}">
-                <a16:creationId xmlns:a16="http://schemas.microsoft.com/office/drawing/2014/main" id="{14F90424-FDBA-44EF-9D13-EE99D8011691}"/>
+                <a16:creationId xmlns:a16="http://schemas.microsoft.com/office/drawing/2014/main" id="{AE0C7104-9444-4033-9F1A-632FAEEF7DD7}"/>
               </a:ext>
             </a:extLst>
           </p:cNvPr>
@@ -5837,7 +5837,7 @@
           <p:cNvPr id="12" name="630: voice assistant on the phone">
             <a:extLst xmlns:a="http://schemas.openxmlformats.org/drawingml/2006/main">
               <a:ext uri="{FF2B5EF4-FFF2-40B4-BE49-F238E27FC236}">
-                <a16:creationId xmlns:a16="http://schemas.microsoft.com/office/drawing/2014/main" id="{02EFB659-E397-49E0-9B0E-FB452F6B8819}"/>
+                <a16:creationId xmlns:a16="http://schemas.microsoft.com/office/drawing/2014/main" id="{AEC9B0ED-EED8-48DC-BE47-A578ADC52387}"/>
               </a:ext>
             </a:extLst>
           </p:cNvPr>
@@ -5995,7 +5995,7 @@
           <p:cNvPr id="2" name="10">
             <a:extLst xmlns:a="http://schemas.openxmlformats.org/drawingml/2006/main">
               <a:ext uri="{FF2B5EF4-FFF2-40B4-BE49-F238E27FC236}">
-                <a16:creationId xmlns:a16="http://schemas.microsoft.com/office/drawing/2014/main" id="{BE078BB7-A169-424C-8D43-F0CA4D121C72}"/>
+                <a16:creationId xmlns:a16="http://schemas.microsoft.com/office/drawing/2014/main" id="{41839F6C-BE86-49CD-981B-5266EB858CD5}"/>
               </a:ext>
             </a:extLst>
           </p:cNvPr>
@@ -6153,7 +6153,7 @@
           <p:cNvPr id="3" name="cisco">
             <a:extLst xmlns:a="http://schemas.openxmlformats.org/drawingml/2006/main">
               <a:ext uri="{FF2B5EF4-FFF2-40B4-BE49-F238E27FC236}">
-                <a16:creationId xmlns:a16="http://schemas.microsoft.com/office/drawing/2014/main" id="{42F917B8-1D04-4EAF-95B6-6295C993547B}"/>
+                <a16:creationId xmlns:a16="http://schemas.microsoft.com/office/drawing/2014/main" id="{C605C14E-EC96-4F2A-A0E1-14850E109389}"/>
               </a:ext>
             </a:extLst>
           </p:cNvPr>
@@ -6363,7 +6363,7 @@
           <p:cNvPr id="4" name="codec">
             <a:extLst xmlns:a="http://schemas.openxmlformats.org/drawingml/2006/main">
               <a:ext uri="{FF2B5EF4-FFF2-40B4-BE49-F238E27FC236}">
-                <a16:creationId xmlns:a16="http://schemas.microsoft.com/office/drawing/2014/main" id="{2A3107F3-2A1B-450C-BD42-2583565ADAE3}"/>
+                <a16:creationId xmlns:a16="http://schemas.microsoft.com/office/drawing/2014/main" id="{8FBFC649-707F-4995-AFAE-A4BC54588B71}"/>
               </a:ext>
             </a:extLst>
           </p:cNvPr>
@@ -6573,7 +6573,7 @@
           <p:cNvPr id="5" name="assist">
             <a:extLst xmlns:a="http://schemas.openxmlformats.org/drawingml/2006/main">
               <a:ext uri="{FF2B5EF4-FFF2-40B4-BE49-F238E27FC236}">
-                <a16:creationId xmlns:a16="http://schemas.microsoft.com/office/drawing/2014/main" id="{C399CD51-DA35-419B-B990-378F8EBEF14C}"/>
+                <a16:creationId xmlns:a16="http://schemas.microsoft.com/office/drawing/2014/main" id="{E8F9AAD9-4690-47F2-A9AC-F251C1FD592D}"/>
               </a:ext>
             </a:extLst>
           </p:cNvPr>
@@ -6783,7 +6783,7 @@
           <p:cNvPr id="7" name="SIP TCP&#10;RTP">
             <a:extLst xmlns:a="http://schemas.openxmlformats.org/drawingml/2006/main">
               <a:ext uri="{FF2B5EF4-FFF2-40B4-BE49-F238E27FC236}">
-                <a16:creationId xmlns:a16="http://schemas.microsoft.com/office/drawing/2014/main" id="{1A27C7F0-0B9B-43B2-9794-47490842E51D}"/>
+                <a16:creationId xmlns:a16="http://schemas.microsoft.com/office/drawing/2014/main" id="{470DB8BF-F0B1-4E8D-AB3D-0369EE7E23C8}"/>
               </a:ext>
             </a:extLst>
           </p:cNvPr>
@@ -6964,7 +6964,7 @@
           <p:cNvPr id="9" name="SIP UDP&#10;RTP">
             <a:extLst xmlns:a="http://schemas.openxmlformats.org/drawingml/2006/main">
               <a:ext uri="{FF2B5EF4-FFF2-40B4-BE49-F238E27FC236}">
-                <a16:creationId xmlns:a16="http://schemas.microsoft.com/office/drawing/2014/main" id="{2E9CAF76-D9A8-4789-B48B-3CFEA8CB312D}"/>
+                <a16:creationId xmlns:a16="http://schemas.microsoft.com/office/drawing/2014/main" id="{39FDE56A-2EB3-4EB8-91FC-6FAA4927FF25}"/>
               </a:ext>
             </a:extLst>
           </p:cNvPr>
@@ -7145,7 +7145,7 @@
           <p:cNvPr id="10" name="First call: enable Allow calls and select a pipeline in HA.&#10;Then ">
             <a:extLst xmlns:a="http://schemas.openxmlformats.org/drawingml/2006/main">
               <a:ext uri="{FF2B5EF4-FFF2-40B4-BE49-F238E27FC236}">
-                <a16:creationId xmlns:a16="http://schemas.microsoft.com/office/drawing/2014/main" id="{D65C11D8-D7E6-4AB7-97B2-B2CBBCFC5615}"/>
+                <a16:creationId xmlns:a16="http://schemas.microsoft.com/office/drawing/2014/main" id="{1E68F88D-F993-4526-B7C6-C2504CD079A1}"/>
               </a:ext>
             </a:extLst>
           </p:cNvPr>
@@ -7326,7 +7326,7 @@
           <p:cNvPr id="11" name="SIP From retains the phone extension. HA uses dynamic UDP ports f">
             <a:extLst xmlns:a="http://schemas.openxmlformats.org/drawingml/2006/main">
               <a:ext uri="{FF2B5EF4-FFF2-40B4-BE49-F238E27FC236}">
-                <a16:creationId xmlns:a16="http://schemas.microsoft.com/office/drawing/2014/main" id="{348A4007-6E56-45A0-9A79-092424D72C66}"/>
+                <a16:creationId xmlns:a16="http://schemas.microsoft.com/office/drawing/2014/main" id="{E0A02A38-14AF-4E53-9865-31FB0AA65C33}"/>
               </a:ext>
             </a:extLst>
           </p:cNvPr>
@@ -7505,7 +7505,7 @@
     </p:spTree>
     <p:extLst>
       <p:ext uri="{BB962C8B-B14F-4D97-AF65-F5344CB8AC3E}">
-        <p14:creationId xmlns:p14="http://schemas.microsoft.com/office/powerpoint/2010/main" val="731273391"/>
+        <p14:creationId xmlns:p14="http://schemas.microsoft.com/office/powerpoint/2010/main" val="11594150"/>
       </p:ext>
     </p:extLst>
   </p:cSld>
@@ -7536,7 +7536,7 @@
           <p:cNvPr id="15" name="Deployment and commissioning">
             <a:extLst xmlns:a="http://schemas.openxmlformats.org/drawingml/2006/main">
               <a:ext uri="{FF2B5EF4-FFF2-40B4-BE49-F238E27FC236}">
-                <a16:creationId xmlns:a16="http://schemas.microsoft.com/office/drawing/2014/main" id="{1DF64D8C-92AA-45AD-88B7-3681B71924A6}"/>
+                <a16:creationId xmlns:a16="http://schemas.microsoft.com/office/drawing/2014/main" id="{C9BC0E38-B5E2-409A-8977-9793A8F0C676}"/>
               </a:ext>
             </a:extLst>
           </p:cNvPr>
@@ -7694,7 +7694,7 @@
           <p:cNvPr id="2" name="11">
             <a:extLst xmlns:a="http://schemas.openxmlformats.org/drawingml/2006/main">
               <a:ext uri="{FF2B5EF4-FFF2-40B4-BE49-F238E27FC236}">
-                <a16:creationId xmlns:a16="http://schemas.microsoft.com/office/drawing/2014/main" id="{C0D3CF69-BCBC-499E-A01D-746263BFB3D7}"/>
+                <a16:creationId xmlns:a16="http://schemas.microsoft.com/office/drawing/2014/main" id="{E6A7E217-0B66-41CC-ADFE-83DBE908B2F2}"/>
               </a:ext>
             </a:extLst>
           </p:cNvPr>
@@ -7852,7 +7852,7 @@
           <p:cNvPr id="3" name="01">
             <a:extLst xmlns:a="http://schemas.openxmlformats.org/drawingml/2006/main">
               <a:ext uri="{FF2B5EF4-FFF2-40B4-BE49-F238E27FC236}">
-                <a16:creationId xmlns:a16="http://schemas.microsoft.com/office/drawing/2014/main" id="{DA368D37-A51D-4775-B035-E252BBCDF52C}"/>
+                <a16:creationId xmlns:a16="http://schemas.microsoft.com/office/drawing/2014/main" id="{10A244A6-2798-4CC6-A8FE-57AE97BD1B55}"/>
               </a:ext>
             </a:extLst>
           </p:cNvPr>
@@ -8010,7 +8010,7 @@
           <p:cNvPr id="4" name="Server bootstrap">
             <a:extLst xmlns:a="http://schemas.openxmlformats.org/drawingml/2006/main">
               <a:ext uri="{FF2B5EF4-FFF2-40B4-BE49-F238E27FC236}">
-                <a16:creationId xmlns:a16="http://schemas.microsoft.com/office/drawing/2014/main" id="{FC445BC5-0C0F-44BB-97A1-57C8A6A6BA45}"/>
+                <a16:creationId xmlns:a16="http://schemas.microsoft.com/office/drawing/2014/main" id="{63BAED3C-6850-4691-A8DE-6B9EF29CD7FC}"/>
               </a:ext>
             </a:extLst>
           </p:cNvPr>
@@ -8168,7 +8168,7 @@
           <p:cNvPr id="5" name="Images, static IP, firewall, Asterisk and Opus">
             <a:extLst xmlns:a="http://schemas.openxmlformats.org/drawingml/2006/main">
               <a:ext uri="{FF2B5EF4-FFF2-40B4-BE49-F238E27FC236}">
-                <a16:creationId xmlns:a16="http://schemas.microsoft.com/office/drawing/2014/main" id="{EE4BAF10-8468-44CB-892E-619F692B4D59}"/>
+                <a16:creationId xmlns:a16="http://schemas.microsoft.com/office/drawing/2014/main" id="{BFDAB3B1-9E97-4CF5-9CF1-B0D693DE7CB2}"/>
               </a:ext>
             </a:extLst>
           </p:cNvPr>
@@ -8326,7 +8326,7 @@
           <p:cNvPr id="6" name="02">
             <a:extLst xmlns:a="http://schemas.openxmlformats.org/drawingml/2006/main">
               <a:ext uri="{FF2B5EF4-FFF2-40B4-BE49-F238E27FC236}">
-                <a16:creationId xmlns:a16="http://schemas.microsoft.com/office/drawing/2014/main" id="{5D3AF0D3-928F-416A-8DF8-A090908B3164}"/>
+                <a16:creationId xmlns:a16="http://schemas.microsoft.com/office/drawing/2014/main" id="{2D3455E1-B692-4416-A8C4-49060D2885E3}"/>
               </a:ext>
             </a:extLst>
           </p:cNvPr>
@@ -8484,7 +8484,7 @@
           <p:cNvPr id="7" name="Verified pilot phone">
             <a:extLst xmlns:a="http://schemas.openxmlformats.org/drawingml/2006/main">
               <a:ext uri="{FF2B5EF4-FFF2-40B4-BE49-F238E27FC236}">
-                <a16:creationId xmlns:a16="http://schemas.microsoft.com/office/drawing/2014/main" id="{ACA92AFC-A9EA-42D1-A741-E008B0ADD55C}"/>
+                <a16:creationId xmlns:a16="http://schemas.microsoft.com/office/drawing/2014/main" id="{414DEA84-39BC-469A-BB7B-76FEF56194E4}"/>
               </a:ext>
             </a:extLst>
           </p:cNvPr>
@@ -8642,7 +8642,7 @@
           <p:cNvPr id="8" name="PID / HW / Load / MAC, SIP profile, temporary TFTP">
             <a:extLst xmlns:a="http://schemas.openxmlformats.org/drawingml/2006/main">
               <a:ext uri="{FF2B5EF4-FFF2-40B4-BE49-F238E27FC236}">
-                <a16:creationId xmlns:a16="http://schemas.microsoft.com/office/drawing/2014/main" id="{81B86B97-570A-438F-BF16-D68A075734D4}"/>
+                <a16:creationId xmlns:a16="http://schemas.microsoft.com/office/drawing/2014/main" id="{D3182C5A-C890-4225-8F5B-3C0BB2902982}"/>
               </a:ext>
             </a:extLst>
           </p:cNvPr>
@@ -8800,7 +8800,7 @@
           <p:cNvPr id="9" name="03">
             <a:extLst xmlns:a="http://schemas.openxmlformats.org/drawingml/2006/main">
               <a:ext uri="{FF2B5EF4-FFF2-40B4-BE49-F238E27FC236}">
-                <a16:creationId xmlns:a16="http://schemas.microsoft.com/office/drawing/2014/main" id="{123F9AC1-B1C5-4B56-A480-A1669EFF9480}"/>
+                <a16:creationId xmlns:a16="http://schemas.microsoft.com/office/drawing/2014/main" id="{DE984E86-2133-4028-B0E1-880F1C737135}"/>
               </a:ext>
             </a:extLst>
           </p:cNvPr>
@@ -8958,7 +8958,7 @@
           <p:cNvPr id="10" name="Home Assistant setup">
             <a:extLst xmlns:a="http://schemas.openxmlformats.org/drawingml/2006/main">
               <a:ext uri="{FF2B5EF4-FFF2-40B4-BE49-F238E27FC236}">
-                <a16:creationId xmlns:a16="http://schemas.microsoft.com/office/drawing/2014/main" id="{FAE4DB09-7D46-4568-820B-712104D66182}"/>
+                <a16:creationId xmlns:a16="http://schemas.microsoft.com/office/drawing/2014/main" id="{5FCCCD68-EDBD-4E86-9CDC-F19CF3ECF5B1}"/>
               </a:ext>
             </a:extLst>
           </p:cNvPr>
@@ -9116,7 +9116,7 @@
           <p:cNvPr id="11" name="AMI /32, secret, actual entity IDs and VoIP pipeline">
             <a:extLst xmlns:a="http://schemas.openxmlformats.org/drawingml/2006/main">
               <a:ext uri="{FF2B5EF4-FFF2-40B4-BE49-F238E27FC236}">
-                <a16:creationId xmlns:a16="http://schemas.microsoft.com/office/drawing/2014/main" id="{18C6CB8E-5B7C-47DC-9531-E7A100DAE8EF}"/>
+                <a16:creationId xmlns:a16="http://schemas.microsoft.com/office/drawing/2014/main" id="{87F0D3FA-CE1F-4D9D-833D-AA2D201163CE}"/>
               </a:ext>
             </a:extLst>
           </p:cNvPr>
@@ -9274,7 +9274,7 @@
           <p:cNvPr id="12" name="04">
             <a:extLst xmlns:a="http://schemas.openxmlformats.org/drawingml/2006/main">
               <a:ext uri="{FF2B5EF4-FFF2-40B4-BE49-F238E27FC236}">
-                <a16:creationId xmlns:a16="http://schemas.microsoft.com/office/drawing/2014/main" id="{CDE2475C-6868-4C87-9F17-0DEAE8B85C9F}"/>
+                <a16:creationId xmlns:a16="http://schemas.microsoft.com/office/drawing/2014/main" id="{4503E7FE-01D3-4E7D-8514-F59EC9E8F7CA}"/>
               </a:ext>
             </a:extLst>
           </p:cNvPr>
@@ -9432,7 +9432,7 @@
           <p:cNvPr id="13" name="Acceptance and rollout">
             <a:extLst xmlns:a="http://schemas.openxmlformats.org/drawingml/2006/main">
               <a:ext uri="{FF2B5EF4-FFF2-40B4-BE49-F238E27FC236}">
-                <a16:creationId xmlns:a16="http://schemas.microsoft.com/office/drawing/2014/main" id="{2E3C4FB1-CE76-4C8E-9784-29D0CF1ECB5D}"/>
+                <a16:creationId xmlns:a16="http://schemas.microsoft.com/office/drawing/2014/main" id="{1C615C94-6AC1-46CD-A9E5-EF2861064357}"/>
               </a:ext>
             </a:extLst>
           </p:cNvPr>
@@ -9590,7 +9590,7 @@
           <p:cNvPr id="14" name="Two phones, a call to 630, then the remaining phones">
             <a:extLst xmlns:a="http://schemas.openxmlformats.org/drawingml/2006/main">
               <a:ext uri="{FF2B5EF4-FFF2-40B4-BE49-F238E27FC236}">
-                <a16:creationId xmlns:a16="http://schemas.microsoft.com/office/drawing/2014/main" id="{6DBBFD03-ED55-4BCC-B6C3-79B9D4DEB215}"/>
+                <a16:creationId xmlns:a16="http://schemas.microsoft.com/office/drawing/2014/main" id="{39EEA17B-AD1B-4B1B-ADCB-A7DD3A3483C9}"/>
               </a:ext>
             </a:extLst>
           </p:cNvPr>
@@ -9746,7 +9746,7 @@
     </p:spTree>
     <p:extLst>
       <p:ext uri="{BB962C8B-B14F-4D97-AF65-F5344CB8AC3E}">
-        <p14:creationId xmlns:p14="http://schemas.microsoft.com/office/powerpoint/2010/main" val="796105919"/>
+        <p14:creationId xmlns:p14="http://schemas.microsoft.com/office/powerpoint/2010/main" val="1642776518"/>
       </p:ext>
     </p:extLst>
   </p:cSld>
@@ -9777,7 +9777,7 @@
           <p:cNvPr id="10" name="Acceptance tests on real phones">
             <a:extLst xmlns:a="http://schemas.openxmlformats.org/drawingml/2006/main">
               <a:ext uri="{FF2B5EF4-FFF2-40B4-BE49-F238E27FC236}">
-                <a16:creationId xmlns:a16="http://schemas.microsoft.com/office/drawing/2014/main" id="{2EE78E0A-89DE-4459-AC9D-85FF820B2008}"/>
+                <a16:creationId xmlns:a16="http://schemas.microsoft.com/office/drawing/2014/main" id="{7B0B210B-BED8-4A91-AFBD-3D4826C9243C}"/>
               </a:ext>
             </a:extLst>
           </p:cNvPr>
@@ -9935,7 +9935,7 @@
           <p:cNvPr id="2" name="12">
             <a:extLst xmlns:a="http://schemas.openxmlformats.org/drawingml/2006/main">
               <a:ext uri="{FF2B5EF4-FFF2-40B4-BE49-F238E27FC236}">
-                <a16:creationId xmlns:a16="http://schemas.microsoft.com/office/drawing/2014/main" id="{1DDFD031-62B0-4A7C-8224-9156271EA10A}"/>
+                <a16:creationId xmlns:a16="http://schemas.microsoft.com/office/drawing/2014/main" id="{C93DB9C3-BC79-4984-9699-50D75248A8F0}"/>
               </a:ext>
             </a:extLst>
           </p:cNvPr>
@@ -10093,7 +10093,7 @@
           <p:cNvPr id="3" name="Telephony">
             <a:extLst xmlns:a="http://schemas.openxmlformats.org/drawingml/2006/main">
               <a:ext uri="{FF2B5EF4-FFF2-40B4-BE49-F238E27FC236}">
-                <a16:creationId xmlns:a16="http://schemas.microsoft.com/office/drawing/2014/main" id="{230406AF-666B-4986-ADDA-8511BC06EC61}"/>
+                <a16:creationId xmlns:a16="http://schemas.microsoft.com/office/drawing/2014/main" id="{B7F3E9ED-89C3-4314-818E-A9F4C1457339}"/>
               </a:ext>
             </a:extLst>
           </p:cNvPr>
@@ -10251,7 +10251,7 @@
           <p:cNvPr id="4" name="201 and 203: cross-phone audio, hold / transfer">
             <a:extLst xmlns:a="http://schemas.openxmlformats.org/drawingml/2006/main">
               <a:ext uri="{FF2B5EF4-FFF2-40B4-BE49-F238E27FC236}">
-                <a16:creationId xmlns:a16="http://schemas.microsoft.com/office/drawing/2014/main" id="{60E79FAB-9D53-46EF-B94E-20E20A9F58F5}"/>
+                <a16:creationId xmlns:a16="http://schemas.microsoft.com/office/drawing/2014/main" id="{A8FD8E7D-EBCD-4201-B662-8D17F46939EE}"/>
               </a:ext>
             </a:extLst>
           </p:cNvPr>
@@ -10409,7 +10409,7 @@
           <p:cNvPr id="5" name="Home Assistant">
             <a:extLst xmlns:a="http://schemas.openxmlformats.org/drawingml/2006/main">
               <a:ext uri="{FF2B5EF4-FFF2-40B4-BE49-F238E27FC236}">
-                <a16:creationId xmlns:a16="http://schemas.microsoft.com/office/drawing/2014/main" id="{715349AB-2350-485F-A6AF-6238DDAA623A}"/>
+                <a16:creationId xmlns:a16="http://schemas.microsoft.com/office/drawing/2014/main" id="{5AE3BE67-4500-4A08-9C0C-04ACBBFC1979}"/>
               </a:ext>
             </a:extLst>
           </p:cNvPr>
@@ -10567,7 +10567,7 @@
           <p:cNvPr id="6" name="States, Originate, Hangup on the correct Channel, DTMF">
             <a:extLst xmlns:a="http://schemas.openxmlformats.org/drawingml/2006/main">
               <a:ext uri="{FF2B5EF4-FFF2-40B4-BE49-F238E27FC236}">
-                <a16:creationId xmlns:a16="http://schemas.microsoft.com/office/drawing/2014/main" id="{06F2D24F-673D-4296-A404-FE85613E9C36}"/>
+                <a16:creationId xmlns:a16="http://schemas.microsoft.com/office/drawing/2014/main" id="{28445DA8-1464-45D6-90DB-CBFA27D71F08}"/>
               </a:ext>
             </a:extLst>
           </p:cNvPr>
@@ -10725,7 +10725,7 @@
           <p:cNvPr id="7" name="Assist 630">
             <a:extLst xmlns:a="http://schemas.openxmlformats.org/drawingml/2006/main">
               <a:ext uri="{FF2B5EF4-FFF2-40B4-BE49-F238E27FC236}">
-                <a16:creationId xmlns:a16="http://schemas.microsoft.com/office/drawing/2014/main" id="{A1B834F6-80C9-47BA-800E-A47AB5A4E3D5}"/>
+                <a16:creationId xmlns:a16="http://schemas.microsoft.com/office/drawing/2014/main" id="{D984E452-3B1C-41BD-849E-11E82B55615B}"/>
               </a:ext>
             </a:extLst>
           </p:cNvPr>
@@ -10883,7 +10883,7 @@
           <p:cNvPr id="8" name="Speech recognition, spoken reply and hangup">
             <a:extLst xmlns:a="http://schemas.openxmlformats.org/drawingml/2006/main">
               <a:ext uri="{FF2B5EF4-FFF2-40B4-BE49-F238E27FC236}">
-                <a16:creationId xmlns:a16="http://schemas.microsoft.com/office/drawing/2014/main" id="{36B9B9D0-06CD-42EE-B9D6-27AAC2F7DD9A}"/>
+                <a16:creationId xmlns:a16="http://schemas.microsoft.com/office/drawing/2014/main" id="{A5518DEA-6F26-4FF7-8D06-F4871B82FBDF}"/>
               </a:ext>
             </a:extLst>
           </p:cNvPr>
@@ -11041,7 +11041,7 @@
           <p:cNvPr id="9" name="Repeat after phone, PBX and HA restarts. Readiness does not verif">
             <a:extLst xmlns:a="http://schemas.openxmlformats.org/drawingml/2006/main">
               <a:ext uri="{FF2B5EF4-FFF2-40B4-BE49-F238E27FC236}">
-                <a16:creationId xmlns:a16="http://schemas.microsoft.com/office/drawing/2014/main" id="{C8A4BF42-8A54-4466-9290-70A937643DE5}"/>
+                <a16:creationId xmlns:a16="http://schemas.microsoft.com/office/drawing/2014/main" id="{B83BDDD4-8B38-4BB0-9575-83EB1337DDD8}"/>
               </a:ext>
             </a:extLst>
           </p:cNvPr>
@@ -11197,7 +11197,7 @@
     </p:spTree>
     <p:extLst>
       <p:ext uri="{BB962C8B-B14F-4D97-AF65-F5344CB8AC3E}">
-        <p14:creationId xmlns:p14="http://schemas.microsoft.com/office/powerpoint/2010/main" val="1865718998"/>
+        <p14:creationId xmlns:p14="http://schemas.microsoft.com/office/powerpoint/2010/main" val="587425156"/>
       </p:ext>
     </p:extLst>
   </p:cSld>
@@ -11228,7 +11228,7 @@
           <p:cNvPr id="8" name="Operations and recovery">
             <a:extLst xmlns:a="http://schemas.openxmlformats.org/drawingml/2006/main">
               <a:ext uri="{FF2B5EF4-FFF2-40B4-BE49-F238E27FC236}">
-                <a16:creationId xmlns:a16="http://schemas.microsoft.com/office/drawing/2014/main" id="{61983A07-2E5C-4E2E-9786-6A440E696334}"/>
+                <a16:creationId xmlns:a16="http://schemas.microsoft.com/office/drawing/2014/main" id="{0AC030EC-8DEB-4CE3-8FC1-8EBE6B05BB9D}"/>
               </a:ext>
             </a:extLst>
           </p:cNvPr>
@@ -11386,7 +11386,7 @@
           <p:cNvPr id="2" name="13">
             <a:extLst xmlns:a="http://schemas.openxmlformats.org/drawingml/2006/main">
               <a:ext uri="{FF2B5EF4-FFF2-40B4-BE49-F238E27FC236}">
-                <a16:creationId xmlns:a16="http://schemas.microsoft.com/office/drawing/2014/main" id="{EC34E619-93DF-42EB-9E3A-9EABF4258F52}"/>
+                <a16:creationId xmlns:a16="http://schemas.microsoft.com/office/drawing/2014/main" id="{199EBCAE-FB07-4DE6-87FD-C7B0AAD5E2FE}"/>
               </a:ext>
             </a:extLst>
           </p:cNvPr>
@@ -11544,7 +11544,7 @@
           <p:cNvPr id="3" name="Private backups outside Git">
             <a:extLst xmlns:a="http://schemas.openxmlformats.org/drawingml/2006/main">
               <a:ext uri="{FF2B5EF4-FFF2-40B4-BE49-F238E27FC236}">
-                <a16:creationId xmlns:a16="http://schemas.microsoft.com/office/drawing/2014/main" id="{0AC2F08E-B518-4C8C-B3B8-72764C2CFB47}"/>
+                <a16:creationId xmlns:a16="http://schemas.microsoft.com/office/drawing/2014/main" id="{C89A7E4F-2518-430B-98ED-893629929E51}"/>
               </a:ext>
             </a:extLst>
           </p:cNvPr>
@@ -11702,7 +11702,7 @@
           <p:cNvPr id="4" name="Inventory, SIP / AMI secrets and Asterisk data&#10;HA config / .stora">
             <a:extLst xmlns:a="http://schemas.openxmlformats.org/drawingml/2006/main">
               <a:ext uri="{FF2B5EF4-FFF2-40B4-BE49-F238E27FC236}">
-                <a16:creationId xmlns:a16="http://schemas.microsoft.com/office/drawing/2014/main" id="{BF9F9A88-9100-4139-B76E-6B5D3817A8F2}"/>
+                <a16:creationId xmlns:a16="http://schemas.microsoft.com/office/drawing/2014/main" id="{33037C33-D923-466D-AC50-976C2C5671D4}"/>
               </a:ext>
             </a:extLst>
           </p:cNvPr>
@@ -11883,7 +11883,7 @@
           <p:cNvPr id="5" name="One node is a single point of failure">
             <a:extLst xmlns:a="http://schemas.openxmlformats.org/drawingml/2006/main">
               <a:ext uri="{FF2B5EF4-FFF2-40B4-BE49-F238E27FC236}">
-                <a16:creationId xmlns:a16="http://schemas.microsoft.com/office/drawing/2014/main" id="{3793E5F8-ABBF-438A-963A-2C6C3A80BE1F}"/>
+                <a16:creationId xmlns:a16="http://schemas.microsoft.com/office/drawing/2014/main" id="{7F26D8D5-56EB-4DFD-9573-0400E457371F}"/>
               </a:ext>
             </a:extLst>
           </p:cNvPr>
@@ -12041,7 +12041,7 @@
           <p:cNvPr id="6" name="UPS for network equipment and the k3s node&#10;A recovery plan that p">
             <a:extLst xmlns:a="http://schemas.openxmlformats.org/drawingml/2006/main">
               <a:ext uri="{FF2B5EF4-FFF2-40B4-BE49-F238E27FC236}">
-                <a16:creationId xmlns:a16="http://schemas.microsoft.com/office/drawing/2014/main" id="{73C8DED1-2A6C-41DF-BB86-14BD06418759}"/>
+                <a16:creationId xmlns:a16="http://schemas.microsoft.com/office/drawing/2014/main" id="{0C9F6D44-5DAE-4037-BF65-779299E46085}"/>
               </a:ext>
             </a:extLst>
           </p:cNvPr>
@@ -12222,7 +12222,7 @@
           <p:cNvPr id="7" name="Exclude raw DTMF and connected-line data from Recorder. Review ex">
             <a:extLst xmlns:a="http://schemas.openxmlformats.org/drawingml/2006/main">
               <a:ext uri="{FF2B5EF4-FFF2-40B4-BE49-F238E27FC236}">
-                <a16:creationId xmlns:a16="http://schemas.microsoft.com/office/drawing/2014/main" id="{90455F3B-EB1B-45EA-B729-DA522351DEFE}"/>
+                <a16:creationId xmlns:a16="http://schemas.microsoft.com/office/drawing/2014/main" id="{9B776210-1008-4D12-A1A6-7DDD144802F5}"/>
               </a:ext>
             </a:extLst>
           </p:cNvPr>
@@ -12378,7 +12378,7 @@
     </p:spTree>
     <p:extLst>
       <p:ext uri="{BB962C8B-B14F-4D97-AF65-F5344CB8AC3E}">
-        <p14:creationId xmlns:p14="http://schemas.microsoft.com/office/powerpoint/2010/main" val="23234434"/>
+        <p14:creationId xmlns:p14="http://schemas.microsoft.com/office/powerpoint/2010/main" val="1234771222"/>
       </p:ext>
     </p:extLst>
   </p:cSld>
@@ -12409,7 +12409,7 @@
           <p:cNvPr id="8" name="Server readiness and phone acceptance">
             <a:extLst xmlns:a="http://schemas.openxmlformats.org/drawingml/2006/main">
               <a:ext uri="{FF2B5EF4-FFF2-40B4-BE49-F238E27FC236}">
-                <a16:creationId xmlns:a16="http://schemas.microsoft.com/office/drawing/2014/main" id="{EC4D07BC-E90F-4C2C-9D9D-78744AB720FD}"/>
+                <a16:creationId xmlns:a16="http://schemas.microsoft.com/office/drawing/2014/main" id="{1E4C3B8E-4334-4E24-B02E-F5B4954291A7}"/>
               </a:ext>
             </a:extLst>
           </p:cNvPr>
@@ -12567,7 +12567,7 @@
           <p:cNvPr id="2" name="14">
             <a:extLst xmlns:a="http://schemas.openxmlformats.org/drawingml/2006/main">
               <a:ext uri="{FF2B5EF4-FFF2-40B4-BE49-F238E27FC236}">
-                <a16:creationId xmlns:a16="http://schemas.microsoft.com/office/drawing/2014/main" id="{0440BC11-5CCC-4D68-ABF3-5A64C48D281E}"/>
+                <a16:creationId xmlns:a16="http://schemas.microsoft.com/office/drawing/2014/main" id="{08D1E2DB-4E50-4A60-8902-BED8306FDB21}"/>
               </a:ext>
             </a:extLst>
           </p:cNvPr>
@@ -12725,7 +12725,7 @@
           <p:cNvPr id="3" name="Server preparation can come first">
             <a:extLst xmlns:a="http://schemas.openxmlformats.org/drawingml/2006/main">
               <a:ext uri="{FF2B5EF4-FFF2-40B4-BE49-F238E27FC236}">
-                <a16:creationId xmlns:a16="http://schemas.microsoft.com/office/drawing/2014/main" id="{4E26929E-2BD1-473A-BA91-8130A3A9F469}"/>
+                <a16:creationId xmlns:a16="http://schemas.microsoft.com/office/drawing/2014/main" id="{46ADDE3C-8D8D-4A3E-BAAE-E5541AC2DB0F}"/>
               </a:ext>
             </a:extLst>
           </p:cNvPr>
@@ -12883,7 +12883,7 @@
           <p:cNvPr id="4" name="Images, configuration, AMI and Opus&#10;Tests verify the server compo">
             <a:extLst xmlns:a="http://schemas.openxmlformats.org/drawingml/2006/main">
               <a:ext uri="{FF2B5EF4-FFF2-40B4-BE49-F238E27FC236}">
-                <a16:creationId xmlns:a16="http://schemas.microsoft.com/office/drawing/2014/main" id="{4C62E49A-90FC-4402-801C-DF42B49955DE}"/>
+                <a16:creationId xmlns:a16="http://schemas.microsoft.com/office/drawing/2014/main" id="{BB2E98FF-08AD-48B8-8528-2234CBF5F567}"/>
               </a:ext>
             </a:extLst>
           </p:cNvPr>
@@ -13064,7 +13064,7 @@
           <p:cNvPr id="5" name="A pilot verifies the phone experience">
             <a:extLst xmlns:a="http://schemas.openxmlformats.org/drawingml/2006/main">
               <a:ext uri="{FF2B5EF4-FFF2-40B4-BE49-F238E27FC236}">
-                <a16:creationId xmlns:a16="http://schemas.microsoft.com/office/drawing/2014/main" id="{F6DC5F38-6086-4059-9B68-D30D7367EC60}"/>
+                <a16:creationId xmlns:a16="http://schemas.microsoft.com/office/drawing/2014/main" id="{79CA457D-9C3D-4ECC-AE1B-A0AE3E853C98}"/>
               </a:ext>
             </a:extLst>
           </p:cNvPr>
@@ -13222,7 +13222,7 @@
           <p:cNvPr id="6" name="Phone inventory, a two-party call and Assist&#10;Add the remaining ph">
             <a:extLst xmlns:a="http://schemas.openxmlformats.org/drawingml/2006/main">
               <a:ext uri="{FF2B5EF4-FFF2-40B4-BE49-F238E27FC236}">
-                <a16:creationId xmlns:a16="http://schemas.microsoft.com/office/drawing/2014/main" id="{AAF9A17B-9553-4E69-8B84-6505B1A52D61}"/>
+                <a16:creationId xmlns:a16="http://schemas.microsoft.com/office/drawing/2014/main" id="{F18389F7-70E7-40BF-8F09-0E738BB4D7F5}"/>
               </a:ext>
             </a:extLst>
           </p:cNvPr>
@@ -13403,7 +13403,7 @@
           <p:cNvPr id="7" name="Physical acceptance is a separate step. Keep the results in the p">
             <a:extLst xmlns:a="http://schemas.openxmlformats.org/drawingml/2006/main">
               <a:ext uri="{FF2B5EF4-FFF2-40B4-BE49-F238E27FC236}">
-                <a16:creationId xmlns:a16="http://schemas.microsoft.com/office/drawing/2014/main" id="{E9C24186-E0D5-4155-BA3F-ECF5FA78701C}"/>
+                <a16:creationId xmlns:a16="http://schemas.microsoft.com/office/drawing/2014/main" id="{4620321D-0B33-4A8F-A60B-E342BDD74F22}"/>
               </a:ext>
             </a:extLst>
           </p:cNvPr>
@@ -13559,7 +13559,7 @@
     </p:spTree>
     <p:extLst>
       <p:ext uri="{BB962C8B-B14F-4D97-AF65-F5344CB8AC3E}">
-        <p14:creationId xmlns:p14="http://schemas.microsoft.com/office/powerpoint/2010/main" val="1270079051"/>
+        <p14:creationId xmlns:p14="http://schemas.microsoft.com/office/powerpoint/2010/main" val="1132689489"/>
       </p:ext>
     </p:extLst>
   </p:cSld>
@@ -13590,7 +13590,7 @@
           <p:cNvPr id="26" name="Ten Cisco identities, twenty lines">
             <a:extLst xmlns:a="http://schemas.openxmlformats.org/drawingml/2006/main">
               <a:ext uri="{FF2B5EF4-FFF2-40B4-BE49-F238E27FC236}">
-                <a16:creationId xmlns:a16="http://schemas.microsoft.com/office/drawing/2014/main" id="{FA807565-EAE6-4E6D-9CAA-E583B1B599AF}"/>
+                <a16:creationId xmlns:a16="http://schemas.microsoft.com/office/drawing/2014/main" id="{5BB4ECCF-2C6E-4077-8008-812FB4246B55}"/>
               </a:ext>
             </a:extLst>
           </p:cNvPr>
@@ -13748,7 +13748,7 @@
           <p:cNvPr id="2" name="15">
             <a:extLst xmlns:a="http://schemas.openxmlformats.org/drawingml/2006/main">
               <a:ext uri="{FF2B5EF4-FFF2-40B4-BE49-F238E27FC236}">
-                <a16:creationId xmlns:a16="http://schemas.microsoft.com/office/drawing/2014/main" id="{2BFD7B27-BCB5-4E11-81C8-8C6E54D846FD}"/>
+                <a16:creationId xmlns:a16="http://schemas.microsoft.com/office/drawing/2014/main" id="{E5F0AB46-0010-4743-A144-013D6AFB6AC2}"/>
               </a:ext>
             </a:extLst>
           </p:cNvPr>
@@ -13906,7 +13906,7 @@
           <p:cNvPr id="3" name="PHONE 1">
             <a:extLst xmlns:a="http://schemas.openxmlformats.org/drawingml/2006/main">
               <a:ext uri="{FF2B5EF4-FFF2-40B4-BE49-F238E27FC236}">
-                <a16:creationId xmlns:a16="http://schemas.microsoft.com/office/drawing/2014/main" id="{65A4D88E-FDAB-4E19-A53A-C5715E6DF8D3}"/>
+                <a16:creationId xmlns:a16="http://schemas.microsoft.com/office/drawing/2014/main" id="{7CA74B6F-528E-4D64-A497-11729A3894D0}"/>
               </a:ext>
             </a:extLst>
           </p:cNvPr>
@@ -14064,7 +14064,7 @@
           <p:cNvPr id="4" name="201 / 202">
             <a:extLst xmlns:a="http://schemas.openxmlformats.org/drawingml/2006/main">
               <a:ext uri="{FF2B5EF4-FFF2-40B4-BE49-F238E27FC236}">
-                <a16:creationId xmlns:a16="http://schemas.microsoft.com/office/drawing/2014/main" id="{63AE5323-2B11-484E-AE45-894F4A5F4A0F}"/>
+                <a16:creationId xmlns:a16="http://schemas.microsoft.com/office/drawing/2014/main" id="{A11CC33A-8269-42E4-AC32-725C28A0E69F}"/>
               </a:ext>
             </a:extLst>
           </p:cNvPr>
@@ -14222,7 +14222,7 @@
           <p:cNvPr id="5" name="PHONE 2">
             <a:extLst xmlns:a="http://schemas.openxmlformats.org/drawingml/2006/main">
               <a:ext uri="{FF2B5EF4-FFF2-40B4-BE49-F238E27FC236}">
-                <a16:creationId xmlns:a16="http://schemas.microsoft.com/office/drawing/2014/main" id="{F3D9D387-2B18-4E5E-80B5-28459D4B3372}"/>
+                <a16:creationId xmlns:a16="http://schemas.microsoft.com/office/drawing/2014/main" id="{0EA936A1-341D-46D9-A4F9-661B817CC15A}"/>
               </a:ext>
             </a:extLst>
           </p:cNvPr>
@@ -14380,7 +14380,7 @@
           <p:cNvPr id="6" name="203 / 204">
             <a:extLst xmlns:a="http://schemas.openxmlformats.org/drawingml/2006/main">
               <a:ext uri="{FF2B5EF4-FFF2-40B4-BE49-F238E27FC236}">
-                <a16:creationId xmlns:a16="http://schemas.microsoft.com/office/drawing/2014/main" id="{7BACA42B-7490-48E0-9311-BFE59B9D0086}"/>
+                <a16:creationId xmlns:a16="http://schemas.microsoft.com/office/drawing/2014/main" id="{46CDD23B-DAD2-4BC7-BB95-F64FA89DEF41}"/>
               </a:ext>
             </a:extLst>
           </p:cNvPr>
@@ -14538,7 +14538,7 @@
           <p:cNvPr id="7" name="PHONE 3">
             <a:extLst xmlns:a="http://schemas.openxmlformats.org/drawingml/2006/main">
               <a:ext uri="{FF2B5EF4-FFF2-40B4-BE49-F238E27FC236}">
-                <a16:creationId xmlns:a16="http://schemas.microsoft.com/office/drawing/2014/main" id="{996D611C-569E-4A91-9312-03AA3C5A6A23}"/>
+                <a16:creationId xmlns:a16="http://schemas.microsoft.com/office/drawing/2014/main" id="{5E7594A2-B83B-40F4-9DE4-888AE9651910}"/>
               </a:ext>
             </a:extLst>
           </p:cNvPr>
@@ -14696,7 +14696,7 @@
           <p:cNvPr id="8" name="205 / 206">
             <a:extLst xmlns:a="http://schemas.openxmlformats.org/drawingml/2006/main">
               <a:ext uri="{FF2B5EF4-FFF2-40B4-BE49-F238E27FC236}">
-                <a16:creationId xmlns:a16="http://schemas.microsoft.com/office/drawing/2014/main" id="{1DAD76F8-9559-481F-AEEA-C87F37CB1A51}"/>
+                <a16:creationId xmlns:a16="http://schemas.microsoft.com/office/drawing/2014/main" id="{C94B378B-4159-45F7-9FB1-F07F953E50C0}"/>
               </a:ext>
             </a:extLst>
           </p:cNvPr>
@@ -14854,7 +14854,7 @@
           <p:cNvPr id="9" name="PHONE 4">
             <a:extLst xmlns:a="http://schemas.openxmlformats.org/drawingml/2006/main">
               <a:ext uri="{FF2B5EF4-FFF2-40B4-BE49-F238E27FC236}">
-                <a16:creationId xmlns:a16="http://schemas.microsoft.com/office/drawing/2014/main" id="{EA220445-A418-496B-ABAB-3E26F72985C3}"/>
+                <a16:creationId xmlns:a16="http://schemas.microsoft.com/office/drawing/2014/main" id="{FBE020A9-851E-489C-82F5-A801430C9E28}"/>
               </a:ext>
             </a:extLst>
           </p:cNvPr>
@@ -15012,7 +15012,7 @@
           <p:cNvPr id="10" name="207 / 208">
             <a:extLst xmlns:a="http://schemas.openxmlformats.org/drawingml/2006/main">
               <a:ext uri="{FF2B5EF4-FFF2-40B4-BE49-F238E27FC236}">
-                <a16:creationId xmlns:a16="http://schemas.microsoft.com/office/drawing/2014/main" id="{CDAC0B28-27FC-4BFA-AEC4-8F4DF6988F48}"/>
+                <a16:creationId xmlns:a16="http://schemas.microsoft.com/office/drawing/2014/main" id="{77C2E2C2-54F3-43C3-A131-60419C37C48A}"/>
               </a:ext>
             </a:extLst>
           </p:cNvPr>
@@ -15170,7 +15170,7 @@
           <p:cNvPr id="11" name="PHONE 5">
             <a:extLst xmlns:a="http://schemas.openxmlformats.org/drawingml/2006/main">
               <a:ext uri="{FF2B5EF4-FFF2-40B4-BE49-F238E27FC236}">
-                <a16:creationId xmlns:a16="http://schemas.microsoft.com/office/drawing/2014/main" id="{6FB2E825-CCE8-4774-9376-50C249DF59BE}"/>
+                <a16:creationId xmlns:a16="http://schemas.microsoft.com/office/drawing/2014/main" id="{54F4CB82-F5E5-48EE-A828-23CCC2F38A01}"/>
               </a:ext>
             </a:extLst>
           </p:cNvPr>
@@ -15328,7 +15328,7 @@
           <p:cNvPr id="12" name="210 / 211">
             <a:extLst xmlns:a="http://schemas.openxmlformats.org/drawingml/2006/main">
               <a:ext uri="{FF2B5EF4-FFF2-40B4-BE49-F238E27FC236}">
-                <a16:creationId xmlns:a16="http://schemas.microsoft.com/office/drawing/2014/main" id="{E87DB66B-4D26-4B8D-A513-BC74F0C03692}"/>
+                <a16:creationId xmlns:a16="http://schemas.microsoft.com/office/drawing/2014/main" id="{5530985C-3873-478A-B056-30122728F8AD}"/>
               </a:ext>
             </a:extLst>
           </p:cNvPr>
@@ -15486,7 +15486,7 @@
           <p:cNvPr id="13" name="PHONE 6">
             <a:extLst xmlns:a="http://schemas.openxmlformats.org/drawingml/2006/main">
               <a:ext uri="{FF2B5EF4-FFF2-40B4-BE49-F238E27FC236}">
-                <a16:creationId xmlns:a16="http://schemas.microsoft.com/office/drawing/2014/main" id="{C5DD0690-7EC8-4FED-9449-463C87606549}"/>
+                <a16:creationId xmlns:a16="http://schemas.microsoft.com/office/drawing/2014/main" id="{F74677E5-97E1-4ECF-A815-C5622FA593B8}"/>
               </a:ext>
             </a:extLst>
           </p:cNvPr>
@@ -15644,7 +15644,7 @@
           <p:cNvPr id="14" name="212 / 213">
             <a:extLst xmlns:a="http://schemas.openxmlformats.org/drawingml/2006/main">
               <a:ext uri="{FF2B5EF4-FFF2-40B4-BE49-F238E27FC236}">
-                <a16:creationId xmlns:a16="http://schemas.microsoft.com/office/drawing/2014/main" id="{734DE2E9-7DE5-478E-A7D6-3C5BAA7F9C3F}"/>
+                <a16:creationId xmlns:a16="http://schemas.microsoft.com/office/drawing/2014/main" id="{974C4F1D-CED9-4822-A785-03DF9EBC9F25}"/>
               </a:ext>
             </a:extLst>
           </p:cNvPr>
@@ -15802,7 +15802,7 @@
           <p:cNvPr id="15" name="PHONE 7">
             <a:extLst xmlns:a="http://schemas.openxmlformats.org/drawingml/2006/main">
               <a:ext uri="{FF2B5EF4-FFF2-40B4-BE49-F238E27FC236}">
-                <a16:creationId xmlns:a16="http://schemas.microsoft.com/office/drawing/2014/main" id="{64B46511-48E4-4EEE-B713-7A574DD32B78}"/>
+                <a16:creationId xmlns:a16="http://schemas.microsoft.com/office/drawing/2014/main" id="{6D3863DC-D02F-41AD-B7A3-627E564A1D93}"/>
               </a:ext>
             </a:extLst>
           </p:cNvPr>
@@ -15960,7 +15960,7 @@
           <p:cNvPr id="16" name="214 / 215">
             <a:extLst xmlns:a="http://schemas.openxmlformats.org/drawingml/2006/main">
               <a:ext uri="{FF2B5EF4-FFF2-40B4-BE49-F238E27FC236}">
-                <a16:creationId xmlns:a16="http://schemas.microsoft.com/office/drawing/2014/main" id="{DFC63E9B-C2FE-420A-AAC1-61BB0F8B7665}"/>
+                <a16:creationId xmlns:a16="http://schemas.microsoft.com/office/drawing/2014/main" id="{EDAA8015-B567-4CD6-8415-1DFEFB76464E}"/>
               </a:ext>
             </a:extLst>
           </p:cNvPr>
@@ -16118,7 +16118,7 @@
           <p:cNvPr id="17" name="PHONE 8">
             <a:extLst xmlns:a="http://schemas.openxmlformats.org/drawingml/2006/main">
               <a:ext uri="{FF2B5EF4-FFF2-40B4-BE49-F238E27FC236}">
-                <a16:creationId xmlns:a16="http://schemas.microsoft.com/office/drawing/2014/main" id="{65F71913-BCD4-4932-B56A-216BD061F434}"/>
+                <a16:creationId xmlns:a16="http://schemas.microsoft.com/office/drawing/2014/main" id="{E898EDA6-72D6-4CB6-9F15-896B416C595B}"/>
               </a:ext>
             </a:extLst>
           </p:cNvPr>
@@ -16276,7 +16276,7 @@
           <p:cNvPr id="18" name="216 / 217">
             <a:extLst xmlns:a="http://schemas.openxmlformats.org/drawingml/2006/main">
               <a:ext uri="{FF2B5EF4-FFF2-40B4-BE49-F238E27FC236}">
-                <a16:creationId xmlns:a16="http://schemas.microsoft.com/office/drawing/2014/main" id="{A0C78099-AB82-4778-AC49-16144EA7E394}"/>
+                <a16:creationId xmlns:a16="http://schemas.microsoft.com/office/drawing/2014/main" id="{3ACCF647-D5C2-4194-8FF0-65E4E19E43EB}"/>
               </a:ext>
             </a:extLst>
           </p:cNvPr>
@@ -16434,7 +16434,7 @@
           <p:cNvPr id="19" name="PHONE 9">
             <a:extLst xmlns:a="http://schemas.openxmlformats.org/drawingml/2006/main">
               <a:ext uri="{FF2B5EF4-FFF2-40B4-BE49-F238E27FC236}">
-                <a16:creationId xmlns:a16="http://schemas.microsoft.com/office/drawing/2014/main" id="{0FEE3330-CE01-45D5-AFCE-31A2449224EB}"/>
+                <a16:creationId xmlns:a16="http://schemas.microsoft.com/office/drawing/2014/main" id="{53AE9983-2736-4EA5-8723-AB341145598E}"/>
               </a:ext>
             </a:extLst>
           </p:cNvPr>
@@ -16592,7 +16592,7 @@
           <p:cNvPr id="20" name="218 / 219">
             <a:extLst xmlns:a="http://schemas.openxmlformats.org/drawingml/2006/main">
               <a:ext uri="{FF2B5EF4-FFF2-40B4-BE49-F238E27FC236}">
-                <a16:creationId xmlns:a16="http://schemas.microsoft.com/office/drawing/2014/main" id="{C1F80EE4-1E7A-4C33-9232-DFA3DE9CF969}"/>
+                <a16:creationId xmlns:a16="http://schemas.microsoft.com/office/drawing/2014/main" id="{79CD1D77-CF27-487F-B16A-DA8F55059BE1}"/>
               </a:ext>
             </a:extLst>
           </p:cNvPr>
@@ -16750,7 +16750,7 @@
           <p:cNvPr id="21" name="PHONE 10">
             <a:extLst xmlns:a="http://schemas.openxmlformats.org/drawingml/2006/main">
               <a:ext uri="{FF2B5EF4-FFF2-40B4-BE49-F238E27FC236}">
-                <a16:creationId xmlns:a16="http://schemas.microsoft.com/office/drawing/2014/main" id="{6D97C988-D121-4A77-97E1-492A53D6E041}"/>
+                <a16:creationId xmlns:a16="http://schemas.microsoft.com/office/drawing/2014/main" id="{D7EFE6CA-1C08-4924-9F7A-390E1F24E2B3}"/>
               </a:ext>
             </a:extLst>
           </p:cNvPr>
@@ -16908,7 +16908,7 @@
           <p:cNvPr id="22" name="220 / 221">
             <a:extLst xmlns:a="http://schemas.openxmlformats.org/drawingml/2006/main">
               <a:ext uri="{FF2B5EF4-FFF2-40B4-BE49-F238E27FC236}">
-                <a16:creationId xmlns:a16="http://schemas.microsoft.com/office/drawing/2014/main" id="{9F94D026-B3AE-4C1F-A545-5653B68E963B}"/>
+                <a16:creationId xmlns:a16="http://schemas.microsoft.com/office/drawing/2014/main" id="{76D1B84E-E131-4795-A5EF-B9C579A339EB}"/>
               </a:ext>
             </a:extLst>
           </p:cNvPr>
@@ -17066,7 +17066,7 @@
           <p:cNvPr id="23" name="620: one primary line per Cisco device">
             <a:extLst xmlns:a="http://schemas.openxmlformats.org/drawingml/2006/main">
               <a:ext uri="{FF2B5EF4-FFF2-40B4-BE49-F238E27FC236}">
-                <a16:creationId xmlns:a16="http://schemas.microsoft.com/office/drawing/2014/main" id="{8A83306E-5E00-4729-A204-307AA19B3B93}"/>
+                <a16:creationId xmlns:a16="http://schemas.microsoft.com/office/drawing/2014/main" id="{6638A719-D86F-4F33-9F9C-5F9311CE4924}"/>
               </a:ext>
             </a:extLst>
           </p:cNvPr>
@@ -17224,7 +17224,7 @@
           <p:cNvPr id="24" name="201 · 203 · 205 · 207 · 210 · 212 · 214 · 216 · 218 · 220">
             <a:extLst xmlns:a="http://schemas.openxmlformats.org/drawingml/2006/main">
               <a:ext uri="{FF2B5EF4-FFF2-40B4-BE49-F238E27FC236}">
-                <a16:creationId xmlns:a16="http://schemas.microsoft.com/office/drawing/2014/main" id="{21B0FF67-4360-4ACD-BB62-B467BD5A27C4}"/>
+                <a16:creationId xmlns:a16="http://schemas.microsoft.com/office/drawing/2014/main" id="{DF7A30E1-D1EC-414C-826A-CA11FEBB2905}"/>
               </a:ext>
             </a:extLst>
           </p:cNvPr>
@@ -17382,7 +17382,7 @@
           <p:cNvPr id="25" name="Keep each device’s identity and credentials when unplugged. Onlin">
             <a:extLst xmlns:a="http://schemas.openxmlformats.org/drawingml/2006/main">
               <a:ext uri="{FF2B5EF4-FFF2-40B4-BE49-F238E27FC236}">
-                <a16:creationId xmlns:a16="http://schemas.microsoft.com/office/drawing/2014/main" id="{439BE5F6-150F-4E9E-A44A-32CA2BD5EF1E}"/>
+                <a16:creationId xmlns:a16="http://schemas.microsoft.com/office/drawing/2014/main" id="{34F62ED1-6E62-416A-9D4A-2A18475CE85B}"/>
               </a:ext>
             </a:extLst>
           </p:cNvPr>
@@ -17538,7 +17538,7 @@
     </p:spTree>
     <p:extLst>
       <p:ext uri="{BB962C8B-B14F-4D97-AF65-F5344CB8AC3E}">
-        <p14:creationId xmlns:p14="http://schemas.microsoft.com/office/powerpoint/2010/main" val="1102724630"/>
+        <p14:creationId xmlns:p14="http://schemas.microsoft.com/office/powerpoint/2010/main" val="1487893156"/>
       </p:ext>
     </p:extLst>
   </p:cSld>
@@ -17569,7 +17569,7 @@
           <p:cNvPr id="14" name="Home Assistant phone controls">
             <a:extLst xmlns:a="http://schemas.openxmlformats.org/drawingml/2006/main">
               <a:ext uri="{FF2B5EF4-FFF2-40B4-BE49-F238E27FC236}">
-                <a16:creationId xmlns:a16="http://schemas.microsoft.com/office/drawing/2014/main" id="{40F27DFA-7B0E-4F21-8807-665A20D711F4}"/>
+                <a16:creationId xmlns:a16="http://schemas.microsoft.com/office/drawing/2014/main" id="{1A3673CD-42A2-4963-9341-BEEAD71119CA}"/>
               </a:ext>
             </a:extLst>
           </p:cNvPr>
@@ -17727,7 +17727,7 @@
           <p:cNvPr id="2" name="16">
             <a:extLst xmlns:a="http://schemas.openxmlformats.org/drawingml/2006/main">
               <a:ext uri="{FF2B5EF4-FFF2-40B4-BE49-F238E27FC236}">
-                <a16:creationId xmlns:a16="http://schemas.microsoft.com/office/drawing/2014/main" id="{C7B279E1-5DC9-4EE9-9173-53DB826A89A7}"/>
+                <a16:creationId xmlns:a16="http://schemas.microsoft.com/office/drawing/2014/main" id="{EF6D2B23-4405-499D-92A6-F642DA64588C}"/>
               </a:ext>
             </a:extLst>
           </p:cNvPr>
@@ -17885,7 +17885,7 @@
           <p:cNvPr id="3" name="290">
             <a:extLst xmlns:a="http://schemas.openxmlformats.org/drawingml/2006/main">
               <a:ext uri="{FF2B5EF4-FFF2-40B4-BE49-F238E27FC236}">
-                <a16:creationId xmlns:a16="http://schemas.microsoft.com/office/drawing/2014/main" id="{BEBEC94B-8C1C-4B24-B1A0-4183486CE6E7}"/>
+                <a16:creationId xmlns:a16="http://schemas.microsoft.com/office/drawing/2014/main" id="{4930C3D5-8B6D-4380-8D2F-ED70B510DF2D}"/>
               </a:ext>
             </a:extLst>
           </p:cNvPr>
@@ -18043,7 +18043,7 @@
           <p:cNvPr id="4" name="controls across ten phones">
             <a:extLst xmlns:a="http://schemas.openxmlformats.org/drawingml/2006/main">
               <a:ext uri="{FF2B5EF4-FFF2-40B4-BE49-F238E27FC236}">
-                <a16:creationId xmlns:a16="http://schemas.microsoft.com/office/drawing/2014/main" id="{D39E2F4D-79F2-4021-BDDB-AB4C3E3BDD98}"/>
+                <a16:creationId xmlns:a16="http://schemas.microsoft.com/office/drawing/2014/main" id="{E4FC546C-5F36-4042-8785-103ECA935AEC}"/>
               </a:ext>
             </a:extLst>
           </p:cNvPr>
@@ -18201,7 +18201,7 @@
           <p:cNvPr id="5" name="Call controls">
             <a:extLst xmlns:a="http://schemas.openxmlformats.org/drawingml/2006/main">
               <a:ext uri="{FF2B5EF4-FFF2-40B4-BE49-F238E27FC236}">
-                <a16:creationId xmlns:a16="http://schemas.microsoft.com/office/drawing/2014/main" id="{CCB6B624-843F-4B03-85A2-FE27E4436787}"/>
+                <a16:creationId xmlns:a16="http://schemas.microsoft.com/office/drawing/2014/main" id="{8A5E9300-4CD5-45A7-BE59-EB5552335638}"/>
               </a:ext>
             </a:extLst>
           </p:cNvPr>
@@ -18359,7 +18359,7 @@
           <p:cNvPr id="6" name="Line, dial, answer and exact-channel hangup">
             <a:extLst xmlns:a="http://schemas.openxmlformats.org/drawingml/2006/main">
               <a:ext uri="{FF2B5EF4-FFF2-40B4-BE49-F238E27FC236}">
-                <a16:creationId xmlns:a16="http://schemas.microsoft.com/office/drawing/2014/main" id="{DE76919C-F6D8-4300-9399-B344A8743BA6}"/>
+                <a16:creationId xmlns:a16="http://schemas.microsoft.com/office/drawing/2014/main" id="{2EC007B7-01F5-4DC2-9C70-27D16F38EECB}"/>
               </a:ext>
             </a:extLst>
           </p:cNvPr>
@@ -18517,7 +18517,7 @@
           <p:cNvPr id="7" name="Personal settings">
             <a:extLst xmlns:a="http://schemas.openxmlformats.org/drawingml/2006/main">
               <a:ext uri="{FF2B5EF4-FFF2-40B4-BE49-F238E27FC236}">
-                <a16:creationId xmlns:a16="http://schemas.microsoft.com/office/drawing/2014/main" id="{418145F6-E562-4EBB-8998-E1EE63B89680}"/>
+                <a16:creationId xmlns:a16="http://schemas.microsoft.com/office/drawing/2014/main" id="{D44A5596-B5C7-41EB-BD13-BBE76A372A8D}"/>
               </a:ext>
             </a:extLst>
           </p:cNvPr>
@@ -18675,7 +18675,7 @@
           <p:cNvPr id="8" name="PBX DND and optional normal-call auto-answer">
             <a:extLst xmlns:a="http://schemas.openxmlformats.org/drawingml/2006/main">
               <a:ext uri="{FF2B5EF4-FFF2-40B4-BE49-F238E27FC236}">
-                <a16:creationId xmlns:a16="http://schemas.microsoft.com/office/drawing/2014/main" id="{7649DC98-2FEE-4455-AB11-72C8849348B1}"/>
+                <a16:creationId xmlns:a16="http://schemas.microsoft.com/office/drawing/2014/main" id="{990DE7B4-3327-444A-AD8C-F3F7CCE7DD27}"/>
               </a:ext>
             </a:extLst>
           </p:cNvPr>
@@ -18833,7 +18833,7 @@
           <p:cNvPr id="9" name="Schedules">
             <a:extLst xmlns:a="http://schemas.openxmlformats.org/drawingml/2006/main">
               <a:ext uri="{FF2B5EF4-FFF2-40B4-BE49-F238E27FC236}">
-                <a16:creationId xmlns:a16="http://schemas.microsoft.com/office/drawing/2014/main" id="{353CB8E8-A776-4692-87F2-D4F66B2F9583}"/>
+                <a16:creationId xmlns:a16="http://schemas.microsoft.com/office/drawing/2014/main" id="{7651EC92-8DDF-4318-BD87-2A6E1DB0AF06}"/>
               </a:ext>
             </a:extLst>
           </p:cNvPr>
@@ -18991,7 +18991,7 @@
           <p:cNvPr id="10" name="Timers and weekdays with a Stop alert control">
             <a:extLst xmlns:a="http://schemas.openxmlformats.org/drawingml/2006/main">
               <a:ext uri="{FF2B5EF4-FFF2-40B4-BE49-F238E27FC236}">
-                <a16:creationId xmlns:a16="http://schemas.microsoft.com/office/drawing/2014/main" id="{811D499D-E215-4DF6-9CEA-EF73CC8E4D27}"/>
+                <a16:creationId xmlns:a16="http://schemas.microsoft.com/office/drawing/2014/main" id="{901EA246-C030-493C-B875-AFFAEDD9232F}"/>
               </a:ext>
             </a:extLst>
           </p:cNvPr>
@@ -19149,7 +19149,7 @@
           <p:cNvPr id="11" name="Phone screen">
             <a:extLst xmlns:a="http://schemas.openxmlformats.org/drawingml/2006/main">
               <a:ext uri="{FF2B5EF4-FFF2-40B4-BE49-F238E27FC236}">
-                <a16:creationId xmlns:a16="http://schemas.microsoft.com/office/drawing/2014/main" id="{24E2C84C-C62D-44A8-9C42-8E00E3A76229}"/>
+                <a16:creationId xmlns:a16="http://schemas.microsoft.com/office/drawing/2014/main" id="{A6F52BDB-2D9A-4E0E-8BD8-834B08638C55}"/>
               </a:ext>
             </a:extLst>
           </p:cNvPr>
@@ -19307,7 +19307,7 @@
           <p:cNvPr id="12" name="Authenticated text and approved images">
             <a:extLst xmlns:a="http://schemas.openxmlformats.org/drawingml/2006/main">
               <a:ext uri="{FF2B5EF4-FFF2-40B4-BE49-F238E27FC236}">
-                <a16:creationId xmlns:a16="http://schemas.microsoft.com/office/drawing/2014/main" id="{501D263D-4BE4-401A-AB42-A844F627ED3A}"/>
+                <a16:creationId xmlns:a16="http://schemas.microsoft.com/office/drawing/2014/main" id="{44E1277B-06C2-45DD-AD82-64EFDFC909BB}"/>
               </a:ext>
             </a:extLst>
           </p:cNvPr>
@@ -19465,7 +19465,7 @@
           <p:cNvPr id="13" name="Manual timer dismissal and HA Stop passed. A scheduled alarm rang">
             <a:extLst xmlns:a="http://schemas.openxmlformats.org/drawingml/2006/main">
               <a:ext uri="{FF2B5EF4-FFF2-40B4-BE49-F238E27FC236}">
-                <a16:creationId xmlns:a16="http://schemas.microsoft.com/office/drawing/2014/main" id="{32230F4C-683F-4C0D-80C1-E87C4A886C7E}"/>
+                <a16:creationId xmlns:a16="http://schemas.microsoft.com/office/drawing/2014/main" id="{7C934FA8-CAD3-4DBC-A02B-39A84D2190FB}"/>
               </a:ext>
             </a:extLst>
           </p:cNvPr>
@@ -19621,7 +19621,7 @@
     </p:spTree>
     <p:extLst>
       <p:ext uri="{BB962C8B-B14F-4D97-AF65-F5344CB8AC3E}">
-        <p14:creationId xmlns:p14="http://schemas.microsoft.com/office/powerpoint/2010/main" val="580646971"/>
+        <p14:creationId xmlns:p14="http://schemas.microsoft.com/office/powerpoint/2010/main" val="793155246"/>
       </p:ext>
     </p:extLst>
   </p:cSld>
@@ -19652,7 +19652,7 @@
           <p:cNvPr id="22" name="Radio and scheduled alerts">
             <a:extLst xmlns:a="http://schemas.openxmlformats.org/drawingml/2006/main">
               <a:ext uri="{FF2B5EF4-FFF2-40B4-BE49-F238E27FC236}">
-                <a16:creationId xmlns:a16="http://schemas.microsoft.com/office/drawing/2014/main" id="{FF6AFE0E-FD62-43D1-8FC6-52891345BAE7}"/>
+                <a16:creationId xmlns:a16="http://schemas.microsoft.com/office/drawing/2014/main" id="{09ECAE1C-480C-4DD7-A2DD-8B517EE3FA0C}"/>
               </a:ext>
             </a:extLst>
           </p:cNvPr>
@@ -19810,7 +19810,7 @@
           <p:cNvPr id="2" name="17">
             <a:extLst xmlns:a="http://schemas.openxmlformats.org/drawingml/2006/main">
               <a:ext uri="{FF2B5EF4-FFF2-40B4-BE49-F238E27FC236}">
-                <a16:creationId xmlns:a16="http://schemas.microsoft.com/office/drawing/2014/main" id="{7903173A-823D-4DCE-8995-791A15AABA06}"/>
+                <a16:creationId xmlns:a16="http://schemas.microsoft.com/office/drawing/2014/main" id="{9455C9E6-DC2D-41F1-9A80-F660462704DC}"/>
               </a:ext>
             </a:extLst>
           </p:cNvPr>
@@ -19968,7 +19968,7 @@
           <p:cNvPr id="3" name="RING">
             <a:extLst xmlns:a="http://schemas.openxmlformats.org/drawingml/2006/main">
               <a:ext uri="{FF2B5EF4-FFF2-40B4-BE49-F238E27FC236}">
-                <a16:creationId xmlns:a16="http://schemas.microsoft.com/office/drawing/2014/main" id="{F57CA1BC-1EBF-46C6-82EA-3596C33C0392}"/>
+                <a16:creationId xmlns:a16="http://schemas.microsoft.com/office/drawing/2014/main" id="{7D71BBFE-E306-43D7-9117-3A2DCE725E8D}"/>
               </a:ext>
             </a:extLst>
           </p:cNvPr>
@@ -20126,7 +20126,7 @@
           <p:cNvPr id="4" name="Until you stop it">
             <a:extLst xmlns:a="http://schemas.openxmlformats.org/drawingml/2006/main">
               <a:ext uri="{FF2B5EF4-FFF2-40B4-BE49-F238E27FC236}">
-                <a16:creationId xmlns:a16="http://schemas.microsoft.com/office/drawing/2014/main" id="{3AB3C5C8-F9A0-441C-BD72-A9D56A841384}"/>
+                <a16:creationId xmlns:a16="http://schemas.microsoft.com/office/drawing/2014/main" id="{73047626-D6BE-444A-997E-EDA6347A1BF5}"/>
               </a:ext>
             </a:extLst>
           </p:cNvPr>
@@ -20284,7 +20284,7 @@
           <p:cNvPr id="5" name="Answer / reject&#10;or press Stop alert">
             <a:extLst xmlns:a="http://schemas.openxmlformats.org/drawingml/2006/main">
               <a:ext uri="{FF2B5EF4-FFF2-40B4-BE49-F238E27FC236}">
-                <a16:creationId xmlns:a16="http://schemas.microsoft.com/office/drawing/2014/main" id="{689D8CFA-2344-4040-B0A1-AC32597473BE}"/>
+                <a16:creationId xmlns:a16="http://schemas.microsoft.com/office/drawing/2014/main" id="{11732E58-998E-45CD-A9A4-93E1A1924695}"/>
               </a:ext>
             </a:extLst>
           </p:cNvPr>
@@ -20465,7 +20465,7 @@
           <p:cNvPr id="6" name="No auto-answer&#10;No after-answer audio">
             <a:extLst xmlns:a="http://schemas.openxmlformats.org/drawingml/2006/main">
               <a:ext uri="{FF2B5EF4-FFF2-40B4-BE49-F238E27FC236}">
-                <a16:creationId xmlns:a16="http://schemas.microsoft.com/office/drawing/2014/main" id="{7C73A448-8988-4C03-A7A8-3D3591930726}"/>
+                <a16:creationId xmlns:a16="http://schemas.microsoft.com/office/drawing/2014/main" id="{38157446-4798-467A-84EC-C8191E2232E8}"/>
               </a:ext>
             </a:extLst>
           </p:cNvPr>
@@ -20646,7 +20646,7 @@
           <p:cNvPr id="7" name="701">
             <a:extLst xmlns:a="http://schemas.openxmlformats.org/drawingml/2006/main">
               <a:ext uri="{FF2B5EF4-FFF2-40B4-BE49-F238E27FC236}">
-                <a16:creationId xmlns:a16="http://schemas.microsoft.com/office/drawing/2014/main" id="{A1830092-299E-4F75-98F1-3400C3083F25}"/>
+                <a16:creationId xmlns:a16="http://schemas.microsoft.com/office/drawing/2014/main" id="{811E6D17-9BFB-43FB-8905-1AD85A2AC6B8}"/>
               </a:ext>
             </a:extLst>
           </p:cNvPr>
@@ -20804,7 +20804,7 @@
           <p:cNvPr id="8" name="Matryoshka Radio">
             <a:extLst xmlns:a="http://schemas.openxmlformats.org/drawingml/2006/main">
               <a:ext uri="{FF2B5EF4-FFF2-40B4-BE49-F238E27FC236}">
-                <a16:creationId xmlns:a16="http://schemas.microsoft.com/office/drawing/2014/main" id="{C2106D29-7D0F-41DA-94E2-3685AD322152}"/>
+                <a16:creationId xmlns:a16="http://schemas.microsoft.com/office/drawing/2014/main" id="{719C81B0-DA92-493C-B500-4AA87A392B06}"/>
               </a:ext>
             </a:extLst>
           </p:cNvPr>
@@ -20962,7 +20962,7 @@
           <p:cNvPr id="9" name="702">
             <a:extLst xmlns:a="http://schemas.openxmlformats.org/drawingml/2006/main">
               <a:ext uri="{FF2B5EF4-FFF2-40B4-BE49-F238E27FC236}">
-                <a16:creationId xmlns:a16="http://schemas.microsoft.com/office/drawing/2014/main" id="{5879A2CC-A06A-4A98-87F7-DDC2D011F4EC}"/>
+                <a16:creationId xmlns:a16="http://schemas.microsoft.com/office/drawing/2014/main" id="{BA13D973-EB38-475B-9734-999977744FB2}"/>
               </a:ext>
             </a:extLst>
           </p:cNvPr>
@@ -21120,7 +21120,7 @@
           <p:cNvPr id="10" name="Echo online">
             <a:extLst xmlns:a="http://schemas.openxmlformats.org/drawingml/2006/main">
               <a:ext uri="{FF2B5EF4-FFF2-40B4-BE49-F238E27FC236}">
-                <a16:creationId xmlns:a16="http://schemas.microsoft.com/office/drawing/2014/main" id="{3B2D170D-883A-473F-8ECB-B7EBC60851AD}"/>
+                <a16:creationId xmlns:a16="http://schemas.microsoft.com/office/drawing/2014/main" id="{F378653F-ECD2-41E4-8335-D37EC9C8D856}"/>
               </a:ext>
             </a:extLst>
           </p:cNvPr>
@@ -21278,7 +21278,7 @@
           <p:cNvPr id="11" name="703">
             <a:extLst xmlns:a="http://schemas.openxmlformats.org/drawingml/2006/main">
               <a:ext uri="{FF2B5EF4-FFF2-40B4-BE49-F238E27FC236}">
-                <a16:creationId xmlns:a16="http://schemas.microsoft.com/office/drawing/2014/main" id="{3987D1FA-7DF1-43FE-BBBC-8C6FAFCCA439}"/>
+                <a16:creationId xmlns:a16="http://schemas.microsoft.com/office/drawing/2014/main" id="{81676892-4DFD-4776-B274-51DAD5FA6A01}"/>
               </a:ext>
             </a:extLst>
           </p:cNvPr>
@@ -21436,7 +21436,7 @@
           <p:cNvPr id="12" name="RADIO BOB! Rock">
             <a:extLst xmlns:a="http://schemas.openxmlformats.org/drawingml/2006/main">
               <a:ext uri="{FF2B5EF4-FFF2-40B4-BE49-F238E27FC236}">
-                <a16:creationId xmlns:a16="http://schemas.microsoft.com/office/drawing/2014/main" id="{516A8BD0-6F53-4569-AE22-B069B50DDBE3}"/>
+                <a16:creationId xmlns:a16="http://schemas.microsoft.com/office/drawing/2014/main" id="{7CCB9A09-085C-46C6-91D5-24B991A234CA}"/>
               </a:ext>
             </a:extLst>
           </p:cNvPr>
@@ -21594,7 +21594,7 @@
           <p:cNvPr id="13" name="704">
             <a:extLst xmlns:a="http://schemas.openxmlformats.org/drawingml/2006/main">
               <a:ext uri="{FF2B5EF4-FFF2-40B4-BE49-F238E27FC236}">
-                <a16:creationId xmlns:a16="http://schemas.microsoft.com/office/drawing/2014/main" id="{7CB2CA66-0810-4299-914A-B3DA83E7E41D}"/>
+                <a16:creationId xmlns:a16="http://schemas.microsoft.com/office/drawing/2014/main" id="{B6995497-03AA-4813-81E0-79F21A86816F}"/>
               </a:ext>
             </a:extLst>
           </p:cNvPr>
@@ -21752,7 +21752,7 @@
           <p:cNvPr id="14" name="RADIO BOB! Metal">
             <a:extLst xmlns:a="http://schemas.openxmlformats.org/drawingml/2006/main">
               <a:ext uri="{FF2B5EF4-FFF2-40B4-BE49-F238E27FC236}">
-                <a16:creationId xmlns:a16="http://schemas.microsoft.com/office/drawing/2014/main" id="{3F6E2328-35D5-434F-9597-9DA366A991CC}"/>
+                <a16:creationId xmlns:a16="http://schemas.microsoft.com/office/drawing/2014/main" id="{328924B0-249A-41FC-8C03-F369ADDB4792}"/>
               </a:ext>
             </a:extLst>
           </p:cNvPr>
@@ -21910,7 +21910,7 @@
           <p:cNvPr id="15" name="705">
             <a:extLst xmlns:a="http://schemas.openxmlformats.org/drawingml/2006/main">
               <a:ext uri="{FF2B5EF4-FFF2-40B4-BE49-F238E27FC236}">
-                <a16:creationId xmlns:a16="http://schemas.microsoft.com/office/drawing/2014/main" id="{6FA3452F-F7AD-4F9D-971A-1E6B18267819}"/>
+                <a16:creationId xmlns:a16="http://schemas.microsoft.com/office/drawing/2014/main" id="{D08B25FD-963E-4297-81F8-3A5A7D988783}"/>
               </a:ext>
             </a:extLst>
           </p:cNvPr>
@@ -22068,7 +22068,7 @@
           <p:cNvPr id="16" name="RADIO BOB! Gothic">
             <a:extLst xmlns:a="http://schemas.openxmlformats.org/drawingml/2006/main">
               <a:ext uri="{FF2B5EF4-FFF2-40B4-BE49-F238E27FC236}">
-                <a16:creationId xmlns:a16="http://schemas.microsoft.com/office/drawing/2014/main" id="{BA940802-9D5F-4306-9B48-4C6682398FC2}"/>
+                <a16:creationId xmlns:a16="http://schemas.microsoft.com/office/drawing/2014/main" id="{DF096786-1027-405A-AAC0-20AFCE9C2E62}"/>
               </a:ext>
             </a:extLst>
           </p:cNvPr>
@@ -22226,7 +22226,7 @@
           <p:cNvPr id="17" name="706">
             <a:extLst xmlns:a="http://schemas.openxmlformats.org/drawingml/2006/main">
               <a:ext uri="{FF2B5EF4-FFF2-40B4-BE49-F238E27FC236}">
-                <a16:creationId xmlns:a16="http://schemas.microsoft.com/office/drawing/2014/main" id="{58B81A2B-560A-4A32-B46C-85E4BE93348A}"/>
+                <a16:creationId xmlns:a16="http://schemas.microsoft.com/office/drawing/2014/main" id="{550EE60B-F2F2-4206-B4BC-AAE63377C684}"/>
               </a:ext>
             </a:extLst>
           </p:cNvPr>
@@ -22384,7 +22384,7 @@
           <p:cNvPr id="18" name="SomaFM PopTron">
             <a:extLst xmlns:a="http://schemas.openxmlformats.org/drawingml/2006/main">
               <a:ext uri="{FF2B5EF4-FFF2-40B4-BE49-F238E27FC236}">
-                <a16:creationId xmlns:a16="http://schemas.microsoft.com/office/drawing/2014/main" id="{98E3D311-5CF9-47DB-B428-94984F7CFEC8}"/>
+                <a16:creationId xmlns:a16="http://schemas.microsoft.com/office/drawing/2014/main" id="{C158BA92-C076-4B1C-941C-DBC36826D5E2}"/>
               </a:ext>
             </a:extLst>
           </p:cNvPr>
@@ -22542,7 +22542,7 @@
           <p:cNvPr id="19" name="707">
             <a:extLst xmlns:a="http://schemas.openxmlformats.org/drawingml/2006/main">
               <a:ext uri="{FF2B5EF4-FFF2-40B4-BE49-F238E27FC236}">
-                <a16:creationId xmlns:a16="http://schemas.microsoft.com/office/drawing/2014/main" id="{C7BB58F4-F9F9-4FFF-BA3A-A647B140FC34}"/>
+                <a16:creationId xmlns:a16="http://schemas.microsoft.com/office/drawing/2014/main" id="{B8DBE793-92FF-4680-98C3-0148FD13B2AE}"/>
               </a:ext>
             </a:extLst>
           </p:cNvPr>
@@ -22700,7 +22700,7 @@
           <p:cNvPr id="20" name="Radyo Viva / Turkish">
             <a:extLst xmlns:a="http://schemas.openxmlformats.org/drawingml/2006/main">
               <a:ext uri="{FF2B5EF4-FFF2-40B4-BE49-F238E27FC236}">
-                <a16:creationId xmlns:a16="http://schemas.microsoft.com/office/drawing/2014/main" id="{BA7ED548-1923-46AC-8D77-EA47AF768DC8}"/>
+                <a16:creationId xmlns:a16="http://schemas.microsoft.com/office/drawing/2014/main" id="{879937EB-3316-48E2-9413-F7803963FD31}"/>
               </a:ext>
             </a:extLst>
           </p:cNvPr>
@@ -22858,7 +22858,7 @@
           <p:cNvPr id="21" name="For 708–710: handset down, speaker off, enter all digits, then pr">
             <a:extLst xmlns:a="http://schemas.openxmlformats.org/drawingml/2006/main">
               <a:ext uri="{FF2B5EF4-FFF2-40B4-BE49-F238E27FC236}">
-                <a16:creationId xmlns:a16="http://schemas.microsoft.com/office/drawing/2014/main" id="{E792BC59-7E9E-4A95-91B6-CBA0B03262C4}"/>
+                <a16:creationId xmlns:a16="http://schemas.microsoft.com/office/drawing/2014/main" id="{2017C009-91B2-4E55-BDDC-FD88FB244D89}"/>
               </a:ext>
             </a:extLst>
           </p:cNvPr>
@@ -23014,7 +23014,7 @@
     </p:spTree>
     <p:extLst>
       <p:ext uri="{BB962C8B-B14F-4D97-AF65-F5344CB8AC3E}">
-        <p14:creationId xmlns:p14="http://schemas.microsoft.com/office/powerpoint/2010/main" val="441315074"/>
+        <p14:creationId xmlns:p14="http://schemas.microsoft.com/office/powerpoint/2010/main" val="2011674757"/>
       </p:ext>
     </p:extLst>
   </p:cSld>
@@ -23045,7 +23045,7 @@
           <p:cNvPr id="14" name="Free SIP account status">
             <a:extLst xmlns:a="http://schemas.openxmlformats.org/drawingml/2006/main">
               <a:ext uri="{FF2B5EF4-FFF2-40B4-BE49-F238E27FC236}">
-                <a16:creationId xmlns:a16="http://schemas.microsoft.com/office/drawing/2014/main" id="{F904BC32-9772-4C32-BAB0-9F05FE1DFA35}"/>
+                <a16:creationId xmlns:a16="http://schemas.microsoft.com/office/drawing/2014/main" id="{EC36BE38-2DE1-42E9-AEA7-D2E66755A6EA}"/>
               </a:ext>
             </a:extLst>
           </p:cNvPr>
@@ -23203,7 +23203,7 @@
           <p:cNvPr id="2" name="18">
             <a:extLst xmlns:a="http://schemas.openxmlformats.org/drawingml/2006/main">
               <a:ext uri="{FF2B5EF4-FFF2-40B4-BE49-F238E27FC236}">
-                <a16:creationId xmlns:a16="http://schemas.microsoft.com/office/drawing/2014/main" id="{31E4F00E-E3A2-4123-8250-943D440E0F82}"/>
+                <a16:creationId xmlns:a16="http://schemas.microsoft.com/office/drawing/2014/main" id="{6F57057D-A734-4050-BA34-F62FB2EC7C0B}"/>
               </a:ext>
             </a:extLst>
           </p:cNvPr>
@@ -23361,7 +23361,7 @@
           <p:cNvPr id="3" name="SIP2SIP">
             <a:extLst xmlns:a="http://schemas.openxmlformats.org/drawingml/2006/main">
               <a:ext uri="{FF2B5EF4-FFF2-40B4-BE49-F238E27FC236}">
-                <a16:creationId xmlns:a16="http://schemas.microsoft.com/office/drawing/2014/main" id="{36194E7D-C466-4DA1-80F2-49DDB1379029}"/>
+                <a16:creationId xmlns:a16="http://schemas.microsoft.com/office/drawing/2014/main" id="{2A89D0C6-8696-48F6-860B-95998C4B0EA7}"/>
               </a:ext>
             </a:extLst>
           </p:cNvPr>
@@ -23519,7 +23519,7 @@
           <p:cNvPr id="4" name="Echo answered, RTP loss observed">
             <a:extLst xmlns:a="http://schemas.openxmlformats.org/drawingml/2006/main">
               <a:ext uri="{FF2B5EF4-FFF2-40B4-BE49-F238E27FC236}">
-                <a16:creationId xmlns:a16="http://schemas.microsoft.com/office/drawing/2014/main" id="{D2D2114A-8E1B-454F-84E2-4A21DA5A96A7}"/>
+                <a16:creationId xmlns:a16="http://schemas.microsoft.com/office/drawing/2014/main" id="{6072E77A-14DB-4E98-B594-34C97A1BF8C9}"/>
               </a:ext>
             </a:extLst>
           </p:cNvPr>
@@ -23677,7 +23677,7 @@
           <p:cNvPr id="5" name="Callcentric">
             <a:extLst xmlns:a="http://schemas.openxmlformats.org/drawingml/2006/main">
               <a:ext uri="{FF2B5EF4-FFF2-40B4-BE49-F238E27FC236}">
-                <a16:creationId xmlns:a16="http://schemas.microsoft.com/office/drawing/2014/main" id="{12E6F7D4-644C-42A6-9E6F-850487BC5673}"/>
+                <a16:creationId xmlns:a16="http://schemas.microsoft.com/office/drawing/2014/main" id="{E2088791-52CB-4738-9FD5-DC700D9B305C}"/>
               </a:ext>
             </a:extLst>
           </p:cNvPr>
@@ -23835,7 +23835,7 @@
           <p:cNvPr id="6" name="Registered, outbound review required">
             <a:extLst xmlns:a="http://schemas.openxmlformats.org/drawingml/2006/main">
               <a:ext uri="{FF2B5EF4-FFF2-40B4-BE49-F238E27FC236}">
-                <a16:creationId xmlns:a16="http://schemas.microsoft.com/office/drawing/2014/main" id="{29E717F3-AA64-4CED-90CA-250057247831}"/>
+                <a16:creationId xmlns:a16="http://schemas.microsoft.com/office/drawing/2014/main" id="{91BBE654-6FA8-4CAD-A892-612F199FB136}"/>
               </a:ext>
             </a:extLst>
           </p:cNvPr>
@@ -23993,7 +23993,7 @@
           <p:cNvPr id="7" name="Linphone SIP">
             <a:extLst xmlns:a="http://schemas.openxmlformats.org/drawingml/2006/main">
               <a:ext uri="{FF2B5EF4-FFF2-40B4-BE49-F238E27FC236}">
-                <a16:creationId xmlns:a16="http://schemas.microsoft.com/office/drawing/2014/main" id="{A476CC3A-3F03-40B3-BE95-47726D46962F}"/>
+                <a16:creationId xmlns:a16="http://schemas.microsoft.com/office/drawing/2014/main" id="{EE67323A-08F0-49AE-9606-5672EB419819}"/>
               </a:ext>
             </a:extLst>
           </p:cNvPr>
@@ -24148,10 +24148,10 @@
       </p:sp>
       <p:sp>
         <p:nvSpPr>
-          <p:cNvPr id="8" name="Registered, verified peer still needed">
+          <p:cNvPr id="8" name="803 answered, two-way RTP observed">
             <a:extLst xmlns:a="http://schemas.openxmlformats.org/drawingml/2006/main">
               <a:ext uri="{FF2B5EF4-FFF2-40B4-BE49-F238E27FC236}">
-                <a16:creationId xmlns:a16="http://schemas.microsoft.com/office/drawing/2014/main" id="{E2FC7E5D-7B51-43AA-9626-8B934FD01ABE}"/>
+                <a16:creationId xmlns:a16="http://schemas.microsoft.com/office/drawing/2014/main" id="{40B23534-F2D4-4F35-90F7-AF4A0187FCF3}"/>
               </a:ext>
             </a:extLst>
           </p:cNvPr>
@@ -24299,7 +24299,7 @@
                 <a:ea typeface="Arial"/>
                 <a:cs typeface="Arial"/>
               </a:rPr>
-              <a:t>Registered, verified peer still needed</a:t>
+              <a:t>803 answered, two-way RTP observed</a:t>
             </a:r>
           </a:p>
         </p:txBody>
@@ -24309,7 +24309,7 @@
           <p:cNvPr id="9" name="FWD">
             <a:extLst xmlns:a="http://schemas.openxmlformats.org/drawingml/2006/main">
               <a:ext uri="{FF2B5EF4-FFF2-40B4-BE49-F238E27FC236}">
-                <a16:creationId xmlns:a16="http://schemas.microsoft.com/office/drawing/2014/main" id="{0C76474C-D5AA-4850-B4E5-7333ABA36FE6}"/>
+                <a16:creationId xmlns:a16="http://schemas.microsoft.com/office/drawing/2014/main" id="{5728C391-F57F-4B86-8CC1-888678CA1898}"/>
               </a:ext>
             </a:extLst>
           </p:cNvPr>
@@ -24467,7 +24467,7 @@
           <p:cNvPr id="10" name="Stopped at mandatory Verification Fee">
             <a:extLst xmlns:a="http://schemas.openxmlformats.org/drawingml/2006/main">
               <a:ext uri="{FF2B5EF4-FFF2-40B4-BE49-F238E27FC236}">
-                <a16:creationId xmlns:a16="http://schemas.microsoft.com/office/drawing/2014/main" id="{760A4083-D174-4454-AA8A-1D16AEB04583}"/>
+                <a16:creationId xmlns:a16="http://schemas.microsoft.com/office/drawing/2014/main" id="{E21BDE49-FC89-4809-B654-46C5F447051F}"/>
               </a:ext>
             </a:extLst>
           </p:cNvPr>
@@ -24625,7 +24625,7 @@
           <p:cNvPr id="11" name="Google Voice">
             <a:extLst xmlns:a="http://schemas.openxmlformats.org/drawingml/2006/main">
               <a:ext uri="{FF2B5EF4-FFF2-40B4-BE49-F238E27FC236}">
-                <a16:creationId xmlns:a16="http://schemas.microsoft.com/office/drawing/2014/main" id="{F6A284D4-058A-4CC4-940D-68DA52877EBB}"/>
+                <a16:creationId xmlns:a16="http://schemas.microsoft.com/office/drawing/2014/main" id="{4A0DCF52-4A1B-4976-B34F-A5E89C28E625}"/>
               </a:ext>
             </a:extLst>
           </p:cNvPr>
@@ -24783,7 +24783,7 @@
           <p:cNvPr id="12" name="No official free Asterisk SIP trunk">
             <a:extLst xmlns:a="http://schemas.openxmlformats.org/drawingml/2006/main">
               <a:ext uri="{FF2B5EF4-FFF2-40B4-BE49-F238E27FC236}">
-                <a16:creationId xmlns:a16="http://schemas.microsoft.com/office/drawing/2014/main" id="{D32E82E9-12BA-4E3B-858A-FEC7DE6804BF}"/>
+                <a16:creationId xmlns:a16="http://schemas.microsoft.com/office/drawing/2014/main" id="{A18BDCCC-9670-44F9-A4B3-8DB2FCA61AC0}"/>
               </a:ext>
             </a:extLst>
           </p:cNvPr>
@@ -24938,10 +24938,10 @@
       </p:sp>
       <p:sp>
         <p:nvSpPr>
-          <p:cNvPr id="13" name="Three providers registered. External media quality still needs ve">
+          <p:cNvPr id="13" name="Answered calls and RTP verified. Human listening and DTMF menu te">
             <a:extLst xmlns:a="http://schemas.openxmlformats.org/drawingml/2006/main">
               <a:ext uri="{FF2B5EF4-FFF2-40B4-BE49-F238E27FC236}">
-                <a16:creationId xmlns:a16="http://schemas.microsoft.com/office/drawing/2014/main" id="{C3DE8324-CF09-4380-83BF-05351AB87457}"/>
+                <a16:creationId xmlns:a16="http://schemas.microsoft.com/office/drawing/2014/main" id="{57C9345D-44D6-4C1E-BD29-C0298BA2614F}"/>
               </a:ext>
             </a:extLst>
           </p:cNvPr>
@@ -25089,7 +25089,7 @@
                 <a:ea typeface="Arial"/>
                 <a:cs typeface="Arial"/>
               </a:rPr>
-              <a:t>Three providers registered. External media quality still needs verification.</a:t>
+              <a:t>Answered calls and RTP verified. Human listening and DTMF menu tests remain pending.</a:t>
             </a:r>
           </a:p>
         </p:txBody>
@@ -25097,7 +25097,7 @@
     </p:spTree>
     <p:extLst>
       <p:ext uri="{BB962C8B-B14F-4D97-AF65-F5344CB8AC3E}">
-        <p14:creationId xmlns:p14="http://schemas.microsoft.com/office/powerpoint/2010/main" val="659624510"/>
+        <p14:creationId xmlns:p14="http://schemas.microsoft.com/office/powerpoint/2010/main" val="1721707131"/>
       </p:ext>
     </p:extLst>
   </p:cSld>
@@ -25128,7 +25128,7 @@
           <p:cNvPr id="14" name="Mac calling and children’s radio">
             <a:extLst xmlns:a="http://schemas.openxmlformats.org/drawingml/2006/main">
               <a:ext uri="{FF2B5EF4-FFF2-40B4-BE49-F238E27FC236}">
-                <a16:creationId xmlns:a16="http://schemas.microsoft.com/office/drawing/2014/main" id="{C63F208E-810D-48CA-A696-434A4AB9497A}"/>
+                <a16:creationId xmlns:a16="http://schemas.microsoft.com/office/drawing/2014/main" id="{E464D958-FD74-455E-B279-0BD169F63DD5}"/>
               </a:ext>
             </a:extLst>
           </p:cNvPr>
@@ -25286,7 +25286,7 @@
           <p:cNvPr id="2" name="19">
             <a:extLst xmlns:a="http://schemas.openxmlformats.org/drawingml/2006/main">
               <a:ext uri="{FF2B5EF4-FFF2-40B4-BE49-F238E27FC236}">
-                <a16:creationId xmlns:a16="http://schemas.microsoft.com/office/drawing/2014/main" id="{508D7607-FC81-433F-983A-C5000389C567}"/>
+                <a16:creationId xmlns:a16="http://schemas.microsoft.com/office/drawing/2014/main" id="{D0B6E547-806B-4CD1-8249-04A870734D99}"/>
               </a:ext>
             </a:extLst>
           </p:cNvPr>
@@ -25444,7 +25444,7 @@
           <p:cNvPr id="3" name="209">
             <a:extLst xmlns:a="http://schemas.openxmlformats.org/drawingml/2006/main">
               <a:ext uri="{FF2B5EF4-FFF2-40B4-BE49-F238E27FC236}">
-                <a16:creationId xmlns:a16="http://schemas.microsoft.com/office/drawing/2014/main" id="{6F3FFD38-CF14-4526-9A44-78E340966066}"/>
+                <a16:creationId xmlns:a16="http://schemas.microsoft.com/office/drawing/2014/main" id="{80100A12-D796-422D-83AA-D1F3A6475CC3}"/>
               </a:ext>
             </a:extLst>
           </p:cNvPr>
@@ -25599,10 +25599,10 @@
       </p:sp>
       <p:sp>
         <p:nvSpPr>
-          <p:cNvPr id="4" name="Mac SIP client · 209">
+          <p:cNvPr id="4" name="Zoiper5 · Mac 209">
             <a:extLst xmlns:a="http://schemas.openxmlformats.org/drawingml/2006/main">
               <a:ext uri="{FF2B5EF4-FFF2-40B4-BE49-F238E27FC236}">
-                <a16:creationId xmlns:a16="http://schemas.microsoft.com/office/drawing/2014/main" id="{FB9F9631-463D-440C-BE3E-E39B700B567E}"/>
+                <a16:creationId xmlns:a16="http://schemas.microsoft.com/office/drawing/2014/main" id="{828FCEDC-EA65-45CD-A2CA-E606ACBE1D78}"/>
               </a:ext>
             </a:extLst>
           </p:cNvPr>
@@ -25750,7 +25750,7 @@
                 <a:ea typeface="Arial"/>
                 <a:cs typeface="Arial"/>
               </a:rPr>
-              <a:t>Mac SIP client · 209</a:t>
+              <a:t>Zoiper5 · Mac 209</a:t>
             </a:r>
           </a:p>
         </p:txBody>
@@ -25760,7 +25760,7 @@
           <p:cNvPr id="5" name="Own SIP identity&#10;Internal calls and services&#10;Excluded from ring g">
             <a:extLst xmlns:a="http://schemas.openxmlformats.org/drawingml/2006/main">
               <a:ext uri="{FF2B5EF4-FFF2-40B4-BE49-F238E27FC236}">
-                <a16:creationId xmlns:a16="http://schemas.microsoft.com/office/drawing/2014/main" id="{6D43C98B-AD87-43CB-93B7-65EF2CE0BA70}"/>
+                <a16:creationId xmlns:a16="http://schemas.microsoft.com/office/drawing/2014/main" id="{27A6F9B2-F9B4-4CE1-85BD-581A2B3162BD}"/>
               </a:ext>
             </a:extLst>
           </p:cNvPr>
@@ -25964,7 +25964,7 @@
           <p:cNvPr id="6" name="708">
             <a:extLst xmlns:a="http://schemas.openxmlformats.org/drawingml/2006/main">
               <a:ext uri="{FF2B5EF4-FFF2-40B4-BE49-F238E27FC236}">
-                <a16:creationId xmlns:a16="http://schemas.microsoft.com/office/drawing/2014/main" id="{6F804300-9B92-46C9-8F81-1893CBA07BED}"/>
+                <a16:creationId xmlns:a16="http://schemas.microsoft.com/office/drawing/2014/main" id="{AA163A3F-79B4-4B09-8693-4B0FF61DC58B}"/>
               </a:ext>
             </a:extLst>
           </p:cNvPr>
@@ -26122,7 +26122,7 @@
           <p:cNvPr id="7" name="Toddler music">
             <a:extLst xmlns:a="http://schemas.openxmlformats.org/drawingml/2006/main">
               <a:ext uri="{FF2B5EF4-FFF2-40B4-BE49-F238E27FC236}">
-                <a16:creationId xmlns:a16="http://schemas.microsoft.com/office/drawing/2014/main" id="{1148DD89-333D-44DE-95DC-488EEF79F129}"/>
+                <a16:creationId xmlns:a16="http://schemas.microsoft.com/office/drawing/2014/main" id="{A7130485-8E03-4088-8A6D-D6E73632D6EF}"/>
               </a:ext>
             </a:extLst>
           </p:cNvPr>
@@ -26280,7 +26280,7 @@
           <p:cNvPr id="8" name="709">
             <a:extLst xmlns:a="http://schemas.openxmlformats.org/drawingml/2006/main">
               <a:ext uri="{FF2B5EF4-FFF2-40B4-BE49-F238E27FC236}">
-                <a16:creationId xmlns:a16="http://schemas.microsoft.com/office/drawing/2014/main" id="{4BA5CD88-F87C-4C3B-A503-1485434D7A2C}"/>
+                <a16:creationId xmlns:a16="http://schemas.microsoft.com/office/drawing/2014/main" id="{B060FD1F-2AEC-4788-B1D1-8D4180F55EA6}"/>
               </a:ext>
             </a:extLst>
           </p:cNvPr>
@@ -26438,7 +26438,7 @@
           <p:cNvPr id="9" name="Lullabies">
             <a:extLst xmlns:a="http://schemas.openxmlformats.org/drawingml/2006/main">
               <a:ext uri="{FF2B5EF4-FFF2-40B4-BE49-F238E27FC236}">
-                <a16:creationId xmlns:a16="http://schemas.microsoft.com/office/drawing/2014/main" id="{C32D4E51-189D-4601-A7C2-F8177C79E08E}"/>
+                <a16:creationId xmlns:a16="http://schemas.microsoft.com/office/drawing/2014/main" id="{C418A6C3-CA76-4267-913D-31B85A495448}"/>
               </a:ext>
             </a:extLst>
           </p:cNvPr>
@@ -26596,7 +26596,7 @@
           <p:cNvPr id="10" name="710">
             <a:extLst xmlns:a="http://schemas.openxmlformats.org/drawingml/2006/main">
               <a:ext uri="{FF2B5EF4-FFF2-40B4-BE49-F238E27FC236}">
-                <a16:creationId xmlns:a16="http://schemas.microsoft.com/office/drawing/2014/main" id="{8912D8B8-143F-4AA3-9B1A-564ABCAE8033}"/>
+                <a16:creationId xmlns:a16="http://schemas.microsoft.com/office/drawing/2014/main" id="{3CB46B8E-97C0-4CDC-AEE1-587DBA09711B}"/>
               </a:ext>
             </a:extLst>
           </p:cNvPr>
@@ -26754,7 +26754,7 @@
           <p:cNvPr id="11" name="Children’s songs">
             <a:extLst xmlns:a="http://schemas.openxmlformats.org/drawingml/2006/main">
               <a:ext uri="{FF2B5EF4-FFF2-40B4-BE49-F238E27FC236}">
-                <a16:creationId xmlns:a16="http://schemas.microsoft.com/office/drawing/2014/main" id="{424CC106-2C02-44EF-8F83-D658DFE852BB}"/>
+                <a16:creationId xmlns:a16="http://schemas.microsoft.com/office/drawing/2014/main" id="{42990231-1A29-4483-9FD1-8BEEBE48D12E}"/>
               </a:ext>
             </a:extLst>
           </p:cNvPr>
@@ -26912,7 +26912,7 @@
           <p:cNvPr id="12" name="Official Deti FM channels">
             <a:extLst xmlns:a="http://schemas.openxmlformats.org/drawingml/2006/main">
               <a:ext uri="{FF2B5EF4-FFF2-40B4-BE49-F238E27FC236}">
-                <a16:creationId xmlns:a16="http://schemas.microsoft.com/office/drawing/2014/main" id="{1BC4A3CC-0FC9-4BCF-987A-E7E9D28A1683}"/>
+                <a16:creationId xmlns:a16="http://schemas.microsoft.com/office/drawing/2014/main" id="{268301FE-FA91-4A65-9B41-E40AC3634657}"/>
               </a:ext>
             </a:extLst>
           </p:cNvPr>
@@ -27070,7 +27070,7 @@
           <p:cNvPr id="13" name="Mac 209 echo: RTP and human listening passed. All three stations ">
             <a:extLst xmlns:a="http://schemas.openxmlformats.org/drawingml/2006/main">
               <a:ext uri="{FF2B5EF4-FFF2-40B4-BE49-F238E27FC236}">
-                <a16:creationId xmlns:a16="http://schemas.microsoft.com/office/drawing/2014/main" id="{0E1CEF75-2CB7-41BD-BD33-479F11CD8921}"/>
+                <a16:creationId xmlns:a16="http://schemas.microsoft.com/office/drawing/2014/main" id="{1362F38A-0DC3-4115-B125-9C5F63CC56E0}"/>
               </a:ext>
             </a:extLst>
           </p:cNvPr>
@@ -27226,7 +27226,7 @@
     </p:spTree>
     <p:extLst>
       <p:ext uri="{BB962C8B-B14F-4D97-AF65-F5344CB8AC3E}">
-        <p14:creationId xmlns:p14="http://schemas.microsoft.com/office/powerpoint/2010/main" val="1736495284"/>
+        <p14:creationId xmlns:p14="http://schemas.microsoft.com/office/powerpoint/2010/main" val="1165751207"/>
       </p:ext>
     </p:extLst>
   </p:cSld>
@@ -27257,7 +27257,7 @@
           <p:cNvPr id="10" name="Cisco 7945G: model and inventory">
             <a:extLst xmlns:a="http://schemas.openxmlformats.org/drawingml/2006/main">
               <a:ext uri="{FF2B5EF4-FFF2-40B4-BE49-F238E27FC236}">
-                <a16:creationId xmlns:a16="http://schemas.microsoft.com/office/drawing/2014/main" id="{15EF9766-090A-46A6-B489-EB50BBF251D1}"/>
+                <a16:creationId xmlns:a16="http://schemas.microsoft.com/office/drawing/2014/main" id="{E9A9820C-AE34-4D4F-B3F8-E1F693999BB6}"/>
               </a:ext>
             </a:extLst>
           </p:cNvPr>
@@ -27415,7 +27415,7 @@
           <p:cNvPr id="2" name="02">
             <a:extLst xmlns:a="http://schemas.openxmlformats.org/drawingml/2006/main">
               <a:ext uri="{FF2B5EF4-FFF2-40B4-BE49-F238E27FC236}">
-                <a16:creationId xmlns:a16="http://schemas.microsoft.com/office/drawing/2014/main" id="{CE6257AC-A53B-4D56-8908-7EB09A561EB9}"/>
+                <a16:creationId xmlns:a16="http://schemas.microsoft.com/office/drawing/2014/main" id="{8AB7DCC8-4B7D-4CA1-AEF1-535F9D431AEC}"/>
               </a:ext>
             </a:extLst>
           </p:cNvPr>
@@ -27573,7 +27573,7 @@
           <p:cNvPr id="3" name="2">
             <a:extLst xmlns:a="http://schemas.openxmlformats.org/drawingml/2006/main">
               <a:ext uri="{FF2B5EF4-FFF2-40B4-BE49-F238E27FC236}">
-                <a16:creationId xmlns:a16="http://schemas.microsoft.com/office/drawing/2014/main" id="{28ABBF32-5475-4D66-A0A8-997916124CF2}"/>
+                <a16:creationId xmlns:a16="http://schemas.microsoft.com/office/drawing/2014/main" id="{8A9C1CCD-86A8-46D0-910F-68DF8706BD02}"/>
               </a:ext>
             </a:extLst>
           </p:cNvPr>
@@ -27731,7 +27731,7 @@
           <p:cNvPr id="4" name="SIP lines">
             <a:extLst xmlns:a="http://schemas.openxmlformats.org/drawingml/2006/main">
               <a:ext uri="{FF2B5EF4-FFF2-40B4-BE49-F238E27FC236}">
-                <a16:creationId xmlns:a16="http://schemas.microsoft.com/office/drawing/2014/main" id="{DA7299C4-9651-4BFB-B4E0-3E32ABC21444}"/>
+                <a16:creationId xmlns:a16="http://schemas.microsoft.com/office/drawing/2014/main" id="{499DF222-476D-4BE7-96E2-66F96D30EBC6}"/>
               </a:ext>
             </a:extLst>
           </p:cNvPr>
@@ -27889,7 +27889,7 @@
           <p:cNvPr id="5" name="Native 802.3af">
             <a:extLst xmlns:a="http://schemas.openxmlformats.org/drawingml/2006/main">
               <a:ext uri="{FF2B5EF4-FFF2-40B4-BE49-F238E27FC236}">
-                <a16:creationId xmlns:a16="http://schemas.microsoft.com/office/drawing/2014/main" id="{4B7A3058-835F-4304-8178-DBA2E37C6EEB}"/>
+                <a16:creationId xmlns:a16="http://schemas.microsoft.com/office/drawing/2014/main" id="{6CA4C9C3-4A53-4858-9015-D01A2CE2476A}"/>
               </a:ext>
             </a:extLst>
           </p:cNvPr>
@@ -28047,7 +28047,7 @@
           <p:cNvPr id="6" name="7945_7965 SIP firmware family">
             <a:extLst xmlns:a="http://schemas.openxmlformats.org/drawingml/2006/main">
               <a:ext uri="{FF2B5EF4-FFF2-40B4-BE49-F238E27FC236}">
-                <a16:creationId xmlns:a16="http://schemas.microsoft.com/office/drawing/2014/main" id="{57EAABA4-DA4E-4006-94C9-2323B35B1D38}"/>
+                <a16:creationId xmlns:a16="http://schemas.microsoft.com/office/drawing/2014/main" id="{9E104A18-6002-40BD-894D-60A2FFB8DFB4}"/>
               </a:ext>
             </a:extLst>
           </p:cNvPr>
@@ -28205,7 +28205,7 @@
           <p:cNvPr id="7" name="A phone running SCCP needs SIP firmware.&#10;This model does not need">
             <a:extLst xmlns:a="http://schemas.openxmlformats.org/drawingml/2006/main">
               <a:ext uri="{FF2B5EF4-FFF2-40B4-BE49-F238E27FC236}">
-                <a16:creationId xmlns:a16="http://schemas.microsoft.com/office/drawing/2014/main" id="{7A833FB9-6E15-450B-8CEE-DBF2475F0024}"/>
+                <a16:creationId xmlns:a16="http://schemas.microsoft.com/office/drawing/2014/main" id="{BCBF52C7-35BD-444B-A9E4-B2136C6E74BA}"/>
               </a:ext>
             </a:extLst>
           </p:cNvPr>
@@ -28386,7 +28386,7 @@
           <p:cNvPr id="8" name="Before starting">
             <a:extLst xmlns:a="http://schemas.openxmlformats.org/drawingml/2006/main">
               <a:ext uri="{FF2B5EF4-FFF2-40B4-BE49-F238E27FC236}">
-                <a16:creationId xmlns:a16="http://schemas.microsoft.com/office/drawing/2014/main" id="{04514A9C-B431-4400-819F-F26CEF6FFEB6}"/>
+                <a16:creationId xmlns:a16="http://schemas.microsoft.com/office/drawing/2014/main" id="{6CD01270-6FE6-4421-BF9B-9DB915C0238F}"/>
               </a:ext>
             </a:extLst>
           </p:cNvPr>
@@ -28544,7 +28544,7 @@
           <p:cNvPr id="9" name="Record PID, VID/HW, MAC, App Load,&#10;Boot Load, IP and TFTP for eve">
             <a:extLst xmlns:a="http://schemas.openxmlformats.org/drawingml/2006/main">
               <a:ext uri="{FF2B5EF4-FFF2-40B4-BE49-F238E27FC236}">
-                <a16:creationId xmlns:a16="http://schemas.microsoft.com/office/drawing/2014/main" id="{3149A48E-1AF5-4371-A220-DADD01800726}"/>
+                <a16:creationId xmlns:a16="http://schemas.microsoft.com/office/drawing/2014/main" id="{5ACFAA04-3D0A-4226-9637-19B455554032}"/>
               </a:ext>
             </a:extLst>
           </p:cNvPr>
@@ -28723,7 +28723,7 @@
     </p:spTree>
     <p:extLst>
       <p:ext uri="{BB962C8B-B14F-4D97-AF65-F5344CB8AC3E}">
-        <p14:creationId xmlns:p14="http://schemas.microsoft.com/office/powerpoint/2010/main" val="1536221638"/>
+        <p14:creationId xmlns:p14="http://schemas.microsoft.com/office/powerpoint/2010/main" val="1006207186"/>
       </p:ext>
     </p:extLst>
   </p:cSld>
@@ -28754,7 +28754,7 @@
           <p:cNvPr id="17" name="">
             <a:extLst xmlns:a="http://schemas.openxmlformats.org/drawingml/2006/main">
               <a:ext uri="{FF2B5EF4-FFF2-40B4-BE49-F238E27FC236}">
-                <a16:creationId xmlns:a16="http://schemas.microsoft.com/office/drawing/2014/main" id="{18BC9DFD-F53E-4FB1-9ADA-93F1C5E992A2}"/>
+                <a16:creationId xmlns:a16="http://schemas.microsoft.com/office/drawing/2014/main" id="{8810B0B0-70BA-4D03-B574-38C1905B64A0}"/>
               </a:ext>
             </a:extLst>
           </p:cNvPr>
@@ -28786,7 +28786,7 @@
           <p:cNvPr id="15" name="">
             <a:extLst xmlns:a="http://schemas.openxmlformats.org/drawingml/2006/main">
               <a:ext uri="{FF2B5EF4-FFF2-40B4-BE49-F238E27FC236}">
-                <a16:creationId xmlns:a16="http://schemas.microsoft.com/office/drawing/2014/main" id="{4D019C30-C99D-4A98-99C0-081CECA00624}"/>
+                <a16:creationId xmlns:a16="http://schemas.microsoft.com/office/drawing/2014/main" id="{FEA30716-FD6D-44E7-9BFB-77E787D5FB62}"/>
               </a:ext>
             </a:extLst>
           </p:cNvPr>
@@ -28817,7 +28817,7 @@
           <p:cNvPr id="13" name="">
             <a:extLst xmlns:a="http://schemas.openxmlformats.org/drawingml/2006/main">
               <a:ext uri="{FF2B5EF4-FFF2-40B4-BE49-F238E27FC236}">
-                <a16:creationId xmlns:a16="http://schemas.microsoft.com/office/drawing/2014/main" id="{708C1BE8-1FA2-470F-BE53-749EEB931014}"/>
+                <a16:creationId xmlns:a16="http://schemas.microsoft.com/office/drawing/2014/main" id="{B7265C4C-C624-4953-9E45-EDC5E7E672B2}"/>
               </a:ext>
             </a:extLst>
           </p:cNvPr>
@@ -28848,7 +28848,7 @@
           <p:cNvPr id="11" name="">
             <a:extLst xmlns:a="http://schemas.openxmlformats.org/drawingml/2006/main">
               <a:ext uri="{FF2B5EF4-FFF2-40B4-BE49-F238E27FC236}">
-                <a16:creationId xmlns:a16="http://schemas.microsoft.com/office/drawing/2014/main" id="{B35B6F64-2E32-43AD-A491-269C320F4223}"/>
+                <a16:creationId xmlns:a16="http://schemas.microsoft.com/office/drawing/2014/main" id="{DA7E9AAA-DCAB-4173-96A4-02A7274971A0}"/>
               </a:ext>
             </a:extLst>
           </p:cNvPr>
@@ -28880,7 +28880,7 @@
           <p:cNvPr id="9" name="">
             <a:extLst xmlns:a="http://schemas.openxmlformats.org/drawingml/2006/main">
               <a:ext uri="{FF2B5EF4-FFF2-40B4-BE49-F238E27FC236}">
-                <a16:creationId xmlns:a16="http://schemas.microsoft.com/office/drawing/2014/main" id="{B23046B7-9D71-4E2A-AC16-DF5605A36051}"/>
+                <a16:creationId xmlns:a16="http://schemas.microsoft.com/office/drawing/2014/main" id="{D2008A28-9AF9-443B-98F9-6679FF7FF3A6}"/>
               </a:ext>
             </a:extLst>
           </p:cNvPr>
@@ -28912,7 +28912,7 @@
           <p:cNvPr id="20" name="Cisco, Asterisk and Home Assistant">
             <a:extLst xmlns:a="http://schemas.openxmlformats.org/drawingml/2006/main">
               <a:ext uri="{FF2B5EF4-FFF2-40B4-BE49-F238E27FC236}">
-                <a16:creationId xmlns:a16="http://schemas.microsoft.com/office/drawing/2014/main" id="{64499B19-2F31-4A54-8C81-D8A3892841B9}"/>
+                <a16:creationId xmlns:a16="http://schemas.microsoft.com/office/drawing/2014/main" id="{1871254C-565E-415B-954F-FD71D3985359}"/>
               </a:ext>
             </a:extLst>
           </p:cNvPr>
@@ -29070,7 +29070,7 @@
           <p:cNvPr id="2" name="03">
             <a:extLst xmlns:a="http://schemas.openxmlformats.org/drawingml/2006/main">
               <a:ext uri="{FF2B5EF4-FFF2-40B4-BE49-F238E27FC236}">
-                <a16:creationId xmlns:a16="http://schemas.microsoft.com/office/drawing/2014/main" id="{632905B5-31AC-4219-A952-BDE8CBB143CA}"/>
+                <a16:creationId xmlns:a16="http://schemas.microsoft.com/office/drawing/2014/main" id="{055A42B9-F81E-4AEF-A240-47A36A631CA5}"/>
               </a:ext>
             </a:extLst>
           </p:cNvPr>
@@ -29228,7 +29228,7 @@
           <p:cNvPr id="3" name="phones">
             <a:extLst xmlns:a="http://schemas.openxmlformats.org/drawingml/2006/main">
               <a:ext uri="{FF2B5EF4-FFF2-40B4-BE49-F238E27FC236}">
-                <a16:creationId xmlns:a16="http://schemas.microsoft.com/office/drawing/2014/main" id="{15BE453A-C13A-4EC2-AA92-732B9124B6C2}"/>
+                <a16:creationId xmlns:a16="http://schemas.microsoft.com/office/drawing/2014/main" id="{E22360F7-6486-44C0-94DB-ABF3C7A05544}"/>
               </a:ext>
             </a:extLst>
           </p:cNvPr>
@@ -29415,7 +29415,7 @@
           <p:cNvPr id="4" name="switch">
             <a:extLst xmlns:a="http://schemas.openxmlformats.org/drawingml/2006/main">
               <a:ext uri="{FF2B5EF4-FFF2-40B4-BE49-F238E27FC236}">
-                <a16:creationId xmlns:a16="http://schemas.microsoft.com/office/drawing/2014/main" id="{685CC3DA-8372-4E23-9448-8798495FC798}"/>
+                <a16:creationId xmlns:a16="http://schemas.microsoft.com/office/drawing/2014/main" id="{D4F20B57-739E-41B2-931F-57A80A7A71BE}"/>
               </a:ext>
             </a:extLst>
           </p:cNvPr>
@@ -29602,7 +29602,7 @@
           <p:cNvPr id="5" name="ast">
             <a:extLst xmlns:a="http://schemas.openxmlformats.org/drawingml/2006/main">
               <a:ext uri="{FF2B5EF4-FFF2-40B4-BE49-F238E27FC236}">
-                <a16:creationId xmlns:a16="http://schemas.microsoft.com/office/drawing/2014/main" id="{90D70199-9CD2-42A4-9868-60561037E805}"/>
+                <a16:creationId xmlns:a16="http://schemas.microsoft.com/office/drawing/2014/main" id="{63017F86-A46D-41F4-BD33-3AF619EA0EBB}"/>
               </a:ext>
             </a:extLst>
           </p:cNvPr>
@@ -29789,7 +29789,7 @@
           <p:cNvPr id="6" name="router">
             <a:extLst xmlns:a="http://schemas.openxmlformats.org/drawingml/2006/main">
               <a:ext uri="{FF2B5EF4-FFF2-40B4-BE49-F238E27FC236}">
-                <a16:creationId xmlns:a16="http://schemas.microsoft.com/office/drawing/2014/main" id="{9B70D400-2878-4EB3-8592-6B616052CD45}"/>
+                <a16:creationId xmlns:a16="http://schemas.microsoft.com/office/drawing/2014/main" id="{183B6B48-315C-4C10-A539-AF83CFC6AF44}"/>
               </a:ext>
             </a:extLst>
           </p:cNvPr>
@@ -29976,7 +29976,7 @@
           <p:cNvPr id="7" name="tftp">
             <a:extLst xmlns:a="http://schemas.openxmlformats.org/drawingml/2006/main">
               <a:ext uri="{FF2B5EF4-FFF2-40B4-BE49-F238E27FC236}">
-                <a16:creationId xmlns:a16="http://schemas.microsoft.com/office/drawing/2014/main" id="{40FAD31E-F617-4547-84FE-939CB8A4656B}"/>
+                <a16:creationId xmlns:a16="http://schemas.microsoft.com/office/drawing/2014/main" id="{97BA39D5-1819-4C2D-9093-C6328600288B}"/>
               </a:ext>
             </a:extLst>
           </p:cNvPr>
@@ -30163,7 +30163,7 @@
           <p:cNvPr id="8" name="ha">
             <a:extLst xmlns:a="http://schemas.openxmlformats.org/drawingml/2006/main">
               <a:ext uri="{FF2B5EF4-FFF2-40B4-BE49-F238E27FC236}">
-                <a16:creationId xmlns:a16="http://schemas.microsoft.com/office/drawing/2014/main" id="{E66BF2F2-EB0B-434A-B727-00441617792A}"/>
+                <a16:creationId xmlns:a16="http://schemas.microsoft.com/office/drawing/2014/main" id="{BFBC58DE-B4FA-4AAA-9BFA-814EFDA0645C}"/>
               </a:ext>
             </a:extLst>
           </p:cNvPr>
@@ -30350,7 +30350,7 @@
           <p:cNvPr id="10" name="Ethernet">
             <a:extLst xmlns:a="http://schemas.openxmlformats.org/drawingml/2006/main">
               <a:ext uri="{FF2B5EF4-FFF2-40B4-BE49-F238E27FC236}">
-                <a16:creationId xmlns:a16="http://schemas.microsoft.com/office/drawing/2014/main" id="{7B56B320-CE95-49D7-BBBB-9DD7EBFD756C}"/>
+                <a16:creationId xmlns:a16="http://schemas.microsoft.com/office/drawing/2014/main" id="{DB44BEF6-EF13-4914-AE62-08F84EE1813D}"/>
               </a:ext>
             </a:extLst>
           </p:cNvPr>
@@ -30508,7 +30508,7 @@
           <p:cNvPr id="12" name="SIP / RTP">
             <a:extLst xmlns:a="http://schemas.openxmlformats.org/drawingml/2006/main">
               <a:ext uri="{FF2B5EF4-FFF2-40B4-BE49-F238E27FC236}">
-                <a16:creationId xmlns:a16="http://schemas.microsoft.com/office/drawing/2014/main" id="{4FE26089-D36C-4624-A10D-C77707A3AD2E}"/>
+                <a16:creationId xmlns:a16="http://schemas.microsoft.com/office/drawing/2014/main" id="{207F6FCD-0346-4090-BED8-455D753D3093}"/>
               </a:ext>
             </a:extLst>
           </p:cNvPr>
@@ -30666,7 +30666,7 @@
           <p:cNvPr id="14" name="DHCP">
             <a:extLst xmlns:a="http://schemas.openxmlformats.org/drawingml/2006/main">
               <a:ext uri="{FF2B5EF4-FFF2-40B4-BE49-F238E27FC236}">
-                <a16:creationId xmlns:a16="http://schemas.microsoft.com/office/drawing/2014/main" id="{57D97531-D4BA-4BCE-B8E7-7D0ABB3F318F}"/>
+                <a16:creationId xmlns:a16="http://schemas.microsoft.com/office/drawing/2014/main" id="{1D6BA198-276B-43C6-82D7-F19D92CAA184}"/>
               </a:ext>
             </a:extLst>
           </p:cNvPr>
@@ -30824,7 +30824,7 @@
           <p:cNvPr id="16" name="download">
             <a:extLst xmlns:a="http://schemas.openxmlformats.org/drawingml/2006/main">
               <a:ext uri="{FF2B5EF4-FFF2-40B4-BE49-F238E27FC236}">
-                <a16:creationId xmlns:a16="http://schemas.microsoft.com/office/drawing/2014/main" id="{C1DD3A92-E636-439A-B423-398058C163DC}"/>
+                <a16:creationId xmlns:a16="http://schemas.microsoft.com/office/drawing/2014/main" id="{93B9D7C5-DE70-4E4D-BA74-5A5724AF298F}"/>
               </a:ext>
             </a:extLst>
           </p:cNvPr>
@@ -30982,7 +30982,7 @@
           <p:cNvPr id="18" name="AMI&#10;SIP / RTP">
             <a:extLst xmlns:a="http://schemas.openxmlformats.org/drawingml/2006/main">
               <a:ext uri="{FF2B5EF4-FFF2-40B4-BE49-F238E27FC236}">
-                <a16:creationId xmlns:a16="http://schemas.microsoft.com/office/drawing/2014/main" id="{84A45B16-7140-493D-B9DA-E5D11E034E48}"/>
+                <a16:creationId xmlns:a16="http://schemas.microsoft.com/office/drawing/2014/main" id="{D35A3813-D6A4-4714-9862-26604F6F84C1}"/>
               </a:ext>
             </a:extLst>
           </p:cNvPr>
@@ -31163,7 +31163,7 @@
           <p:cNvPr id="19" name="Asterisk uses hostNetwork and one replica. HA opens the AMI conne">
             <a:extLst xmlns:a="http://schemas.openxmlformats.org/drawingml/2006/main">
               <a:ext uri="{FF2B5EF4-FFF2-40B4-BE49-F238E27FC236}">
-                <a16:creationId xmlns:a16="http://schemas.microsoft.com/office/drawing/2014/main" id="{9861F5BB-19E0-454B-B136-0EE39EB71161}"/>
+                <a16:creationId xmlns:a16="http://schemas.microsoft.com/office/drawing/2014/main" id="{32A3C9B8-2A1B-4BDB-87DF-6699D72758F0}"/>
               </a:ext>
             </a:extLst>
           </p:cNvPr>
@@ -31342,7 +31342,7 @@
     </p:spTree>
     <p:extLst>
       <p:ext uri="{BB962C8B-B14F-4D97-AF65-F5344CB8AC3E}">
-        <p14:creationId xmlns:p14="http://schemas.microsoft.com/office/powerpoint/2010/main" val="1130143453"/>
+        <p14:creationId xmlns:p14="http://schemas.microsoft.com/office/powerpoint/2010/main" val="986772296"/>
       </p:ext>
     </p:extLst>
   </p:cSld>
@@ -31373,7 +31373,7 @@
           <p:cNvPr id="16" name="Signaling and audio ports">
             <a:extLst xmlns:a="http://schemas.openxmlformats.org/drawingml/2006/main">
               <a:ext uri="{FF2B5EF4-FFF2-40B4-BE49-F238E27FC236}">
-                <a16:creationId xmlns:a16="http://schemas.microsoft.com/office/drawing/2014/main" id="{02FBA9FA-E602-4DAA-9B4A-37F888795313}"/>
+                <a16:creationId xmlns:a16="http://schemas.microsoft.com/office/drawing/2014/main" id="{ADFB3144-41BB-4B5C-8ACD-EBBFD36F925C}"/>
               </a:ext>
             </a:extLst>
           </p:cNvPr>
@@ -31531,7 +31531,7 @@
           <p:cNvPr id="2" name="04">
             <a:extLst xmlns:a="http://schemas.openxmlformats.org/drawingml/2006/main">
               <a:ext uri="{FF2B5EF4-FFF2-40B4-BE49-F238E27FC236}">
-                <a16:creationId xmlns:a16="http://schemas.microsoft.com/office/drawing/2014/main" id="{2CCD3C0A-C458-4480-ADD8-BA011EB923AF}"/>
+                <a16:creationId xmlns:a16="http://schemas.microsoft.com/office/drawing/2014/main" id="{F3DC872E-BAA9-4A56-B12D-F2752D4D2405}"/>
               </a:ext>
             </a:extLst>
           </p:cNvPr>
@@ -31689,7 +31689,7 @@
           <p:cNvPr id="3" name="5060">
             <a:extLst xmlns:a="http://schemas.openxmlformats.org/drawingml/2006/main">
               <a:ext uri="{FF2B5EF4-FFF2-40B4-BE49-F238E27FC236}">
-                <a16:creationId xmlns:a16="http://schemas.microsoft.com/office/drawing/2014/main" id="{C6713FE2-19A8-4C93-9465-6843D11EA182}"/>
+                <a16:creationId xmlns:a16="http://schemas.microsoft.com/office/drawing/2014/main" id="{AFE992A6-B141-44DC-A8A2-5586C56C56E6}"/>
               </a:ext>
             </a:extLst>
           </p:cNvPr>
@@ -31847,7 +31847,7 @@
           <p:cNvPr id="4" name="TCP / UDP">
             <a:extLst xmlns:a="http://schemas.openxmlformats.org/drawingml/2006/main">
               <a:ext uri="{FF2B5EF4-FFF2-40B4-BE49-F238E27FC236}">
-                <a16:creationId xmlns:a16="http://schemas.microsoft.com/office/drawing/2014/main" id="{988DE252-B2D4-40F9-8D7A-B4051FEA5889}"/>
+                <a16:creationId xmlns:a16="http://schemas.microsoft.com/office/drawing/2014/main" id="{C4718C9F-8000-4C81-9899-0F7C23E75407}"/>
               </a:ext>
             </a:extLst>
           </p:cNvPr>
@@ -32005,7 +32005,7 @@
           <p:cNvPr id="5" name="SIP: Cisco TCP, HA UDP">
             <a:extLst xmlns:a="http://schemas.openxmlformats.org/drawingml/2006/main">
               <a:ext uri="{FF2B5EF4-FFF2-40B4-BE49-F238E27FC236}">
-                <a16:creationId xmlns:a16="http://schemas.microsoft.com/office/drawing/2014/main" id="{2A7FE69A-3C19-4B26-928F-CBD6B1D9C7B9}"/>
+                <a16:creationId xmlns:a16="http://schemas.microsoft.com/office/drawing/2014/main" id="{0A913162-B37D-48E8-9AE2-199597644B87}"/>
               </a:ext>
             </a:extLst>
           </p:cNvPr>
@@ -32163,7 +32163,7 @@
           <p:cNvPr id="6" name="10000–10199">
             <a:extLst xmlns:a="http://schemas.openxmlformats.org/drawingml/2006/main">
               <a:ext uri="{FF2B5EF4-FFF2-40B4-BE49-F238E27FC236}">
-                <a16:creationId xmlns:a16="http://schemas.microsoft.com/office/drawing/2014/main" id="{716F4B58-D328-4E48-93FE-154D01FAF1A7}"/>
+                <a16:creationId xmlns:a16="http://schemas.microsoft.com/office/drawing/2014/main" id="{1A5D1114-DE2C-4FBF-9208-5EAC4C66D499}"/>
               </a:ext>
             </a:extLst>
           </p:cNvPr>
@@ -32321,7 +32321,7 @@
           <p:cNvPr id="7" name="UDP on PBX">
             <a:extLst xmlns:a="http://schemas.openxmlformats.org/drawingml/2006/main">
               <a:ext uri="{FF2B5EF4-FFF2-40B4-BE49-F238E27FC236}">
-                <a16:creationId xmlns:a16="http://schemas.microsoft.com/office/drawing/2014/main" id="{1AE030F9-457E-45D8-A41E-58EDC8D2D16B}"/>
+                <a16:creationId xmlns:a16="http://schemas.microsoft.com/office/drawing/2014/main" id="{F781C6B1-C17C-45B1-9FD6-170F4FDF0B66}"/>
               </a:ext>
             </a:extLst>
           </p:cNvPr>
@@ -32479,7 +32479,7 @@
           <p:cNvPr id="8" name="RTP / audio">
             <a:extLst xmlns:a="http://schemas.openxmlformats.org/drawingml/2006/main">
               <a:ext uri="{FF2B5EF4-FFF2-40B4-BE49-F238E27FC236}">
-                <a16:creationId xmlns:a16="http://schemas.microsoft.com/office/drawing/2014/main" id="{377A2E9F-4AC0-4AD1-B1D8-288A507FAB9E}"/>
+                <a16:creationId xmlns:a16="http://schemas.microsoft.com/office/drawing/2014/main" id="{749C2385-F20C-4664-BC95-28C400DEEFE7}"/>
               </a:ext>
             </a:extLst>
           </p:cNvPr>
@@ -32637,7 +32637,7 @@
           <p:cNvPr id="9" name="5038">
             <a:extLst xmlns:a="http://schemas.openxmlformats.org/drawingml/2006/main">
               <a:ext uri="{FF2B5EF4-FFF2-40B4-BE49-F238E27FC236}">
-                <a16:creationId xmlns:a16="http://schemas.microsoft.com/office/drawing/2014/main" id="{3039C12F-B282-4C5F-B5DF-FE2327DEBF7B}"/>
+                <a16:creationId xmlns:a16="http://schemas.microsoft.com/office/drawing/2014/main" id="{ED47606E-B600-4392-84DF-0C6D430EB423}"/>
               </a:ext>
             </a:extLst>
           </p:cNvPr>
@@ -32795,7 +32795,7 @@
           <p:cNvPr id="10" name="TCP on PBX">
             <a:extLst xmlns:a="http://schemas.openxmlformats.org/drawingml/2006/main">
               <a:ext uri="{FF2B5EF4-FFF2-40B4-BE49-F238E27FC236}">
-                <a16:creationId xmlns:a16="http://schemas.microsoft.com/office/drawing/2014/main" id="{E45B483B-F89A-4548-AB71-207B14CF14B6}"/>
+                <a16:creationId xmlns:a16="http://schemas.microsoft.com/office/drawing/2014/main" id="{3FA8DF12-E4C3-4D54-AD93-F82FCA445916}"/>
               </a:ext>
             </a:extLst>
           </p:cNvPr>
@@ -32953,7 +32953,7 @@
           <p:cNvPr id="11" name="AMI: HA / gateway /32">
             <a:extLst xmlns:a="http://schemas.openxmlformats.org/drawingml/2006/main">
               <a:ext uri="{FF2B5EF4-FFF2-40B4-BE49-F238E27FC236}">
-                <a16:creationId xmlns:a16="http://schemas.microsoft.com/office/drawing/2014/main" id="{C780E3E4-1805-4C18-BE5E-61F7B171F030}"/>
+                <a16:creationId xmlns:a16="http://schemas.microsoft.com/office/drawing/2014/main" id="{D1E900A9-81A2-4C07-A783-2031E0955051}"/>
               </a:ext>
             </a:extLst>
           </p:cNvPr>
@@ -33111,7 +33111,7 @@
           <p:cNvPr id="12" name="69 + 20000–20031">
             <a:extLst xmlns:a="http://schemas.openxmlformats.org/drawingml/2006/main">
               <a:ext uri="{FF2B5EF4-FFF2-40B4-BE49-F238E27FC236}">
-                <a16:creationId xmlns:a16="http://schemas.microsoft.com/office/drawing/2014/main" id="{361DDF65-361B-4681-BDD3-71913463D258}"/>
+                <a16:creationId xmlns:a16="http://schemas.microsoft.com/office/drawing/2014/main" id="{B459CB49-6EBE-4A54-8E58-090B73D162A4}"/>
               </a:ext>
             </a:extLst>
           </p:cNvPr>
@@ -33269,7 +33269,7 @@
           <p:cNvPr id="13" name="UDP on PBX">
             <a:extLst xmlns:a="http://schemas.openxmlformats.org/drawingml/2006/main">
               <a:ext uri="{FF2B5EF4-FFF2-40B4-BE49-F238E27FC236}">
-                <a16:creationId xmlns:a16="http://schemas.microsoft.com/office/drawing/2014/main" id="{E86189F7-77AD-4880-AA15-2A4369264739}"/>
+                <a16:creationId xmlns:a16="http://schemas.microsoft.com/office/drawing/2014/main" id="{9AEA1A8D-822D-46C8-9F19-38A709939E77}"/>
               </a:ext>
             </a:extLst>
           </p:cNvPr>
@@ -33427,7 +33427,7 @@
           <p:cNvPr id="14" name="Temporary TFTP">
             <a:extLst xmlns:a="http://schemas.openxmlformats.org/drawingml/2006/main">
               <a:ext uri="{FF2B5EF4-FFF2-40B4-BE49-F238E27FC236}">
-                <a16:creationId xmlns:a16="http://schemas.microsoft.com/office/drawing/2014/main" id="{AB29F116-F4D9-49FF-A2AC-3678B65E36AC}"/>
+                <a16:creationId xmlns:a16="http://schemas.microsoft.com/office/drawing/2014/main" id="{6869902D-D676-4B0B-8DC3-A76469F9F016}"/>
               </a:ext>
             </a:extLst>
           </p:cNvPr>
@@ -33585,7 +33585,7 @@
           <p:cNvPr id="15" name="HA uses dynamic RTP / RTCP ports. Restrict firewall rules to the ">
             <a:extLst xmlns:a="http://schemas.openxmlformats.org/drawingml/2006/main">
               <a:ext uri="{FF2B5EF4-FFF2-40B4-BE49-F238E27FC236}">
-                <a16:creationId xmlns:a16="http://schemas.microsoft.com/office/drawing/2014/main" id="{B6DD4733-7DE5-4F30-9F32-0793C4FB7E6A}"/>
+                <a16:creationId xmlns:a16="http://schemas.microsoft.com/office/drawing/2014/main" id="{C29160F1-0FD7-4FBB-AEA7-5E77C66E6F3C}"/>
               </a:ext>
             </a:extLst>
           </p:cNvPr>
@@ -33741,7 +33741,7 @@
     </p:spTree>
     <p:extLst>
       <p:ext uri="{BB962C8B-B14F-4D97-AF65-F5344CB8AC3E}">
-        <p14:creationId xmlns:p14="http://schemas.microsoft.com/office/powerpoint/2010/main" val="1539451525"/>
+        <p14:creationId xmlns:p14="http://schemas.microsoft.com/office/powerpoint/2010/main" val="618140235"/>
       </p:ext>
     </p:extLst>
   </p:cSld>
@@ -33772,7 +33772,7 @@
           <p:cNvPr id="12" name="">
             <a:extLst xmlns:a="http://schemas.openxmlformats.org/drawingml/2006/main">
               <a:ext uri="{FF2B5EF4-FFF2-40B4-BE49-F238E27FC236}">
-                <a16:creationId xmlns:a16="http://schemas.microsoft.com/office/drawing/2014/main" id="{D651970D-577F-4017-8147-E9CA8F997769}"/>
+                <a16:creationId xmlns:a16="http://schemas.microsoft.com/office/drawing/2014/main" id="{CF03186D-2341-484C-9087-D1D920A182D0}"/>
               </a:ext>
             </a:extLst>
           </p:cNvPr>
@@ -33803,7 +33803,7 @@
           <p:cNvPr id="10" name="">
             <a:extLst xmlns:a="http://schemas.openxmlformats.org/drawingml/2006/main">
               <a:ext uri="{FF2B5EF4-FFF2-40B4-BE49-F238E27FC236}">
-                <a16:creationId xmlns:a16="http://schemas.microsoft.com/office/drawing/2014/main" id="{59D2B0A9-B027-45AD-98B4-AE99BEE208F5}"/>
+                <a16:creationId xmlns:a16="http://schemas.microsoft.com/office/drawing/2014/main" id="{7057982E-9C0D-4B69-966D-BAD6215B6F19}"/>
               </a:ext>
             </a:extLst>
           </p:cNvPr>
@@ -33834,7 +33834,7 @@
           <p:cNvPr id="8" name="">
             <a:extLst xmlns:a="http://schemas.openxmlformats.org/drawingml/2006/main">
               <a:ext uri="{FF2B5EF4-FFF2-40B4-BE49-F238E27FC236}">
-                <a16:creationId xmlns:a16="http://schemas.microsoft.com/office/drawing/2014/main" id="{3BE57381-13CB-4510-B80C-602235D477AE}"/>
+                <a16:creationId xmlns:a16="http://schemas.microsoft.com/office/drawing/2014/main" id="{782EF5CC-898A-4AAA-B7CF-8419D053DF16}"/>
               </a:ext>
             </a:extLst>
           </p:cNvPr>
@@ -33865,7 +33865,7 @@
           <p:cNvPr id="15" name="7945G has built-in PoE support">
             <a:extLst xmlns:a="http://schemas.openxmlformats.org/drawingml/2006/main">
               <a:ext uri="{FF2B5EF4-FFF2-40B4-BE49-F238E27FC236}">
-                <a16:creationId xmlns:a16="http://schemas.microsoft.com/office/drawing/2014/main" id="{31E97BF2-3617-4FBE-B52E-DFB71CF77357}"/>
+                <a16:creationId xmlns:a16="http://schemas.microsoft.com/office/drawing/2014/main" id="{1F532AD0-5B12-4290-B313-C14461E84BEC}"/>
               </a:ext>
             </a:extLst>
           </p:cNvPr>
@@ -34023,7 +34023,7 @@
           <p:cNvPr id="2" name="05">
             <a:extLst xmlns:a="http://schemas.openxmlformats.org/drawingml/2006/main">
               <a:ext uri="{FF2B5EF4-FFF2-40B4-BE49-F238E27FC236}">
-                <a16:creationId xmlns:a16="http://schemas.microsoft.com/office/drawing/2014/main" id="{F9533124-FD76-417A-B3CA-0576D312D2BE}"/>
+                <a16:creationId xmlns:a16="http://schemas.microsoft.com/office/drawing/2014/main" id="{FDE7E7B7-CEE3-4CA3-85E3-CB7A696BB3CB}"/>
               </a:ext>
             </a:extLst>
           </p:cNvPr>
@@ -34181,7 +34181,7 @@
           <p:cNvPr id="3" name="poe">
             <a:extLst xmlns:a="http://schemas.openxmlformats.org/drawingml/2006/main">
               <a:ext uri="{FF2B5EF4-FFF2-40B4-BE49-F238E27FC236}">
-                <a16:creationId xmlns:a16="http://schemas.microsoft.com/office/drawing/2014/main" id="{E62AA785-D7EA-4D2A-8527-16379E4DBEE7}"/>
+                <a16:creationId xmlns:a16="http://schemas.microsoft.com/office/drawing/2014/main" id="{913256D3-1157-4D0E-B1C6-0A9AC20FA030}"/>
               </a:ext>
             </a:extLst>
           </p:cNvPr>
@@ -34368,7 +34368,7 @@
           <p:cNvPr id="4" name="phone1">
             <a:extLst xmlns:a="http://schemas.openxmlformats.org/drawingml/2006/main">
               <a:ext uri="{FF2B5EF4-FFF2-40B4-BE49-F238E27FC236}">
-                <a16:creationId xmlns:a16="http://schemas.microsoft.com/office/drawing/2014/main" id="{D29821C0-F62B-4335-A7B0-D7DF4C8C5570}"/>
+                <a16:creationId xmlns:a16="http://schemas.microsoft.com/office/drawing/2014/main" id="{4C4F0EA2-2973-42E4-863F-E0AB5B7E4B22}"/>
               </a:ext>
             </a:extLst>
           </p:cNvPr>
@@ -34555,7 +34555,7 @@
           <p:cNvPr id="5" name="lan">
             <a:extLst xmlns:a="http://schemas.openxmlformats.org/drawingml/2006/main">
               <a:ext uri="{FF2B5EF4-FFF2-40B4-BE49-F238E27FC236}">
-                <a16:creationId xmlns:a16="http://schemas.microsoft.com/office/drawing/2014/main" id="{63B15D34-97B6-4C61-95C5-2173B4F6EB01}"/>
+                <a16:creationId xmlns:a16="http://schemas.microsoft.com/office/drawing/2014/main" id="{18C166E8-02EA-438C-B3E7-7C14CCB308DF}"/>
               </a:ext>
             </a:extLst>
           </p:cNvPr>
@@ -34742,7 +34742,7 @@
           <p:cNvPr id="6" name="injector">
             <a:extLst xmlns:a="http://schemas.openxmlformats.org/drawingml/2006/main">
               <a:ext uri="{FF2B5EF4-FFF2-40B4-BE49-F238E27FC236}">
-                <a16:creationId xmlns:a16="http://schemas.microsoft.com/office/drawing/2014/main" id="{4278423D-91C6-4E25-8828-6CD5DBDF611A}"/>
+                <a16:creationId xmlns:a16="http://schemas.microsoft.com/office/drawing/2014/main" id="{4ED16FB4-516B-41EE-95E6-3F5BCB0C3169}"/>
               </a:ext>
             </a:extLst>
           </p:cNvPr>
@@ -34929,7 +34929,7 @@
           <p:cNvPr id="7" name="phone2">
             <a:extLst xmlns:a="http://schemas.openxmlformats.org/drawingml/2006/main">
               <a:ext uri="{FF2B5EF4-FFF2-40B4-BE49-F238E27FC236}">
-                <a16:creationId xmlns:a16="http://schemas.microsoft.com/office/drawing/2014/main" id="{55FCD764-DCB3-4D61-A3D7-9987F7E5957B}"/>
+                <a16:creationId xmlns:a16="http://schemas.microsoft.com/office/drawing/2014/main" id="{B0E6109A-3F30-4717-8938-A770191A191D}"/>
               </a:ext>
             </a:extLst>
           </p:cNvPr>
@@ -35116,7 +35116,7 @@
           <p:cNvPr id="9" name="data + power">
             <a:extLst xmlns:a="http://schemas.openxmlformats.org/drawingml/2006/main">
               <a:ext uri="{FF2B5EF4-FFF2-40B4-BE49-F238E27FC236}">
-                <a16:creationId xmlns:a16="http://schemas.microsoft.com/office/drawing/2014/main" id="{2AF88158-A4EE-4CAD-A60F-2976BF23F5E3}"/>
+                <a16:creationId xmlns:a16="http://schemas.microsoft.com/office/drawing/2014/main" id="{DEACA30B-B670-409A-A138-3CE25581A60E}"/>
               </a:ext>
             </a:extLst>
           </p:cNvPr>
@@ -35274,7 +35274,7 @@
           <p:cNvPr id="11" name="data">
             <a:extLst xmlns:a="http://schemas.openxmlformats.org/drawingml/2006/main">
               <a:ext uri="{FF2B5EF4-FFF2-40B4-BE49-F238E27FC236}">
-                <a16:creationId xmlns:a16="http://schemas.microsoft.com/office/drawing/2014/main" id="{3050FB94-0AD2-4519-B8CF-AB0FC23EF353}"/>
+                <a16:creationId xmlns:a16="http://schemas.microsoft.com/office/drawing/2014/main" id="{4A637FF0-32C4-433D-BF6D-0AC20422B09C}"/>
               </a:ext>
             </a:extLst>
           </p:cNvPr>
@@ -35432,7 +35432,7 @@
           <p:cNvPr id="13" name="PoE">
             <a:extLst xmlns:a="http://schemas.openxmlformats.org/drawingml/2006/main">
               <a:ext uri="{FF2B5EF4-FFF2-40B4-BE49-F238E27FC236}">
-                <a16:creationId xmlns:a16="http://schemas.microsoft.com/office/drawing/2014/main" id="{9C30E92E-A239-49A4-AAFB-9C410AE9ED0F}"/>
+                <a16:creationId xmlns:a16="http://schemas.microsoft.com/office/drawing/2014/main" id="{B20DF461-30FE-4CAB-91CD-B5FBDEC4F59A}"/>
               </a:ext>
             </a:extLst>
           </p:cNvPr>
@@ -35590,7 +35590,7 @@
           <p:cNvPr id="14" name="A passive 24 V injector is unsuitable. The UPS also needs to powe">
             <a:extLst xmlns:a="http://schemas.openxmlformats.org/drawingml/2006/main">
               <a:ext uri="{FF2B5EF4-FFF2-40B4-BE49-F238E27FC236}">
-                <a16:creationId xmlns:a16="http://schemas.microsoft.com/office/drawing/2014/main" id="{307DB303-EED6-4CF1-97FC-56D6D2964C42}"/>
+                <a16:creationId xmlns:a16="http://schemas.microsoft.com/office/drawing/2014/main" id="{530BCB0A-8770-4D67-AC9A-382AE0CEC04F}"/>
               </a:ext>
             </a:extLst>
           </p:cNvPr>
@@ -35746,7 +35746,7 @@
     </p:spTree>
     <p:extLst>
       <p:ext uri="{BB962C8B-B14F-4D97-AF65-F5344CB8AC3E}">
-        <p14:creationId xmlns:p14="http://schemas.microsoft.com/office/powerpoint/2010/main" val="182533156"/>
+        <p14:creationId xmlns:p14="http://schemas.microsoft.com/office/powerpoint/2010/main" val="1410708371"/>
       </p:ext>
     </p:extLst>
   </p:cSld>
@@ -35777,7 +35777,7 @@
           <p:cNvPr id="13" name="">
             <a:extLst xmlns:a="http://schemas.openxmlformats.org/drawingml/2006/main">
               <a:ext uri="{FF2B5EF4-FFF2-40B4-BE49-F238E27FC236}">
-                <a16:creationId xmlns:a16="http://schemas.microsoft.com/office/drawing/2014/main" id="{251C3059-CA4C-4DA6-B88A-FEF2C7339BFE}"/>
+                <a16:creationId xmlns:a16="http://schemas.microsoft.com/office/drawing/2014/main" id="{77F10AD4-769A-4F4A-8862-77373C564535}"/>
               </a:ext>
             </a:extLst>
           </p:cNvPr>
@@ -35808,7 +35808,7 @@
           <p:cNvPr id="12" name="">
             <a:extLst xmlns:a="http://schemas.openxmlformats.org/drawingml/2006/main">
               <a:ext uri="{FF2B5EF4-FFF2-40B4-BE49-F238E27FC236}">
-                <a16:creationId xmlns:a16="http://schemas.microsoft.com/office/drawing/2014/main" id="{44177214-185C-4092-8217-E35068936F26}"/>
+                <a16:creationId xmlns:a16="http://schemas.microsoft.com/office/drawing/2014/main" id="{D70085A4-7D08-4B81-8FD0-65E3E97395F7}"/>
               </a:ext>
             </a:extLst>
           </p:cNvPr>
@@ -35839,7 +35839,7 @@
           <p:cNvPr id="11" name="">
             <a:extLst xmlns:a="http://schemas.openxmlformats.org/drawingml/2006/main">
               <a:ext uri="{FF2B5EF4-FFF2-40B4-BE49-F238E27FC236}">
-                <a16:creationId xmlns:a16="http://schemas.microsoft.com/office/drawing/2014/main" id="{73F9E4BF-3B0E-4B45-BC15-D14E4407C0CF}"/>
+                <a16:creationId xmlns:a16="http://schemas.microsoft.com/office/drawing/2014/main" id="{4B26F8A8-6DBE-4980-9E8D-E9F269C6F68D}"/>
               </a:ext>
             </a:extLst>
           </p:cNvPr>
@@ -35870,7 +35870,7 @@
           <p:cNvPr id="10" name="">
             <a:extLst xmlns:a="http://schemas.openxmlformats.org/drawingml/2006/main">
               <a:ext uri="{FF2B5EF4-FFF2-40B4-BE49-F238E27FC236}">
-                <a16:creationId xmlns:a16="http://schemas.microsoft.com/office/drawing/2014/main" id="{6D31C885-5881-43D4-AC1B-C6FA6527A981}"/>
+                <a16:creationId xmlns:a16="http://schemas.microsoft.com/office/drawing/2014/main" id="{F73E6DD4-542F-44AE-94EA-A63639F5C741}"/>
               </a:ext>
             </a:extLst>
           </p:cNvPr>
@@ -35901,7 +35901,7 @@
           <p:cNvPr id="9" name="">
             <a:extLst xmlns:a="http://schemas.openxmlformats.org/drawingml/2006/main">
               <a:ext uri="{FF2B5EF4-FFF2-40B4-BE49-F238E27FC236}">
-                <a16:creationId xmlns:a16="http://schemas.microsoft.com/office/drawing/2014/main" id="{BC8F885C-52C8-40AC-94AF-D4F3956B6F10}"/>
+                <a16:creationId xmlns:a16="http://schemas.microsoft.com/office/drawing/2014/main" id="{8B93A437-E255-49E1-A924-456C7B52645B}"/>
               </a:ext>
             </a:extLst>
           </p:cNvPr>
@@ -35932,7 +35932,7 @@
           <p:cNvPr id="15" name="One pilot phone before the full fleet">
             <a:extLst xmlns:a="http://schemas.openxmlformats.org/drawingml/2006/main">
               <a:ext uri="{FF2B5EF4-FFF2-40B4-BE49-F238E27FC236}">
-                <a16:creationId xmlns:a16="http://schemas.microsoft.com/office/drawing/2014/main" id="{A3113D57-686E-4FCF-8A9D-4A8EB1D90D6D}"/>
+                <a16:creationId xmlns:a16="http://schemas.microsoft.com/office/drawing/2014/main" id="{04AF5CB7-A82E-41F3-A401-4713675F3021}"/>
               </a:ext>
             </a:extLst>
           </p:cNvPr>
@@ -36090,7 +36090,7 @@
           <p:cNvPr id="2" name="06">
             <a:extLst xmlns:a="http://schemas.openxmlformats.org/drawingml/2006/main">
               <a:ext uri="{FF2B5EF4-FFF2-40B4-BE49-F238E27FC236}">
-                <a16:creationId xmlns:a16="http://schemas.microsoft.com/office/drawing/2014/main" id="{9B3B119F-1F61-4C69-A80B-E32FF5951F3C}"/>
+                <a16:creationId xmlns:a16="http://schemas.microsoft.com/office/drawing/2014/main" id="{BA13F99E-C84E-44FE-97EB-2FF4A3BC81FF}"/>
               </a:ext>
             </a:extLst>
           </p:cNvPr>
@@ -36248,7 +36248,7 @@
           <p:cNvPr id="3" name="inventory">
             <a:extLst xmlns:a="http://schemas.openxmlformats.org/drawingml/2006/main">
               <a:ext uri="{FF2B5EF4-FFF2-40B4-BE49-F238E27FC236}">
-                <a16:creationId xmlns:a16="http://schemas.microsoft.com/office/drawing/2014/main" id="{88DBBD88-BC4E-4AA4-80FA-CAA27DED89FD}"/>
+                <a16:creationId xmlns:a16="http://schemas.microsoft.com/office/drawing/2014/main" id="{B1483B0B-AF0E-4FB9-BE94-D262D807B212}"/>
               </a:ext>
             </a:extLst>
           </p:cNvPr>
@@ -36435,7 +36435,7 @@
           <p:cNvPr id="4" name="firmware">
             <a:extLst xmlns:a="http://schemas.openxmlformats.org/drawingml/2006/main">
               <a:ext uri="{FF2B5EF4-FFF2-40B4-BE49-F238E27FC236}">
-                <a16:creationId xmlns:a16="http://schemas.microsoft.com/office/drawing/2014/main" id="{8D8D1C49-F214-495E-8954-2C666DBCDE8E}"/>
+                <a16:creationId xmlns:a16="http://schemas.microsoft.com/office/drawing/2014/main" id="{DD0F6E91-8B71-4E21-932F-42EE0825C7BF}"/>
               </a:ext>
             </a:extLst>
           </p:cNvPr>
@@ -36622,7 +36622,7 @@
           <p:cNvPr id="5" name="tftp">
             <a:extLst xmlns:a="http://schemas.openxmlformats.org/drawingml/2006/main">
               <a:ext uri="{FF2B5EF4-FFF2-40B4-BE49-F238E27FC236}">
-                <a16:creationId xmlns:a16="http://schemas.microsoft.com/office/drawing/2014/main" id="{495591E8-C97C-442F-B52E-A1681BB71A3A}"/>
+                <a16:creationId xmlns:a16="http://schemas.microsoft.com/office/drawing/2014/main" id="{C640A1A7-7560-425B-A884-007AFD06BAA1}"/>
               </a:ext>
             </a:extLst>
           </p:cNvPr>
@@ -36809,7 +36809,7 @@
           <p:cNvPr id="6" name="pilot">
             <a:extLst xmlns:a="http://schemas.openxmlformats.org/drawingml/2006/main">
               <a:ext uri="{FF2B5EF4-FFF2-40B4-BE49-F238E27FC236}">
-                <a16:creationId xmlns:a16="http://schemas.microsoft.com/office/drawing/2014/main" id="{713FEE86-F675-43EA-BC72-72674EB79C49}"/>
+                <a16:creationId xmlns:a16="http://schemas.microsoft.com/office/drawing/2014/main" id="{0C533D11-1372-46D7-B019-26B60CE2FB48}"/>
               </a:ext>
             </a:extLst>
           </p:cNvPr>
@@ -36996,7 +36996,7 @@
           <p:cNvPr id="7" name="accept">
             <a:extLst xmlns:a="http://schemas.openxmlformats.org/drawingml/2006/main">
               <a:ext uri="{FF2B5EF4-FFF2-40B4-BE49-F238E27FC236}">
-                <a16:creationId xmlns:a16="http://schemas.microsoft.com/office/drawing/2014/main" id="{58387E37-B062-416C-B331-FB3D19CAE28C}"/>
+                <a16:creationId xmlns:a16="http://schemas.microsoft.com/office/drawing/2014/main" id="{DE2329A5-CD81-4447-8A34-BFDBC4F7506B}"/>
               </a:ext>
             </a:extLst>
           </p:cNvPr>
@@ -37183,7 +37183,7 @@
           <p:cNvPr id="8" name="fleet">
             <a:extLst xmlns:a="http://schemas.openxmlformats.org/drawingml/2006/main">
               <a:ext uri="{FF2B5EF4-FFF2-40B4-BE49-F238E27FC236}">
-                <a16:creationId xmlns:a16="http://schemas.microsoft.com/office/drawing/2014/main" id="{5CE594E6-12DE-48FF-BA6E-69A334F47226}"/>
+                <a16:creationId xmlns:a16="http://schemas.microsoft.com/office/drawing/2014/main" id="{6BF02383-56A2-4858-AE3D-F657593ABF44}"/>
               </a:ext>
             </a:extLst>
           </p:cNvPr>
@@ -37370,7 +37370,7 @@
           <p:cNvPr id="14" name="HW 13.0+ requires at least 9.3(1)SR3. The upgrade path depends on">
             <a:extLst xmlns:a="http://schemas.openxmlformats.org/drawingml/2006/main">
               <a:ext uri="{FF2B5EF4-FFF2-40B4-BE49-F238E27FC236}">
-                <a16:creationId xmlns:a16="http://schemas.microsoft.com/office/drawing/2014/main" id="{99A841C0-34A7-480C-9CB0-CC68D3A2900E}"/>
+                <a16:creationId xmlns:a16="http://schemas.microsoft.com/office/drawing/2014/main" id="{39225B8C-8E56-4F9C-8ED9-4C304FDBD368}"/>
               </a:ext>
             </a:extLst>
           </p:cNvPr>
@@ -37549,7 +37549,7 @@
     </p:spTree>
     <p:extLst>
       <p:ext uri="{BB962C8B-B14F-4D97-AF65-F5344CB8AC3E}">
-        <p14:creationId xmlns:p14="http://schemas.microsoft.com/office/powerpoint/2010/main" val="1437108232"/>
+        <p14:creationId xmlns:p14="http://schemas.microsoft.com/office/powerpoint/2010/main" val="1975334921"/>
       </p:ext>
     </p:extLst>
   </p:cSld>
@@ -37580,7 +37580,7 @@
           <p:cNvPr id="8" name="TFTP preparation before restart">
             <a:extLst xmlns:a="http://schemas.openxmlformats.org/drawingml/2006/main">
               <a:ext uri="{FF2B5EF4-FFF2-40B4-BE49-F238E27FC236}">
-                <a16:creationId xmlns:a16="http://schemas.microsoft.com/office/drawing/2014/main" id="{4B9B8745-C16B-4B49-B91A-42C5ED9538CF}"/>
+                <a16:creationId xmlns:a16="http://schemas.microsoft.com/office/drawing/2014/main" id="{6A512294-3BE1-4163-9A18-2D02D7765185}"/>
               </a:ext>
             </a:extLst>
           </p:cNvPr>
@@ -37738,7 +37738,7 @@
           <p:cNvPr id="2" name="07">
             <a:extLst xmlns:a="http://schemas.openxmlformats.org/drawingml/2006/main">
               <a:ext uri="{FF2B5EF4-FFF2-40B4-BE49-F238E27FC236}">
-                <a16:creationId xmlns:a16="http://schemas.microsoft.com/office/drawing/2014/main" id="{D50B9C09-6D0D-4FA1-B076-9830197D4A27}"/>
+                <a16:creationId xmlns:a16="http://schemas.microsoft.com/office/drawing/2014/main" id="{44065361-0207-42E4-9D17-4C53551E2ADF}"/>
               </a:ext>
             </a:extLst>
           </p:cNvPr>
@@ -37896,7 +37896,7 @@
           <p:cNvPr id="3" name="Complete official firmware bundle">
             <a:extLst xmlns:a="http://schemas.openxmlformats.org/drawingml/2006/main">
               <a:ext uri="{FF2B5EF4-FFF2-40B4-BE49-F238E27FC236}">
-                <a16:creationId xmlns:a16="http://schemas.microsoft.com/office/drawing/2014/main" id="{B81F4F2F-3D5A-47A8-A290-F9C420A8F882}"/>
+                <a16:creationId xmlns:a16="http://schemas.microsoft.com/office/drawing/2014/main" id="{455C4AE9-0E6D-4A9B-86B0-84A3AB6DF690}"/>
               </a:ext>
             </a:extLst>
           </p:cNvPr>
@@ -38054,7 +38054,7 @@
           <p:cNvPr id="4" name=".loads and every referenced binary file&#10;with the original filenam">
             <a:extLst xmlns:a="http://schemas.openxmlformats.org/drawingml/2006/main">
               <a:ext uri="{FF2B5EF4-FFF2-40B4-BE49-F238E27FC236}">
-                <a16:creationId xmlns:a16="http://schemas.microsoft.com/office/drawing/2014/main" id="{00FE1FCA-ECDF-434A-AC2D-6701A8F4AA09}"/>
+                <a16:creationId xmlns:a16="http://schemas.microsoft.com/office/drawing/2014/main" id="{AE3DE605-C46D-496B-8F4E-F564CE3AF61F}"/>
               </a:ext>
             </a:extLst>
           </p:cNvPr>
@@ -38235,7 +38235,7 @@
           <p:cNvPr id="5" name="SEP&lt;MAC&gt;.cnf.xml">
             <a:extLst xmlns:a="http://schemas.openxmlformats.org/drawingml/2006/main">
               <a:ext uri="{FF2B5EF4-FFF2-40B4-BE49-F238E27FC236}">
-                <a16:creationId xmlns:a16="http://schemas.microsoft.com/office/drawing/2014/main" id="{054F2B88-2F27-4FC9-9932-9F33DCB1238F}"/>
+                <a16:creationId xmlns:a16="http://schemas.microsoft.com/office/drawing/2014/main" id="{3AEA0BDB-DF6A-414C-B665-E596CC112F89}"/>
               </a:ext>
             </a:extLst>
           </p:cNvPr>
@@ -38393,7 +38393,7 @@
           <p:cNvPr id="6" name="SIP server, extension and a unique password&#10;Load ID from the sele">
             <a:extLst xmlns:a="http://schemas.openxmlformats.org/drawingml/2006/main">
               <a:ext uri="{FF2B5EF4-FFF2-40B4-BE49-F238E27FC236}">
-                <a16:creationId xmlns:a16="http://schemas.microsoft.com/office/drawing/2014/main" id="{CC41FCA7-3FFE-4B4F-8E9E-F5C7785EE17E}"/>
+                <a16:creationId xmlns:a16="http://schemas.microsoft.com/office/drawing/2014/main" id="{A95C44B6-0E15-4B24-BE2A-AB57039CE12E}"/>
               </a:ext>
             </a:extLst>
           </p:cNvPr>
@@ -38574,7 +38574,7 @@
           <p:cNvPr id="7" name="Use DHCP option 150 on the home router or Alternate TFTP on the p">
             <a:extLst xmlns:a="http://schemas.openxmlformats.org/drawingml/2006/main">
               <a:ext uri="{FF2B5EF4-FFF2-40B4-BE49-F238E27FC236}">
-                <a16:creationId xmlns:a16="http://schemas.microsoft.com/office/drawing/2014/main" id="{C582834F-171A-4E6E-890A-D6CB7EFB9CEA}"/>
+                <a16:creationId xmlns:a16="http://schemas.microsoft.com/office/drawing/2014/main" id="{F1DCFAC5-DF95-4814-A780-5D336F1D4E1A}"/>
               </a:ext>
             </a:extLst>
           </p:cNvPr>
@@ -38730,7 +38730,7 @@
     </p:spTree>
     <p:extLst>
       <p:ext uri="{BB962C8B-B14F-4D97-AF65-F5344CB8AC3E}">
-        <p14:creationId xmlns:p14="http://schemas.microsoft.com/office/powerpoint/2010/main" val="384114579"/>
+        <p14:creationId xmlns:p14="http://schemas.microsoft.com/office/powerpoint/2010/main" val="1801680276"/>
       </p:ext>
     </p:extLst>
   </p:cSld>
@@ -38761,7 +38761,7 @@
           <p:cNvPr id="8" name="Asterisk: independent SIP lines">
             <a:extLst xmlns:a="http://schemas.openxmlformats.org/drawingml/2006/main">
               <a:ext uri="{FF2B5EF4-FFF2-40B4-BE49-F238E27FC236}">
-                <a16:creationId xmlns:a16="http://schemas.microsoft.com/office/drawing/2014/main" id="{D3BC15EC-D970-45C7-8F69-FE3E115AE318}"/>
+                <a16:creationId xmlns:a16="http://schemas.microsoft.com/office/drawing/2014/main" id="{BEB9D201-FB62-498E-ADE3-B54F0C05F470}"/>
               </a:ext>
             </a:extLst>
           </p:cNvPr>
@@ -38919,7 +38919,7 @@
           <p:cNvPr id="2" name="08">
             <a:extLst xmlns:a="http://schemas.openxmlformats.org/drawingml/2006/main">
               <a:ext uri="{FF2B5EF4-FFF2-40B4-BE49-F238E27FC236}">
-                <a16:creationId xmlns:a16="http://schemas.microsoft.com/office/drawing/2014/main" id="{DD3D1ABB-8764-4D3D-B5AD-CAE0C998F2F5}"/>
+                <a16:creationId xmlns:a16="http://schemas.microsoft.com/office/drawing/2014/main" id="{12FC38A1-406B-4FFE-AF31-F1B59611E560}"/>
               </a:ext>
             </a:extLst>
           </p:cNvPr>
@@ -39077,7 +39077,7 @@
           <p:cNvPr id="3" name="201 / 202">
             <a:extLst xmlns:a="http://schemas.openxmlformats.org/drawingml/2006/main">
               <a:ext uri="{FF2B5EF4-FFF2-40B4-BE49-F238E27FC236}">
-                <a16:creationId xmlns:a16="http://schemas.microsoft.com/office/drawing/2014/main" id="{1BFA9D4B-8C58-4663-A7DB-C80D9ED11D39}"/>
+                <a16:creationId xmlns:a16="http://schemas.microsoft.com/office/drawing/2014/main" id="{2D343321-BF00-41C7-90AF-4921DB33425C}"/>
               </a:ext>
             </a:extLst>
           </p:cNvPr>
@@ -39235,7 +39235,7 @@
           <p:cNvPr id="4" name="one phone">
             <a:extLst xmlns:a="http://schemas.openxmlformats.org/drawingml/2006/main">
               <a:ext uri="{FF2B5EF4-FFF2-40B4-BE49-F238E27FC236}">
-                <a16:creationId xmlns:a16="http://schemas.microsoft.com/office/drawing/2014/main" id="{F5F3C217-745F-4C19-8433-E89AC4895477}"/>
+                <a16:creationId xmlns:a16="http://schemas.microsoft.com/office/drawing/2014/main" id="{E597754A-ADFB-4865-961D-B1C6680E519D}"/>
               </a:ext>
             </a:extLst>
           </p:cNvPr>
@@ -39393,7 +39393,7 @@
           <p:cNvPr id="5" name="One endpoint, auth and AOR per line&#10;A unique password for each li">
             <a:extLst xmlns:a="http://schemas.openxmlformats.org/drawingml/2006/main">
               <a:ext uri="{FF2B5EF4-FFF2-40B4-BE49-F238E27FC236}">
-                <a16:creationId xmlns:a16="http://schemas.microsoft.com/office/drawing/2014/main" id="{FDD88CFE-2C7E-436C-B921-BB31B9EA3BFC}"/>
+                <a16:creationId xmlns:a16="http://schemas.microsoft.com/office/drawing/2014/main" id="{D442CB34-E740-4315-9925-F054FD671ACF}"/>
               </a:ext>
             </a:extLst>
           </p:cNvPr>
@@ -39574,7 +39574,7 @@
           <p:cNvPr id="6" name="G.711 ulaw / alaw&#10;direct_media=no keeps RTP on Asterisk">
             <a:extLst xmlns:a="http://schemas.openxmlformats.org/drawingml/2006/main">
               <a:ext uri="{FF2B5EF4-FFF2-40B4-BE49-F238E27FC236}">
-                <a16:creationId xmlns:a16="http://schemas.microsoft.com/office/drawing/2014/main" id="{5225C6E4-3246-4D7F-B967-7CCFFF3EAC84}"/>
+                <a16:creationId xmlns:a16="http://schemas.microsoft.com/office/drawing/2014/main" id="{51D2E950-EE68-44AD-8E4F-1AE9E02450E9}"/>
               </a:ext>
             </a:extLst>
           </p:cNvPr>
@@ -39755,7 +39755,7 @@
           <p:cNvPr id="7" name="600 echo, 601 tone, 620 ring group. Extension 630 requires Assist">
             <a:extLst xmlns:a="http://schemas.openxmlformats.org/drawingml/2006/main">
               <a:ext uri="{FF2B5EF4-FFF2-40B4-BE49-F238E27FC236}">
-                <a16:creationId xmlns:a16="http://schemas.microsoft.com/office/drawing/2014/main" id="{A74AD764-558F-429A-B1DF-A68AEB64EF66}"/>
+                <a16:creationId xmlns:a16="http://schemas.microsoft.com/office/drawing/2014/main" id="{96F401B3-B24E-45C1-BBB5-FF46A347D12A}"/>
               </a:ext>
             </a:extLst>
           </p:cNvPr>
@@ -39911,7 +39911,7 @@
     </p:spTree>
     <p:extLst>
       <p:ext uri="{BB962C8B-B14F-4D97-AF65-F5344CB8AC3E}">
-        <p14:creationId xmlns:p14="http://schemas.microsoft.com/office/powerpoint/2010/main" val="411781559"/>
+        <p14:creationId xmlns:p14="http://schemas.microsoft.com/office/powerpoint/2010/main" val="1365858718"/>
       </p:ext>
     </p:extLst>
   </p:cSld>
@@ -39942,7 +39942,7 @@
           <p:cNvPr id="8" name="AMI: status and call control">
             <a:extLst xmlns:a="http://schemas.openxmlformats.org/drawingml/2006/main">
               <a:ext uri="{FF2B5EF4-FFF2-40B4-BE49-F238E27FC236}">
-                <a16:creationId xmlns:a16="http://schemas.microsoft.com/office/drawing/2014/main" id="{DB3ABA55-C8CD-471E-881F-214B1803D3A3}"/>
+                <a16:creationId xmlns:a16="http://schemas.microsoft.com/office/drawing/2014/main" id="{2650EE70-B5E7-4C68-B6F1-2BBEEA9CEE92}"/>
               </a:ext>
             </a:extLst>
           </p:cNvPr>
@@ -40100,7 +40100,7 @@
           <p:cNvPr id="2" name="09">
             <a:extLst xmlns:a="http://schemas.openxmlformats.org/drawingml/2006/main">
               <a:ext uri="{FF2B5EF4-FFF2-40B4-BE49-F238E27FC236}">
-                <a16:creationId xmlns:a16="http://schemas.microsoft.com/office/drawing/2014/main" id="{662298C5-6ED3-4607-86D4-A8580F7C46D7}"/>
+                <a16:creationId xmlns:a16="http://schemas.microsoft.com/office/drawing/2014/main" id="{6BD4CBD9-D3FD-4483-80AC-6D4A22F84753}"/>
               </a:ext>
             </a:extLst>
           </p:cNvPr>
@@ -40258,7 +40258,7 @@
           <p:cNvPr id="3" name="Home Assistant connects to PBX:5038">
             <a:extLst xmlns:a="http://schemas.openxmlformats.org/drawingml/2006/main">
               <a:ext uri="{FF2B5EF4-FFF2-40B4-BE49-F238E27FC236}">
-                <a16:creationId xmlns:a16="http://schemas.microsoft.com/office/drawing/2014/main" id="{2C14E1D9-B98B-4B8D-A68F-E214C3908578}"/>
+                <a16:creationId xmlns:a16="http://schemas.microsoft.com/office/drawing/2014/main" id="{3B433A05-D2C3-4484-B317-C16AA0987D4D}"/>
               </a:ext>
             </a:extLst>
           </p:cNvPr>
@@ -40416,7 +40416,7 @@
           <p:cNvPr id="4" name="Status, connected line and DTMF&#10;Actual entity IDs from your HA in">
             <a:extLst xmlns:a="http://schemas.openxmlformats.org/drawingml/2006/main">
               <a:ext uri="{FF2B5EF4-FFF2-40B4-BE49-F238E27FC236}">
-                <a16:creationId xmlns:a16="http://schemas.microsoft.com/office/drawing/2014/main" id="{F98E2C5A-E4A0-4728-AEF2-C44614D98898}"/>
+                <a16:creationId xmlns:a16="http://schemas.microsoft.com/office/drawing/2014/main" id="{D2BBE51F-AC24-427A-A04F-F7079AEFC7AD}"/>
               </a:ext>
             </a:extLst>
           </p:cNvPr>
@@ -40597,7 +40597,7 @@
           <p:cNvPr id="5" name="Place calls and hang up a specific channel">
             <a:extLst xmlns:a="http://schemas.openxmlformats.org/drawingml/2006/main">
               <a:ext uri="{FF2B5EF4-FFF2-40B4-BE49-F238E27FC236}">
-                <a16:creationId xmlns:a16="http://schemas.microsoft.com/office/drawing/2014/main" id="{E7D89A30-ED69-4C95-8BF5-90ACFB36C676}"/>
+                <a16:creationId xmlns:a16="http://schemas.microsoft.com/office/drawing/2014/main" id="{3156EC23-0CB1-422C-83E4-B627CA75A7CA}"/>
               </a:ext>
             </a:extLst>
           </p:cNvPr>
@@ -40755,7 +40755,7 @@
           <p:cNvPr id="6" name="asterisk.send_action: Originate / Hangup&#10;The DTMF example sends a">
             <a:extLst xmlns:a="http://schemas.openxmlformats.org/drawingml/2006/main">
               <a:ext uri="{FF2B5EF4-FFF2-40B4-BE49-F238E27FC236}">
-                <a16:creationId xmlns:a16="http://schemas.microsoft.com/office/drawing/2014/main" id="{CB48CFF7-9CAF-429B-A6C5-4F4AB6FF5ACE}"/>
+                <a16:creationId xmlns:a16="http://schemas.microsoft.com/office/drawing/2014/main" id="{274B6124-549B-41A7-B18F-C372ECFB5F9B}"/>
               </a:ext>
             </a:extLst>
           </p:cNvPr>
@@ -40936,7 +40936,7 @@
           <p:cNvPr id="7" name="Use a separate secret and a /32 ACL. The system permission allows">
             <a:extLst xmlns:a="http://schemas.openxmlformats.org/drawingml/2006/main">
               <a:ext uri="{FF2B5EF4-FFF2-40B4-BE49-F238E27FC236}">
-                <a16:creationId xmlns:a16="http://schemas.microsoft.com/office/drawing/2014/main" id="{3918F16C-79A8-46F3-9183-28678A54F829}"/>
+                <a16:creationId xmlns:a16="http://schemas.microsoft.com/office/drawing/2014/main" id="{A12CB9B7-7D32-44C3-B7CC-9FD8B57E3C26}"/>
               </a:ext>
             </a:extLst>
           </p:cNvPr>
@@ -41092,7 +41092,7 @@
     </p:spTree>
     <p:extLst>
       <p:ext uri="{BB962C8B-B14F-4D97-AF65-F5344CB8AC3E}">
-        <p14:creationId xmlns:p14="http://schemas.microsoft.com/office/powerpoint/2010/main" val="1693943508"/>
+        <p14:creationId xmlns:p14="http://schemas.microsoft.com/office/powerpoint/2010/main" val="41986417"/>
       </p:ext>
     </p:extLst>
   </p:cSld>

</xml_diff>